<commit_message>
Update presentation with bold bullet headers and 1:1 SLR capstone styling
</commit_message>
<xml_diff>
--- a/Internship Presentation PPTs Template Final.pptx
+++ b/Internship Presentation PPTs Template Final.pptx
@@ -5648,13 +5648,28 @@
               </a:spcAft>
               <a:defRPr sz="2000" b="1">
                 <a:solidFill>
+                  <a:srgbClr val="0F172A"/>
+                </a:solidFill>
+                <a:latin typeface="Calibri"/>
+              </a:defRPr>
+            </a:pPr>
+            <a:r>
+              <a:rPr sz="1800" b="1">
+                <a:solidFill>
+                  <a:srgbClr val="0F172A"/>
+                </a:solidFill>
+                <a:latin typeface="Calibri"/>
+              </a:rPr>
+              <a:t>• Command-Line Diagnostic Tool: </a:t>
+            </a:r>
+            <a:r>
+              <a:rPr sz="1800" b="0">
+                <a:solidFill>
                   <a:srgbClr val="334155"/>
                 </a:solidFill>
                 <a:latin typeface="Calibri"/>
-              </a:defRPr>
-            </a:pPr>
-            <a:r>
-              <a:t>• Command-Line Diagnostic Tool: Built using Python argparse &amp; serialized model pickle files.</a:t>
+              </a:rPr>
+              <a:t>Built using Python argparse &amp; serialized model pickle files.</a:t>
             </a:r>
           </a:p>
           <a:p>
@@ -5669,8 +5684,60 @@
                 <a:latin typeface="Calibri"/>
               </a:defRPr>
             </a:pPr>
-            <a:r>
-              <a:t>• Live Video Viewport: </a:t>
+          </a:p>
+          <a:p>
+            <a:pPr>
+              <a:spcAft>
+                <a:spcPts val="600"/>
+              </a:spcAft>
+              <a:defRPr sz="2000" b="1">
+                <a:solidFill>
+                  <a:srgbClr val="0F172A"/>
+                </a:solidFill>
+                <a:latin typeface="Calibri"/>
+              </a:defRPr>
+            </a:pPr>
+          </a:p>
+          <a:p>
+            <a:pPr>
+              <a:spcAft>
+                <a:spcPts val="600"/>
+              </a:spcAft>
+              <a:defRPr sz="2000" b="1">
+                <a:solidFill>
+                  <a:srgbClr val="0F172A"/>
+                </a:solidFill>
+                <a:latin typeface="Calibri"/>
+              </a:defRPr>
+            </a:pPr>
+          </a:p>
+          <a:p>
+            <a:pPr>
+              <a:spcAft>
+                <a:spcPts val="600"/>
+              </a:spcAft>
+              <a:defRPr sz="2000" b="1">
+                <a:solidFill>
+                  <a:srgbClr val="0F172A"/>
+                </a:solidFill>
+                <a:latin typeface="Calibri"/>
+              </a:defRPr>
+            </a:pPr>
+          </a:p>
+          <a:p>
+            <a:pPr>
+              <a:spcAft>
+                <a:spcPts val="1400"/>
+              </a:spcAft>
+            </a:pPr>
+            <a:r>
+              <a:rPr sz="1800" b="1">
+                <a:solidFill>
+                  <a:srgbClr val="0F172A"/>
+                </a:solidFill>
+                <a:latin typeface="Calibri"/>
+              </a:rPr>
+              <a:t>• Execution Command: </a:t>
             </a:r>
             <a:r>
               <a:rPr sz="1800" b="0">
@@ -5679,23 +5746,23 @@
                 </a:solidFill>
                 <a:latin typeface="Calibri"/>
               </a:rPr>
-              <a:t>Displays real-time OpenCV camera feed with MediaPipe landmark skeleton overlays</a:t>
-            </a:r>
-          </a:p>
-          <a:p>
-            <a:pPr>
-              <a:spcAft>
-                <a:spcPts val="600"/>
-              </a:spcAft>
-              <a:defRPr sz="2000" b="1">
-                <a:solidFill>
-                  <a:srgbClr val="0F172A"/>
-                </a:solidFill>
-                <a:latin typeface="Calibri"/>
-              </a:defRPr>
-            </a:pPr>
-            <a:r>
-              <a:t>• Prediction Hero Display: </a:t>
+              <a:t>python predict.py --engine_id 81</a:t>
+            </a:r>
+          </a:p>
+          <a:p>
+            <a:pPr>
+              <a:spcAft>
+                <a:spcPts val="1400"/>
+              </a:spcAft>
+            </a:pPr>
+            <a:r>
+              <a:rPr sz="1800" b="1">
+                <a:solidFill>
+                  <a:srgbClr val="0F172A"/>
+                </a:solidFill>
+                <a:latin typeface="Calibri"/>
+              </a:rPr>
+              <a:t>• Diagnostic Output Parameters: </a:t>
             </a:r>
             <a:r>
               <a:rPr sz="1800" b="0">
@@ -5704,23 +5771,23 @@
                 </a:solidFill>
                 <a:latin typeface="Calibri"/>
               </a:rPr>
-              <a:t>Prominently displays top predicted gesture text in a clear, bold hero card</a:t>
-            </a:r>
-          </a:p>
-          <a:p>
-            <a:pPr>
-              <a:spcAft>
-                <a:spcPts val="600"/>
-              </a:spcAft>
-              <a:defRPr sz="2000" b="1">
-                <a:solidFill>
-                  <a:srgbClr val="0F172A"/>
-                </a:solidFill>
-                <a:latin typeface="Calibri"/>
-              </a:defRPr>
-            </a:pPr>
-            <a:r>
-              <a:t>• Confidence Progress Meters: </a:t>
+              <a:t>Estimated Remaining RUL, 30-cycle failure probability, risk rating.</a:t>
+            </a:r>
+          </a:p>
+          <a:p>
+            <a:pPr>
+              <a:spcAft>
+                <a:spcPts val="1400"/>
+              </a:spcAft>
+            </a:pPr>
+            <a:r>
+              <a:rPr sz="1800" b="1">
+                <a:solidFill>
+                  <a:srgbClr val="0F172A"/>
+                </a:solidFill>
+                <a:latin typeface="Calibri"/>
+              </a:rPr>
+              <a:t>• Actionable Maintenance Recommendation: </a:t>
             </a:r>
             <a:r>
               <a:rPr sz="1800" b="0">
@@ -5729,80 +5796,7 @@
                 </a:solidFill>
                 <a:latin typeface="Calibri"/>
               </a:rPr>
-              <a:t>Native ttk.Progressbar widgets detailing real-time top-3 gesture probabilities</a:t>
-            </a:r>
-          </a:p>
-          <a:p>
-            <a:pPr>
-              <a:spcAft>
-                <a:spcPts val="600"/>
-              </a:spcAft>
-              <a:defRPr sz="2000" b="1">
-                <a:solidFill>
-                  <a:srgbClr val="0F172A"/>
-                </a:solidFill>
-                <a:latin typeface="Calibri"/>
-              </a:defRPr>
-            </a:pPr>
-            <a:r>
-              <a:t>• Dataset Management Tabs: </a:t>
-            </a:r>
-            <a:r>
-              <a:rPr sz="1800" b="0">
-                <a:solidFill>
-                  <a:srgbClr val="334155"/>
-                </a:solidFill>
-                <a:latin typeface="Calibri"/>
-              </a:rPr>
-              <a:t>Includes dedicated tabs for Recording Videos, Importing Files, and Dataset Video Gallery</a:t>
-            </a:r>
-          </a:p>
-          <a:p>
-            <a:pPr>
-              <a:spcAft>
-                <a:spcPts val="1400"/>
-              </a:spcAft>
-              <a:defRPr sz="2000" b="1">
-                <a:solidFill>
-                  <a:srgbClr val="334155"/>
-                </a:solidFill>
-                <a:latin typeface="Calibri"/>
-              </a:defRPr>
-            </a:pPr>
-            <a:r>
-              <a:t>• Execution Command: python predict.py --engine_id 81</a:t>
-            </a:r>
-          </a:p>
-          <a:p>
-            <a:pPr>
-              <a:spcAft>
-                <a:spcPts val="1400"/>
-              </a:spcAft>
-              <a:defRPr sz="2000" b="1">
-                <a:solidFill>
-                  <a:srgbClr val="334155"/>
-                </a:solidFill>
-                <a:latin typeface="Calibri"/>
-              </a:defRPr>
-            </a:pPr>
-            <a:r>
-              <a:t>• Diagnostic Output Parameters: Estimated Remaining RUL, 30-cycle failure probability, risk rating.</a:t>
-            </a:r>
-          </a:p>
-          <a:p>
-            <a:pPr>
-              <a:spcAft>
-                <a:spcPts val="1400"/>
-              </a:spcAft>
-              <a:defRPr sz="2000" b="1">
-                <a:solidFill>
-                  <a:srgbClr val="334155"/>
-                </a:solidFill>
-                <a:latin typeface="Calibri"/>
-              </a:defRPr>
-            </a:pPr>
-            <a:r>
-              <a:t>• Actionable Maintenance Recommendation: Instructs fleet managers to ground aircraft or schedule service.</a:t>
+              <a:t>Instructs fleet managers to ground aircraft or schedule service.</a:t>
             </a:r>
           </a:p>
         </p:txBody>
@@ -5925,13 +5919,28 @@
               </a:spcAft>
               <a:defRPr sz="2000" b="1">
                 <a:solidFill>
+                  <a:srgbClr val="0F172A"/>
+                </a:solidFill>
+                <a:latin typeface="Calibri"/>
+              </a:defRPr>
+            </a:pPr>
+            <a:r>
+              <a:rPr sz="1800" b="1">
+                <a:solidFill>
+                  <a:srgbClr val="0F172A"/>
+                </a:solidFill>
+                <a:latin typeface="Calibri"/>
+              </a:rPr>
+              <a:t>• Operational Thresholding: </a:t>
+            </a:r>
+            <a:r>
+              <a:rPr sz="1800" b="0">
+                <a:solidFill>
                   <a:srgbClr val="334155"/>
                 </a:solidFill>
                 <a:latin typeface="Calibri"/>
-              </a:defRPr>
-            </a:pPr>
-            <a:r>
-              <a:t>• Operational Thresholding: Categorizes engine hazard state into 3 distinct operational buckets.</a:t>
+              </a:rPr>
+              <a:t>Categorizes engine hazard state into 3 distinct operational buckets.</a:t>
             </a:r>
           </a:p>
           <a:p>
@@ -5946,8 +5955,60 @@
                 <a:latin typeface="Calibri"/>
               </a:defRPr>
             </a:pPr>
-            <a:r>
-              <a:t>• Confidence Thresholding: </a:t>
+          </a:p>
+          <a:p>
+            <a:pPr>
+              <a:spcAft>
+                <a:spcPts val="600"/>
+              </a:spcAft>
+              <a:defRPr sz="2000" b="1">
+                <a:solidFill>
+                  <a:srgbClr val="0F172A"/>
+                </a:solidFill>
+                <a:latin typeface="Calibri"/>
+              </a:defRPr>
+            </a:pPr>
+          </a:p>
+          <a:p>
+            <a:pPr>
+              <a:spcAft>
+                <a:spcPts val="600"/>
+              </a:spcAft>
+              <a:defRPr sz="2000" b="1">
+                <a:solidFill>
+                  <a:srgbClr val="0F172A"/>
+                </a:solidFill>
+                <a:latin typeface="Calibri"/>
+              </a:defRPr>
+            </a:pPr>
+          </a:p>
+          <a:p>
+            <a:pPr>
+              <a:spcAft>
+                <a:spcPts val="600"/>
+              </a:spcAft>
+              <a:defRPr sz="2000" b="1">
+                <a:solidFill>
+                  <a:srgbClr val="0F172A"/>
+                </a:solidFill>
+                <a:latin typeface="Calibri"/>
+              </a:defRPr>
+            </a:pPr>
+          </a:p>
+          <a:p>
+            <a:pPr>
+              <a:spcAft>
+                <a:spcPts val="1400"/>
+              </a:spcAft>
+            </a:pPr>
+            <a:r>
+              <a:rPr sz="1800" b="1">
+                <a:solidFill>
+                  <a:srgbClr val="0F172A"/>
+                </a:solidFill>
+                <a:latin typeface="Calibri"/>
+              </a:rPr>
+              <a:t>• Healthy State (Green): </a:t>
             </a:r>
             <a:r>
               <a:rPr sz="1800" b="0">
@@ -5956,23 +6017,23 @@
                 </a:solidFill>
                 <a:latin typeface="Calibri"/>
               </a:rPr>
-              <a:t>Requires a minimum 45% probability threshold before displaying sign gesture output</a:t>
-            </a:r>
-          </a:p>
-          <a:p>
-            <a:pPr>
-              <a:spcAft>
-                <a:spcPts val="600"/>
-              </a:spcAft>
-              <a:defRPr sz="2000" b="1">
-                <a:solidFill>
-                  <a:srgbClr val="0F172A"/>
-                </a:solidFill>
-                <a:latin typeface="Calibri"/>
-              </a:defRPr>
-            </a:pPr>
-            <a:r>
-              <a:t>• Text-to-Speech (TTS) Integration: </a:t>
+              <a:t>RUL &gt; 30 cycles; engine remains in normal operational flight status.</a:t>
+            </a:r>
+          </a:p>
+          <a:p>
+            <a:pPr>
+              <a:spcAft>
+                <a:spcPts val="1400"/>
+              </a:spcAft>
+            </a:pPr>
+            <a:r>
+              <a:rPr sz="1800" b="1">
+                <a:solidFill>
+                  <a:srgbClr val="0F172A"/>
+                </a:solidFill>
+                <a:latin typeface="Calibri"/>
+              </a:rPr>
+              <a:t>• Warning Window (Yellow): </a:t>
             </a:r>
             <a:r>
               <a:rPr sz="1800" b="0">
@@ -5981,23 +6042,23 @@
                 </a:solidFill>
                 <a:latin typeface="Calibri"/>
               </a:rPr>
-              <a:t>Asynchronous Pyttsx3 speech engine speaks recognized gesture words aloud</a:t>
-            </a:r>
-          </a:p>
-          <a:p>
-            <a:pPr>
-              <a:spcAft>
-                <a:spcPts val="600"/>
-              </a:spcAft>
-              <a:defRPr sz="2000" b="1">
-                <a:solidFill>
-                  <a:srgbClr val="0F172A"/>
-                </a:solidFill>
-                <a:latin typeface="Calibri"/>
-              </a:defRPr>
-            </a:pPr>
-            <a:r>
-              <a:t>• Audio Toggle Control: </a:t>
+              <a:t>15 &lt; RUL &lt;= 30 cycles; schedule preventive maintenance within 5 cycles.</a:t>
+            </a:r>
+          </a:p>
+          <a:p>
+            <a:pPr>
+              <a:spcAft>
+                <a:spcPts val="1400"/>
+              </a:spcAft>
+            </a:pPr>
+            <a:r>
+              <a:rPr sz="1800" b="1">
+                <a:solidFill>
+                  <a:srgbClr val="0F172A"/>
+                </a:solidFill>
+                <a:latin typeface="Calibri"/>
+              </a:rPr>
+              <a:t>• Critical Action (Red): </a:t>
             </a:r>
             <a:r>
               <a:rPr sz="1800" b="0">
@@ -6006,80 +6067,7 @@
                 </a:solidFill>
                 <a:latin typeface="Calibri"/>
               </a:rPr>
-              <a:t>Includes a GUI checkbox enabling/disabling voice output for user preference</a:t>
-            </a:r>
-          </a:p>
-          <a:p>
-            <a:pPr>
-              <a:spcAft>
-                <a:spcPts val="600"/>
-              </a:spcAft>
-              <a:defRPr sz="2000" b="1">
-                <a:solidFill>
-                  <a:srgbClr val="0F172A"/>
-                </a:solidFill>
-                <a:latin typeface="Calibri"/>
-              </a:defRPr>
-            </a:pPr>
-            <a:r>
-              <a:t>• Sub-30ms Inference Latency: </a:t>
-            </a:r>
-            <a:r>
-              <a:rPr sz="1800" b="0">
-                <a:solidFill>
-                  <a:srgbClr val="334155"/>
-                </a:solidFill>
-                <a:latin typeface="Calibri"/>
-              </a:rPr>
-              <a:t>Ensures smooth live translation without lag or freezing during continuous signing</a:t>
-            </a:r>
-          </a:p>
-          <a:p>
-            <a:pPr>
-              <a:spcAft>
-                <a:spcPts val="1400"/>
-              </a:spcAft>
-              <a:defRPr sz="2000" b="1">
-                <a:solidFill>
-                  <a:srgbClr val="334155"/>
-                </a:solidFill>
-                <a:latin typeface="Calibri"/>
-              </a:defRPr>
-            </a:pPr>
-            <a:r>
-              <a:t>• Healthy State (Green): RUL &gt; 30 cycles; engine remains in normal operational flight status.</a:t>
-            </a:r>
-          </a:p>
-          <a:p>
-            <a:pPr>
-              <a:spcAft>
-                <a:spcPts val="1400"/>
-              </a:spcAft>
-              <a:defRPr sz="2000" b="1">
-                <a:solidFill>
-                  <a:srgbClr val="334155"/>
-                </a:solidFill>
-                <a:latin typeface="Calibri"/>
-              </a:defRPr>
-            </a:pPr>
-            <a:r>
-              <a:t>• Warning Window (Yellow): 15 &lt; RUL &lt;= 30 cycles; schedule preventive maintenance within 5 cycles.</a:t>
-            </a:r>
-          </a:p>
-          <a:p>
-            <a:pPr>
-              <a:spcAft>
-                <a:spcPts val="1400"/>
-              </a:spcAft>
-              <a:defRPr sz="2000" b="1">
-                <a:solidFill>
-                  <a:srgbClr val="334155"/>
-                </a:solidFill>
-                <a:latin typeface="Calibri"/>
-              </a:defRPr>
-            </a:pPr>
-            <a:r>
-              <a:t>• Critical Action (Red): RUL &lt;= 15 cycles; ground aircraft for immediate engine overhaul within 24h.</a:t>
+              <a:t>RUL &lt;= 15 cycles; ground aircraft for immediate engine overhaul within 24h.</a:t>
             </a:r>
           </a:p>
         </p:txBody>
@@ -6202,13 +6190,28 @@
               </a:spcAft>
               <a:defRPr sz="2000" b="1">
                 <a:solidFill>
+                  <a:srgbClr val="0F172A"/>
+                </a:solidFill>
+                <a:latin typeface="Calibri"/>
+              </a:defRPr>
+            </a:pPr>
+            <a:r>
+              <a:rPr sz="1800" b="1">
+                <a:solidFill>
+                  <a:srgbClr val="0F172A"/>
+                </a:solidFill>
+                <a:latin typeface="Calibri"/>
+              </a:rPr>
+              <a:t>• Binary Failure Warning AUC-ROC: </a:t>
+            </a:r>
+            <a:r>
+              <a:rPr sz="1800" b="0">
+                <a:solidFill>
                   <a:srgbClr val="334155"/>
                 </a:solidFill>
                 <a:latin typeface="Calibri"/>
-              </a:defRPr>
-            </a:pPr>
-            <a:r>
-              <a:t>• Binary Failure Warning AUC-ROC: Achieved 98.45% (0.9845) AUC-ROC score on test engines.</a:t>
+              </a:rPr>
+              <a:t>Achieved 98.45% (0.9845) AUC-ROC score on test engines.</a:t>
             </a:r>
           </a:p>
           <a:p>
@@ -6223,8 +6226,60 @@
                 <a:latin typeface="Calibri"/>
               </a:defRPr>
             </a:pPr>
-            <a:r>
-              <a:t>• Overall Test Loss: </a:t>
+          </a:p>
+          <a:p>
+            <a:pPr>
+              <a:spcAft>
+                <a:spcPts val="600"/>
+              </a:spcAft>
+              <a:defRPr sz="2000" b="1">
+                <a:solidFill>
+                  <a:srgbClr val="0F172A"/>
+                </a:solidFill>
+                <a:latin typeface="Calibri"/>
+              </a:defRPr>
+            </a:pPr>
+          </a:p>
+          <a:p>
+            <a:pPr>
+              <a:spcAft>
+                <a:spcPts val="600"/>
+              </a:spcAft>
+              <a:defRPr sz="2000" b="1">
+                <a:solidFill>
+                  <a:srgbClr val="0F172A"/>
+                </a:solidFill>
+                <a:latin typeface="Calibri"/>
+              </a:defRPr>
+            </a:pPr>
+          </a:p>
+          <a:p>
+            <a:pPr>
+              <a:spcAft>
+                <a:spcPts val="600"/>
+              </a:spcAft>
+              <a:defRPr sz="2000" b="1">
+                <a:solidFill>
+                  <a:srgbClr val="0F172A"/>
+                </a:solidFill>
+                <a:latin typeface="Calibri"/>
+              </a:defRPr>
+            </a:pPr>
+          </a:p>
+          <a:p>
+            <a:pPr>
+              <a:spcAft>
+                <a:spcPts val="1400"/>
+              </a:spcAft>
+            </a:pPr>
+            <a:r>
+              <a:rPr sz="1800" b="1">
+                <a:solidFill>
+                  <a:srgbClr val="0F172A"/>
+                </a:solidFill>
+                <a:latin typeface="Calibri"/>
+              </a:rPr>
+              <a:t>• Binary Alert Precision: </a:t>
             </a:r>
             <a:r>
               <a:rPr sz="1800" b="0">
@@ -6233,23 +6288,23 @@
                 </a:solidFill>
                 <a:latin typeface="Calibri"/>
               </a:rPr>
-              <a:t>Achieved low cross-entropy loss of 0.0459 during test set evaluation</a:t>
-            </a:r>
-          </a:p>
-          <a:p>
-            <a:pPr>
-              <a:spcAft>
-                <a:spcPts val="600"/>
-              </a:spcAft>
-              <a:defRPr sz="2000" b="1">
-                <a:solidFill>
-                  <a:srgbClr val="0F172A"/>
-                </a:solidFill>
-                <a:latin typeface="Calibri"/>
-              </a:defRPr>
-            </a:pPr>
-            <a:r>
-              <a:t>• Macro Average F1-Score: </a:t>
+              <a:t>Achieved 94.44% Precision on positive failure window warnings.</a:t>
+            </a:r>
+          </a:p>
+          <a:p>
+            <a:pPr>
+              <a:spcAft>
+                <a:spcPts val="1400"/>
+              </a:spcAft>
+            </a:pPr>
+            <a:r>
+              <a:rPr sz="1800" b="1">
+                <a:solidFill>
+                  <a:srgbClr val="0F172A"/>
+                </a:solidFill>
+                <a:latin typeface="Calibri"/>
+              </a:rPr>
+              <a:t>• RUL Regression RMSE: </a:t>
             </a:r>
             <a:r>
               <a:rPr sz="1800" b="0">
@@ -6258,23 +6313,23 @@
                 </a:solidFill>
                 <a:latin typeface="Calibri"/>
               </a:rPr>
-              <a:t>Macro F1-Score of 0.99 demonstrating balanced per-class model accuracy</a:t>
-            </a:r>
-          </a:p>
-          <a:p>
-            <a:pPr>
-              <a:spcAft>
-                <a:spcPts val="600"/>
-              </a:spcAft>
-              <a:defRPr sz="2000" b="1">
-                <a:solidFill>
-                  <a:srgbClr val="0F172A"/>
-                </a:solidFill>
-                <a:latin typeface="Calibri"/>
-              </a:defRPr>
-            </a:pPr>
-            <a:r>
-              <a:t>• Weighted Average F1-Score: </a:t>
+              <a:t>Achieved 33.39 cycles Root Mean Squared Error (MAE: 22.90 cycles).</a:t>
+            </a:r>
+          </a:p>
+          <a:p>
+            <a:pPr>
+              <a:spcAft>
+                <a:spcPts val="1400"/>
+              </a:spcAft>
+            </a:pPr>
+            <a:r>
+              <a:rPr sz="1800" b="1">
+                <a:solidFill>
+                  <a:srgbClr val="0F172A"/>
+                </a:solidFill>
+                <a:latin typeface="Calibri"/>
+              </a:rPr>
+              <a:t>• Multi-Class Neural MLP Accuracy: </a:t>
             </a:r>
             <a:r>
               <a:rPr sz="1800" b="0">
@@ -6283,80 +6338,7 @@
                 </a:solidFill>
                 <a:latin typeface="Calibri"/>
               </a:rPr>
-              <a:t>Weighted F1-Score of 0.99 confirming strong generalizability across all gesture classes</a:t>
-            </a:r>
-          </a:p>
-          <a:p>
-            <a:pPr>
-              <a:spcAft>
-                <a:spcPts val="600"/>
-              </a:spcAft>
-              <a:defRPr sz="2000" b="1">
-                <a:solidFill>
-                  <a:srgbClr val="0F172A"/>
-                </a:solidFill>
-                <a:latin typeface="Calibri"/>
-              </a:defRPr>
-            </a:pPr>
-            <a:r>
-              <a:t>• Inference Latency: </a:t>
-            </a:r>
-            <a:r>
-              <a:rPr sz="1800" b="0">
-                <a:solidFill>
-                  <a:srgbClr val="334155"/>
-                </a:solidFill>
-                <a:latin typeface="Calibri"/>
-              </a:rPr>
-              <a:t>Average frame processing time under 30ms, operating smoothly at 15+ FPS</a:t>
-            </a:r>
-          </a:p>
-          <a:p>
-            <a:pPr>
-              <a:spcAft>
-                <a:spcPts val="1400"/>
-              </a:spcAft>
-              <a:defRPr sz="2000" b="1">
-                <a:solidFill>
-                  <a:srgbClr val="334155"/>
-                </a:solidFill>
-                <a:latin typeface="Calibri"/>
-              </a:defRPr>
-            </a:pPr>
-            <a:r>
-              <a:t>• Binary Alert Precision: Achieved 94.44% Precision on positive failure window warnings.</a:t>
-            </a:r>
-          </a:p>
-          <a:p>
-            <a:pPr>
-              <a:spcAft>
-                <a:spcPts val="1400"/>
-              </a:spcAft>
-              <a:defRPr sz="2000" b="1">
-                <a:solidFill>
-                  <a:srgbClr val="334155"/>
-                </a:solidFill>
-                <a:latin typeface="Calibri"/>
-              </a:defRPr>
-            </a:pPr>
-            <a:r>
-              <a:t>• RUL Regression RMSE: Achieved 33.39 cycles Root Mean Squared Error (MAE: 22.90 cycles).</a:t>
-            </a:r>
-          </a:p>
-          <a:p>
-            <a:pPr>
-              <a:spcAft>
-                <a:spcPts val="1400"/>
-              </a:spcAft>
-              <a:defRPr sz="2000" b="1">
-                <a:solidFill>
-                  <a:srgbClr val="334155"/>
-                </a:solidFill>
-                <a:latin typeface="Calibri"/>
-              </a:defRPr>
-            </a:pPr>
-            <a:r>
-              <a:t>• Multi-Class Neural MLP Accuracy: Achieved 75.00% exact multi-class categorization accuracy.</a:t>
+              <a:t>Achieved 75.00% exact multi-class categorization accuracy.</a:t>
             </a:r>
           </a:p>
         </p:txBody>
@@ -6402,15 +6384,15 @@
           <a:lstStyle/>
           <a:p>
             <a:pPr>
-              <a:defRPr sz="3200" b="1">
-                <a:solidFill>
-                  <a:srgbClr val="0F172A"/>
-                </a:solidFill>
-                <a:latin typeface="Calibri"/>
-              </a:defRPr>
-            </a:pPr>
-            <a:r>
-              <a:t>Per-Class Evaluation Methodology Table</a:t>
+              <a:defRPr sz="1500" b="1">
+                <a:solidFill>
+                  <a:srgbClr val="334155"/>
+                </a:solidFill>
+                <a:latin typeface="Calibri"/>
+              </a:defRPr>
+            </a:pPr>
+            <a:r>
+              <a:t>Table 1: Per-Class Precision, Recall, F1-Score, and Support Sample Counts</a:t>
             </a:r>
           </a:p>
         </p:txBody>
@@ -6440,7 +6422,7 @@
             <a:pPr algn="r">
               <a:defRPr sz="1400">
                 <a:solidFill>
-                  <a:srgbClr val="334155"/>
+                  <a:srgbClr val="64748B"/>
                 </a:solidFill>
                 <a:latin typeface="Calibri"/>
               </a:defRPr>
@@ -8220,13 +8202,28 @@
               </a:spcAft>
               <a:defRPr sz="2000" b="1">
                 <a:solidFill>
+                  <a:srgbClr val="0F172A"/>
+                </a:solidFill>
+                <a:latin typeface="Calibri"/>
+              </a:defRPr>
+            </a:pPr>
+            <a:r>
+              <a:rPr sz="1800" b="1">
+                <a:solidFill>
+                  <a:srgbClr val="0F172A"/>
+                </a:solidFill>
+                <a:latin typeface="Calibri"/>
+              </a:rPr>
+              <a:t>• Feature Engineering Impact: </a:t>
+            </a:r>
+            <a:r>
+              <a:rPr sz="1800" b="0">
+                <a:solidFill>
                   <a:srgbClr val="334155"/>
                 </a:solidFill>
                 <a:latin typeface="Calibri"/>
-              </a:defRPr>
-            </a:pPr>
-            <a:r>
-              <a:t>• Feature Engineering Impact: 5-cycle rolling statistics (av, sd) significantly outperform raw sensors.</a:t>
+              </a:rPr>
+              <a:t>5-cycle rolling statistics (av, sd) significantly outperform raw sensors.</a:t>
             </a:r>
           </a:p>
           <a:p>
@@ -8241,8 +8238,60 @@
                 <a:latin typeface="Calibri"/>
               </a:defRPr>
             </a:pPr>
-            <a:r>
-              <a:t>• Minor Gesture Overlap: </a:t>
+          </a:p>
+          <a:p>
+            <a:pPr>
+              <a:spcAft>
+                <a:spcPts val="600"/>
+              </a:spcAft>
+              <a:defRPr sz="2000" b="1">
+                <a:solidFill>
+                  <a:srgbClr val="0F172A"/>
+                </a:solidFill>
+                <a:latin typeface="Calibri"/>
+              </a:defRPr>
+            </a:pPr>
+          </a:p>
+          <a:p>
+            <a:pPr>
+              <a:spcAft>
+                <a:spcPts val="600"/>
+              </a:spcAft>
+              <a:defRPr sz="2000" b="1">
+                <a:solidFill>
+                  <a:srgbClr val="0F172A"/>
+                </a:solidFill>
+                <a:latin typeface="Calibri"/>
+              </a:defRPr>
+            </a:pPr>
+          </a:p>
+          <a:p>
+            <a:pPr>
+              <a:spcAft>
+                <a:spcPts val="600"/>
+              </a:spcAft>
+              <a:defRPr sz="2000" b="1">
+                <a:solidFill>
+                  <a:srgbClr val="0F172A"/>
+                </a:solidFill>
+                <a:latin typeface="Calibri"/>
+              </a:defRPr>
+            </a:pPr>
+          </a:p>
+          <a:p>
+            <a:pPr>
+              <a:spcAft>
+                <a:spcPts val="1400"/>
+              </a:spcAft>
+            </a:pPr>
+            <a:r>
+              <a:rPr sz="1800" b="1">
+                <a:solidFill>
+                  <a:srgbClr val="0F172A"/>
+                </a:solidFill>
+                <a:latin typeface="Calibri"/>
+              </a:rPr>
+              <a:t>• Optimal Thresholding: </a:t>
             </a:r>
             <a:r>
               <a:rPr sz="1800" b="0">
@@ -8251,23 +8300,23 @@
                 </a:solidFill>
                 <a:latin typeface="Calibri"/>
               </a:rPr>
-              <a:t>Slight overlap observed between 'Country' (0.96 F1) and 'Time' (0.95 F1) due to similar arm positions</a:t>
-            </a:r>
-          </a:p>
-          <a:p>
-            <a:pPr>
-              <a:spcAft>
-                <a:spcPts val="600"/>
-              </a:spcAft>
-              <a:defRPr sz="2000" b="1">
-                <a:solidFill>
-                  <a:srgbClr val="0F172A"/>
-                </a:solidFill>
-                <a:latin typeface="Calibri"/>
-              </a:defRPr>
-            </a:pPr>
-            <a:r>
-              <a:t>• Signer Position Independence: </a:t>
+              <a:t>Operating Random Forest at tau = 0.17 yields 100% precision &amp; 68% recall.</a:t>
+            </a:r>
+          </a:p>
+          <a:p>
+            <a:pPr>
+              <a:spcAft>
+                <a:spcPts val="1400"/>
+              </a:spcAft>
+            </a:pPr>
+            <a:r>
+              <a:rPr sz="1800" b="1">
+                <a:solidFill>
+                  <a:srgbClr val="0F172A"/>
+                </a:solidFill>
+                <a:latin typeface="Calibri"/>
+              </a:rPr>
+              <a:t>• Cost Matrix Minimization: </a:t>
             </a:r>
             <a:r>
               <a:rPr sz="1800" b="0">
@@ -8276,23 +8325,23 @@
                 </a:solidFill>
                 <a:latin typeface="Calibri"/>
               </a:rPr>
-              <a:t>Keypoint spatial normalization successfully eliminated distance &amp; clothing variations</a:t>
-            </a:r>
-          </a:p>
-          <a:p>
-            <a:pPr>
-              <a:spcAft>
-                <a:spcPts val="600"/>
-              </a:spcAft>
-              <a:defRPr sz="2000" b="1">
-                <a:solidFill>
-                  <a:srgbClr val="0F172A"/>
-                </a:solidFill>
-                <a:latin typeface="Calibri"/>
-              </a:defRPr>
-            </a:pPr>
-            <a:r>
-              <a:t>• Resting State Stability: </a:t>
+              <a:t>Prevents $250,000+ catastrophic in-flight failures via planned $15,000 repairs.</a:t>
+            </a:r>
+          </a:p>
+          <a:p>
+            <a:pPr>
+              <a:spcAft>
+                <a:spcPts val="1400"/>
+              </a:spcAft>
+            </a:pPr>
+            <a:r>
+              <a:rPr sz="1800" b="1">
+                <a:solidFill>
+                  <a:srgbClr val="0F172A"/>
+                </a:solidFill>
+                <a:latin typeface="Calibri"/>
+              </a:rPr>
+              <a:t>• Neural Network Stability: </a:t>
             </a:r>
             <a:r>
               <a:rPr sz="1800" b="0">
@@ -8301,80 +8350,7 @@
                 </a:solidFill>
                 <a:latin typeface="Calibri"/>
               </a:rPr>
-              <a:t>Hand gating prevented false random predictions when signer arms were at rest</a:t>
-            </a:r>
-          </a:p>
-          <a:p>
-            <a:pPr>
-              <a:spcAft>
-                <a:spcPts val="600"/>
-              </a:spcAft>
-              <a:defRPr sz="2000" b="1">
-                <a:solidFill>
-                  <a:srgbClr val="0F172A"/>
-                </a:solidFill>
-                <a:latin typeface="Calibri"/>
-              </a:defRPr>
-            </a:pPr>
-            <a:r>
-              <a:t>• Audio Responsiveness: </a:t>
-            </a:r>
-            <a:r>
-              <a:rPr sz="1800" b="0">
-                <a:solidFill>
-                  <a:srgbClr val="334155"/>
-                </a:solidFill>
-                <a:latin typeface="Calibri"/>
-              </a:rPr>
-              <a:t>Text-to-speech audio feedback triggered smoothly within ~0.4s of gesture completion</a:t>
-            </a:r>
-          </a:p>
-          <a:p>
-            <a:pPr>
-              <a:spcAft>
-                <a:spcPts val="1400"/>
-              </a:spcAft>
-              <a:defRPr sz="2000" b="1">
-                <a:solidFill>
-                  <a:srgbClr val="334155"/>
-                </a:solidFill>
-                <a:latin typeface="Calibri"/>
-              </a:defRPr>
-            </a:pPr>
-            <a:r>
-              <a:t>• Optimal Thresholding: Operating Random Forest at tau = 0.17 yields 100% precision &amp; 68% recall.</a:t>
-            </a:r>
-          </a:p>
-          <a:p>
-            <a:pPr>
-              <a:spcAft>
-                <a:spcPts val="1400"/>
-              </a:spcAft>
-              <a:defRPr sz="2000" b="1">
-                <a:solidFill>
-                  <a:srgbClr val="334155"/>
-                </a:solidFill>
-                <a:latin typeface="Calibri"/>
-              </a:defRPr>
-            </a:pPr>
-            <a:r>
-              <a:t>• Cost Matrix Minimization: Prevents $250,000+ catastrophic in-flight failures via planned $15,000 repairs.</a:t>
-            </a:r>
-          </a:p>
-          <a:p>
-            <a:pPr>
-              <a:spcAft>
-                <a:spcPts val="1400"/>
-              </a:spcAft>
-              <a:defRPr sz="2000" b="1">
-                <a:solidFill>
-                  <a:srgbClr val="334155"/>
-                </a:solidFill>
-                <a:latin typeface="Calibri"/>
-              </a:defRPr>
-            </a:pPr>
-            <a:r>
-              <a:t>• Neural Network Stability: Multi-layer Perceptron provides high accuracy on critical hazard windows.</a:t>
+              <a:t>Multi-layer Perceptron provides high accuracy on critical hazard windows.</a:t>
             </a:r>
           </a:p>
         </p:txBody>
@@ -8497,13 +8473,28 @@
               </a:spcAft>
               <a:defRPr sz="2000" b="1">
                 <a:solidFill>
+                  <a:srgbClr val="0F172A"/>
+                </a:solidFill>
+                <a:latin typeface="Calibri"/>
+              </a:defRPr>
+            </a:pPr>
+            <a:r>
+              <a:rPr sz="1800" b="1">
+                <a:solidFill>
+                  <a:srgbClr val="0F172A"/>
+                </a:solidFill>
+                <a:latin typeface="Calibri"/>
+              </a:rPr>
+              <a:t>• Successful System Delivery: </a:t>
+            </a:r>
+            <a:r>
+              <a:rPr sz="1800" b="0">
+                <a:solidFill>
                   <a:srgbClr val="334155"/>
                 </a:solidFill>
                 <a:latin typeface="Calibri"/>
-              </a:defRPr>
-            </a:pPr>
-            <a:r>
-              <a:t>• Successful System Delivery: Built a complete predictive health management pipeline for jet engines.</a:t>
+              </a:rPr>
+              <a:t>Built a complete predictive health management pipeline for jet engines.</a:t>
             </a:r>
           </a:p>
           <a:p>
@@ -8518,8 +8509,60 @@
                 <a:latin typeface="Calibri"/>
               </a:defRPr>
             </a:pPr>
-            <a:r>
-              <a:t>• High Model Performance: </a:t>
+          </a:p>
+          <a:p>
+            <a:pPr>
+              <a:spcAft>
+                <a:spcPts val="600"/>
+              </a:spcAft>
+              <a:defRPr sz="2000" b="1">
+                <a:solidFill>
+                  <a:srgbClr val="0F172A"/>
+                </a:solidFill>
+                <a:latin typeface="Calibri"/>
+              </a:defRPr>
+            </a:pPr>
+          </a:p>
+          <a:p>
+            <a:pPr>
+              <a:spcAft>
+                <a:spcPts val="600"/>
+              </a:spcAft>
+              <a:defRPr sz="2000" b="1">
+                <a:solidFill>
+                  <a:srgbClr val="0F172A"/>
+                </a:solidFill>
+                <a:latin typeface="Calibri"/>
+              </a:defRPr>
+            </a:pPr>
+          </a:p>
+          <a:p>
+            <a:pPr>
+              <a:spcAft>
+                <a:spcPts val="600"/>
+              </a:spcAft>
+              <a:defRPr sz="2000" b="1">
+                <a:solidFill>
+                  <a:srgbClr val="0F172A"/>
+                </a:solidFill>
+                <a:latin typeface="Calibri"/>
+              </a:defRPr>
+            </a:pPr>
+          </a:p>
+          <a:p>
+            <a:pPr>
+              <a:spcAft>
+                <a:spcPts val="1400"/>
+              </a:spcAft>
+            </a:pPr>
+            <a:r>
+              <a:rPr sz="1800" b="1">
+                <a:solidFill>
+                  <a:srgbClr val="0F172A"/>
+                </a:solidFill>
+                <a:latin typeface="Calibri"/>
+              </a:rPr>
+              <a:t>• High Predictive Performance: </a:t>
             </a:r>
             <a:r>
               <a:rPr sz="1800" b="0">
@@ -8528,23 +8571,23 @@
                 </a:solidFill>
                 <a:latin typeface="Calibri"/>
               </a:rPr>
-              <a:t>Achieved 98.67% overall test accuracy utilizing MediaPipe keypoints &amp; LSTM architecture</a:t>
-            </a:r>
-          </a:p>
-          <a:p>
-            <a:pPr>
-              <a:spcAft>
-                <a:spcPts val="600"/>
-              </a:spcAft>
-              <a:defRPr sz="2000" b="1">
-                <a:solidFill>
-                  <a:srgbClr val="0F172A"/>
-                </a:solidFill>
-                <a:latin typeface="Calibri"/>
-              </a:defRPr>
-            </a:pPr>
-            <a:r>
-              <a:t>• Sign-to-Speech Integration: </a:t>
+              <a:t>Achieved 98.45% AUC-ROC failure detection and 33.39 cycles RUL RMSE.</a:t>
+            </a:r>
+          </a:p>
+          <a:p>
+            <a:pPr>
+              <a:spcAft>
+                <a:spcPts val="1400"/>
+              </a:spcAft>
+            </a:pPr>
+            <a:r>
+              <a:rPr sz="1800" b="1">
+                <a:solidFill>
+                  <a:srgbClr val="0F172A"/>
+                </a:solidFill>
+                <a:latin typeface="Calibri"/>
+              </a:rPr>
+              <a:t>• CLI Diagnostic Tool: </a:t>
             </a:r>
             <a:r>
               <a:rPr sz="1800" b="0">
@@ -8553,23 +8596,23 @@
                 </a:solidFill>
                 <a:latin typeface="Calibri"/>
               </a:rPr>
-              <a:t>Successfully integrated live text display and Pyttsx3 speech audio output for accessibility</a:t>
-            </a:r>
-          </a:p>
-          <a:p>
-            <a:pPr>
-              <a:spcAft>
-                <a:spcPts val="600"/>
-              </a:spcAft>
-              <a:defRPr sz="2000" b="1">
-                <a:solidFill>
-                  <a:srgbClr val="0F172A"/>
-                </a:solidFill>
-                <a:latin typeface="Calibri"/>
-              </a:defRPr>
-            </a:pPr>
-            <a:r>
-              <a:t>• Native Desktop Application: </a:t>
+              <a:t>Delivered interactive predict.py tool for real-time fleet health diagnostic reports.</a:t>
+            </a:r>
+          </a:p>
+          <a:p>
+            <a:pPr>
+              <a:spcAft>
+                <a:spcPts val="1400"/>
+              </a:spcAft>
+            </a:pPr>
+            <a:r>
+              <a:rPr sz="1800" b="1">
+                <a:solidFill>
+                  <a:srgbClr val="0F172A"/>
+                </a:solidFill>
+                <a:latin typeface="Calibri"/>
+              </a:rPr>
+              <a:t>• Fleet Cost Minimization: </a:t>
             </a:r>
             <a:r>
               <a:rPr sz="1800" b="0">
@@ -8578,80 +8621,7 @@
                 </a:solidFill>
                 <a:latin typeface="Calibri"/>
               </a:rPr>
-              <a:t>Developed a 100% native Python Tkinter GUI featuring Live View, Recording, &amp; Gallery tabs</a:t>
-            </a:r>
-          </a:p>
-          <a:p>
-            <a:pPr>
-              <a:spcAft>
-                <a:spcPts val="600"/>
-              </a:spcAft>
-              <a:defRPr sz="2000" b="1">
-                <a:solidFill>
-                  <a:srgbClr val="0F172A"/>
-                </a:solidFill>
-                <a:latin typeface="Calibri"/>
-              </a:defRPr>
-            </a:pPr>
-            <a:r>
-              <a:t>• Real-World Practicality: </a:t>
-            </a:r>
-            <a:r>
-              <a:rPr sz="1800" b="0">
-                <a:solidFill>
-                  <a:srgbClr val="334155"/>
-                </a:solidFill>
-                <a:latin typeface="Calibri"/>
-              </a:rPr>
-              <a:t>Provides an effective, low-latency communication tool for deaf &amp; hard-of-hearing assistance</a:t>
-            </a:r>
-          </a:p>
-          <a:p>
-            <a:pPr>
-              <a:spcAft>
-                <a:spcPts val="1400"/>
-              </a:spcAft>
-              <a:defRPr sz="2000" b="1">
-                <a:solidFill>
-                  <a:srgbClr val="334155"/>
-                </a:solidFill>
-                <a:latin typeface="Calibri"/>
-              </a:defRPr>
-            </a:pPr>
-            <a:r>
-              <a:t>• High Predictive Performance: Achieved 98.45% AUC-ROC failure detection and 33.39 cycles RUL RMSE.</a:t>
-            </a:r>
-          </a:p>
-          <a:p>
-            <a:pPr>
-              <a:spcAft>
-                <a:spcPts val="1400"/>
-              </a:spcAft>
-              <a:defRPr sz="2000" b="1">
-                <a:solidFill>
-                  <a:srgbClr val="334155"/>
-                </a:solidFill>
-                <a:latin typeface="Calibri"/>
-              </a:defRPr>
-            </a:pPr>
-            <a:r>
-              <a:t>• CLI Diagnostic Tool: Delivered interactive predict.py tool for real-time fleet health diagnostic reports.</a:t>
-            </a:r>
-          </a:p>
-          <a:p>
-            <a:pPr>
-              <a:spcAft>
-                <a:spcPts val="1400"/>
-              </a:spcAft>
-              <a:defRPr sz="2000" b="1">
-                <a:solidFill>
-                  <a:srgbClr val="334155"/>
-                </a:solidFill>
-                <a:latin typeface="Calibri"/>
-              </a:defRPr>
-            </a:pPr>
-            <a:r>
-              <a:t>• Fleet Cost Minimization: Optimizes maintenance capacity allocation and eliminates flight delays.</a:t>
+              <a:t>Optimizes maintenance capacity allocation and eliminates flight delays.</a:t>
             </a:r>
           </a:p>
         </p:txBody>
@@ -8774,13 +8744,28 @@
               </a:spcAft>
               <a:defRPr sz="2000" b="1">
                 <a:solidFill>
+                  <a:srgbClr val="0F172A"/>
+                </a:solidFill>
+                <a:latin typeface="Calibri"/>
+              </a:defRPr>
+            </a:pPr>
+            <a:r>
+              <a:rPr sz="1800" b="1">
+                <a:solidFill>
+                  <a:srgbClr val="0F172A"/>
+                </a:solidFill>
+                <a:latin typeface="Calibri"/>
+              </a:rPr>
+              <a:t>• Deep Time-Series Architecture: </a:t>
+            </a:r>
+            <a:r>
+              <a:rPr sz="1800" b="0">
+                <a:solidFill>
                   <a:srgbClr val="334155"/>
                 </a:solidFill>
                 <a:latin typeface="Calibri"/>
-              </a:defRPr>
-            </a:pPr>
-            <a:r>
-              <a:t>• Deep Time-Series Architecture: Integrate Recurrent LSTM and Transformer networks for temporal dynamics.</a:t>
+              </a:rPr>
+              <a:t>Integrate Recurrent LSTM and Transformer networks for temporal dynamics.</a:t>
             </a:r>
           </a:p>
           <a:p>
@@ -8795,8 +8780,60 @@
                 <a:latin typeface="Calibri"/>
               </a:defRPr>
             </a:pPr>
-            <a:r>
-              <a:t>• Sentence-Level Translation: </a:t>
+          </a:p>
+          <a:p>
+            <a:pPr>
+              <a:spcAft>
+                <a:spcPts val="600"/>
+              </a:spcAft>
+              <a:defRPr sz="2000" b="1">
+                <a:solidFill>
+                  <a:srgbClr val="0F172A"/>
+                </a:solidFill>
+                <a:latin typeface="Calibri"/>
+              </a:defRPr>
+            </a:pPr>
+          </a:p>
+          <a:p>
+            <a:pPr>
+              <a:spcAft>
+                <a:spcPts val="600"/>
+              </a:spcAft>
+              <a:defRPr sz="2000" b="1">
+                <a:solidFill>
+                  <a:srgbClr val="0F172A"/>
+                </a:solidFill>
+                <a:latin typeface="Calibri"/>
+              </a:defRPr>
+            </a:pPr>
+          </a:p>
+          <a:p>
+            <a:pPr>
+              <a:spcAft>
+                <a:spcPts val="600"/>
+              </a:spcAft>
+              <a:defRPr sz="2000" b="1">
+                <a:solidFill>
+                  <a:srgbClr val="0F172A"/>
+                </a:solidFill>
+                <a:latin typeface="Calibri"/>
+              </a:defRPr>
+            </a:pPr>
+          </a:p>
+          <a:p>
+            <a:pPr>
+              <a:spcAft>
+                <a:spcPts val="1400"/>
+              </a:spcAft>
+            </a:pPr>
+            <a:r>
+              <a:rPr sz="1800" b="1">
+                <a:solidFill>
+                  <a:srgbClr val="0F172A"/>
+                </a:solidFill>
+                <a:latin typeface="Calibri"/>
+              </a:rPr>
+              <a:t>• Cloud Streaming Integration: </a:t>
             </a:r>
             <a:r>
               <a:rPr sz="1800" b="0">
@@ -8805,23 +8842,23 @@
                 </a:solidFill>
                 <a:latin typeface="Calibri"/>
               </a:rPr>
-              <a:t>Extend from word-level gestures to full continuous sentence translation using Transformer models</a:t>
-            </a:r>
-          </a:p>
-          <a:p>
-            <a:pPr>
-              <a:spcAft>
-                <a:spcPts val="600"/>
-              </a:spcAft>
-              <a:defRPr sz="2000" b="1">
-                <a:solidFill>
-                  <a:srgbClr val="0F172A"/>
-                </a:solidFill>
-                <a:latin typeface="Calibri"/>
-              </a:defRPr>
-            </a:pPr>
-            <a:r>
-              <a:t>• Mobile &amp; Edge Deployment: </a:t>
+              <a:t>Deploy REST API endpoints for real-time IoT stream data ingestion.</a:t>
+            </a:r>
+          </a:p>
+          <a:p>
+            <a:pPr>
+              <a:spcAft>
+                <a:spcPts val="1400"/>
+              </a:spcAft>
+            </a:pPr>
+            <a:r>
+              <a:rPr sz="1800" b="1">
+                <a:solidFill>
+                  <a:srgbClr val="0F172A"/>
+                </a:solidFill>
+                <a:latin typeface="Calibri"/>
+              </a:rPr>
+              <a:t>• Multi-Mode Flight Profiles: </a:t>
             </a:r>
             <a:r>
               <a:rPr sz="1800" b="0">
@@ -8830,23 +8867,23 @@
                 </a:solidFill>
                 <a:latin typeface="Calibri"/>
               </a:rPr>
-              <a:t>Export model to TensorFlow Lite (TFLite) for deployment on mobile devices &amp; Raspberry Pi</a:t>
-            </a:r>
-          </a:p>
-          <a:p>
-            <a:pPr>
-              <a:spcAft>
-                <a:spcPts val="600"/>
-              </a:spcAft>
-              <a:defRPr sz="2000" b="1">
-                <a:solidFill>
-                  <a:srgbClr val="0F172A"/>
-                </a:solidFill>
-                <a:latin typeface="Calibri"/>
-              </a:defRPr>
-            </a:pPr>
-            <a:r>
-              <a:t>• Multi-Language Speech Output: </a:t>
+              <a:t>Expand fleet training dataset to variable altitude and speed profiles.</a:t>
+            </a:r>
+          </a:p>
+          <a:p>
+            <a:pPr>
+              <a:spcAft>
+                <a:spcPts val="1400"/>
+              </a:spcAft>
+            </a:pPr>
+            <a:r>
+              <a:rPr sz="1800" b="1">
+                <a:solidFill>
+                  <a:srgbClr val="0F172A"/>
+                </a:solidFill>
+                <a:latin typeface="Calibri"/>
+              </a:rPr>
+              <a:t>• Edge Device Deployment: </a:t>
             </a:r>
             <a:r>
               <a:rPr sz="1800" b="0">
@@ -8855,80 +8892,7 @@
                 </a:solidFill>
                 <a:latin typeface="Calibri"/>
               </a:rPr>
-              <a:t>Add multi-language TTS translation options (e.g. Hindi, Spanish, French audio output)</a:t>
-            </a:r>
-          </a:p>
-          <a:p>
-            <a:pPr>
-              <a:spcAft>
-                <a:spcPts val="600"/>
-              </a:spcAft>
-              <a:defRPr sz="2000" b="1">
-                <a:solidFill>
-                  <a:srgbClr val="0F172A"/>
-                </a:solidFill>
-                <a:latin typeface="Calibri"/>
-              </a:defRPr>
-            </a:pPr>
-            <a:r>
-              <a:t>• Dataset Mirror Augmentation: </a:t>
-            </a:r>
-            <a:r>
-              <a:rPr sz="1800" b="0">
-                <a:solidFill>
-                  <a:srgbClr val="334155"/>
-                </a:solidFill>
-                <a:latin typeface="Calibri"/>
-              </a:rPr>
-              <a:t>Incorporate mirror data augmentation for left/right hand signer generalizability</a:t>
-            </a:r>
-          </a:p>
-          <a:p>
-            <a:pPr>
-              <a:spcAft>
-                <a:spcPts val="1400"/>
-              </a:spcAft>
-              <a:defRPr sz="2000" b="1">
-                <a:solidFill>
-                  <a:srgbClr val="334155"/>
-                </a:solidFill>
-                <a:latin typeface="Calibri"/>
-              </a:defRPr>
-            </a:pPr>
-            <a:r>
-              <a:t>• Cloud Streaming Integration: Deploy REST API endpoints for real-time IoT stream data ingestion.</a:t>
-            </a:r>
-          </a:p>
-          <a:p>
-            <a:pPr>
-              <a:spcAft>
-                <a:spcPts val="1400"/>
-              </a:spcAft>
-              <a:defRPr sz="2000" b="1">
-                <a:solidFill>
-                  <a:srgbClr val="334155"/>
-                </a:solidFill>
-                <a:latin typeface="Calibri"/>
-              </a:defRPr>
-            </a:pPr>
-            <a:r>
-              <a:t>• Multi-Mode Flight Profiles: Expand fleet training dataset to variable altitude and speed profiles.</a:t>
-            </a:r>
-          </a:p>
-          <a:p>
-            <a:pPr>
-              <a:spcAft>
-                <a:spcPts val="1400"/>
-              </a:spcAft>
-              <a:defRPr sz="2000" b="1">
-                <a:solidFill>
-                  <a:srgbClr val="334155"/>
-                </a:solidFill>
-                <a:latin typeface="Calibri"/>
-              </a:defRPr>
-            </a:pPr>
-            <a:r>
-              <a:t>• Edge Device Deployment: Optimize model execution for lightweight onboard avionics hardware.</a:t>
+              <a:t>Optimize model execution for lightweight onboard avionics hardware.</a:t>
             </a:r>
           </a:p>
         </p:txBody>
@@ -9049,7 +9013,7 @@
               <a:spcAft>
                 <a:spcPts val="1400"/>
               </a:spcAft>
-              <a:defRPr sz="2000" b="1">
+              <a:defRPr sz="2000" b="0">
                 <a:solidFill>
                   <a:srgbClr val="334155"/>
                 </a:solidFill>
@@ -9057,7 +9021,22 @@
               </a:defRPr>
             </a:pPr>
             <a:r>
-              <a:t>• 1. NASA Ames Prognostics Center of Excellence - C-MAPSS Jet Engine Degradation Dataset.</a:t>
+              <a:rPr sz="1800" b="1">
+                <a:solidFill>
+                  <a:srgbClr val="0F172A"/>
+                </a:solidFill>
+                <a:latin typeface="Calibri"/>
+              </a:rPr>
+              <a:t>• 1. NASA Ames Prognostics Center of Excellence - </a:t>
+            </a:r>
+            <a:r>
+              <a:rPr sz="1800" b="0">
+                <a:solidFill>
+                  <a:srgbClr val="334155"/>
+                </a:solidFill>
+                <a:latin typeface="Calibri"/>
+              </a:rPr>
+              <a:t>C-MAPSS Jet Engine Degradation Dataset.</a:t>
             </a:r>
           </a:p>
           <a:p>
@@ -9072,9 +9051,6 @@
                 <a:latin typeface="Calibri"/>
               </a:defRPr>
             </a:pPr>
-            <a:r>
-              <a:t>• 2. Hochreiter, S., &amp; Schmidhuber, J., 'Long Short-Term Memory', Neural Computation, 9(8), 1735-1780, 1997.</a:t>
-            </a:r>
           </a:p>
           <a:p>
             <a:pPr>
@@ -9088,9 +9064,6 @@
                 <a:latin typeface="Calibri"/>
               </a:defRPr>
             </a:pPr>
-            <a:r>
-              <a:t>• 3. Li, D., et al., 'Word-Level Deep Sign Language Recognition', IEEE/CVF Conference on Computer Vision (CVPR), 2020.</a:t>
-            </a:r>
           </a:p>
           <a:p>
             <a:pPr>
@@ -9104,9 +9077,6 @@
                 <a:latin typeface="Calibri"/>
               </a:defRPr>
             </a:pPr>
-            <a:r>
-              <a:t>• 4. Metehan Ozdeniz, 'Sign Language Recognition Dataset &amp; Benchmark', Kaggle Dataset Repository, 2024.</a:t>
-            </a:r>
           </a:p>
           <a:p>
             <a:pPr>
@@ -9120,9 +9090,6 @@
                 <a:latin typeface="Calibri"/>
               </a:defRPr>
             </a:pPr>
-            <a:r>
-              <a:t>• 5. Google Keras 3.3 &amp; TensorFlow 2.17 Official Documentation and API Reference, 2026.</a:t>
-            </a:r>
           </a:p>
           <a:p>
             <a:pPr>
@@ -9136,24 +9103,30 @@
                 <a:latin typeface="Calibri"/>
               </a:defRPr>
             </a:pPr>
-            <a:r>
-              <a:t>• 6. OpenCV Open Source Computer Vision Library Documentation, 2026.</a:t>
-            </a:r>
           </a:p>
           <a:p>
             <a:pPr>
               <a:spcAft>
                 <a:spcPts val="1400"/>
               </a:spcAft>
-              <a:defRPr sz="2000" b="1">
+            </a:pPr>
+            <a:r>
+              <a:rPr sz="1800" b="1">
+                <a:solidFill>
+                  <a:srgbClr val="0F172A"/>
+                </a:solidFill>
+                <a:latin typeface="Calibri"/>
+              </a:rPr>
+              <a:t>• 2. Saxena, A., et al., </a:t>
+            </a:r>
+            <a:r>
+              <a:rPr sz="1800" b="0">
                 <a:solidFill>
                   <a:srgbClr val="334155"/>
                 </a:solidFill>
                 <a:latin typeface="Calibri"/>
-              </a:defRPr>
-            </a:pPr>
-            <a:r>
-              <a:t>• 2. Saxena, A., et al., 'Damage Propagation Modeling for Aircraft Engine Simulation', IEEE 2008.</a:t>
+              </a:rPr>
+              <a:t>'Damage Propagation Modeling for Aircraft Engine Simulation', IEEE 2008.</a:t>
             </a:r>
           </a:p>
           <a:p>
@@ -9161,15 +9134,24 @@
               <a:spcAft>
                 <a:spcPts val="1400"/>
               </a:spcAft>
-              <a:defRPr sz="2000" b="1">
+            </a:pPr>
+            <a:r>
+              <a:rPr sz="1800" b="1">
+                <a:solidFill>
+                  <a:srgbClr val="0F172A"/>
+                </a:solidFill>
+                <a:latin typeface="Calibri"/>
+              </a:rPr>
+              <a:t>• 3. Springboard Data Science Career Track - </a:t>
+            </a:r>
+            <a:r>
+              <a:rPr sz="1800" b="0">
                 <a:solidFill>
                   <a:srgbClr val="334155"/>
                 </a:solidFill>
                 <a:latin typeface="Calibri"/>
-              </a:defRPr>
-            </a:pPr>
-            <a:r>
-              <a:t>• 3. Springboard Data Science Career Track Bootcamp Curriculum &amp; Mentorship.</a:t>
+              </a:rPr>
+              <a:t>Bootcamp Curriculum &amp; Mentorship.</a:t>
             </a:r>
           </a:p>
           <a:p>
@@ -9177,15 +9159,24 @@
               <a:spcAft>
                 <a:spcPts val="1400"/>
               </a:spcAft>
-              <a:defRPr sz="2000" b="1">
+            </a:pPr>
+            <a:r>
+              <a:rPr sz="1800" b="1">
+                <a:solidFill>
+                  <a:srgbClr val="0F172A"/>
+                </a:solidFill>
+                <a:latin typeface="Calibri"/>
+              </a:rPr>
+              <a:t>• 4. Scikit-Learn Open Source Library - </a:t>
+            </a:r>
+            <a:r>
+              <a:rPr sz="1800" b="0">
                 <a:solidFill>
                   <a:srgbClr val="334155"/>
                 </a:solidFill>
                 <a:latin typeface="Calibri"/>
-              </a:defRPr>
-            </a:pPr>
-            <a:r>
-              <a:t>• 4. Scikit-Learn Open Source Machine Learning &amp; Neural Network Library Documentation.</a:t>
+              </a:rPr>
+              <a:t>Machine Learning &amp; Neural Network Documentation.</a:t>
             </a:r>
           </a:p>
           <a:p>
@@ -9193,15 +9184,24 @@
               <a:spcAft>
                 <a:spcPts val="1400"/>
               </a:spcAft>
-              <a:defRPr sz="2000" b="1">
+            </a:pPr>
+            <a:r>
+              <a:rPr sz="1800" b="1">
+                <a:solidFill>
+                  <a:srgbClr val="0F172A"/>
+                </a:solidFill>
+                <a:latin typeface="Calibri"/>
+              </a:rPr>
+              <a:t>• 5. Microsoft Azure Machine Learning - </a:t>
+            </a:r>
+            <a:r>
+              <a:rPr sz="1800" b="0">
                 <a:solidFill>
                   <a:srgbClr val="334155"/>
                 </a:solidFill>
                 <a:latin typeface="Calibri"/>
-              </a:defRPr>
-            </a:pPr>
-            <a:r>
-              <a:t>• 5. Microsoft Azure Machine Learning Predictive Maintenance Simulation Templates.</a:t>
+              </a:rPr>
+              <a:t>Predictive Maintenance Simulation Templates.</a:t>
             </a:r>
           </a:p>
         </p:txBody>
@@ -9404,13 +9404,28 @@
               </a:spcAft>
               <a:defRPr sz="2000" b="1">
                 <a:solidFill>
+                  <a:srgbClr val="0F172A"/>
+                </a:solidFill>
+                <a:latin typeface="Calibri"/>
+              </a:defRPr>
+            </a:pPr>
+            <a:r>
+              <a:rPr sz="1800" b="1">
+                <a:solidFill>
+                  <a:srgbClr val="0F172A"/>
+                </a:solidFill>
+                <a:latin typeface="Calibri"/>
+              </a:rPr>
+              <a:t>• 1. Introduction &amp; Objectives: </a:t>
+            </a:r>
+            <a:r>
+              <a:rPr sz="1800" b="0">
+                <a:solidFill>
                   <a:srgbClr val="334155"/>
                 </a:solidFill>
                 <a:latin typeface="Calibri"/>
-              </a:defRPr>
-            </a:pPr>
-            <a:r>
-              <a:t>• 1. Introduction &amp; Objectives: Industrial domain, PHM technology &amp; project goals.</a:t>
+              </a:rPr>
+              <a:t>Domain of work, industrial AI, aviation PHM technology &amp; project goals.</a:t>
             </a:r>
           </a:p>
           <a:p>
@@ -9425,8 +9440,125 @@
                 <a:latin typeface="Calibri"/>
               </a:defRPr>
             </a:pPr>
-            <a:r>
-              <a:t>• 2. Problem Statement: </a:t>
+          </a:p>
+          <a:p>
+            <a:pPr>
+              <a:spcAft>
+                <a:spcPts val="600"/>
+              </a:spcAft>
+              <a:defRPr sz="2000" b="1">
+                <a:solidFill>
+                  <a:srgbClr val="0F172A"/>
+                </a:solidFill>
+                <a:latin typeface="Calibri"/>
+              </a:defRPr>
+            </a:pPr>
+          </a:p>
+          <a:p>
+            <a:pPr>
+              <a:spcAft>
+                <a:spcPts val="600"/>
+              </a:spcAft>
+              <a:defRPr sz="2000" b="1">
+                <a:solidFill>
+                  <a:srgbClr val="0F172A"/>
+                </a:solidFill>
+                <a:latin typeface="Calibri"/>
+              </a:defRPr>
+            </a:pPr>
+          </a:p>
+          <a:p>
+            <a:pPr>
+              <a:spcAft>
+                <a:spcPts val="600"/>
+              </a:spcAft>
+              <a:defRPr sz="2000" b="1">
+                <a:solidFill>
+                  <a:srgbClr val="0F172A"/>
+                </a:solidFill>
+                <a:latin typeface="Calibri"/>
+              </a:defRPr>
+            </a:pPr>
+          </a:p>
+          <a:p>
+            <a:pPr>
+              <a:spcAft>
+                <a:spcPts val="600"/>
+              </a:spcAft>
+              <a:defRPr sz="2000" b="1">
+                <a:solidFill>
+                  <a:srgbClr val="0F172A"/>
+                </a:solidFill>
+                <a:latin typeface="Calibri"/>
+              </a:defRPr>
+            </a:pPr>
+          </a:p>
+          <a:p>
+            <a:pPr>
+              <a:spcAft>
+                <a:spcPts val="600"/>
+              </a:spcAft>
+              <a:defRPr sz="2000" b="1">
+                <a:solidFill>
+                  <a:srgbClr val="0F172A"/>
+                </a:solidFill>
+                <a:latin typeface="Calibri"/>
+              </a:defRPr>
+            </a:pPr>
+          </a:p>
+          <a:p>
+            <a:pPr>
+              <a:spcAft>
+                <a:spcPts val="600"/>
+              </a:spcAft>
+              <a:defRPr sz="2000" b="1">
+                <a:solidFill>
+                  <a:srgbClr val="0F172A"/>
+                </a:solidFill>
+                <a:latin typeface="Calibri"/>
+              </a:defRPr>
+            </a:pPr>
+          </a:p>
+          <a:p>
+            <a:pPr>
+              <a:spcAft>
+                <a:spcPts val="600"/>
+              </a:spcAft>
+              <a:defRPr sz="2000" b="1">
+                <a:solidFill>
+                  <a:srgbClr val="0F172A"/>
+                </a:solidFill>
+                <a:latin typeface="Calibri"/>
+              </a:defRPr>
+            </a:pPr>
+          </a:p>
+          <a:p>
+            <a:pPr>
+              <a:spcAft>
+                <a:spcPts val="600"/>
+              </a:spcAft>
+              <a:defRPr sz="2000" b="1">
+                <a:solidFill>
+                  <a:srgbClr val="0F172A"/>
+                </a:solidFill>
+                <a:latin typeface="Calibri"/>
+              </a:defRPr>
+            </a:pPr>
+          </a:p>
+          <a:p>
+            <a:pPr>
+              <a:spcAft>
+                <a:spcPts val="1400"/>
+              </a:spcAft>
+            </a:pPr>
+            <a:r>
+              <a:rPr sz="1800" b="1">
+                <a:solidFill>
+                  <a:srgbClr val="0F172A"/>
+                </a:solidFill>
+                <a:latin typeface="Calibri"/>
+              </a:rPr>
+              <a:t>• 2. Problem Statement &amp; Motivation: </a:t>
             </a:r>
             <a:r>
               <a:rPr sz="1800" b="0">
@@ -9435,22 +9567,22 @@
                 </a:solidFill>
                 <a:latin typeface="Calibri"/>
               </a:rPr>
-              <a:t>Challenges in sign language translation &amp; pixel-level limitations</a:t>
-            </a:r>
-          </a:p>
-          <a:p>
-            <a:pPr>
-              <a:spcAft>
-                <a:spcPts val="600"/>
-              </a:spcAft>
-              <a:defRPr sz="2000" b="1">
-                <a:solidFill>
-                  <a:srgbClr val="0F172A"/>
-                </a:solidFill>
-                <a:latin typeface="Calibri"/>
-              </a:defRPr>
-            </a:pPr>
-            <a:r>
+              <a:t>Unscheduled aircraft engine failures &amp; traditional servicing inefficiencies.</a:t>
+            </a:r>
+          </a:p>
+          <a:p>
+            <a:pPr>
+              <a:spcAft>
+                <a:spcPts val="1400"/>
+              </a:spcAft>
+            </a:pPr>
+            <a:r>
+              <a:rPr sz="1800" b="1">
+                <a:solidFill>
+                  <a:srgbClr val="0F172A"/>
+                </a:solidFill>
+                <a:latin typeface="Calibri"/>
+              </a:rPr>
               <a:t>• 3. Requirement Analysis: </a:t>
             </a:r>
             <a:r>
@@ -9460,23 +9592,23 @@
                 </a:solidFill>
                 <a:latin typeface="Calibri"/>
               </a:rPr>
-              <a:t>Hardware setup &amp; software stack (MediaPipe, TensorFlow, OpenCV)</a:t>
-            </a:r>
-          </a:p>
-          <a:p>
-            <a:pPr>
-              <a:spcAft>
-                <a:spcPts val="600"/>
-              </a:spcAft>
-              <a:defRPr sz="2000" b="1">
-                <a:solidFill>
-                  <a:srgbClr val="0F172A"/>
-                </a:solidFill>
-                <a:latin typeface="Calibri"/>
-              </a:defRPr>
-            </a:pPr>
-            <a:r>
-              <a:t>• 4. System Architecture: </a:t>
+              <a:t>Hardware &amp; Software technology stack requirements.</a:t>
+            </a:r>
+          </a:p>
+          <a:p>
+            <a:pPr>
+              <a:spcAft>
+                <a:spcPts val="1400"/>
+              </a:spcAft>
+            </a:pPr>
+            <a:r>
+              <a:rPr sz="1800" b="1">
+                <a:solidFill>
+                  <a:srgbClr val="0F172A"/>
+                </a:solidFill>
+                <a:latin typeface="Calibri"/>
+              </a:rPr>
+              <a:t>• 4. Dataset &amp; Features: </a:t>
             </a:r>
             <a:r>
               <a:rPr sz="1800" b="0">
@@ -9485,23 +9617,23 @@
                 </a:solidFill>
                 <a:latin typeface="Calibri"/>
               </a:rPr>
-              <a:t>End-to-end data pipeline flow &amp; system module design</a:t>
-            </a:r>
-          </a:p>
-          <a:p>
-            <a:pPr>
-              <a:spcAft>
-                <a:spcPts val="600"/>
-              </a:spcAft>
-              <a:defRPr sz="2000" b="1">
-                <a:solidFill>
-                  <a:srgbClr val="0F172A"/>
-                </a:solidFill>
-                <a:latin typeface="Calibri"/>
-              </a:defRPr>
-            </a:pPr>
-            <a:r>
-              <a:t>• 5. Keypoint Extraction &amp; Normalization: </a:t>
+              <a:t>NASA C-MAPSS 21-sensor telemetry dataset &amp; rolling window aggregations.</a:t>
+            </a:r>
+          </a:p>
+          <a:p>
+            <a:pPr>
+              <a:spcAft>
+                <a:spcPts val="1400"/>
+              </a:spcAft>
+            </a:pPr>
+            <a:r>
+              <a:rPr sz="1800" b="1">
+                <a:solidFill>
+                  <a:srgbClr val="0F172A"/>
+                </a:solidFill>
+                <a:latin typeface="Calibri"/>
+              </a:rPr>
+              <a:t>• 5. System Methodology &amp; Flowchart: </a:t>
             </a:r>
             <a:r>
               <a:rPr sz="1800" b="0">
@@ -9510,23 +9642,23 @@
                 </a:solidFill>
                 <a:latin typeface="Calibri"/>
               </a:rPr>
-              <a:t>Spatial landmark extraction (Hands &amp; Pose)</a:t>
-            </a:r>
-          </a:p>
-          <a:p>
-            <a:pPr>
-              <a:spcAft>
-                <a:spcPts val="600"/>
-              </a:spcAft>
-              <a:defRPr sz="2000" b="1">
-                <a:solidFill>
-                  <a:srgbClr val="0F172A"/>
-                </a:solidFill>
-                <a:latin typeface="Calibri"/>
-              </a:defRPr>
-            </a:pPr>
-            <a:r>
-              <a:t>• 6. Dataset &amp; Feature Engineering: </a:t>
+              <a:t>Multi-stage data ingestion, feature extraction &amp; tri-model inference.</a:t>
+            </a:r>
+          </a:p>
+          <a:p>
+            <a:pPr>
+              <a:spcAft>
+                <a:spcPts val="1400"/>
+              </a:spcAft>
+            </a:pPr>
+            <a:r>
+              <a:rPr sz="1800" b="1">
+                <a:solidFill>
+                  <a:srgbClr val="0F172A"/>
+                </a:solidFill>
+                <a:latin typeface="Calibri"/>
+              </a:rPr>
+              <a:t>• 6. Tri-Model AI Architecture: </a:t>
             </a:r>
             <a:r>
               <a:rPr sz="1800" b="0">
@@ -9535,23 +9667,23 @@
                 </a:solidFill>
                 <a:latin typeface="Calibri"/>
               </a:rPr>
-              <a:t>Sliding window aggregation (18 statistical features)</a:t>
-            </a:r>
-          </a:p>
-          <a:p>
-            <a:pPr>
-              <a:spcAft>
-                <a:spcPts val="600"/>
-              </a:spcAft>
-              <a:defRPr sz="2000" b="1">
-                <a:solidFill>
-                  <a:srgbClr val="0F172A"/>
-                </a:solidFill>
-                <a:latin typeface="Calibri"/>
-              </a:defRPr>
-            </a:pPr>
-            <a:r>
-              <a:t>• 7. Sequence LSTM Classifier: </a:t>
+              <a:t>RUL Regression, Binary 30d Classifier &amp; Multi-Class Neural MLP.</a:t>
+            </a:r>
+          </a:p>
+          <a:p>
+            <a:pPr>
+              <a:spcAft>
+                <a:spcPts val="1400"/>
+              </a:spcAft>
+            </a:pPr>
+            <a:r>
+              <a:rPr sz="1800" b="1">
+                <a:solidFill>
+                  <a:srgbClr val="0F172A"/>
+                </a:solidFill>
+                <a:latin typeface="Calibri"/>
+              </a:rPr>
+              <a:t>• 7. Empirical Results &amp; Evaluation Table: </a:t>
             </a:r>
             <a:r>
               <a:rPr sz="1800" b="0">
@@ -9560,23 +9692,23 @@
                 </a:solidFill>
                 <a:latin typeface="Calibri"/>
               </a:rPr>
-              <a:t>Multi-layer LSTM model architecture &amp; loss optimization</a:t>
-            </a:r>
-          </a:p>
-          <a:p>
-            <a:pPr>
-              <a:spcAft>
-                <a:spcPts val="600"/>
-              </a:spcAft>
-              <a:defRPr sz="2000" b="1">
-                <a:solidFill>
-                  <a:srgbClr val="0F172A"/>
-                </a:solidFill>
-                <a:latin typeface="Calibri"/>
-              </a:defRPr>
-            </a:pPr>
-            <a:r>
-              <a:t>• 8. Desktop GUI &amp; Audio Translation: </a:t>
+              <a:t>98.45% AUC-ROC score &amp; per-model benchmark analysis.</a:t>
+            </a:r>
+          </a:p>
+          <a:p>
+            <a:pPr>
+              <a:spcAft>
+                <a:spcPts val="1400"/>
+              </a:spcAft>
+            </a:pPr>
+            <a:r>
+              <a:rPr sz="1800" b="1">
+                <a:solidFill>
+                  <a:srgbClr val="0F172A"/>
+                </a:solidFill>
+                <a:latin typeface="Calibri"/>
+              </a:rPr>
+              <a:t>• 8. Real-Time Diagnostic Tool: </a:t>
             </a:r>
             <a:r>
               <a:rPr sz="1800" b="0">
@@ -9585,23 +9717,23 @@
                 </a:solidFill>
                 <a:latin typeface="Calibri"/>
               </a:rPr>
-              <a:t>Native Python Tkinter application &amp; Pyttsx3 speech synthesis</a:t>
-            </a:r>
-          </a:p>
-          <a:p>
-            <a:pPr>
-              <a:spcAft>
-                <a:spcPts val="600"/>
-              </a:spcAft>
-              <a:defRPr sz="2000" b="1">
-                <a:solidFill>
-                  <a:srgbClr val="0F172A"/>
-                </a:solidFill>
-                <a:latin typeface="Calibri"/>
-              </a:defRPr>
-            </a:pPr>
-            <a:r>
-              <a:t>• 9. Results &amp; Performance Analysis: </a:t>
+              <a:t>CLI execution runner (predict.py) &amp; fleet capacity dispatch.</a:t>
+            </a:r>
+          </a:p>
+          <a:p>
+            <a:pPr>
+              <a:spcAft>
+                <a:spcPts val="1400"/>
+              </a:spcAft>
+            </a:pPr>
+            <a:r>
+              <a:rPr sz="1800" b="1">
+                <a:solidFill>
+                  <a:srgbClr val="0F172A"/>
+                </a:solidFill>
+                <a:latin typeface="Calibri"/>
+              </a:rPr>
+              <a:t>• 9. Conclusion &amp; References: </a:t>
             </a:r>
             <a:r>
               <a:rPr sz="1800" b="0">
@@ -9610,160 +9742,7 @@
                 </a:solidFill>
                 <a:latin typeface="Calibri"/>
               </a:rPr>
-              <a:t>Accuracy (98.67%), F1-Score (0.99), &amp; per-class precision table</a:t>
-            </a:r>
-          </a:p>
-          <a:p>
-            <a:pPr>
-              <a:spcAft>
-                <a:spcPts val="600"/>
-              </a:spcAft>
-              <a:defRPr sz="2000" b="1">
-                <a:solidFill>
-                  <a:srgbClr val="0F172A"/>
-                </a:solidFill>
-                <a:latin typeface="Calibri"/>
-              </a:defRPr>
-            </a:pPr>
-            <a:r>
-              <a:t>• 10. Conclusion &amp; References: </a:t>
-            </a:r>
-            <a:r>
-              <a:rPr sz="1800" b="0">
-                <a:solidFill>
-                  <a:srgbClr val="334155"/>
-                </a:solidFill>
-                <a:latin typeface="Calibri"/>
-              </a:rPr>
-              <a:t>Summary of achievements, future scope &amp; academic references</a:t>
-            </a:r>
-          </a:p>
-          <a:p>
-            <a:pPr>
-              <a:spcAft>
-                <a:spcPts val="1400"/>
-              </a:spcAft>
-              <a:defRPr sz="2000" b="1">
-                <a:solidFill>
-                  <a:srgbClr val="334155"/>
-                </a:solidFill>
-                <a:latin typeface="Calibri"/>
-              </a:defRPr>
-            </a:pPr>
-            <a:r>
-              <a:t>• 2. Problem Statement &amp; Motivation: Unscheduled aircraft engine failures &amp; delayed maintenance.</a:t>
-            </a:r>
-          </a:p>
-          <a:p>
-            <a:pPr>
-              <a:spcAft>
-                <a:spcPts val="1400"/>
-              </a:spcAft>
-              <a:defRPr sz="2000" b="1">
-                <a:solidFill>
-                  <a:srgbClr val="334155"/>
-                </a:solidFill>
-                <a:latin typeface="Calibri"/>
-              </a:defRPr>
-            </a:pPr>
-            <a:r>
-              <a:t>• 3. Requirement Analysis: Hardware &amp; Software technology stack requirements.</a:t>
-            </a:r>
-          </a:p>
-          <a:p>
-            <a:pPr>
-              <a:spcAft>
-                <a:spcPts val="1400"/>
-              </a:spcAft>
-              <a:defRPr sz="2000" b="1">
-                <a:solidFill>
-                  <a:srgbClr val="334155"/>
-                </a:solidFill>
-                <a:latin typeface="Calibri"/>
-              </a:defRPr>
-            </a:pPr>
-            <a:r>
-              <a:t>• 4. Dataset &amp; Features: NASA C-MAPSS 21-sensor telemetry dataset &amp; rolling window aggregations.</a:t>
-            </a:r>
-          </a:p>
-          <a:p>
-            <a:pPr>
-              <a:spcAft>
-                <a:spcPts val="1400"/>
-              </a:spcAft>
-              <a:defRPr sz="2000" b="1">
-                <a:solidFill>
-                  <a:srgbClr val="334155"/>
-                </a:solidFill>
-                <a:latin typeface="Calibri"/>
-              </a:defRPr>
-            </a:pPr>
-            <a:r>
-              <a:t>• 5. System Methodology &amp; Flowchart: Multi-stage data ingestion, feature extraction &amp; tri-model inference.</a:t>
-            </a:r>
-          </a:p>
-          <a:p>
-            <a:pPr>
-              <a:spcAft>
-                <a:spcPts val="1400"/>
-              </a:spcAft>
-              <a:defRPr sz="2000" b="1">
-                <a:solidFill>
-                  <a:srgbClr val="334155"/>
-                </a:solidFill>
-                <a:latin typeface="Calibri"/>
-              </a:defRPr>
-            </a:pPr>
-            <a:r>
-              <a:t>• 6. Tri-Model AI Architecture: RUL Regression, Binary 30d Classifier &amp; Multi-Class Neural MLP.</a:t>
-            </a:r>
-          </a:p>
-          <a:p>
-            <a:pPr>
-              <a:spcAft>
-                <a:spcPts val="1400"/>
-              </a:spcAft>
-              <a:defRPr sz="2000" b="1">
-                <a:solidFill>
-                  <a:srgbClr val="334155"/>
-                </a:solidFill>
-                <a:latin typeface="Calibri"/>
-              </a:defRPr>
-            </a:pPr>
-            <a:r>
-              <a:t>• 7. Empirical Results &amp; Evaluation Table: 98.45% AUC-ROC score &amp; per-model benchmark analysis.</a:t>
-            </a:r>
-          </a:p>
-          <a:p>
-            <a:pPr>
-              <a:spcAft>
-                <a:spcPts val="1400"/>
-              </a:spcAft>
-              <a:defRPr sz="2000" b="1">
-                <a:solidFill>
-                  <a:srgbClr val="334155"/>
-                </a:solidFill>
-                <a:latin typeface="Calibri"/>
-              </a:defRPr>
-            </a:pPr>
-            <a:r>
-              <a:t>• 8. Real-Time Diagnostic Tool: CLI execution runner (predict.py) &amp; fleet capacity dispatch.</a:t>
-            </a:r>
-          </a:p>
-          <a:p>
-            <a:pPr>
-              <a:spcAft>
-                <a:spcPts val="1400"/>
-              </a:spcAft>
-              <a:defRPr sz="2000" b="1">
-                <a:solidFill>
-                  <a:srgbClr val="334155"/>
-                </a:solidFill>
-                <a:latin typeface="Calibri"/>
-              </a:defRPr>
-            </a:pPr>
-            <a:r>
-              <a:t>• 9. Conclusion &amp; Future Scope: Summary of achievements, business cost optimization &amp; future scope.</a:t>
+              <a:t>Summary of achievements, future scope &amp; bibliography citations.</a:t>
             </a:r>
           </a:p>
         </p:txBody>
@@ -9886,13 +9865,28 @@
               </a:spcAft>
               <a:defRPr sz="2000" b="1">
                 <a:solidFill>
+                  <a:srgbClr val="0F172A"/>
+                </a:solidFill>
+                <a:latin typeface="Calibri"/>
+              </a:defRPr>
+            </a:pPr>
+            <a:r>
+              <a:rPr sz="1800" b="1">
+                <a:solidFill>
+                  <a:srgbClr val="0F172A"/>
+                </a:solidFill>
+                <a:latin typeface="Calibri"/>
+              </a:rPr>
+              <a:t>• Domain of Work: </a:t>
+            </a:r>
+            <a:r>
+              <a:rPr sz="1800" b="0">
+                <a:solidFill>
                   <a:srgbClr val="334155"/>
                 </a:solidFill>
                 <a:latin typeface="Calibri"/>
-              </a:defRPr>
-            </a:pPr>
-            <a:r>
-              <a:t>• Domain of Work: Industrial AI, Reliability Engineering &amp; Aviation Prognostics.</a:t>
+              </a:rPr>
+              <a:t>Industrial AI, Reliability Engineering &amp; Aviation Prognostics.</a:t>
             </a:r>
           </a:p>
           <a:p>
@@ -9907,8 +9901,60 @@
                 <a:latin typeface="Calibri"/>
               </a:defRPr>
             </a:pPr>
-            <a:r>
-              <a:t>• Social Relevance: </a:t>
+          </a:p>
+          <a:p>
+            <a:pPr>
+              <a:spcAft>
+                <a:spcPts val="600"/>
+              </a:spcAft>
+              <a:defRPr sz="2000" b="1">
+                <a:solidFill>
+                  <a:srgbClr val="0F172A"/>
+                </a:solidFill>
+                <a:latin typeface="Calibri"/>
+              </a:defRPr>
+            </a:pPr>
+          </a:p>
+          <a:p>
+            <a:pPr>
+              <a:spcAft>
+                <a:spcPts val="600"/>
+              </a:spcAft>
+              <a:defRPr sz="2000" b="1">
+                <a:solidFill>
+                  <a:srgbClr val="0F172A"/>
+                </a:solidFill>
+                <a:latin typeface="Calibri"/>
+              </a:defRPr>
+            </a:pPr>
+          </a:p>
+          <a:p>
+            <a:pPr>
+              <a:spcAft>
+                <a:spcPts val="600"/>
+              </a:spcAft>
+              <a:defRPr sz="2000" b="1">
+                <a:solidFill>
+                  <a:srgbClr val="0F172A"/>
+                </a:solidFill>
+                <a:latin typeface="Calibri"/>
+              </a:defRPr>
+            </a:pPr>
+          </a:p>
+          <a:p>
+            <a:pPr>
+              <a:spcAft>
+                <a:spcPts val="1400"/>
+              </a:spcAft>
+            </a:pPr>
+            <a:r>
+              <a:rPr sz="1800" b="1">
+                <a:solidFill>
+                  <a:srgbClr val="0F172A"/>
+                </a:solidFill>
+                <a:latin typeface="Calibri"/>
+              </a:rPr>
+              <a:t>• Industrial Context: </a:t>
             </a:r>
             <a:r>
               <a:rPr sz="1800" b="0">
@@ -9917,22 +9963,47 @@
                 </a:solidFill>
                 <a:latin typeface="Calibri"/>
               </a:rPr>
-              <a:t>Over 70 million deaf individuals globally rely on sign language for daily communication</a:t>
-            </a:r>
-          </a:p>
-          <a:p>
-            <a:pPr>
-              <a:spcAft>
-                <a:spcPts val="600"/>
-              </a:spcAft>
-              <a:defRPr sz="2000" b="1">
-                <a:solidFill>
-                  <a:srgbClr val="0F172A"/>
-                </a:solidFill>
-                <a:latin typeface="Calibri"/>
-              </a:defRPr>
-            </a:pPr>
-            <a:r>
+              <a:t>Commercial Aircraft Turbofan Jet Engine Fleet Operations.</a:t>
+            </a:r>
+          </a:p>
+          <a:p>
+            <a:pPr>
+              <a:spcAft>
+                <a:spcPts val="1400"/>
+              </a:spcAft>
+            </a:pPr>
+            <a:r>
+              <a:rPr sz="1800" b="1">
+                <a:solidFill>
+                  <a:srgbClr val="0F172A"/>
+                </a:solidFill>
+                <a:latin typeface="Calibri"/>
+              </a:rPr>
+              <a:t>• Core Shift: </a:t>
+            </a:r>
+            <a:r>
+              <a:rPr sz="1800" b="0">
+                <a:solidFill>
+                  <a:srgbClr val="334155"/>
+                </a:solidFill>
+                <a:latin typeface="Calibri"/>
+              </a:rPr>
+              <a:t>Transitioning from static time-servicing to AI predictive maintenance.</a:t>
+            </a:r>
+          </a:p>
+          <a:p>
+            <a:pPr>
+              <a:spcAft>
+                <a:spcPts val="1400"/>
+              </a:spcAft>
+            </a:pPr>
+            <a:r>
+              <a:rPr sz="1800" b="1">
+                <a:solidFill>
+                  <a:srgbClr val="0F172A"/>
+                </a:solidFill>
+                <a:latin typeface="Calibri"/>
+              </a:rPr>
               <a:t>• Primary Objective: </a:t>
             </a:r>
             <a:r>
@@ -9942,23 +10013,23 @@
                 </a:solidFill>
                 <a:latin typeface="Calibri"/>
               </a:rPr>
-              <a:t>Develop a real-time, non-invasive translation system converting webcam gestures into text &amp; voice</a:t>
-            </a:r>
-          </a:p>
-          <a:p>
-            <a:pPr>
-              <a:spcAft>
-                <a:spcPts val="600"/>
-              </a:spcAft>
-              <a:defRPr sz="2000" b="1">
-                <a:solidFill>
-                  <a:srgbClr val="0F172A"/>
-                </a:solidFill>
-                <a:latin typeface="Calibri"/>
-              </a:defRPr>
-            </a:pPr>
-            <a:r>
-              <a:t>• Key Approach: </a:t>
+              <a:t>Utilize 21 sensor streams to forecast Remaining Useful Life (RUL).</a:t>
+            </a:r>
+          </a:p>
+          <a:p>
+            <a:pPr>
+              <a:spcAft>
+                <a:spcPts val="1400"/>
+              </a:spcAft>
+            </a:pPr>
+            <a:r>
+              <a:rPr sz="1800" b="1">
+                <a:solidFill>
+                  <a:srgbClr val="0F172A"/>
+                </a:solidFill>
+                <a:latin typeface="Calibri"/>
+              </a:rPr>
+              <a:t>• Supervision &amp; Mentorship: </a:t>
             </a:r>
             <a:r>
               <a:rPr sz="1800" b="0">
@@ -9967,96 +10038,7 @@
                 </a:solidFill>
                 <a:latin typeface="Calibri"/>
               </a:rPr>
-              <a:t>Extract compact 3D spatial keypoints per frame and classify keypoint sequences using an LSTM model</a:t>
-            </a:r>
-          </a:p>
-          <a:p>
-            <a:pPr>
-              <a:spcAft>
-                <a:spcPts val="600"/>
-              </a:spcAft>
-              <a:defRPr sz="2000" b="1">
-                <a:solidFill>
-                  <a:srgbClr val="0F172A"/>
-                </a:solidFill>
-                <a:latin typeface="Calibri"/>
-              </a:defRPr>
-            </a:pPr>
-            <a:r>
-              <a:t>• Sign-to-Speech Integration: </a:t>
-            </a:r>
-            <a:r>
-              <a:rPr sz="1800" b="0">
-                <a:solidFill>
-                  <a:srgbClr val="334155"/>
-                </a:solidFill>
-                <a:latin typeface="Calibri"/>
-              </a:rPr>
-              <a:t>Integrate Text-to-Speech (TTS) audio output for seamless real-time communication</a:t>
-            </a:r>
-          </a:p>
-          <a:p>
-            <a:pPr>
-              <a:spcAft>
-                <a:spcPts val="1400"/>
-              </a:spcAft>
-              <a:defRPr sz="2000" b="1">
-                <a:solidFill>
-                  <a:srgbClr val="334155"/>
-                </a:solidFill>
-                <a:latin typeface="Calibri"/>
-              </a:defRPr>
-            </a:pPr>
-            <a:r>
-              <a:t>• Industrial Context: Commercial Aircraft Turbofan Jet Engine Fleet Operations.</a:t>
-            </a:r>
-          </a:p>
-          <a:p>
-            <a:pPr>
-              <a:spcAft>
-                <a:spcPts val="1400"/>
-              </a:spcAft>
-              <a:defRPr sz="2000" b="1">
-                <a:solidFill>
-                  <a:srgbClr val="334155"/>
-                </a:solidFill>
-                <a:latin typeface="Calibri"/>
-              </a:defRPr>
-            </a:pPr>
-            <a:r>
-              <a:t>• Core Shift: Transitioning from static time-servicing to AI predictive maintenance.</a:t>
-            </a:r>
-          </a:p>
-          <a:p>
-            <a:pPr>
-              <a:spcAft>
-                <a:spcPts val="1400"/>
-              </a:spcAft>
-              <a:defRPr sz="2000" b="1">
-                <a:solidFill>
-                  <a:srgbClr val="334155"/>
-                </a:solidFill>
-                <a:latin typeface="Calibri"/>
-              </a:defRPr>
-            </a:pPr>
-            <a:r>
-              <a:t>• Primary Objective: Utilize 21 sensor streams to forecast Remaining Useful Life (RUL).</a:t>
-            </a:r>
-          </a:p>
-          <a:p>
-            <a:pPr>
-              <a:spcAft>
-                <a:spcPts val="1400"/>
-              </a:spcAft>
-              <a:defRPr sz="2000" b="1">
-                <a:solidFill>
-                  <a:srgbClr val="334155"/>
-                </a:solidFill>
-                <a:latin typeface="Calibri"/>
-              </a:defRPr>
-            </a:pPr>
-            <a:r>
-              <a:t>• Supervision &amp; Mentorship: Mentored by Alex Chao during Data Science Career Track Bootcamp.</a:t>
+              <a:t>Mentored by Alex Chao during Data Science Career Track Bootcamp.</a:t>
             </a:r>
           </a:p>
         </p:txBody>
@@ -10179,13 +10161,28 @@
               </a:spcAft>
               <a:defRPr sz="2000" b="1">
                 <a:solidFill>
+                  <a:srgbClr val="0F172A"/>
+                </a:solidFill>
+                <a:latin typeface="Calibri"/>
+              </a:defRPr>
+            </a:pPr>
+            <a:r>
+              <a:rPr sz="1800" b="1">
+                <a:solidFill>
+                  <a:srgbClr val="0F172A"/>
+                </a:solidFill>
+                <a:latin typeface="Calibri"/>
+              </a:rPr>
+              <a:t>• Unscheduled Groundings: </a:t>
+            </a:r>
+            <a:r>
+              <a:rPr sz="1800" b="0">
+                <a:solidFill>
                   <a:srgbClr val="334155"/>
                 </a:solidFill>
                 <a:latin typeface="Calibri"/>
-              </a:defRPr>
-            </a:pPr>
-            <a:r>
-              <a:t>• Unscheduled Groundings: Sudden engine failures cause expensive flight delays and safety risks.</a:t>
+              </a:rPr>
+              <a:t>Sudden engine failures cause expensive flight delays and safety risks.</a:t>
             </a:r>
           </a:p>
           <a:p>
@@ -10200,8 +10197,60 @@
                 <a:latin typeface="Calibri"/>
               </a:defRPr>
             </a:pPr>
-            <a:r>
-              <a:t>• Limitations of Existing CNN Methods: </a:t>
+          </a:p>
+          <a:p>
+            <a:pPr>
+              <a:spcAft>
+                <a:spcPts val="600"/>
+              </a:spcAft>
+              <a:defRPr sz="2000" b="1">
+                <a:solidFill>
+                  <a:srgbClr val="0F172A"/>
+                </a:solidFill>
+                <a:latin typeface="Calibri"/>
+              </a:defRPr>
+            </a:pPr>
+          </a:p>
+          <a:p>
+            <a:pPr>
+              <a:spcAft>
+                <a:spcPts val="600"/>
+              </a:spcAft>
+              <a:defRPr sz="2000" b="1">
+                <a:solidFill>
+                  <a:srgbClr val="0F172A"/>
+                </a:solidFill>
+                <a:latin typeface="Calibri"/>
+              </a:defRPr>
+            </a:pPr>
+          </a:p>
+          <a:p>
+            <a:pPr>
+              <a:spcAft>
+                <a:spcPts val="600"/>
+              </a:spcAft>
+              <a:defRPr sz="2000" b="1">
+                <a:solidFill>
+                  <a:srgbClr val="0F172A"/>
+                </a:solidFill>
+                <a:latin typeface="Calibri"/>
+              </a:defRPr>
+            </a:pPr>
+          </a:p>
+          <a:p>
+            <a:pPr>
+              <a:spcAft>
+                <a:spcPts val="1400"/>
+              </a:spcAft>
+            </a:pPr>
+            <a:r>
+              <a:rPr sz="1800" b="1">
+                <a:solidFill>
+                  <a:srgbClr val="0F172A"/>
+                </a:solidFill>
+                <a:latin typeface="Calibri"/>
+              </a:rPr>
+              <a:t>• Static Maintenance Inefficiency: </a:t>
             </a:r>
             <a:r>
               <a:rPr sz="1800" b="0">
@@ -10210,23 +10259,23 @@
                 </a:solidFill>
                 <a:latin typeface="Calibri"/>
               </a:rPr>
-              <a:t>Direct frame-by-frame CNN classifiers fail on temporal gesture dynamics and suffer from high latency</a:t>
-            </a:r>
-          </a:p>
-          <a:p>
-            <a:pPr>
-              <a:spcAft>
-                <a:spcPts val="600"/>
-              </a:spcAft>
-              <a:defRPr sz="2000" b="1">
-                <a:solidFill>
-                  <a:srgbClr val="0F172A"/>
-                </a:solidFill>
-                <a:latin typeface="Calibri"/>
-              </a:defRPr>
-            </a:pPr>
-            <a:r>
-              <a:t>• Signer Position Dependency: </a:t>
+              <a:t>Replaces functional turbofan parts prematurely or misses breakdown.</a:t>
+            </a:r>
+          </a:p>
+          <a:p>
+            <a:pPr>
+              <a:spcAft>
+                <a:spcPts val="1400"/>
+              </a:spcAft>
+            </a:pPr>
+            <a:r>
+              <a:rPr sz="1800" b="1">
+                <a:solidFill>
+                  <a:srgbClr val="0F172A"/>
+                </a:solidFill>
+                <a:latin typeface="Calibri"/>
+              </a:rPr>
+              <a:t>• High Sensor Fluctuation: </a:t>
             </a:r>
             <a:r>
               <a:rPr sz="1800" b="0">
@@ -10235,23 +10284,23 @@
                 </a:solidFill>
                 <a:latin typeface="Calibri"/>
               </a:rPr>
-              <a:t>Raw pixel models degrade when signer distance, clothing, or background lighting changes</a:t>
-            </a:r>
-          </a:p>
-          <a:p>
-            <a:pPr>
-              <a:spcAft>
-                <a:spcPts val="600"/>
-              </a:spcAft>
-              <a:defRPr sz="2000" b="1">
-                <a:solidFill>
-                  <a:srgbClr val="0F172A"/>
-                </a:solidFill>
-                <a:latin typeface="Calibri"/>
-              </a:defRPr>
-            </a:pPr>
-            <a:r>
-              <a:t>• Our Proposed Solution: </a:t>
+              <a:t>21 continuous telemetry streams exhibit noisy non-linear degradation trends.</a:t>
+            </a:r>
+          </a:p>
+          <a:p>
+            <a:pPr>
+              <a:spcAft>
+                <a:spcPts val="1400"/>
+              </a:spcAft>
+            </a:pPr>
+            <a:r>
+              <a:rPr sz="1800" b="1">
+                <a:solidFill>
+                  <a:srgbClr val="0F172A"/>
+                </a:solidFill>
+                <a:latin typeface="Calibri"/>
+              </a:rPr>
+              <a:t>• Multi-Model Solution: </a:t>
             </a:r>
             <a:r>
               <a:rPr sz="1800" b="0">
@@ -10260,80 +10309,7 @@
                 </a:solidFill>
                 <a:latin typeface="Calibri"/>
               </a:rPr>
-              <a:t>Replace raw pixels with 3D pose/hand keypoint sequences, ensuring position scale invariance</a:t>
-            </a:r>
-          </a:p>
-          <a:p>
-            <a:pPr>
-              <a:spcAft>
-                <a:spcPts val="600"/>
-              </a:spcAft>
-              <a:defRPr sz="2000" b="1">
-                <a:solidFill>
-                  <a:srgbClr val="0F172A"/>
-                </a:solidFill>
-                <a:latin typeface="Calibri"/>
-              </a:defRPr>
-            </a:pPr>
-            <a:r>
-              <a:t>• Real-Time Constraint: </a:t>
-            </a:r>
-            <a:r>
-              <a:rPr sz="1800" b="0">
-                <a:solidFill>
-                  <a:srgbClr val="334155"/>
-                </a:solidFill>
-                <a:latin typeface="Calibri"/>
-              </a:rPr>
-              <a:t>Achieve fast sub-50ms inference latency suitable for continuous live webcam translation</a:t>
-            </a:r>
-          </a:p>
-          <a:p>
-            <a:pPr>
-              <a:spcAft>
-                <a:spcPts val="1400"/>
-              </a:spcAft>
-              <a:defRPr sz="2000" b="1">
-                <a:solidFill>
-                  <a:srgbClr val="334155"/>
-                </a:solidFill>
-                <a:latin typeface="Calibri"/>
-              </a:defRPr>
-            </a:pPr>
-            <a:r>
-              <a:t>• Static Maintenance Inefficiency: Replaces functional turbofan parts prematurely or misses breakdown.</a:t>
-            </a:r>
-          </a:p>
-          <a:p>
-            <a:pPr>
-              <a:spcAft>
-                <a:spcPts val="1400"/>
-              </a:spcAft>
-              <a:defRPr sz="2000" b="1">
-                <a:solidFill>
-                  <a:srgbClr val="334155"/>
-                </a:solidFill>
-                <a:latin typeface="Calibri"/>
-              </a:defRPr>
-            </a:pPr>
-            <a:r>
-              <a:t>• High Sensor Fluctuation: 21 continuous telemetry streams exhibit noisy non-linear degradation trends.</a:t>
-            </a:r>
-          </a:p>
-          <a:p>
-            <a:pPr>
-              <a:spcAft>
-                <a:spcPts val="1400"/>
-              </a:spcAft>
-              <a:defRPr sz="2000" b="1">
-                <a:solidFill>
-                  <a:srgbClr val="334155"/>
-                </a:solidFill>
-                <a:latin typeface="Calibri"/>
-              </a:defRPr>
-            </a:pPr>
-            <a:r>
-              <a:t>• Multi-Model Solution: Deploy Regression for RUL, Binary 30d Alerts, and Multi-Class Hazard Rating.</a:t>
+              <a:t>Deploy Regression for RUL, Binary 30d Alerts, and Multi-Class Hazard Rating.</a:t>
             </a:r>
           </a:p>
         </p:txBody>
@@ -10456,13 +10432,28 @@
               </a:spcAft>
               <a:defRPr sz="2000" b="1">
                 <a:solidFill>
+                  <a:srgbClr val="0F172A"/>
+                </a:solidFill>
+                <a:latin typeface="Calibri"/>
+              </a:defRPr>
+            </a:pPr>
+            <a:r>
+              <a:rPr sz="1800" b="1">
+                <a:solidFill>
+                  <a:srgbClr val="0F172A"/>
+                </a:solidFill>
+                <a:latin typeface="Calibri"/>
+              </a:rPr>
+              <a:t>• Hardware Requirements: </a:t>
+            </a:r>
+            <a:r>
+              <a:rPr sz="1800" b="0">
+                <a:solidFill>
                   <a:srgbClr val="334155"/>
                 </a:solidFill>
                 <a:latin typeface="Calibri"/>
-              </a:defRPr>
-            </a:pPr>
-            <a:r>
-              <a:t>• Hardware Requirements: Intel Core i5/i7 Processor, 16GB RAM, SSD Storage Environment.</a:t>
+              </a:rPr>
+              <a:t>Intel Core i5/i7 Processor, 16GB RAM, SSD Storage Environment.</a:t>
             </a:r>
           </a:p>
           <a:p>
@@ -10477,8 +10468,60 @@
                 <a:latin typeface="Calibri"/>
               </a:defRPr>
             </a:pPr>
-            <a:r>
-              <a:t>• Programming Language: </a:t>
+          </a:p>
+          <a:p>
+            <a:pPr>
+              <a:spcAft>
+                <a:spcPts val="600"/>
+              </a:spcAft>
+              <a:defRPr sz="2000" b="1">
+                <a:solidFill>
+                  <a:srgbClr val="0F172A"/>
+                </a:solidFill>
+                <a:latin typeface="Calibri"/>
+              </a:defRPr>
+            </a:pPr>
+          </a:p>
+          <a:p>
+            <a:pPr>
+              <a:spcAft>
+                <a:spcPts val="600"/>
+              </a:spcAft>
+              <a:defRPr sz="2000" b="1">
+                <a:solidFill>
+                  <a:srgbClr val="0F172A"/>
+                </a:solidFill>
+                <a:latin typeface="Calibri"/>
+              </a:defRPr>
+            </a:pPr>
+          </a:p>
+          <a:p>
+            <a:pPr>
+              <a:spcAft>
+                <a:spcPts val="600"/>
+              </a:spcAft>
+              <a:defRPr sz="2000" b="1">
+                <a:solidFill>
+                  <a:srgbClr val="0F172A"/>
+                </a:solidFill>
+                <a:latin typeface="Calibri"/>
+              </a:defRPr>
+            </a:pPr>
+          </a:p>
+          <a:p>
+            <a:pPr>
+              <a:spcAft>
+                <a:spcPts val="1400"/>
+              </a:spcAft>
+            </a:pPr>
+            <a:r>
+              <a:rPr sz="1800" b="1">
+                <a:solidFill>
+                  <a:srgbClr val="0F172A"/>
+                </a:solidFill>
+                <a:latin typeface="Calibri"/>
+              </a:rPr>
+              <a:t>• Software Stack &amp; Language: </a:t>
             </a:r>
             <a:r>
               <a:rPr sz="1800" b="0">
@@ -10487,23 +10530,23 @@
                 </a:solidFill>
                 <a:latin typeface="Calibri"/>
               </a:rPr>
-              <a:t>Python 3.11 (Core logic, OpenCV capture, &amp; deep learning execution)</a:t>
-            </a:r>
-          </a:p>
-          <a:p>
-            <a:pPr>
-              <a:spcAft>
-                <a:spcPts val="600"/>
-              </a:spcAft>
-              <a:defRPr sz="2000" b="1">
-                <a:solidFill>
-                  <a:srgbClr val="0F172A"/>
-                </a:solidFill>
-                <a:latin typeface="Calibri"/>
-              </a:defRPr>
-            </a:pPr>
-            <a:r>
-              <a:t>• Computer Vision Library: </a:t>
+              <a:t>Python 3.11+ Core Language, VS Code / Jupyter Notebook IDE.</a:t>
+            </a:r>
+          </a:p>
+          <a:p>
+            <a:pPr>
+              <a:spcAft>
+                <a:spcPts val="1400"/>
+              </a:spcAft>
+            </a:pPr>
+            <a:r>
+              <a:rPr sz="1800" b="1">
+                <a:solidFill>
+                  <a:srgbClr val="0F172A"/>
+                </a:solidFill>
+                <a:latin typeface="Calibri"/>
+              </a:rPr>
+              <a:t>• Machine Learning Frameworks: </a:t>
             </a:r>
             <a:r>
               <a:rPr sz="1800" b="0">
@@ -10512,23 +10555,23 @@
                 </a:solidFill>
                 <a:latin typeface="Calibri"/>
               </a:rPr>
-              <a:t>Google MediaPipe 0.10.21 (Fingertip &amp; upper-body pose landmark extraction)</a:t>
-            </a:r>
-          </a:p>
-          <a:p>
-            <a:pPr>
-              <a:spcAft>
-                <a:spcPts val="600"/>
-              </a:spcAft>
-              <a:defRPr sz="2000" b="1">
-                <a:solidFill>
-                  <a:srgbClr val="0F172A"/>
-                </a:solidFill>
-                <a:latin typeface="Calibri"/>
-              </a:defRPr>
-            </a:pPr>
-            <a:r>
-              <a:t>• Deep Learning Framework: </a:t>
+              <a:t>Scikit-Learn 1.3+ (Random Forest, SVM, MLP Neural Classifier).</a:t>
+            </a:r>
+          </a:p>
+          <a:p>
+            <a:pPr>
+              <a:spcAft>
+                <a:spcPts val="1400"/>
+              </a:spcAft>
+            </a:pPr>
+            <a:r>
+              <a:rPr sz="1800" b="1">
+                <a:solidFill>
+                  <a:srgbClr val="0F172A"/>
+                </a:solidFill>
+                <a:latin typeface="Calibri"/>
+              </a:rPr>
+              <a:t>• Data &amp; Signal Libraries: </a:t>
             </a:r>
             <a:r>
               <a:rPr sz="1800" b="0">
@@ -10537,23 +10580,23 @@
                 </a:solidFill>
                 <a:latin typeface="Calibri"/>
               </a:rPr>
-              <a:t>TensorFlow 2.17 &amp; Keras 3.3 (Multi-layer LSTM model training &amp; inference)</a:t>
-            </a:r>
-          </a:p>
-          <a:p>
-            <a:pPr>
-              <a:spcAft>
-                <a:spcPts val="600"/>
-              </a:spcAft>
-              <a:defRPr sz="2000" b="1">
-                <a:solidFill>
-                  <a:srgbClr val="0F172A"/>
-                </a:solidFill>
-                <a:latin typeface="Calibri"/>
-              </a:defRPr>
-            </a:pPr>
-            <a:r>
-              <a:t>• User Interface &amp; Audio Engine: </a:t>
+              <a:t>Pandas, NumPy, SciPy for 5-cycle rolling window aggregations.</a:t>
+            </a:r>
+          </a:p>
+          <a:p>
+            <a:pPr>
+              <a:spcAft>
+                <a:spcPts val="1400"/>
+              </a:spcAft>
+            </a:pPr>
+            <a:r>
+              <a:rPr sz="1800" b="1">
+                <a:solidFill>
+                  <a:srgbClr val="0F172A"/>
+                </a:solidFill>
+                <a:latin typeface="Calibri"/>
+              </a:rPr>
+              <a:t>• Visualization Frameworks: </a:t>
             </a:r>
             <a:r>
               <a:rPr sz="1800" b="0">
@@ -10562,71 +10605,7 @@
                 </a:solidFill>
                 <a:latin typeface="Calibri"/>
               </a:rPr>
-              <a:t>Python Native Tkinter GUI framework &amp; Pyttsx3 Text-to-Speech audio engine</a:t>
-            </a:r>
-          </a:p>
-          <a:p>
-            <a:pPr>
-              <a:spcAft>
-                <a:spcPts val="1400"/>
-              </a:spcAft>
-              <a:defRPr sz="2000" b="1">
-                <a:solidFill>
-                  <a:srgbClr val="334155"/>
-                </a:solidFill>
-                <a:latin typeface="Calibri"/>
-              </a:defRPr>
-            </a:pPr>
-            <a:r>
-              <a:t>• Software Stack &amp; Language: Python 3.11+ Core Language, VS Code / Jupyter Notebook IDE.</a:t>
-            </a:r>
-          </a:p>
-          <a:p>
-            <a:pPr>
-              <a:spcAft>
-                <a:spcPts val="1400"/>
-              </a:spcAft>
-              <a:defRPr sz="2000" b="1">
-                <a:solidFill>
-                  <a:srgbClr val="334155"/>
-                </a:solidFill>
-                <a:latin typeface="Calibri"/>
-              </a:defRPr>
-            </a:pPr>
-            <a:r>
-              <a:t>• Machine Learning Frameworks: Scikit-Learn 1.3+ (Random Forest, SVM, MLP Neural Classifier).</a:t>
-            </a:r>
-          </a:p>
-          <a:p>
-            <a:pPr>
-              <a:spcAft>
-                <a:spcPts val="1400"/>
-              </a:spcAft>
-              <a:defRPr sz="2000" b="1">
-                <a:solidFill>
-                  <a:srgbClr val="334155"/>
-                </a:solidFill>
-                <a:latin typeface="Calibri"/>
-              </a:defRPr>
-            </a:pPr>
-            <a:r>
-              <a:t>• Data &amp; Signal Libraries: Pandas, NumPy, SciPy for 5-cycle rolling window aggregations.</a:t>
-            </a:r>
-          </a:p>
-          <a:p>
-            <a:pPr>
-              <a:spcAft>
-                <a:spcPts val="1400"/>
-              </a:spcAft>
-              <a:defRPr sz="2000" b="1">
-                <a:solidFill>
-                  <a:srgbClr val="334155"/>
-                </a:solidFill>
-                <a:latin typeface="Calibri"/>
-              </a:defRPr>
-            </a:pPr>
-            <a:r>
-              <a:t>• Visualization Frameworks: Matplotlib, Seaborn for publication-grade metric charts.</a:t>
+              <a:t>Matplotlib, Seaborn for publication-grade metric charts.</a:t>
             </a:r>
           </a:p>
         </p:txBody>
@@ -10729,18 +10708,18 @@
         </p:nvSpPr>
         <p:spPr>
           <a:xfrm>
-            <a:off x="548640" y="1188720"/>
-            <a:ext cx="8046720" cy="4846320"/>
+            <a:off x="548640" y="1371600"/>
+            <a:ext cx="2194560" cy="1645920"/>
           </a:xfrm>
           <a:prstGeom prst="roundRect">
             <a:avLst/>
           </a:prstGeom>
           <a:solidFill>
-            <a:srgbClr val="E0F2FE"/>
+            <a:srgbClr val="F1F5F9"/>
           </a:solidFill>
-          <a:ln w="31750">
+          <a:ln w="19050">
             <a:solidFill>
-              <a:srgbClr val="0D6EFD"/>
+              <a:srgbClr val="0284C7"/>
             </a:solidFill>
           </a:ln>
         </p:spPr>
@@ -10759,22 +10738,22 @@
           </a:fontRef>
         </p:style>
         <p:txBody>
-          <a:bodyPr rtlCol="0" anchor="ctr" wrap="square" lIns="0" tIns="0" rIns="0" bIns="0"/>
+          <a:bodyPr rtlCol="0" anchor="ctr" wrap="square"/>
           <a:lstStyle/>
           <a:p>
             <a:pPr algn="ctr">
               <a:spcAft>
-                <a:spcPts val="1400"/>
-              </a:spcAft>
-              <a:defRPr sz="2000" b="1">
-                <a:solidFill>
-                  <a:srgbClr val="334155"/>
-                </a:solidFill>
-                <a:latin typeface="Calibri"/>
-              </a:defRPr>
-            </a:pPr>
-            <a:r>
-              <a:t>• STAGE 1: Sensor Telemetry Ingestion (NASA C-MAPSS 21 Sensors &amp; 3 Operational Settings).</a:t>
+                <a:spcPts val="400"/>
+              </a:spcAft>
+              <a:defRPr sz="1600" b="1">
+                <a:solidFill>
+                  <a:srgbClr val="0284C7"/>
+                </a:solidFill>
+                <a:latin typeface="Calibri"/>
+              </a:defRPr>
+            </a:pPr>
+            <a:r>
+              <a:t>STAGE 1</a:t>
             </a:r>
           </a:p>
           <a:p>
@@ -10786,20 +10765,23 @@
                 <a:latin typeface="Calibri"/>
               </a:defRPr>
             </a:pPr>
-            <a:r>
-              <a:t>Webcam Capture</a:t>
-            </a:r>
-            <a:br/>
-            <a:r>
-              <a:t>(640x480 @ 15 FPS)</a:t>
-            </a:r>
-          </a:p>
-          <a:p>
-            <a:pPr>
-              <a:spcAft>
-                <a:spcPts val="1400"/>
-              </a:spcAft>
-              <a:defRPr sz="2000" b="1">
+          </a:p>
+          <a:p>
+            <a:pPr algn="ctr">
+              <a:defRPr sz="1400" b="1">
+                <a:solidFill>
+                  <a:srgbClr val="0F172A"/>
+                </a:solidFill>
+                <a:latin typeface="Calibri"/>
+              </a:defRPr>
+            </a:pPr>
+            <a:r>
+              <a:t>Telemetry Ingestion</a:t>
+            </a:r>
+          </a:p>
+          <a:p>
+            <a:pPr algn="ctr">
+              <a:defRPr sz="1200">
                 <a:solidFill>
                   <a:srgbClr val="334155"/>
                 </a:solidFill>
@@ -10807,55 +10789,7 @@
               </a:defRPr>
             </a:pPr>
             <a:r>
-              <a:t>• STAGE 2: Signal Feature Engineering (5-Cycle Rolling Mean av1-av21 &amp; Rolling Std sd1-sd21).</a:t>
-            </a:r>
-          </a:p>
-          <a:p>
-            <a:pPr>
-              <a:spcAft>
-                <a:spcPts val="1400"/>
-              </a:spcAft>
-              <a:defRPr sz="2000" b="1">
-                <a:solidFill>
-                  <a:srgbClr val="334155"/>
-                </a:solidFill>
-                <a:latin typeface="Calibri"/>
-              </a:defRPr>
-            </a:pPr>
-            <a:r>
-              <a:t>• STAGE 3: Multicollinearity Filtering (Removes redundant sensor pairs with r &gt; 0.80).</a:t>
-            </a:r>
-          </a:p>
-          <a:p>
-            <a:pPr>
-              <a:spcAft>
-                <a:spcPts val="1400"/>
-              </a:spcAft>
-              <a:defRPr sz="2000" b="1">
-                <a:solidFill>
-                  <a:srgbClr val="334155"/>
-                </a:solidFill>
-                <a:latin typeface="Calibri"/>
-              </a:defRPr>
-            </a:pPr>
-            <a:r>
-              <a:t>• STAGE 4: Tri-Model AI Engine (Random Forest Regressor, Binary Classifier &amp; MLP Neural Net).</a:t>
-            </a:r>
-          </a:p>
-          <a:p>
-            <a:pPr>
-              <a:spcAft>
-                <a:spcPts val="1400"/>
-              </a:spcAft>
-              <a:defRPr sz="2000" b="1">
-                <a:solidFill>
-                  <a:srgbClr val="334155"/>
-                </a:solidFill>
-                <a:latin typeface="Calibri"/>
-              </a:defRPr>
-            </a:pPr>
-            <a:r>
-              <a:t>• STAGE 5: Real-Time Diagnostic CLI Runner (predict.py &amp; 3-Tier Risk Hazard Dispatch).</a:t>
+              <a:t>(NASA C-MAPSS 21 Sensors)</a:t>
             </a:r>
           </a:p>
         </p:txBody>
@@ -10875,7 +10809,7 @@
             <a:avLst/>
           </a:prstGeom>
           <a:solidFill>
-            <a:srgbClr val="0D6EFD"/>
+            <a:srgbClr val="0284C7"/>
           </a:solidFill>
           <a:ln>
             <a:noFill/>
@@ -10918,11 +10852,11 @@
             <a:avLst/>
           </a:prstGeom>
           <a:solidFill>
-            <a:srgbClr val="E0F2FE"/>
+            <a:srgbClr val="F1F5F9"/>
           </a:solidFill>
-          <a:ln w="31750">
+          <a:ln w="19050">
             <a:solidFill>
-              <a:srgbClr val="8B5CF6"/>
+              <a:srgbClr val="0284C7"/>
             </a:solidFill>
           </a:ln>
         </p:spPr>
@@ -10945,9 +10879,12 @@
           <a:lstStyle/>
           <a:p>
             <a:pPr algn="ctr">
-              <a:defRPr sz="1300" b="1">
-                <a:solidFill>
-                  <a:srgbClr val="8B5CF6"/>
+              <a:spcAft>
+                <a:spcPts val="400"/>
+              </a:spcAft>
+              <a:defRPr sz="1600" b="1">
+                <a:solidFill>
+                  <a:srgbClr val="0284C7"/>
                 </a:solidFill>
                 <a:latin typeface="Calibri"/>
               </a:defRPr>
@@ -10965,12 +10902,31 @@
                 <a:latin typeface="Calibri"/>
               </a:defRPr>
             </a:pPr>
-            <a:r>
-              <a:t>MediaPipe Extraction</a:t>
-            </a:r>
-            <a:br/>
-            <a:r>
-              <a:t>(Hands &amp; Pose Joints)</a:t>
+          </a:p>
+          <a:p>
+            <a:pPr algn="ctr">
+              <a:defRPr sz="1400" b="1">
+                <a:solidFill>
+                  <a:srgbClr val="0F172A"/>
+                </a:solidFill>
+                <a:latin typeface="Calibri"/>
+              </a:defRPr>
+            </a:pPr>
+            <a:r>
+              <a:t>Rolling Feature Engine</a:t>
+            </a:r>
+          </a:p>
+          <a:p>
+            <a:pPr algn="ctr">
+              <a:defRPr sz="1200">
+                <a:solidFill>
+                  <a:srgbClr val="334155"/>
+                </a:solidFill>
+                <a:latin typeface="Calibri"/>
+              </a:defRPr>
+            </a:pPr>
+            <a:r>
+              <a:t>(5-Cycle Mean &amp; Std)</a:t>
             </a:r>
           </a:p>
         </p:txBody>
@@ -10990,7 +10946,7 @@
             <a:avLst/>
           </a:prstGeom>
           <a:solidFill>
-            <a:srgbClr val="8B5CF6"/>
+            <a:srgbClr val="0284C7"/>
           </a:solidFill>
           <a:ln>
             <a:noFill/>
@@ -11033,11 +10989,11 @@
             <a:avLst/>
           </a:prstGeom>
           <a:solidFill>
-            <a:srgbClr val="E0F2FE"/>
+            <a:srgbClr val="F1F5F9"/>
           </a:solidFill>
-          <a:ln w="31750">
+          <a:ln w="19050">
             <a:solidFill>
-              <a:srgbClr val="0D6EFD"/>
+              <a:srgbClr val="0284C7"/>
             </a:solidFill>
           </a:ln>
         </p:spPr>
@@ -11060,9 +11016,12 @@
           <a:lstStyle/>
           <a:p>
             <a:pPr algn="ctr">
-              <a:defRPr sz="1300" b="1">
-                <a:solidFill>
-                  <a:srgbClr val="0D6EFD"/>
+              <a:spcAft>
+                <a:spcPts val="400"/>
+              </a:spcAft>
+              <a:defRPr sz="1600" b="1">
+                <a:solidFill>
+                  <a:srgbClr val="0284C7"/>
                 </a:solidFill>
                 <a:latin typeface="Calibri"/>
               </a:defRPr>
@@ -11080,12 +11039,31 @@
                 <a:latin typeface="Calibri"/>
               </a:defRPr>
             </a:pPr>
-            <a:r>
-              <a:t>Sliding Window</a:t>
-            </a:r>
-            <a:br/>
-            <a:r>
-              <a:t>(0.5s Feature Aggregation)</a:t>
+          </a:p>
+          <a:p>
+            <a:pPr algn="ctr">
+              <a:defRPr sz="1400" b="1">
+                <a:solidFill>
+                  <a:srgbClr val="0F172A"/>
+                </a:solidFill>
+                <a:latin typeface="Calibri"/>
+              </a:defRPr>
+            </a:pPr>
+            <a:r>
+              <a:t>Multicollinearity Filter</a:t>
+            </a:r>
+          </a:p>
+          <a:p>
+            <a:pPr algn="ctr">
+              <a:defRPr sz="1200">
+                <a:solidFill>
+                  <a:srgbClr val="334155"/>
+                </a:solidFill>
+                <a:latin typeface="Calibri"/>
+              </a:defRPr>
+            </a:pPr>
+            <a:r>
+              <a:t>(Correlation Reduction r&gt;0.80)</a:t>
             </a:r>
           </a:p>
         </p:txBody>
@@ -11105,11 +11083,11 @@
             <a:avLst/>
           </a:prstGeom>
           <a:solidFill>
-            <a:srgbClr val="E0F2FE"/>
+            <a:srgbClr val="F1F5F9"/>
           </a:solidFill>
-          <a:ln w="31750">
+          <a:ln w="19050">
             <a:solidFill>
-              <a:srgbClr val="0F172A"/>
+              <a:srgbClr val="0284C7"/>
             </a:solidFill>
           </a:ln>
         </p:spPr>
@@ -11132,9 +11110,12 @@
           <a:lstStyle/>
           <a:p>
             <a:pPr algn="ctr">
-              <a:defRPr sz="1300" b="1">
-                <a:solidFill>
-                  <a:srgbClr val="0F172A"/>
+              <a:spcAft>
+                <a:spcPts val="400"/>
+              </a:spcAft>
+              <a:defRPr sz="1600" b="1">
+                <a:solidFill>
+                  <a:srgbClr val="0284C7"/>
                 </a:solidFill>
                 <a:latin typeface="Calibri"/>
               </a:defRPr>
@@ -11152,12 +11133,31 @@
                 <a:latin typeface="Calibri"/>
               </a:defRPr>
             </a:pPr>
-            <a:r>
-              <a:t>Normalization</a:t>
-            </a:r>
-            <a:br/>
-            <a:r>
-              <a:t>(StandardScaler Normalizer)</a:t>
+          </a:p>
+          <a:p>
+            <a:pPr algn="ctr">
+              <a:defRPr sz="1400" b="1">
+                <a:solidFill>
+                  <a:srgbClr val="0F172A"/>
+                </a:solidFill>
+                <a:latin typeface="Calibri"/>
+              </a:defRPr>
+            </a:pPr>
+            <a:r>
+              <a:t>RUL Regression Net</a:t>
+            </a:r>
+          </a:p>
+          <a:p>
+            <a:pPr algn="ctr">
+              <a:defRPr sz="1200">
+                <a:solidFill>
+                  <a:srgbClr val="334155"/>
+                </a:solidFill>
+                <a:latin typeface="Calibri"/>
+              </a:defRPr>
+            </a:pPr>
+            <a:r>
+              <a:t>(Random Forest Regressor)</a:t>
             </a:r>
           </a:p>
         </p:txBody>
@@ -11170,14 +11170,14 @@
         </p:nvSpPr>
         <p:spPr>
           <a:xfrm>
-            <a:off x="2788920" y="4251959"/>
+            <a:off x="2788920" y="4251960"/>
             <a:ext cx="457200" cy="274320"/>
           </a:xfrm>
           <a:prstGeom prst="rightArrow">
             <a:avLst/>
           </a:prstGeom>
           <a:solidFill>
-            <a:srgbClr val="0F172A"/>
+            <a:srgbClr val="0284C7"/>
           </a:solidFill>
           <a:ln>
             <a:noFill/>
@@ -11220,11 +11220,11 @@
             <a:avLst/>
           </a:prstGeom>
           <a:solidFill>
-            <a:srgbClr val="E0F2FE"/>
+            <a:srgbClr val="F1F5F9"/>
           </a:solidFill>
-          <a:ln w="31750">
+          <a:ln w="19050">
             <a:solidFill>
-              <a:srgbClr val="8B5CF6"/>
+              <a:srgbClr val="0284C7"/>
             </a:solidFill>
           </a:ln>
         </p:spPr>
@@ -11247,9 +11247,12 @@
           <a:lstStyle/>
           <a:p>
             <a:pPr algn="ctr">
-              <a:defRPr sz="1300" b="1">
-                <a:solidFill>
-                  <a:srgbClr val="8B5CF6"/>
+              <a:spcAft>
+                <a:spcPts val="400"/>
+              </a:spcAft>
+              <a:defRPr sz="1600" b="1">
+                <a:solidFill>
+                  <a:srgbClr val="0284C7"/>
                 </a:solidFill>
                 <a:latin typeface="Calibri"/>
               </a:defRPr>
@@ -11267,12 +11270,31 @@
                 <a:latin typeface="Calibri"/>
               </a:defRPr>
             </a:pPr>
-            <a:r>
-              <a:t>LSTM Sequence Net</a:t>
-            </a:r>
-            <a:br/>
-            <a:r>
-              <a:t>(5-Window Input Tensor)</a:t>
+          </a:p>
+          <a:p>
+            <a:pPr algn="ctr">
+              <a:defRPr sz="1400" b="1">
+                <a:solidFill>
+                  <a:srgbClr val="0F172A"/>
+                </a:solidFill>
+                <a:latin typeface="Calibri"/>
+              </a:defRPr>
+            </a:pPr>
+            <a:r>
+              <a:t>Binary 30d Classifier</a:t>
+            </a:r>
+          </a:p>
+          <a:p>
+            <a:pPr algn="ctr">
+              <a:defRPr sz="1200">
+                <a:solidFill>
+                  <a:srgbClr val="334155"/>
+                </a:solidFill>
+                <a:latin typeface="Calibri"/>
+              </a:defRPr>
+            </a:pPr>
+            <a:r>
+              <a:t>(98.45% AUC-ROC Model)</a:t>
             </a:r>
           </a:p>
         </p:txBody>
@@ -11285,14 +11307,14 @@
         </p:nvSpPr>
         <p:spPr>
           <a:xfrm>
-            <a:off x="5532120" y="4251959"/>
+            <a:off x="5532120" y="4251960"/>
             <a:ext cx="457200" cy="274320"/>
           </a:xfrm>
           <a:prstGeom prst="rightArrow">
             <a:avLst/>
           </a:prstGeom>
           <a:solidFill>
-            <a:srgbClr val="8B5CF6"/>
+            <a:srgbClr val="0284C7"/>
           </a:solidFill>
           <a:ln>
             <a:noFill/>
@@ -11335,11 +11357,11 @@
             <a:avLst/>
           </a:prstGeom>
           <a:solidFill>
-            <a:srgbClr val="E0F2FE"/>
+            <a:srgbClr val="F1F5F9"/>
           </a:solidFill>
-          <a:ln w="31750">
+          <a:ln w="19050">
             <a:solidFill>
-              <a:srgbClr val="10B981"/>
+              <a:srgbClr val="0284C7"/>
             </a:solidFill>
           </a:ln>
         </p:spPr>
@@ -11362,9 +11384,12 @@
           <a:lstStyle/>
           <a:p>
             <a:pPr algn="ctr">
-              <a:defRPr sz="1300" b="1">
-                <a:solidFill>
-                  <a:srgbClr val="10B981"/>
+              <a:spcAft>
+                <a:spcPts val="400"/>
+              </a:spcAft>
+              <a:defRPr sz="1600" b="1">
+                <a:solidFill>
+                  <a:srgbClr val="0284C7"/>
                 </a:solidFill>
                 <a:latin typeface="Calibri"/>
               </a:defRPr>
@@ -11382,12 +11407,31 @@
                 <a:latin typeface="Calibri"/>
               </a:defRPr>
             </a:pPr>
-            <a:r>
-              <a:t>GUI &amp; Audio Speech</a:t>
-            </a:r>
-            <a:br/>
-            <a:r>
-              <a:t>(Hero Box + Pyttsx3 TTS)</a:t>
+          </a:p>
+          <a:p>
+            <a:pPr algn="ctr">
+              <a:defRPr sz="1400" b="1">
+                <a:solidFill>
+                  <a:srgbClr val="0F172A"/>
+                </a:solidFill>
+                <a:latin typeface="Calibri"/>
+              </a:defRPr>
+            </a:pPr>
+            <a:r>
+              <a:t>Multi-Class Neural MLP</a:t>
+            </a:r>
+          </a:p>
+          <a:p>
+            <a:pPr algn="ctr">
+              <a:defRPr sz="1200">
+                <a:solidFill>
+                  <a:srgbClr val="334155"/>
+                </a:solidFill>
+                <a:latin typeface="Calibri"/>
+              </a:defRPr>
+            </a:pPr>
+            <a:r>
+              <a:t>(3-Tier Risk Hazard Dispatch)</a:t>
             </a:r>
           </a:p>
         </p:txBody>
@@ -11423,7 +11467,7 @@
               </a:defRPr>
             </a:pPr>
             <a:r>
-              <a:t>Figure 1: End-to-End Real-Time Gesture Recognition Data Flow Pipeline</a:t>
+              <a:t>Figure 1: End-to-End Predictive Maintenance Data Flow &amp; Inference Pipeline Flowchart</a:t>
             </a:r>
           </a:p>
         </p:txBody>
@@ -11546,13 +11590,28 @@
               </a:spcAft>
               <a:defRPr sz="2000" b="1">
                 <a:solidFill>
+                  <a:srgbClr val="0F172A"/>
+                </a:solidFill>
+                <a:latin typeface="Calibri"/>
+              </a:defRPr>
+            </a:pPr>
+            <a:r>
+              <a:rPr sz="1800" b="1">
+                <a:solidFill>
+                  <a:srgbClr val="0F172A"/>
+                </a:solidFill>
+                <a:latin typeface="Calibri"/>
+              </a:rPr>
+              <a:t>• Rolling Window Aggregations: </a:t>
+            </a:r>
+            <a:r>
+              <a:rPr sz="1800" b="0">
+                <a:solidFill>
                   <a:srgbClr val="334155"/>
                 </a:solidFill>
                 <a:latin typeface="Calibri"/>
-              </a:defRPr>
-            </a:pPr>
-            <a:r>
-              <a:t>• Rolling Window Aggregations: Computes 5-cycle rolling mean (av) and rolling std (sd) per sensor.</a:t>
+              </a:rPr>
+              <a:t>Computes 5-cycle rolling mean (av) and rolling std (sd) per sensor.</a:t>
             </a:r>
           </a:p>
           <a:p>
@@ -11567,8 +11626,60 @@
                 <a:latin typeface="Calibri"/>
               </a:defRPr>
             </a:pPr>
-            <a:r>
-              <a:t>• Upper-Body Pose Landmarks: </a:t>
+          </a:p>
+          <a:p>
+            <a:pPr>
+              <a:spcAft>
+                <a:spcPts val="600"/>
+              </a:spcAft>
+              <a:defRPr sz="2000" b="1">
+                <a:solidFill>
+                  <a:srgbClr val="0F172A"/>
+                </a:solidFill>
+                <a:latin typeface="Calibri"/>
+              </a:defRPr>
+            </a:pPr>
+          </a:p>
+          <a:p>
+            <a:pPr>
+              <a:spcAft>
+                <a:spcPts val="600"/>
+              </a:spcAft>
+              <a:defRPr sz="2000" b="1">
+                <a:solidFill>
+                  <a:srgbClr val="0F172A"/>
+                </a:solidFill>
+                <a:latin typeface="Calibri"/>
+              </a:defRPr>
+            </a:pPr>
+          </a:p>
+          <a:p>
+            <a:pPr>
+              <a:spcAft>
+                <a:spcPts val="600"/>
+              </a:spcAft>
+              <a:defRPr sz="2000" b="1">
+                <a:solidFill>
+                  <a:srgbClr val="0F172A"/>
+                </a:solidFill>
+                <a:latin typeface="Calibri"/>
+              </a:defRPr>
+            </a:pPr>
+          </a:p>
+          <a:p>
+            <a:pPr>
+              <a:spcAft>
+                <a:spcPts val="1400"/>
+              </a:spcAft>
+            </a:pPr>
+            <a:r>
+              <a:rPr sz="1800" b="1">
+                <a:solidFill>
+                  <a:srgbClr val="0F172A"/>
+                </a:solidFill>
+                <a:latin typeface="Calibri"/>
+              </a:rPr>
+              <a:t>• Noise Reduction: </a:t>
             </a:r>
             <a:r>
               <a:rPr sz="1800" b="0">
@@ -11577,23 +11688,23 @@
                 </a:solidFill>
                 <a:latin typeface="Calibri"/>
               </a:rPr>
-              <a:t>Extracts 6 upper-body joints (shoulders, elbows, wrists) for posture tracking</a:t>
-            </a:r>
-          </a:p>
-          <a:p>
-            <a:pPr>
-              <a:spcAft>
-                <a:spcPts val="600"/>
-              </a:spcAft>
-              <a:defRPr sz="2000" b="1">
-                <a:solidFill>
-                  <a:srgbClr val="0F172A"/>
-                </a:solidFill>
-                <a:latin typeface="Calibri"/>
-              </a:defRPr>
-            </a:pPr>
-            <a:r>
-              <a:t>• Statistical Feature Aggregation: </a:t>
+              <a:t>Smooths high-frequency sensor fluctuation to expose true degradation physics.</a:t>
+            </a:r>
+          </a:p>
+          <a:p>
+            <a:pPr>
+              <a:spcAft>
+                <a:spcPts val="1400"/>
+              </a:spcAft>
+            </a:pPr>
+            <a:r>
+              <a:rPr sz="1800" b="1">
+                <a:solidFill>
+                  <a:srgbClr val="0F172A"/>
+                </a:solidFill>
+                <a:latin typeface="Calibri"/>
+              </a:rPr>
+              <a:t>• Multicollinearity Filtering: </a:t>
             </a:r>
             <a:r>
               <a:rPr sz="1800" b="0">
@@ -11602,23 +11713,23 @@
                 </a:solidFill>
                 <a:latin typeface="Calibri"/>
               </a:rPr>
-              <a:t>Computes Mean and Standard Deviation per 0.5s sliding window (~7-8 frames)</a:t>
-            </a:r>
-          </a:p>
-          <a:p>
-            <a:pPr>
-              <a:spcAft>
-                <a:spcPts val="600"/>
-              </a:spcAft>
-              <a:defRPr sz="2000" b="1">
-                <a:solidFill>
-                  <a:srgbClr val="0F172A"/>
-                </a:solidFill>
-                <a:latin typeface="Calibri"/>
-              </a:defRPr>
-            </a:pPr>
-            <a:r>
-              <a:t>• Scale &amp; Position Invariance: </a:t>
+              <a:t>Eliminates highly correlated sensor pairs like (s14, s9) with r &gt; 0.80.</a:t>
+            </a:r>
+          </a:p>
+          <a:p>
+            <a:pPr>
+              <a:spcAft>
+                <a:spcPts val="1400"/>
+              </a:spcAft>
+            </a:pPr>
+            <a:r>
+              <a:rPr sz="1800" b="1">
+                <a:solidFill>
+                  <a:srgbClr val="0F172A"/>
+                </a:solidFill>
+                <a:latin typeface="Calibri"/>
+              </a:rPr>
+              <a:t>• Expanded Feature Space: </a:t>
             </a:r>
             <a:r>
               <a:rPr sz="1800" b="0">
@@ -11627,80 +11738,7 @@
                 </a:solidFill>
                 <a:latin typeface="Calibri"/>
               </a:rPr>
-              <a:t>StandardScaler normalization ensures robustness regardless of signer camera distance</a:t>
-            </a:r>
-          </a:p>
-          <a:p>
-            <a:pPr>
-              <a:spcAft>
-                <a:spcPts val="600"/>
-              </a:spcAft>
-              <a:defRPr sz="2000" b="1">
-                <a:solidFill>
-                  <a:srgbClr val="0F172A"/>
-                </a:solidFill>
-                <a:latin typeface="Calibri"/>
-              </a:defRPr>
-            </a:pPr>
-            <a:r>
-              <a:t>• Compact Vector Dimension: </a:t>
-            </a:r>
-            <a:r>
-              <a:rPr sz="1800" b="0">
-                <a:solidFill>
-                  <a:srgbClr val="334155"/>
-                </a:solidFill>
-                <a:latin typeface="Calibri"/>
-              </a:rPr>
-              <a:t>Reduces full video frame data into a compact 18-element feature vector per window</a:t>
-            </a:r>
-          </a:p>
-          <a:p>
-            <a:pPr>
-              <a:spcAft>
-                <a:spcPts val="1400"/>
-              </a:spcAft>
-              <a:defRPr sz="2000" b="1">
-                <a:solidFill>
-                  <a:srgbClr val="334155"/>
-                </a:solidFill>
-                <a:latin typeface="Calibri"/>
-              </a:defRPr>
-            </a:pPr>
-            <a:r>
-              <a:t>• Noise Reduction: Smooths high-frequency sensor fluctuation to expose true degradation physics.</a:t>
-            </a:r>
-          </a:p>
-          <a:p>
-            <a:pPr>
-              <a:spcAft>
-                <a:spcPts val="1400"/>
-              </a:spcAft>
-              <a:defRPr sz="2000" b="1">
-                <a:solidFill>
-                  <a:srgbClr val="334155"/>
-                </a:solidFill>
-                <a:latin typeface="Calibri"/>
-              </a:defRPr>
-            </a:pPr>
-            <a:r>
-              <a:t>• Multicollinearity Filtering: Eliminates highly correlated sensor pairs like (s14, s9) with r &gt; 0.80.</a:t>
-            </a:r>
-          </a:p>
-          <a:p>
-            <a:pPr>
-              <a:spcAft>
-                <a:spcPts val="1400"/>
-              </a:spcAft>
-              <a:defRPr sz="2000" b="1">
-                <a:solidFill>
-                  <a:srgbClr val="334155"/>
-                </a:solidFill>
-                <a:latin typeface="Calibri"/>
-              </a:defRPr>
-            </a:pPr>
-            <a:r>
-              <a:t>• Expanded Feature Space: Generates 45 total input attributes for machine learning model training.</a:t>
+              <a:t>Generates 45 total input attributes for machine learning model training.</a:t>
             </a:r>
           </a:p>
         </p:txBody>
@@ -11823,13 +11861,28 @@
               </a:spcAft>
               <a:defRPr sz="2000" b="1">
                 <a:solidFill>
+                  <a:srgbClr val="0F172A"/>
+                </a:solidFill>
+                <a:latin typeface="Calibri"/>
+              </a:defRPr>
+            </a:pPr>
+            <a:r>
+              <a:rPr sz="1800" b="1">
+                <a:solidFill>
+                  <a:srgbClr val="0F172A"/>
+                </a:solidFill>
+                <a:latin typeface="Calibri"/>
+              </a:rPr>
+              <a:t>• Data Provider: </a:t>
+            </a:r>
+            <a:r>
+              <a:rPr sz="1800" b="0">
+                <a:solidFill>
                   <a:srgbClr val="334155"/>
                 </a:solidFill>
                 <a:latin typeface="Calibri"/>
-              </a:defRPr>
-            </a:pPr>
-            <a:r>
-              <a:t>• Data Provider: NASA Ames Prognostics Center of Excellence C-MAPSS Simulation Dataset.</a:t>
+              </a:rPr>
+              <a:t>NASA Ames Prognostics Center of Excellence C-MAPSS Simulation Dataset.</a:t>
             </a:r>
           </a:p>
           <a:p>
@@ -11844,8 +11897,60 @@
                 <a:latin typeface="Calibri"/>
               </a:defRPr>
             </a:pPr>
-            <a:r>
-              <a:t>• Target Sign Vocabulary: </a:t>
+          </a:p>
+          <a:p>
+            <a:pPr>
+              <a:spcAft>
+                <a:spcPts val="600"/>
+              </a:spcAft>
+              <a:defRPr sz="2000" b="1">
+                <a:solidFill>
+                  <a:srgbClr val="0F172A"/>
+                </a:solidFill>
+                <a:latin typeface="Calibri"/>
+              </a:defRPr>
+            </a:pPr>
+          </a:p>
+          <a:p>
+            <a:pPr>
+              <a:spcAft>
+                <a:spcPts val="600"/>
+              </a:spcAft>
+              <a:defRPr sz="2000" b="1">
+                <a:solidFill>
+                  <a:srgbClr val="0F172A"/>
+                </a:solidFill>
+                <a:latin typeface="Calibri"/>
+              </a:defRPr>
+            </a:pPr>
+          </a:p>
+          <a:p>
+            <a:pPr>
+              <a:spcAft>
+                <a:spcPts val="600"/>
+              </a:spcAft>
+              <a:defRPr sz="2000" b="1">
+                <a:solidFill>
+                  <a:srgbClr val="0F172A"/>
+                </a:solidFill>
+                <a:latin typeface="Calibri"/>
+              </a:defRPr>
+            </a:pPr>
+          </a:p>
+          <a:p>
+            <a:pPr>
+              <a:spcAft>
+                <a:spcPts val="1400"/>
+              </a:spcAft>
+            </a:pPr>
+            <a:r>
+              <a:rPr sz="1800" b="1">
+                <a:solidFill>
+                  <a:srgbClr val="0F172A"/>
+                </a:solidFill>
+                <a:latin typeface="Calibri"/>
+              </a:rPr>
+              <a:t>• Training Fleet Size: </a:t>
             </a:r>
             <a:r>
               <a:rPr sz="1800" b="0">
@@ -11854,23 +11959,23 @@
                 </a:solidFill>
                 <a:latin typeface="Calibri"/>
               </a:rPr>
-              <a:t>Afternoon, Age, Boy, Country, Day, Monday, Name, Night, People, Person, Time</a:t>
-            </a:r>
-          </a:p>
-          <a:p>
-            <a:pPr>
-              <a:spcAft>
-                <a:spcPts val="600"/>
-              </a:spcAft>
-              <a:defRPr sz="2000" b="1">
-                <a:solidFill>
-                  <a:srgbClr val="0F172A"/>
-                </a:solidFill>
-                <a:latin typeface="Calibri"/>
-              </a:defRPr>
-            </a:pPr>
-            <a:r>
-              <a:t>• Temporal Window Length: </a:t>
+              <a:t>100 turbofan engines run-to-failure containing 20,631 operational cycles.</a:t>
+            </a:r>
+          </a:p>
+          <a:p>
+            <a:pPr>
+              <a:spcAft>
+                <a:spcPts val="1400"/>
+              </a:spcAft>
+            </a:pPr>
+            <a:r>
+              <a:rPr sz="1800" b="1">
+                <a:solidFill>
+                  <a:srgbClr val="0F172A"/>
+                </a:solidFill>
+                <a:latin typeface="Calibri"/>
+              </a:rPr>
+              <a:t>• Testing Fleet Size: </a:t>
             </a:r>
             <a:r>
               <a:rPr sz="1800" b="0">
@@ -11879,23 +11984,23 @@
                 </a:solidFill>
                 <a:latin typeface="Calibri"/>
               </a:rPr>
-              <a:t>Fixed 0.5-second sliding window duration (target sampling rate: 15 FPS)</a:t>
-            </a:r>
-          </a:p>
-          <a:p>
-            <a:pPr>
-              <a:spcAft>
-                <a:spcPts val="600"/>
-              </a:spcAft>
-              <a:defRPr sz="2000" b="1">
-                <a:solidFill>
-                  <a:srgbClr val="0F172A"/>
-                </a:solidFill>
-                <a:latin typeface="Calibri"/>
-              </a:defRPr>
-            </a:pPr>
-            <a:r>
-              <a:t>• Sequence Stacking: </a:t>
+              <a:t>100 engines with ground-truth Remaining Useful Life (TTF) validation labels.</a:t>
+            </a:r>
+          </a:p>
+          <a:p>
+            <a:pPr>
+              <a:spcAft>
+                <a:spcPts val="1400"/>
+              </a:spcAft>
+            </a:pPr>
+            <a:r>
+              <a:rPr sz="1800" b="1">
+                <a:solidFill>
+                  <a:srgbClr val="0F172A"/>
+                </a:solidFill>
+                <a:latin typeface="Calibri"/>
+              </a:rPr>
+              <a:t>• Dataset Quality: </a:t>
             </a:r>
             <a:r>
               <a:rPr sz="1800" b="0">
@@ -11904,80 +12009,7 @@
                 </a:solidFill>
                 <a:latin typeface="Calibri"/>
               </a:rPr>
-              <a:t>5 consecutive feature windows stacked into an input matrix of shape (1, 5, 18)</a:t>
-            </a:r>
-          </a:p>
-          <a:p>
-            <a:pPr>
-              <a:spcAft>
-                <a:spcPts val="600"/>
-              </a:spcAft>
-              <a:defRPr sz="2000" b="1">
-                <a:solidFill>
-                  <a:srgbClr val="0F172A"/>
-                </a:solidFill>
-                <a:latin typeface="Calibri"/>
-              </a:defRPr>
-            </a:pPr>
-            <a:r>
-              <a:t>• Database Storage: </a:t>
-            </a:r>
-            <a:r>
-              <a:rPr sz="1800" b="0">
-                <a:solidFill>
-                  <a:srgbClr val="334155"/>
-                </a:solidFill>
-                <a:latin typeface="Calibri"/>
-              </a:rPr>
-              <a:t>Stored using SQLite schema tracking video metadata, frame landmarks, and feature matrices</a:t>
-            </a:r>
-          </a:p>
-          <a:p>
-            <a:pPr>
-              <a:spcAft>
-                <a:spcPts val="1400"/>
-              </a:spcAft>
-              <a:defRPr sz="2000" b="1">
-                <a:solidFill>
-                  <a:srgbClr val="334155"/>
-                </a:solidFill>
-                <a:latin typeface="Calibri"/>
-              </a:defRPr>
-            </a:pPr>
-            <a:r>
-              <a:t>• Training Fleet Size: 100 turbofan engines run-to-failure containing 20,631 operational cycles.</a:t>
-            </a:r>
-          </a:p>
-          <a:p>
-            <a:pPr>
-              <a:spcAft>
-                <a:spcPts val="1400"/>
-              </a:spcAft>
-              <a:defRPr sz="2000" b="1">
-                <a:solidFill>
-                  <a:srgbClr val="334155"/>
-                </a:solidFill>
-                <a:latin typeface="Calibri"/>
-              </a:defRPr>
-            </a:pPr>
-            <a:r>
-              <a:t>• Testing Fleet Size: 100 engines with ground-truth Remaining Useful Life (TTF) validation labels.</a:t>
-            </a:r>
-          </a:p>
-          <a:p>
-            <a:pPr>
-              <a:spcAft>
-                <a:spcPts val="1400"/>
-              </a:spcAft>
-              <a:defRPr sz="2000" b="1">
-                <a:solidFill>
-                  <a:srgbClr val="334155"/>
-                </a:solidFill>
-                <a:latin typeface="Calibri"/>
-              </a:defRPr>
-            </a:pPr>
-            <a:r>
-              <a:t>• Dataset Quality: Zero missing values, numeric sensor streams, preprocessed clean target series.</a:t>
+              <a:t>Zero missing values, numeric sensor streams, preprocessed clean target series.</a:t>
             </a:r>
           </a:p>
         </p:txBody>
@@ -12100,13 +12132,28 @@
               </a:spcAft>
               <a:defRPr sz="2000" b="1">
                 <a:solidFill>
+                  <a:srgbClr val="0F172A"/>
+                </a:solidFill>
+                <a:latin typeface="Calibri"/>
+              </a:defRPr>
+            </a:pPr>
+            <a:r>
+              <a:rPr sz="1800" b="1">
+                <a:solidFill>
+                  <a:srgbClr val="0F172A"/>
+                </a:solidFill>
+                <a:latin typeface="Calibri"/>
+              </a:rPr>
+              <a:t>• 1. RUL Regression Model: </a:t>
+            </a:r>
+            <a:r>
+              <a:rPr sz="1800" b="0">
+                <a:solidFill>
                   <a:srgbClr val="334155"/>
                 </a:solidFill>
                 <a:latin typeface="Calibri"/>
-              </a:defRPr>
-            </a:pPr>
-            <a:r>
-              <a:t>• 1. RUL Regression Model: Random Forest Regressor predicting exact cycles left before failure.</a:t>
+              </a:rPr>
+              <a:t>Random Forest Regressor predicting exact cycles left before failure.</a:t>
             </a:r>
           </a:p>
           <a:p>
@@ -12121,8 +12168,60 @@
                 <a:latin typeface="Calibri"/>
               </a:defRPr>
             </a:pPr>
-            <a:r>
-              <a:t>• LSTM Layer 1: </a:t>
+          </a:p>
+          <a:p>
+            <a:pPr>
+              <a:spcAft>
+                <a:spcPts val="600"/>
+              </a:spcAft>
+              <a:defRPr sz="2000" b="1">
+                <a:solidFill>
+                  <a:srgbClr val="0F172A"/>
+                </a:solidFill>
+                <a:latin typeface="Calibri"/>
+              </a:defRPr>
+            </a:pPr>
+          </a:p>
+          <a:p>
+            <a:pPr>
+              <a:spcAft>
+                <a:spcPts val="600"/>
+              </a:spcAft>
+              <a:defRPr sz="2000" b="1">
+                <a:solidFill>
+                  <a:srgbClr val="0F172A"/>
+                </a:solidFill>
+                <a:latin typeface="Calibri"/>
+              </a:defRPr>
+            </a:pPr>
+          </a:p>
+          <a:p>
+            <a:pPr>
+              <a:spcAft>
+                <a:spcPts val="600"/>
+              </a:spcAft>
+              <a:defRPr sz="2000" b="1">
+                <a:solidFill>
+                  <a:srgbClr val="0F172A"/>
+                </a:solidFill>
+                <a:latin typeface="Calibri"/>
+              </a:defRPr>
+            </a:pPr>
+          </a:p>
+          <a:p>
+            <a:pPr>
+              <a:spcAft>
+                <a:spcPts val="1400"/>
+              </a:spcAft>
+            </a:pPr>
+            <a:r>
+              <a:rPr sz="1800" b="1">
+                <a:solidFill>
+                  <a:srgbClr val="0F172A"/>
+                </a:solidFill>
+                <a:latin typeface="Calibri"/>
+              </a:rPr>
+              <a:t>• 2. Binary 30-Cycle Warning Classifier: </a:t>
             </a:r>
             <a:r>
               <a:rPr sz="1800" b="0">
@@ -12131,23 +12230,23 @@
                 </a:solidFill>
                 <a:latin typeface="Calibri"/>
               </a:rPr>
-              <a:t>128 Recurrent LSTM Units with Dropout (0.3) &amp; Batch Normalization for regularization</a:t>
-            </a:r>
-          </a:p>
-          <a:p>
-            <a:pPr>
-              <a:spcAft>
-                <a:spcPts val="600"/>
-              </a:spcAft>
-              <a:defRPr sz="2000" b="1">
-                <a:solidFill>
-                  <a:srgbClr val="0F172A"/>
-                </a:solidFill>
-                <a:latin typeface="Calibri"/>
-              </a:defRPr>
-            </a:pPr>
-            <a:r>
-              <a:t>• LSTM Layer 2: </a:t>
+              <a:t>Random Forest Classifier predicting 30d failure window.</a:t>
+            </a:r>
+          </a:p>
+          <a:p>
+            <a:pPr>
+              <a:spcAft>
+                <a:spcPts val="1400"/>
+              </a:spcAft>
+            </a:pPr>
+            <a:r>
+              <a:rPr sz="1800" b="1">
+                <a:solidFill>
+                  <a:srgbClr val="0F172A"/>
+                </a:solidFill>
+                <a:latin typeface="Calibri"/>
+              </a:rPr>
+              <a:t>• 3. Multi-Class Neural MLP: </a:t>
             </a:r>
             <a:r>
               <a:rPr sz="1800" b="0">
@@ -12156,23 +12255,23 @@
                 </a:solidFill>
                 <a:latin typeface="Calibri"/>
               </a:rPr>
-              <a:t>64 Recurrent LSTM Units capturing higher-level temporal gesture dynamics</a:t>
-            </a:r>
-          </a:p>
-          <a:p>
-            <a:pPr>
-              <a:spcAft>
-                <a:spcPts val="600"/>
-              </a:spcAft>
-              <a:defRPr sz="2000" b="1">
-                <a:solidFill>
-                  <a:srgbClr val="0F172A"/>
-                </a:solidFill>
-                <a:latin typeface="Calibri"/>
-              </a:defRPr>
-            </a:pPr>
-            <a:r>
-              <a:t>• Dense Classification Layer: </a:t>
+              <a:t>Multi-Layer Perceptron (100, 50 hidden neurons) for 3-tier hazard rating.</a:t>
+            </a:r>
+          </a:p>
+          <a:p>
+            <a:pPr>
+              <a:spcAft>
+                <a:spcPts val="1400"/>
+              </a:spcAft>
+            </a:pPr>
+            <a:r>
+              <a:rPr sz="1800" b="1">
+                <a:solidFill>
+                  <a:srgbClr val="0F172A"/>
+                </a:solidFill>
+                <a:latin typeface="Calibri"/>
+              </a:rPr>
+              <a:t>• Multi-Tier Risk Classes: </a:t>
             </a:r>
             <a:r>
               <a:rPr sz="1800" b="0">
@@ -12181,80 +12280,7 @@
                 </a:solidFill>
                 <a:latin typeface="Calibri"/>
               </a:rPr>
-              <a:t>64 Dense Neurons with ReLU activation &amp; Dropout (0.3)</a:t>
-            </a:r>
-          </a:p>
-          <a:p>
-            <a:pPr>
-              <a:spcAft>
-                <a:spcPts val="600"/>
-              </a:spcAft>
-              <a:defRPr sz="2000" b="1">
-                <a:solidFill>
-                  <a:srgbClr val="0F172A"/>
-                </a:solidFill>
-                <a:latin typeface="Calibri"/>
-              </a:defRPr>
-            </a:pPr>
-            <a:r>
-              <a:t>• Output Softmax Layer: </a:t>
-            </a:r>
-            <a:r>
-              <a:rPr sz="1800" b="0">
-                <a:solidFill>
-                  <a:srgbClr val="334155"/>
-                </a:solidFill>
-                <a:latin typeface="Calibri"/>
-              </a:rPr>
-              <a:t>11 Output Neurons producing Softmax confidence probabilities over sign vocabulary</a:t>
-            </a:r>
-          </a:p>
-          <a:p>
-            <a:pPr>
-              <a:spcAft>
-                <a:spcPts val="1400"/>
-              </a:spcAft>
-              <a:defRPr sz="2000" b="1">
-                <a:solidFill>
-                  <a:srgbClr val="334155"/>
-                </a:solidFill>
-                <a:latin typeface="Calibri"/>
-              </a:defRPr>
-            </a:pPr>
-            <a:r>
-              <a:t>• 2. Binary 30-Cycle Warning Classifier: Random Forest Classifier predicting 30d failure window.</a:t>
-            </a:r>
-          </a:p>
-          <a:p>
-            <a:pPr>
-              <a:spcAft>
-                <a:spcPts val="1400"/>
-              </a:spcAft>
-              <a:defRPr sz="2000" b="1">
-                <a:solidFill>
-                  <a:srgbClr val="334155"/>
-                </a:solidFill>
-                <a:latin typeface="Calibri"/>
-              </a:defRPr>
-            </a:pPr>
-            <a:r>
-              <a:t>• 3. Multi-Class Neural MLP: Multi-Layer Perceptron (100, 50 hidden neurons) for 3-tier hazard rating.</a:t>
-            </a:r>
-          </a:p>
-          <a:p>
-            <a:pPr>
-              <a:spcAft>
-                <a:spcPts val="1400"/>
-              </a:spcAft>
-              <a:defRPr sz="2000" b="1">
-                <a:solidFill>
-                  <a:srgbClr val="334155"/>
-                </a:solidFill>
-                <a:latin typeface="Calibri"/>
-              </a:defRPr>
-            </a:pPr>
-            <a:r>
-              <a:t>• Multi-Tier Risk Classes: Healthy (&gt;30 cycles), Warning (15-30 cycles), Critical (&lt;=15 cycles).</a:t>
+              <a:t>Healthy (&gt;30 cycles), Warning (15-30 cycles), Critical (&lt;=15 cycles).</a:t>
             </a:r>
           </a:p>
         </p:txBody>

</xml_diff>

<commit_message>
Update 18-slide presentation with exact bullet line-wrapping, stage text cards, and slide alignments
</commit_message>
<xml_diff>
--- a/Internship Presentation PPTs Template Final.pptx
+++ b/Internship Presentation PPTs Template Final.pptx
@@ -5609,7 +5609,7 @@
             <a:pPr algn="r">
               <a:defRPr sz="1400">
                 <a:solidFill>
-                  <a:srgbClr val="64748B"/>
+                  <a:srgbClr val="334155"/>
                 </a:solidFill>
                 <a:latin typeface="Calibri"/>
               </a:defRPr>
@@ -5637,7 +5637,7 @@
           <a:noFill/>
         </p:spPr>
         <p:txBody>
-          <a:bodyPr wrap="square" lIns="0" tIns="0" rIns="0" bIns="0">
+          <a:bodyPr wrap="square">
             <a:spAutoFit/>
           </a:bodyPr>
           <a:lstStyle/>
@@ -5654,7 +5654,7 @@
               </a:defRPr>
             </a:pPr>
             <a:r>
-              <a:rPr sz="1800" b="1">
+              <a:rPr sz="2000" b="1">
                 <a:solidFill>
                   <a:srgbClr val="0F172A"/>
                 </a:solidFill>
@@ -5663,7 +5663,7 @@
               <a:t>• Command-Line Diagnostic Tool: </a:t>
             </a:r>
             <a:r>
-              <a:rPr sz="1800" b="0">
+              <a:rPr sz="2000" b="0">
                 <a:solidFill>
                   <a:srgbClr val="334155"/>
                 </a:solidFill>
@@ -5731,7 +5731,7 @@
               </a:spcAft>
             </a:pPr>
             <a:r>
-              <a:rPr sz="1800" b="1">
+              <a:rPr sz="2000" b="1">
                 <a:solidFill>
                   <a:srgbClr val="0F172A"/>
                 </a:solidFill>
@@ -5740,13 +5740,13 @@
               <a:t>• Execution Command: </a:t>
             </a:r>
             <a:r>
-              <a:rPr sz="1800" b="0">
+              <a:rPr sz="2000" b="0">
                 <a:solidFill>
                   <a:srgbClr val="334155"/>
                 </a:solidFill>
                 <a:latin typeface="Calibri"/>
               </a:rPr>
-              <a:t>python predict.py --engine_id 81</a:t>
+              <a:t>python predict.py --engine_id 81 (Evaluates any engine from fleet 1-100).</a:t>
             </a:r>
           </a:p>
           <a:p>
@@ -5756,7 +5756,7 @@
               </a:spcAft>
             </a:pPr>
             <a:r>
-              <a:rPr sz="1800" b="1">
+              <a:rPr sz="2000" b="1">
                 <a:solidFill>
                   <a:srgbClr val="0F172A"/>
                 </a:solidFill>
@@ -5765,7 +5765,7 @@
               <a:t>• Diagnostic Output Parameters: </a:t>
             </a:r>
             <a:r>
-              <a:rPr sz="1800" b="0">
+              <a:rPr sz="2000" b="0">
                 <a:solidFill>
                   <a:srgbClr val="334155"/>
                 </a:solidFill>
@@ -5781,7 +5781,32 @@
               </a:spcAft>
             </a:pPr>
             <a:r>
-              <a:rPr sz="1800" b="1">
+              <a:rPr sz="2000" b="1">
+                <a:solidFill>
+                  <a:srgbClr val="0F172A"/>
+                </a:solidFill>
+                <a:latin typeface="Calibri"/>
+              </a:rPr>
+              <a:t>• Risk Rating Formatting: </a:t>
+            </a:r>
+            <a:r>
+              <a:rPr sz="2000" b="0">
+                <a:solidFill>
+                  <a:srgbClr val="334155"/>
+                </a:solidFill>
+                <a:latin typeface="Calibri"/>
+              </a:rPr>
+              <a:t>Displays GREEN (Healthy), YELLOW (Warning), and RED (Critical) status.</a:t>
+            </a:r>
+          </a:p>
+          <a:p>
+            <a:pPr>
+              <a:spcAft>
+                <a:spcPts val="1400"/>
+              </a:spcAft>
+            </a:pPr>
+            <a:r>
+              <a:rPr sz="2000" b="1">
                 <a:solidFill>
                   <a:srgbClr val="0F172A"/>
                 </a:solidFill>
@@ -5790,7 +5815,7 @@
               <a:t>• Actionable Maintenance Recommendation: </a:t>
             </a:r>
             <a:r>
-              <a:rPr sz="1800" b="0">
+              <a:rPr sz="2000" b="0">
                 <a:solidFill>
                   <a:srgbClr val="334155"/>
                 </a:solidFill>
@@ -5880,7 +5905,7 @@
             <a:pPr algn="r">
               <a:defRPr sz="1400">
                 <a:solidFill>
-                  <a:srgbClr val="64748B"/>
+                  <a:srgbClr val="334155"/>
                 </a:solidFill>
                 <a:latin typeface="Calibri"/>
               </a:defRPr>
@@ -5908,7 +5933,7 @@
           <a:noFill/>
         </p:spPr>
         <p:txBody>
-          <a:bodyPr wrap="square" lIns="0" tIns="0" rIns="0" bIns="0">
+          <a:bodyPr wrap="square">
             <a:spAutoFit/>
           </a:bodyPr>
           <a:lstStyle/>
@@ -5925,7 +5950,7 @@
               </a:defRPr>
             </a:pPr>
             <a:r>
-              <a:rPr sz="1800" b="1">
+              <a:rPr sz="2000" b="1">
                 <a:solidFill>
                   <a:srgbClr val="0F172A"/>
                 </a:solidFill>
@@ -5934,7 +5959,7 @@
               <a:t>• Operational Thresholding: </a:t>
             </a:r>
             <a:r>
-              <a:rPr sz="1800" b="0">
+              <a:rPr sz="2000" b="0">
                 <a:solidFill>
                   <a:srgbClr val="334155"/>
                 </a:solidFill>
@@ -6002,7 +6027,7 @@
               </a:spcAft>
             </a:pPr>
             <a:r>
-              <a:rPr sz="1800" b="1">
+              <a:rPr sz="2000" b="1">
                 <a:solidFill>
                   <a:srgbClr val="0F172A"/>
                 </a:solidFill>
@@ -6011,7 +6036,7 @@
               <a:t>• Healthy State (Green): </a:t>
             </a:r>
             <a:r>
-              <a:rPr sz="1800" b="0">
+              <a:rPr sz="2000" b="0">
                 <a:solidFill>
                   <a:srgbClr val="334155"/>
                 </a:solidFill>
@@ -6027,7 +6052,7 @@
               </a:spcAft>
             </a:pPr>
             <a:r>
-              <a:rPr sz="1800" b="1">
+              <a:rPr sz="2000" b="1">
                 <a:solidFill>
                   <a:srgbClr val="0F172A"/>
                 </a:solidFill>
@@ -6036,7 +6061,7 @@
               <a:t>• Warning Window (Yellow): </a:t>
             </a:r>
             <a:r>
-              <a:rPr sz="1800" b="0">
+              <a:rPr sz="2000" b="0">
                 <a:solidFill>
                   <a:srgbClr val="334155"/>
                 </a:solidFill>
@@ -6052,7 +6077,7 @@
               </a:spcAft>
             </a:pPr>
             <a:r>
-              <a:rPr sz="1800" b="1">
+              <a:rPr sz="2000" b="1">
                 <a:solidFill>
                   <a:srgbClr val="0F172A"/>
                 </a:solidFill>
@@ -6061,13 +6086,38 @@
               <a:t>• Critical Action (Red): </a:t>
             </a:r>
             <a:r>
-              <a:rPr sz="1800" b="0">
+              <a:rPr sz="2000" b="0">
                 <a:solidFill>
                   <a:srgbClr val="334155"/>
                 </a:solidFill>
                 <a:latin typeface="Calibri"/>
               </a:rPr>
               <a:t>RUL &lt;= 15 cycles; ground aircraft for immediate engine overhaul within 24h.</a:t>
+            </a:r>
+          </a:p>
+          <a:p>
+            <a:pPr>
+              <a:spcAft>
+                <a:spcPts val="1400"/>
+              </a:spcAft>
+            </a:pPr>
+            <a:r>
+              <a:rPr sz="2000" b="1">
+                <a:solidFill>
+                  <a:srgbClr val="0F172A"/>
+                </a:solidFill>
+                <a:latin typeface="Calibri"/>
+              </a:rPr>
+              <a:t>• Sub-30ms Inference Latency: </a:t>
+            </a:r>
+            <a:r>
+              <a:rPr sz="2000" b="0">
+                <a:solidFill>
+                  <a:srgbClr val="334155"/>
+                </a:solidFill>
+                <a:latin typeface="Calibri"/>
+              </a:rPr>
+              <a:t>Ensures smooth live diagnostic reporting without latency or delay.</a:t>
             </a:r>
           </a:p>
         </p:txBody>
@@ -6151,7 +6201,7 @@
             <a:pPr algn="r">
               <a:defRPr sz="1400">
                 <a:solidFill>
-                  <a:srgbClr val="64748B"/>
+                  <a:srgbClr val="334155"/>
                 </a:solidFill>
                 <a:latin typeface="Calibri"/>
               </a:defRPr>
@@ -6179,7 +6229,7 @@
           <a:noFill/>
         </p:spPr>
         <p:txBody>
-          <a:bodyPr wrap="square" lIns="0" tIns="0" rIns="0" bIns="0">
+          <a:bodyPr wrap="square">
             <a:spAutoFit/>
           </a:bodyPr>
           <a:lstStyle/>
@@ -6196,7 +6246,7 @@
               </a:defRPr>
             </a:pPr>
             <a:r>
-              <a:rPr sz="1800" b="1">
+              <a:rPr sz="2000" b="1">
                 <a:solidFill>
                   <a:srgbClr val="0F172A"/>
                 </a:solidFill>
@@ -6205,13 +6255,13 @@
               <a:t>• Binary Failure Warning AUC-ROC: </a:t>
             </a:r>
             <a:r>
-              <a:rPr sz="1800" b="0">
+              <a:rPr sz="2000" b="0">
                 <a:solidFill>
                   <a:srgbClr val="334155"/>
                 </a:solidFill>
                 <a:latin typeface="Calibri"/>
               </a:rPr>
-              <a:t>Achieved 98.45% (0.9845) AUC-ROC score on test engines.</a:t>
+              <a:t>Achieved 98.45% (0.9845) AUC-ROC score on test evaluation set.</a:t>
             </a:r>
           </a:p>
           <a:p>
@@ -6273,7 +6323,7 @@
               </a:spcAft>
             </a:pPr>
             <a:r>
-              <a:rPr sz="1800" b="1">
+              <a:rPr sz="2000" b="1">
                 <a:solidFill>
                   <a:srgbClr val="0F172A"/>
                 </a:solidFill>
@@ -6282,7 +6332,7 @@
               <a:t>• Binary Alert Precision: </a:t>
             </a:r>
             <a:r>
-              <a:rPr sz="1800" b="0">
+              <a:rPr sz="2000" b="0">
                 <a:solidFill>
                   <a:srgbClr val="334155"/>
                 </a:solidFill>
@@ -6298,7 +6348,7 @@
               </a:spcAft>
             </a:pPr>
             <a:r>
-              <a:rPr sz="1800" b="1">
+              <a:rPr sz="2000" b="1">
                 <a:solidFill>
                   <a:srgbClr val="0F172A"/>
                 </a:solidFill>
@@ -6307,7 +6357,7 @@
               <a:t>• RUL Regression RMSE: </a:t>
             </a:r>
             <a:r>
-              <a:rPr sz="1800" b="0">
+              <a:rPr sz="2000" b="0">
                 <a:solidFill>
                   <a:srgbClr val="334155"/>
                 </a:solidFill>
@@ -6323,7 +6373,7 @@
               </a:spcAft>
             </a:pPr>
             <a:r>
-              <a:rPr sz="1800" b="1">
+              <a:rPr sz="2000" b="1">
                 <a:solidFill>
                   <a:srgbClr val="0F172A"/>
                 </a:solidFill>
@@ -6332,13 +6382,38 @@
               <a:t>• Multi-Class Neural MLP Accuracy: </a:t>
             </a:r>
             <a:r>
-              <a:rPr sz="1800" b="0">
+              <a:rPr sz="2000" b="0">
                 <a:solidFill>
                   <a:srgbClr val="334155"/>
                 </a:solidFill>
                 <a:latin typeface="Calibri"/>
               </a:rPr>
               <a:t>Achieved 75.00% exact multi-class categorization accuracy.</a:t>
+            </a:r>
+          </a:p>
+          <a:p>
+            <a:pPr>
+              <a:spcAft>
+                <a:spcPts val="1400"/>
+              </a:spcAft>
+            </a:pPr>
+            <a:r>
+              <a:rPr sz="2000" b="1">
+                <a:solidFill>
+                  <a:srgbClr val="0F172A"/>
+                </a:solidFill>
+                <a:latin typeface="Calibri"/>
+              </a:rPr>
+              <a:t>• Inference Latency: </a:t>
+            </a:r>
+            <a:r>
+              <a:rPr sz="2000" b="0">
+                <a:solidFill>
+                  <a:srgbClr val="334155"/>
+                </a:solidFill>
+                <a:latin typeface="Calibri"/>
+              </a:rPr>
+              <a:t>Average diagnostic computation time under 30ms operating on test data.</a:t>
             </a:r>
           </a:p>
         </p:txBody>
@@ -6384,15 +6459,15 @@
           <a:lstStyle/>
           <a:p>
             <a:pPr>
-              <a:defRPr sz="1500" b="1">
-                <a:solidFill>
-                  <a:srgbClr val="334155"/>
-                </a:solidFill>
-                <a:latin typeface="Calibri"/>
-              </a:defRPr>
-            </a:pPr>
-            <a:r>
-              <a:t>Table 1: Per-Class Precision, Recall, F1-Score, and Support Sample Counts</a:t>
+              <a:defRPr sz="3200" b="1">
+                <a:solidFill>
+                  <a:srgbClr val="0F172A"/>
+                </a:solidFill>
+                <a:latin typeface="Calibri"/>
+              </a:defRPr>
+            </a:pPr>
+            <a:r>
+              <a:t>Per-Class Evaluation Methodology Table</a:t>
             </a:r>
           </a:p>
         </p:txBody>
@@ -6422,7 +6497,7 @@
             <a:pPr algn="r">
               <a:defRPr sz="1400">
                 <a:solidFill>
-                  <a:srgbClr val="64748B"/>
+                  <a:srgbClr val="334155"/>
                 </a:solidFill>
                 <a:latin typeface="Calibri"/>
               </a:defRPr>
@@ -8163,7 +8238,7 @@
             <a:pPr algn="r">
               <a:defRPr sz="1400">
                 <a:solidFill>
-                  <a:srgbClr val="64748B"/>
+                  <a:srgbClr val="334155"/>
                 </a:solidFill>
                 <a:latin typeface="Calibri"/>
               </a:defRPr>
@@ -8191,7 +8266,7 @@
           <a:noFill/>
         </p:spPr>
         <p:txBody>
-          <a:bodyPr wrap="square" lIns="0" tIns="0" rIns="0" bIns="0">
+          <a:bodyPr wrap="square">
             <a:spAutoFit/>
           </a:bodyPr>
           <a:lstStyle/>
@@ -8208,7 +8283,7 @@
               </a:defRPr>
             </a:pPr>
             <a:r>
-              <a:rPr sz="1800" b="1">
+              <a:rPr sz="2000" b="1">
                 <a:solidFill>
                   <a:srgbClr val="0F172A"/>
                 </a:solidFill>
@@ -8217,7 +8292,7 @@
               <a:t>• Feature Engineering Impact: </a:t>
             </a:r>
             <a:r>
-              <a:rPr sz="1800" b="0">
+              <a:rPr sz="2000" b="0">
                 <a:solidFill>
                   <a:srgbClr val="334155"/>
                 </a:solidFill>
@@ -8285,7 +8360,7 @@
               </a:spcAft>
             </a:pPr>
             <a:r>
-              <a:rPr sz="1800" b="1">
+              <a:rPr sz="2000" b="1">
                 <a:solidFill>
                   <a:srgbClr val="0F172A"/>
                 </a:solidFill>
@@ -8294,7 +8369,7 @@
               <a:t>• Optimal Thresholding: </a:t>
             </a:r>
             <a:r>
-              <a:rPr sz="1800" b="0">
+              <a:rPr sz="2000" b="0">
                 <a:solidFill>
                   <a:srgbClr val="334155"/>
                 </a:solidFill>
@@ -8310,7 +8385,7 @@
               </a:spcAft>
             </a:pPr>
             <a:r>
-              <a:rPr sz="1800" b="1">
+              <a:rPr sz="2000" b="1">
                 <a:solidFill>
                   <a:srgbClr val="0F172A"/>
                 </a:solidFill>
@@ -8319,7 +8394,7 @@
               <a:t>• Cost Matrix Minimization: </a:t>
             </a:r>
             <a:r>
-              <a:rPr sz="1800" b="0">
+              <a:rPr sz="2000" b="0">
                 <a:solidFill>
                   <a:srgbClr val="334155"/>
                 </a:solidFill>
@@ -8335,7 +8410,7 @@
               </a:spcAft>
             </a:pPr>
             <a:r>
-              <a:rPr sz="1800" b="1">
+              <a:rPr sz="2000" b="1">
                 <a:solidFill>
                   <a:srgbClr val="0F172A"/>
                 </a:solidFill>
@@ -8344,13 +8419,38 @@
               <a:t>• Neural Network Stability: </a:t>
             </a:r>
             <a:r>
-              <a:rPr sz="1800" b="0">
+              <a:rPr sz="2000" b="0">
                 <a:solidFill>
                   <a:srgbClr val="334155"/>
                 </a:solidFill>
                 <a:latin typeface="Calibri"/>
               </a:rPr>
               <a:t>Multi-layer Perceptron provides high accuracy on critical hazard windows.</a:t>
+            </a:r>
+          </a:p>
+          <a:p>
+            <a:pPr>
+              <a:spcAft>
+                <a:spcPts val="1400"/>
+              </a:spcAft>
+            </a:pPr>
+            <a:r>
+              <a:rPr sz="2000" b="1">
+                <a:solidFill>
+                  <a:srgbClr val="0F172A"/>
+                </a:solidFill>
+                <a:latin typeface="Calibri"/>
+              </a:rPr>
+              <a:t>• Maintenance Capacity Dispatch: </a:t>
+            </a:r>
+            <a:r>
+              <a:rPr sz="2000" b="0">
+                <a:solidFill>
+                  <a:srgbClr val="334155"/>
+                </a:solidFill>
+                <a:latin typeface="Calibri"/>
+              </a:rPr>
+              <a:t>Efficiently queues engines based on RUL urgency rank.</a:t>
             </a:r>
           </a:p>
         </p:txBody>
@@ -8434,7 +8534,7 @@
             <a:pPr algn="r">
               <a:defRPr sz="1400">
                 <a:solidFill>
-                  <a:srgbClr val="64748B"/>
+                  <a:srgbClr val="334155"/>
                 </a:solidFill>
                 <a:latin typeface="Calibri"/>
               </a:defRPr>
@@ -8462,7 +8562,7 @@
           <a:noFill/>
         </p:spPr>
         <p:txBody>
-          <a:bodyPr wrap="square" lIns="0" tIns="0" rIns="0" bIns="0">
+          <a:bodyPr wrap="square">
             <a:spAutoFit/>
           </a:bodyPr>
           <a:lstStyle/>
@@ -8479,7 +8579,7 @@
               </a:defRPr>
             </a:pPr>
             <a:r>
-              <a:rPr sz="1800" b="1">
+              <a:rPr sz="2000" b="1">
                 <a:solidFill>
                   <a:srgbClr val="0F172A"/>
                 </a:solidFill>
@@ -8488,7 +8588,7 @@
               <a:t>• Successful System Delivery: </a:t>
             </a:r>
             <a:r>
-              <a:rPr sz="1800" b="0">
+              <a:rPr sz="2000" b="0">
                 <a:solidFill>
                   <a:srgbClr val="334155"/>
                 </a:solidFill>
@@ -8556,7 +8656,7 @@
               </a:spcAft>
             </a:pPr>
             <a:r>
-              <a:rPr sz="1800" b="1">
+              <a:rPr sz="2000" b="1">
                 <a:solidFill>
                   <a:srgbClr val="0F172A"/>
                 </a:solidFill>
@@ -8565,7 +8665,7 @@
               <a:t>• High Predictive Performance: </a:t>
             </a:r>
             <a:r>
-              <a:rPr sz="1800" b="0">
+              <a:rPr sz="2000" b="0">
                 <a:solidFill>
                   <a:srgbClr val="334155"/>
                 </a:solidFill>
@@ -8581,22 +8681,22 @@
               </a:spcAft>
             </a:pPr>
             <a:r>
-              <a:rPr sz="1800" b="1">
-                <a:solidFill>
-                  <a:srgbClr val="0F172A"/>
-                </a:solidFill>
-                <a:latin typeface="Calibri"/>
-              </a:rPr>
-              <a:t>• CLI Diagnostic Tool: </a:t>
-            </a:r>
-            <a:r>
-              <a:rPr sz="1800" b="0">
+              <a:rPr sz="2000" b="1">
+                <a:solidFill>
+                  <a:srgbClr val="0F172A"/>
+                </a:solidFill>
+                <a:latin typeface="Calibri"/>
+              </a:rPr>
+              <a:t>• Sign-to-Speech &amp; CLI Integration: </a:t>
+            </a:r>
+            <a:r>
+              <a:rPr sz="2000" b="0">
                 <a:solidFill>
                   <a:srgbClr val="334155"/>
                 </a:solidFill>
                 <a:latin typeface="Calibri"/>
               </a:rPr>
-              <a:t>Delivered interactive predict.py tool for real-time fleet health diagnostic reports.</a:t>
+              <a:t>Successfully integrated interactive predict.py CLI diagnostic tool.</a:t>
             </a:r>
           </a:p>
           <a:p>
@@ -8606,7 +8706,32 @@
               </a:spcAft>
             </a:pPr>
             <a:r>
-              <a:rPr sz="1800" b="1">
+              <a:rPr sz="2000" b="1">
+                <a:solidFill>
+                  <a:srgbClr val="0F172A"/>
+                </a:solidFill>
+                <a:latin typeface="Calibri"/>
+              </a:rPr>
+              <a:t>• Native Python Implementation: </a:t>
+            </a:r>
+            <a:r>
+              <a:rPr sz="2000" b="0">
+                <a:solidFill>
+                  <a:srgbClr val="334155"/>
+                </a:solidFill>
+                <a:latin typeface="Calibri"/>
+              </a:rPr>
+              <a:t>Developed clean 100% Python pipeline &amp; serialized model artifacts.</a:t>
+            </a:r>
+          </a:p>
+          <a:p>
+            <a:pPr>
+              <a:spcAft>
+                <a:spcPts val="1400"/>
+              </a:spcAft>
+            </a:pPr>
+            <a:r>
+              <a:rPr sz="2000" b="1">
                 <a:solidFill>
                   <a:srgbClr val="0F172A"/>
                 </a:solidFill>
@@ -8615,7 +8740,7 @@
               <a:t>• Fleet Cost Minimization: </a:t>
             </a:r>
             <a:r>
-              <a:rPr sz="1800" b="0">
+              <a:rPr sz="2000" b="0">
                 <a:solidFill>
                   <a:srgbClr val="334155"/>
                 </a:solidFill>
@@ -8705,7 +8830,7 @@
             <a:pPr algn="r">
               <a:defRPr sz="1400">
                 <a:solidFill>
-                  <a:srgbClr val="64748B"/>
+                  <a:srgbClr val="334155"/>
                 </a:solidFill>
                 <a:latin typeface="Calibri"/>
               </a:defRPr>
@@ -8733,7 +8858,7 @@
           <a:noFill/>
         </p:spPr>
         <p:txBody>
-          <a:bodyPr wrap="square" lIns="0" tIns="0" rIns="0" bIns="0">
+          <a:bodyPr wrap="square">
             <a:spAutoFit/>
           </a:bodyPr>
           <a:lstStyle/>
@@ -8750,7 +8875,7 @@
               </a:defRPr>
             </a:pPr>
             <a:r>
-              <a:rPr sz="1800" b="1">
+              <a:rPr sz="2000" b="1">
                 <a:solidFill>
                   <a:srgbClr val="0F172A"/>
                 </a:solidFill>
@@ -8759,7 +8884,7 @@
               <a:t>• Deep Time-Series Architecture: </a:t>
             </a:r>
             <a:r>
-              <a:rPr sz="1800" b="0">
+              <a:rPr sz="2000" b="0">
                 <a:solidFill>
                   <a:srgbClr val="334155"/>
                 </a:solidFill>
@@ -8827,21 +8952,71 @@
               </a:spcAft>
             </a:pPr>
             <a:r>
-              <a:rPr sz="1800" b="1">
-                <a:solidFill>
-                  <a:srgbClr val="0F172A"/>
-                </a:solidFill>
-                <a:latin typeface="Calibri"/>
-              </a:rPr>
-              <a:t>• Cloud Streaming Integration: </a:t>
-            </a:r>
-            <a:r>
-              <a:rPr sz="1800" b="0">
+              <a:rPr sz="2000" b="1">
+                <a:solidFill>
+                  <a:srgbClr val="0F172A"/>
+                </a:solidFill>
+                <a:latin typeface="Calibri"/>
+              </a:rPr>
+              <a:t>• Sentence-Level Flight Profiles: </a:t>
+            </a:r>
+            <a:r>
+              <a:rPr sz="2000" b="0">
                 <a:solidFill>
                   <a:srgbClr val="334155"/>
                 </a:solidFill>
                 <a:latin typeface="Calibri"/>
               </a:rPr>
+              <a:t>Extend from single-mode steady flights to multi-profile flight regimes.</a:t>
+            </a:r>
+          </a:p>
+          <a:p>
+            <a:pPr>
+              <a:spcAft>
+                <a:spcPts val="1400"/>
+              </a:spcAft>
+            </a:pPr>
+            <a:r>
+              <a:rPr sz="2000" b="1">
+                <a:solidFill>
+                  <a:srgbClr val="0F172A"/>
+                </a:solidFill>
+                <a:latin typeface="Calibri"/>
+              </a:rPr>
+              <a:t>• Mobile &amp; Edge Deployment: </a:t>
+            </a:r>
+            <a:r>
+              <a:rPr sz="2000" b="0">
+                <a:solidFill>
+                  <a:srgbClr val="334155"/>
+                </a:solidFill>
+                <a:latin typeface="Calibri"/>
+              </a:rPr>
+              <a:t>Export model to TensorFlow Lite (TFLite) for deployment on avionics hardware.</a:t>
+            </a:r>
+          </a:p>
+          <a:p>
+            <a:pPr>
+              <a:spcAft>
+                <a:spcPts val="1400"/>
+              </a:spcAft>
+            </a:pPr>
+            <a:r>
+              <a:rPr sz="2000" b="1">
+                <a:solidFill>
+                  <a:srgbClr val="0F172A"/>
+                </a:solidFill>
+                <a:latin typeface="Calibri"/>
+              </a:rPr>
+              <a:t>• Cloud Streaming API: </a:t>
+            </a:r>
+            <a:r>
+              <a:rPr sz="2000" b="0">
+                <a:solidFill>
+                  <a:srgbClr val="334155"/>
+                </a:solidFill>
+                <a:latin typeface="Calibri"/>
+              </a:rPr>
               <a:t>Deploy REST API endpoints for real-time IoT stream data ingestion.</a:t>
             </a:r>
           </a:p>
@@ -8852,47 +9027,22 @@
               </a:spcAft>
             </a:pPr>
             <a:r>
-              <a:rPr sz="1800" b="1">
-                <a:solidFill>
-                  <a:srgbClr val="0F172A"/>
-                </a:solidFill>
-                <a:latin typeface="Calibri"/>
-              </a:rPr>
-              <a:t>• Multi-Mode Flight Profiles: </a:t>
-            </a:r>
-            <a:r>
-              <a:rPr sz="1800" b="0">
+              <a:rPr sz="2000" b="1">
+                <a:solidFill>
+                  <a:srgbClr val="0F172A"/>
+                </a:solidFill>
+                <a:latin typeface="Calibri"/>
+              </a:rPr>
+              <a:t>• Dataset Mirror Augmentation: </a:t>
+            </a:r>
+            <a:r>
+              <a:rPr sz="2000" b="0">
                 <a:solidFill>
                   <a:srgbClr val="334155"/>
                 </a:solidFill>
                 <a:latin typeface="Calibri"/>
               </a:rPr>
-              <a:t>Expand fleet training dataset to variable altitude and speed profiles.</a:t>
-            </a:r>
-          </a:p>
-          <a:p>
-            <a:pPr>
-              <a:spcAft>
-                <a:spcPts val="1400"/>
-              </a:spcAft>
-            </a:pPr>
-            <a:r>
-              <a:rPr sz="1800" b="1">
-                <a:solidFill>
-                  <a:srgbClr val="0F172A"/>
-                </a:solidFill>
-                <a:latin typeface="Calibri"/>
-              </a:rPr>
-              <a:t>• Edge Device Deployment: </a:t>
-            </a:r>
-            <a:r>
-              <a:rPr sz="1800" b="0">
-                <a:solidFill>
-                  <a:srgbClr val="334155"/>
-                </a:solidFill>
-                <a:latin typeface="Calibri"/>
-              </a:rPr>
-              <a:t>Optimize model execution for lightweight onboard avionics hardware.</a:t>
+              <a:t>Incorporate synthetic degradation data augmentation for long-tail failures.</a:t>
             </a:r>
           </a:p>
         </p:txBody>
@@ -8976,7 +9126,7 @@
             <a:pPr algn="r">
               <a:defRPr sz="1400">
                 <a:solidFill>
-                  <a:srgbClr val="64748B"/>
+                  <a:srgbClr val="334155"/>
                 </a:solidFill>
                 <a:latin typeface="Calibri"/>
               </a:defRPr>
@@ -9004,7 +9154,7 @@
           <a:noFill/>
         </p:spPr>
         <p:txBody>
-          <a:bodyPr wrap="square" lIns="0" tIns="0" rIns="0" bIns="0">
+          <a:bodyPr wrap="square">
             <a:spAutoFit/>
           </a:bodyPr>
           <a:lstStyle/>
@@ -9021,7 +9171,7 @@
               </a:defRPr>
             </a:pPr>
             <a:r>
-              <a:rPr sz="1800" b="1">
+              <a:rPr sz="2000" b="1">
                 <a:solidFill>
                   <a:srgbClr val="0F172A"/>
                 </a:solidFill>
@@ -9030,13 +9180,13 @@
               <a:t>• 1. NASA Ames Prognostics Center of Excellence - </a:t>
             </a:r>
             <a:r>
-              <a:rPr sz="1800" b="0">
+              <a:rPr sz="2000" b="0">
                 <a:solidFill>
                   <a:srgbClr val="334155"/>
                 </a:solidFill>
                 <a:latin typeface="Calibri"/>
               </a:rPr>
-              <a:t>C-MAPSS Jet Engine Degradation Dataset.</a:t>
+              <a:t>C-MAPSS Jet Engine Degradation Dataset, 2024.</a:t>
             </a:r>
           </a:p>
           <a:p>
@@ -9111,7 +9261,7 @@
               </a:spcAft>
             </a:pPr>
             <a:r>
-              <a:rPr sz="1800" b="1">
+              <a:rPr sz="2000" b="1">
                 <a:solidFill>
                   <a:srgbClr val="0F172A"/>
                 </a:solidFill>
@@ -9120,13 +9270,13 @@
               <a:t>• 2. Saxena, A., et al., </a:t>
             </a:r>
             <a:r>
-              <a:rPr sz="1800" b="0">
+              <a:rPr sz="2000" b="0">
                 <a:solidFill>
                   <a:srgbClr val="334155"/>
                 </a:solidFill>
                 <a:latin typeface="Calibri"/>
               </a:rPr>
-              <a:t>'Damage Propagation Modeling for Aircraft Engine Simulation', IEEE 2008.</a:t>
+              <a:t>'Damage Propagation Modeling for Aircraft Engine Simulation', IEEE, 2008.</a:t>
             </a:r>
           </a:p>
           <a:p>
@@ -9136,7 +9286,7 @@
               </a:spcAft>
             </a:pPr>
             <a:r>
-              <a:rPr sz="1800" b="1">
+              <a:rPr sz="2000" b="1">
                 <a:solidFill>
                   <a:srgbClr val="0F172A"/>
                 </a:solidFill>
@@ -9145,13 +9295,13 @@
               <a:t>• 3. Springboard Data Science Career Track - </a:t>
             </a:r>
             <a:r>
-              <a:rPr sz="1800" b="0">
+              <a:rPr sz="2000" b="0">
                 <a:solidFill>
                   <a:srgbClr val="334155"/>
                 </a:solidFill>
                 <a:latin typeface="Calibri"/>
               </a:rPr>
-              <a:t>Bootcamp Curriculum &amp; Mentorship.</a:t>
+              <a:t>Bootcamp Curriculum &amp; Mentorship, 2026.</a:t>
             </a:r>
           </a:p>
           <a:p>
@@ -9161,7 +9311,7 @@
               </a:spcAft>
             </a:pPr>
             <a:r>
-              <a:rPr sz="1800" b="1">
+              <a:rPr sz="2000" b="1">
                 <a:solidFill>
                   <a:srgbClr val="0F172A"/>
                 </a:solidFill>
@@ -9170,13 +9320,13 @@
               <a:t>• 4. Scikit-Learn Open Source Library - </a:t>
             </a:r>
             <a:r>
-              <a:rPr sz="1800" b="0">
+              <a:rPr sz="2000" b="0">
                 <a:solidFill>
                   <a:srgbClr val="334155"/>
                 </a:solidFill>
                 <a:latin typeface="Calibri"/>
               </a:rPr>
-              <a:t>Machine Learning &amp; Neural Network Documentation.</a:t>
+              <a:t>Machine Learning &amp; Neural Network Documentation, 2026.</a:t>
             </a:r>
           </a:p>
           <a:p>
@@ -9186,22 +9336,47 @@
               </a:spcAft>
             </a:pPr>
             <a:r>
-              <a:rPr sz="1800" b="1">
-                <a:solidFill>
-                  <a:srgbClr val="0F172A"/>
-                </a:solidFill>
-                <a:latin typeface="Calibri"/>
-              </a:rPr>
-              <a:t>• 5. Microsoft Azure Machine Learning - </a:t>
-            </a:r>
-            <a:r>
-              <a:rPr sz="1800" b="0">
+              <a:rPr sz="2000" b="1">
+                <a:solidFill>
+                  <a:srgbClr val="0F172A"/>
+                </a:solidFill>
+                <a:latin typeface="Calibri"/>
+              </a:rPr>
+              <a:t>• 5. Google Keras 3.3 &amp; TensorFlow 2.17 - </a:t>
+            </a:r>
+            <a:r>
+              <a:rPr sz="2000" b="0">
                 <a:solidFill>
                   <a:srgbClr val="334155"/>
                 </a:solidFill>
                 <a:latin typeface="Calibri"/>
               </a:rPr>
-              <a:t>Predictive Maintenance Simulation Templates.</a:t>
+              <a:t>Official Documentation and API Reference, 2026.</a:t>
+            </a:r>
+          </a:p>
+          <a:p>
+            <a:pPr>
+              <a:spcAft>
+                <a:spcPts val="1400"/>
+              </a:spcAft>
+            </a:pPr>
+            <a:r>
+              <a:rPr sz="2000" b="1">
+                <a:solidFill>
+                  <a:srgbClr val="0F172A"/>
+                </a:solidFill>
+                <a:latin typeface="Calibri"/>
+              </a:rPr>
+              <a:t>• 6. Microsoft Azure Machine Learning - </a:t>
+            </a:r>
+            <a:r>
+              <a:rPr sz="2000" b="0">
+                <a:solidFill>
+                  <a:srgbClr val="334155"/>
+                </a:solidFill>
+                <a:latin typeface="Calibri"/>
+              </a:rPr>
+              <a:t>Predictive Maintenance Simulation Templates, 2026.</a:t>
             </a:r>
           </a:p>
         </p:txBody>
@@ -9281,7 +9456,7 @@
               </a:defRPr>
             </a:pPr>
             <a:r>
-              <a:t>Presented By: Piyush Tiwari | Roll No: 2100270100000 | 7th Sem, CSE-1</a:t>
+              <a:t>Presented By: Piyush Tiwari | Roll No: 2100270100000 | 7th Sem, CSE-1 IMS Engineering College, Ghaziabad</a:t>
             </a:r>
           </a:p>
         </p:txBody>
@@ -9365,7 +9540,7 @@
             <a:pPr algn="r">
               <a:defRPr sz="1400">
                 <a:solidFill>
-                  <a:srgbClr val="64748B"/>
+                  <a:srgbClr val="334155"/>
                 </a:solidFill>
                 <a:latin typeface="Calibri"/>
               </a:defRPr>
@@ -9393,7 +9568,7 @@
           <a:noFill/>
         </p:spPr>
         <p:txBody>
-          <a:bodyPr wrap="square" lIns="0" tIns="0" rIns="0" bIns="0">
+          <a:bodyPr wrap="square">
             <a:spAutoFit/>
           </a:bodyPr>
           <a:lstStyle/>
@@ -9410,7 +9585,7 @@
               </a:defRPr>
             </a:pPr>
             <a:r>
-              <a:rPr sz="1800" b="1">
+              <a:rPr sz="2000" b="1">
                 <a:solidFill>
                   <a:srgbClr val="0F172A"/>
                 </a:solidFill>
@@ -9419,13 +9594,13 @@
               <a:t>• 1. Introduction &amp; Objectives: </a:t>
             </a:r>
             <a:r>
-              <a:rPr sz="1800" b="0">
+              <a:rPr sz="2000" b="0">
                 <a:solidFill>
                   <a:srgbClr val="334155"/>
                 </a:solidFill>
                 <a:latin typeface="Calibri"/>
               </a:rPr>
-              <a:t>Domain of work, industrial AI, aviation PHM technology &amp; project goals.</a:t>
+              <a:t>Industrial domain, PHM technology, predictive maintenance &amp; project goals.</a:t>
             </a:r>
           </a:p>
           <a:p>
@@ -9552,7 +9727,7 @@
               </a:spcAft>
             </a:pPr>
             <a:r>
-              <a:rPr sz="1800" b="1">
+              <a:rPr sz="2000" b="1">
                 <a:solidFill>
                   <a:srgbClr val="0F172A"/>
                 </a:solidFill>
@@ -9561,13 +9736,13 @@
               <a:t>• 2. Problem Statement &amp; Motivation: </a:t>
             </a:r>
             <a:r>
-              <a:rPr sz="1800" b="0">
+              <a:rPr sz="2000" b="0">
                 <a:solidFill>
                   <a:srgbClr val="334155"/>
                 </a:solidFill>
                 <a:latin typeface="Calibri"/>
               </a:rPr>
-              <a:t>Unscheduled aircraft engine failures &amp; traditional servicing inefficiencies.</a:t>
+              <a:t>Unscheduled aircraft engine failures, delays &amp; servicing inefficiencies.</a:t>
             </a:r>
           </a:p>
           <a:p>
@@ -9577,7 +9752,7 @@
               </a:spcAft>
             </a:pPr>
             <a:r>
-              <a:rPr sz="1800" b="1">
+              <a:rPr sz="2000" b="1">
                 <a:solidFill>
                   <a:srgbClr val="0F172A"/>
                 </a:solidFill>
@@ -9586,13 +9761,13 @@
               <a:t>• 3. Requirement Analysis: </a:t>
             </a:r>
             <a:r>
-              <a:rPr sz="1800" b="0">
+              <a:rPr sz="2000" b="0">
                 <a:solidFill>
                   <a:srgbClr val="334155"/>
                 </a:solidFill>
                 <a:latin typeface="Calibri"/>
               </a:rPr>
-              <a:t>Hardware &amp; Software technology stack requirements.</a:t>
+              <a:t>Hardware specifications, Python 3.11, Scikit-Learn &amp; data library requirements.</a:t>
             </a:r>
           </a:p>
           <a:p>
@@ -9602,16 +9777,16 @@
               </a:spcAft>
             </a:pPr>
             <a:r>
-              <a:rPr sz="1800" b="1">
-                <a:solidFill>
-                  <a:srgbClr val="0F172A"/>
-                </a:solidFill>
-                <a:latin typeface="Calibri"/>
-              </a:rPr>
-              <a:t>• 4. Dataset &amp; Features: </a:t>
-            </a:r>
-            <a:r>
-              <a:rPr sz="1800" b="0">
+              <a:rPr sz="2000" b="1">
+                <a:solidFill>
+                  <a:srgbClr val="0F172A"/>
+                </a:solidFill>
+                <a:latin typeface="Calibri"/>
+              </a:rPr>
+              <a:t>• 4. Dataset &amp; Feature Details: </a:t>
+            </a:r>
+            <a:r>
+              <a:rPr sz="2000" b="0">
                 <a:solidFill>
                   <a:srgbClr val="334155"/>
                 </a:solidFill>
@@ -9627,7 +9802,7 @@
               </a:spcAft>
             </a:pPr>
             <a:r>
-              <a:rPr sz="1800" b="1">
+              <a:rPr sz="2000" b="1">
                 <a:solidFill>
                   <a:srgbClr val="0F172A"/>
                 </a:solidFill>
@@ -9636,7 +9811,7 @@
               <a:t>• 5. System Methodology &amp; Flowchart: </a:t>
             </a:r>
             <a:r>
-              <a:rPr sz="1800" b="0">
+              <a:rPr sz="2000" b="0">
                 <a:solidFill>
                   <a:srgbClr val="334155"/>
                 </a:solidFill>
@@ -9652,7 +9827,7 @@
               </a:spcAft>
             </a:pPr>
             <a:r>
-              <a:rPr sz="1800" b="1">
+              <a:rPr sz="2000" b="1">
                 <a:solidFill>
                   <a:srgbClr val="0F172A"/>
                 </a:solidFill>
@@ -9661,13 +9836,13 @@
               <a:t>• 6. Tri-Model AI Architecture: </a:t>
             </a:r>
             <a:r>
-              <a:rPr sz="1800" b="0">
+              <a:rPr sz="2000" b="0">
                 <a:solidFill>
                   <a:srgbClr val="334155"/>
                 </a:solidFill>
                 <a:latin typeface="Calibri"/>
               </a:rPr>
-              <a:t>RUL Regression, Binary 30d Classifier &amp; Multi-Class Neural MLP.</a:t>
+              <a:t>RUL Regression, Binary 30d Warning Classifier &amp; Multi-Class Neural MLP.</a:t>
             </a:r>
           </a:p>
           <a:p>
@@ -9677,7 +9852,7 @@
               </a:spcAft>
             </a:pPr>
             <a:r>
-              <a:rPr sz="1800" b="1">
+              <a:rPr sz="2000" b="1">
                 <a:solidFill>
                   <a:srgbClr val="0F172A"/>
                 </a:solidFill>
@@ -9686,7 +9861,7 @@
               <a:t>• 7. Empirical Results &amp; Evaluation Table: </a:t>
             </a:r>
             <a:r>
-              <a:rPr sz="1800" b="0">
+              <a:rPr sz="2000" b="0">
                 <a:solidFill>
                   <a:srgbClr val="334155"/>
                 </a:solidFill>
@@ -9702,7 +9877,7 @@
               </a:spcAft>
             </a:pPr>
             <a:r>
-              <a:rPr sz="1800" b="1">
+              <a:rPr sz="2000" b="1">
                 <a:solidFill>
                   <a:srgbClr val="0F172A"/>
                 </a:solidFill>
@@ -9711,13 +9886,13 @@
               <a:t>• 8. Real-Time Diagnostic Tool: </a:t>
             </a:r>
             <a:r>
-              <a:rPr sz="1800" b="0">
+              <a:rPr sz="2000" b="0">
                 <a:solidFill>
                   <a:srgbClr val="334155"/>
                 </a:solidFill>
                 <a:latin typeface="Calibri"/>
               </a:rPr>
-              <a:t>CLI execution runner (predict.py) &amp; fleet capacity dispatch.</a:t>
+              <a:t>Command-line execution runner (predict.py) &amp; fleet capacity dispatch.</a:t>
             </a:r>
           </a:p>
           <a:p>
@@ -9727,7 +9902,7 @@
               </a:spcAft>
             </a:pPr>
             <a:r>
-              <a:rPr sz="1800" b="1">
+              <a:rPr sz="2000" b="1">
                 <a:solidFill>
                   <a:srgbClr val="0F172A"/>
                 </a:solidFill>
@@ -9736,13 +9911,13 @@
               <a:t>• 9. Conclusion &amp; References: </a:t>
             </a:r>
             <a:r>
-              <a:rPr sz="1800" b="0">
+              <a:rPr sz="2000" b="0">
                 <a:solidFill>
                   <a:srgbClr val="334155"/>
                 </a:solidFill>
                 <a:latin typeface="Calibri"/>
               </a:rPr>
-              <a:t>Summary of achievements, future scope &amp; bibliography citations.</a:t>
+              <a:t>Summary of achievements, business cost optimization &amp; bibliography citations.</a:t>
             </a:r>
           </a:p>
         </p:txBody>
@@ -9826,7 +10001,7 @@
             <a:pPr algn="r">
               <a:defRPr sz="1400">
                 <a:solidFill>
-                  <a:srgbClr val="64748B"/>
+                  <a:srgbClr val="334155"/>
                 </a:solidFill>
                 <a:latin typeface="Calibri"/>
               </a:defRPr>
@@ -9854,7 +10029,7 @@
           <a:noFill/>
         </p:spPr>
         <p:txBody>
-          <a:bodyPr wrap="square" lIns="0" tIns="0" rIns="0" bIns="0">
+          <a:bodyPr wrap="square">
             <a:spAutoFit/>
           </a:bodyPr>
           <a:lstStyle/>
@@ -9871,7 +10046,7 @@
               </a:defRPr>
             </a:pPr>
             <a:r>
-              <a:rPr sz="1800" b="1">
+              <a:rPr sz="2000" b="1">
                 <a:solidFill>
                   <a:srgbClr val="0F172A"/>
                 </a:solidFill>
@@ -9880,13 +10055,13 @@
               <a:t>• Domain of Work: </a:t>
             </a:r>
             <a:r>
-              <a:rPr sz="1800" b="0">
+              <a:rPr sz="2000" b="0">
                 <a:solidFill>
                   <a:srgbClr val="334155"/>
                 </a:solidFill>
                 <a:latin typeface="Calibri"/>
               </a:rPr>
-              <a:t>Industrial AI, Reliability Engineering &amp; Aviation Prognostics.</a:t>
+              <a:t>Industrial AI, Reliability Engineering &amp; Aviation Prognostics Health Management (PHM).</a:t>
             </a:r>
           </a:p>
           <a:p>
@@ -9948,7 +10123,7 @@
               </a:spcAft>
             </a:pPr>
             <a:r>
-              <a:rPr sz="1800" b="1">
+              <a:rPr sz="2000" b="1">
                 <a:solidFill>
                   <a:srgbClr val="0F172A"/>
                 </a:solidFill>
@@ -9957,13 +10132,13 @@
               <a:t>• Industrial Context: </a:t>
             </a:r>
             <a:r>
-              <a:rPr sz="1800" b="0">
+              <a:rPr sz="2000" b="0">
                 <a:solidFill>
                   <a:srgbClr val="334155"/>
                 </a:solidFill>
                 <a:latin typeface="Calibri"/>
               </a:rPr>
-              <a:t>Commercial Aircraft Turbofan Jet Engine Fleet Operations.</a:t>
+              <a:t>Commercial Aircraft Turbofan Jet Engine Fleet Maintenance Operations &amp; Maintenance.</a:t>
             </a:r>
           </a:p>
           <a:p>
@@ -9973,16 +10148,16 @@
               </a:spcAft>
             </a:pPr>
             <a:r>
-              <a:rPr sz="1800" b="1">
-                <a:solidFill>
-                  <a:srgbClr val="0F172A"/>
-                </a:solidFill>
-                <a:latin typeface="Calibri"/>
-              </a:rPr>
-              <a:t>• Core Shift: </a:t>
-            </a:r>
-            <a:r>
-              <a:rPr sz="1800" b="0">
+              <a:rPr sz="2000" b="1">
+                <a:solidFill>
+                  <a:srgbClr val="0F172A"/>
+                </a:solidFill>
+                <a:latin typeface="Calibri"/>
+              </a:rPr>
+              <a:t>• Core Operational Shift: </a:t>
+            </a:r>
+            <a:r>
+              <a:rPr sz="2000" b="0">
                 <a:solidFill>
                   <a:srgbClr val="334155"/>
                 </a:solidFill>
@@ -9998,7 +10173,7 @@
               </a:spcAft>
             </a:pPr>
             <a:r>
-              <a:rPr sz="1800" b="1">
+              <a:rPr sz="2000" b="1">
                 <a:solidFill>
                   <a:srgbClr val="0F172A"/>
                 </a:solidFill>
@@ -10007,13 +10182,13 @@
               <a:t>• Primary Objective: </a:t>
             </a:r>
             <a:r>
-              <a:rPr sz="1800" b="0">
+              <a:rPr sz="2000" b="0">
                 <a:solidFill>
                   <a:srgbClr val="334155"/>
                 </a:solidFill>
                 <a:latin typeface="Calibri"/>
               </a:rPr>
-              <a:t>Utilize 21 sensor streams to forecast Remaining Useful Life (RUL).</a:t>
+              <a:t>Utilize 21 sensor streams to forecast Remaining Useful Life (RUL) before breakdown.</a:t>
             </a:r>
           </a:p>
           <a:p>
@@ -10023,7 +10198,7 @@
               </a:spcAft>
             </a:pPr>
             <a:r>
-              <a:rPr sz="1800" b="1">
+              <a:rPr sz="2000" b="1">
                 <a:solidFill>
                   <a:srgbClr val="0F172A"/>
                 </a:solidFill>
@@ -10032,7 +10207,7 @@
               <a:t>• Supervision &amp; Mentorship: </a:t>
             </a:r>
             <a:r>
-              <a:rPr sz="1800" b="0">
+              <a:rPr sz="2000" b="0">
                 <a:solidFill>
                   <a:srgbClr val="334155"/>
                 </a:solidFill>
@@ -10122,7 +10297,7 @@
             <a:pPr algn="r">
               <a:defRPr sz="1400">
                 <a:solidFill>
-                  <a:srgbClr val="64748B"/>
+                  <a:srgbClr val="334155"/>
                 </a:solidFill>
                 <a:latin typeface="Calibri"/>
               </a:defRPr>
@@ -10150,7 +10325,7 @@
           <a:noFill/>
         </p:spPr>
         <p:txBody>
-          <a:bodyPr wrap="square" lIns="0" tIns="0" rIns="0" bIns="0">
+          <a:bodyPr wrap="square">
             <a:spAutoFit/>
           </a:bodyPr>
           <a:lstStyle/>
@@ -10167,7 +10342,7 @@
               </a:defRPr>
             </a:pPr>
             <a:r>
-              <a:rPr sz="1800" b="1">
+              <a:rPr sz="2000" b="1">
                 <a:solidFill>
                   <a:srgbClr val="0F172A"/>
                 </a:solidFill>
@@ -10176,13 +10351,13 @@
               <a:t>• Unscheduled Groundings: </a:t>
             </a:r>
             <a:r>
-              <a:rPr sz="1800" b="0">
+              <a:rPr sz="2000" b="0">
                 <a:solidFill>
                   <a:srgbClr val="334155"/>
                 </a:solidFill>
                 <a:latin typeface="Calibri"/>
               </a:rPr>
-              <a:t>Sudden engine failures cause expensive flight delays and safety risks.</a:t>
+              <a:t>Sudden engine failures cause expensive flight delays and severe safety risks.</a:t>
             </a:r>
           </a:p>
           <a:p>
@@ -10244,7 +10419,7 @@
               </a:spcAft>
             </a:pPr>
             <a:r>
-              <a:rPr sz="1800" b="1">
+              <a:rPr sz="2000" b="1">
                 <a:solidFill>
                   <a:srgbClr val="0F172A"/>
                 </a:solidFill>
@@ -10253,13 +10428,13 @@
               <a:t>• Static Maintenance Inefficiency: </a:t>
             </a:r>
             <a:r>
-              <a:rPr sz="1800" b="0">
+              <a:rPr sz="2000" b="0">
                 <a:solidFill>
                   <a:srgbClr val="334155"/>
                 </a:solidFill>
                 <a:latin typeface="Calibri"/>
               </a:rPr>
-              <a:t>Replaces functional turbofan parts prematurely or misses breakdown.</a:t>
+              <a:t>Replaces functional turbofan parts prematurely or misses failure events.</a:t>
             </a:r>
           </a:p>
           <a:p>
@@ -10269,7 +10444,7 @@
               </a:spcAft>
             </a:pPr>
             <a:r>
-              <a:rPr sz="1800" b="1">
+              <a:rPr sz="2000" b="1">
                 <a:solidFill>
                   <a:srgbClr val="0F172A"/>
                 </a:solidFill>
@@ -10278,7 +10453,7 @@
               <a:t>• High Sensor Fluctuation: </a:t>
             </a:r>
             <a:r>
-              <a:rPr sz="1800" b="0">
+              <a:rPr sz="2000" b="0">
                 <a:solidFill>
                   <a:srgbClr val="334155"/>
                 </a:solidFill>
@@ -10294,7 +10469,7 @@
               </a:spcAft>
             </a:pPr>
             <a:r>
-              <a:rPr sz="1800" b="1">
+              <a:rPr sz="2000" b="1">
                 <a:solidFill>
                   <a:srgbClr val="0F172A"/>
                 </a:solidFill>
@@ -10303,13 +10478,38 @@
               <a:t>• Multi-Model Solution: </a:t>
             </a:r>
             <a:r>
-              <a:rPr sz="1800" b="0">
+              <a:rPr sz="2000" b="0">
                 <a:solidFill>
                   <a:srgbClr val="334155"/>
                 </a:solidFill>
                 <a:latin typeface="Calibri"/>
               </a:rPr>
               <a:t>Deploy Regression for RUL, Binary 30d Alerts, and Multi-Class Hazard Rating.</a:t>
+            </a:r>
+          </a:p>
+          <a:p>
+            <a:pPr>
+              <a:spcAft>
+                <a:spcPts val="1400"/>
+              </a:spcAft>
+            </a:pPr>
+            <a:r>
+              <a:rPr sz="2000" b="1">
+                <a:solidFill>
+                  <a:srgbClr val="0F172A"/>
+                </a:solidFill>
+                <a:latin typeface="Calibri"/>
+              </a:rPr>
+              <a:t>• Real-Time Constraint: </a:t>
+            </a:r>
+            <a:r>
+              <a:rPr sz="2000" b="0">
+                <a:solidFill>
+                  <a:srgbClr val="334155"/>
+                </a:solidFill>
+                <a:latin typeface="Calibri"/>
+              </a:rPr>
+              <a:t>Achieve fast sub-30ms inference latency for immediate operational dispatch.</a:t>
             </a:r>
           </a:p>
         </p:txBody>
@@ -10393,7 +10593,7 @@
             <a:pPr algn="r">
               <a:defRPr sz="1400">
                 <a:solidFill>
-                  <a:srgbClr val="64748B"/>
+                  <a:srgbClr val="334155"/>
                 </a:solidFill>
                 <a:latin typeface="Calibri"/>
               </a:defRPr>
@@ -10421,7 +10621,7 @@
           <a:noFill/>
         </p:spPr>
         <p:txBody>
-          <a:bodyPr wrap="square" lIns="0" tIns="0" rIns="0" bIns="0">
+          <a:bodyPr wrap="square">
             <a:spAutoFit/>
           </a:bodyPr>
           <a:lstStyle/>
@@ -10438,7 +10638,7 @@
               </a:defRPr>
             </a:pPr>
             <a:r>
-              <a:rPr sz="1800" b="1">
+              <a:rPr sz="2000" b="1">
                 <a:solidFill>
                   <a:srgbClr val="0F172A"/>
                 </a:solidFill>
@@ -10447,7 +10647,7 @@
               <a:t>• Hardware Requirements: </a:t>
             </a:r>
             <a:r>
-              <a:rPr sz="1800" b="0">
+              <a:rPr sz="2000" b="0">
                 <a:solidFill>
                   <a:srgbClr val="334155"/>
                 </a:solidFill>
@@ -10515,22 +10715,22 @@
               </a:spcAft>
             </a:pPr>
             <a:r>
-              <a:rPr sz="1800" b="1">
-                <a:solidFill>
-                  <a:srgbClr val="0F172A"/>
-                </a:solidFill>
-                <a:latin typeface="Calibri"/>
-              </a:rPr>
-              <a:t>• Software Stack &amp; Language: </a:t>
-            </a:r>
-            <a:r>
-              <a:rPr sz="1800" b="0">
+              <a:rPr sz="2000" b="1">
+                <a:solidFill>
+                  <a:srgbClr val="0F172A"/>
+                </a:solidFill>
+                <a:latin typeface="Calibri"/>
+              </a:rPr>
+              <a:t>• Programming Language: </a:t>
+            </a:r>
+            <a:r>
+              <a:rPr sz="2000" b="0">
                 <a:solidFill>
                   <a:srgbClr val="334155"/>
                 </a:solidFill>
                 <a:latin typeface="Calibri"/>
               </a:rPr>
-              <a:t>Python 3.11+ Core Language, VS Code / Jupyter Notebook IDE.</a:t>
+              <a:t>Python 3.11 (Core predictive logic, data wrangling &amp; model serialization).</a:t>
             </a:r>
           </a:p>
           <a:p>
@@ -10540,7 +10740,7 @@
               </a:spcAft>
             </a:pPr>
             <a:r>
-              <a:rPr sz="1800" b="1">
+              <a:rPr sz="2000" b="1">
                 <a:solidFill>
                   <a:srgbClr val="0F172A"/>
                 </a:solidFill>
@@ -10549,7 +10749,7 @@
               <a:t>• Machine Learning Frameworks: </a:t>
             </a:r>
             <a:r>
-              <a:rPr sz="1800" b="0">
+              <a:rPr sz="2000" b="0">
                 <a:solidFill>
                   <a:srgbClr val="334155"/>
                 </a:solidFill>
@@ -10565,7 +10765,7 @@
               </a:spcAft>
             </a:pPr>
             <a:r>
-              <a:rPr sz="1800" b="1">
+              <a:rPr sz="2000" b="1">
                 <a:solidFill>
                   <a:srgbClr val="0F172A"/>
                 </a:solidFill>
@@ -10574,7 +10774,7 @@
               <a:t>• Data &amp; Signal Libraries: </a:t>
             </a:r>
             <a:r>
-              <a:rPr sz="1800" b="0">
+              <a:rPr sz="2000" b="0">
                 <a:solidFill>
                   <a:srgbClr val="334155"/>
                 </a:solidFill>
@@ -10590,7 +10790,7 @@
               </a:spcAft>
             </a:pPr>
             <a:r>
-              <a:rPr sz="1800" b="1">
+              <a:rPr sz="2000" b="1">
                 <a:solidFill>
                   <a:srgbClr val="0F172A"/>
                 </a:solidFill>
@@ -10599,13 +10799,13 @@
               <a:t>• Visualization Frameworks: </a:t>
             </a:r>
             <a:r>
-              <a:rPr sz="1800" b="0">
+              <a:rPr sz="2000" b="0">
                 <a:solidFill>
                   <a:srgbClr val="334155"/>
                 </a:solidFill>
                 <a:latin typeface="Calibri"/>
               </a:rPr>
-              <a:t>Matplotlib, Seaborn for publication-grade metric charts.</a:t>
+              <a:t>Matplotlib, Seaborn for publication-grade metric evaluation charts.</a:t>
             </a:r>
           </a:p>
         </p:txBody>
@@ -10689,7 +10889,7 @@
             <a:pPr algn="r">
               <a:defRPr sz="1400">
                 <a:solidFill>
-                  <a:srgbClr val="64748B"/>
+                  <a:srgbClr val="334155"/>
                 </a:solidFill>
                 <a:latin typeface="Calibri"/>
               </a:defRPr>
@@ -10715,11 +10915,11 @@
             <a:avLst/>
           </a:prstGeom>
           <a:solidFill>
-            <a:srgbClr val="F1F5F9"/>
+            <a:srgbClr val="E0F2FE"/>
           </a:solidFill>
-          <a:ln w="19050">
+          <a:ln w="31750">
             <a:solidFill>
-              <a:srgbClr val="0284C7"/>
+              <a:srgbClr val="0D6EFD"/>
             </a:solidFill>
           </a:ln>
         </p:spPr>
@@ -10738,7 +10938,7 @@
           </a:fontRef>
         </p:style>
         <p:txBody>
-          <a:bodyPr rtlCol="0" anchor="ctr" wrap="square"/>
+          <a:bodyPr rtlCol="0" anchor="ctr" wrap="square" lIns="45720" rIns="45720"/>
           <a:lstStyle/>
           <a:p>
             <a:pPr algn="ctr">
@@ -10768,7 +10968,7 @@
           </a:p>
           <a:p>
             <a:pPr algn="ctr">
-              <a:defRPr sz="1400" b="1">
+              <a:defRPr sz="1300" b="0">
                 <a:solidFill>
                   <a:srgbClr val="0F172A"/>
                 </a:solidFill>
@@ -10778,16 +10978,7 @@
             <a:r>
               <a:t>Telemetry Ingestion</a:t>
             </a:r>
-          </a:p>
-          <a:p>
-            <a:pPr algn="ctr">
-              <a:defRPr sz="1200">
-                <a:solidFill>
-                  <a:srgbClr val="334155"/>
-                </a:solidFill>
-                <a:latin typeface="Calibri"/>
-              </a:defRPr>
-            </a:pPr>
+            <a:br/>
             <a:r>
               <a:t>(NASA C-MAPSS 21 Sensors)</a:t>
             </a:r>
@@ -10809,7 +11000,7 @@
             <a:avLst/>
           </a:prstGeom>
           <a:solidFill>
-            <a:srgbClr val="0284C7"/>
+            <a:srgbClr val="0D6EFD"/>
           </a:solidFill>
           <a:ln>
             <a:noFill/>
@@ -10852,11 +11043,11 @@
             <a:avLst/>
           </a:prstGeom>
           <a:solidFill>
-            <a:srgbClr val="F1F5F9"/>
+            <a:srgbClr val="E0F2FE"/>
           </a:solidFill>
-          <a:ln w="19050">
+          <a:ln w="31750">
             <a:solidFill>
-              <a:srgbClr val="0284C7"/>
+              <a:srgbClr val="8B5CF6"/>
             </a:solidFill>
           </a:ln>
         </p:spPr>
@@ -10875,7 +11066,7 @@
           </a:fontRef>
         </p:style>
         <p:txBody>
-          <a:bodyPr rtlCol="0" anchor="ctr" wrap="square"/>
+          <a:bodyPr rtlCol="0" anchor="ctr" wrap="square" lIns="45720" rIns="45720"/>
           <a:lstStyle/>
           <a:p>
             <a:pPr algn="ctr">
@@ -10905,7 +11096,7 @@
           </a:p>
           <a:p>
             <a:pPr algn="ctr">
-              <a:defRPr sz="1400" b="1">
+              <a:defRPr sz="1300" b="0">
                 <a:solidFill>
                   <a:srgbClr val="0F172A"/>
                 </a:solidFill>
@@ -10915,18 +11106,9 @@
             <a:r>
               <a:t>Rolling Feature Engine</a:t>
             </a:r>
-          </a:p>
-          <a:p>
-            <a:pPr algn="ctr">
-              <a:defRPr sz="1200">
-                <a:solidFill>
-                  <a:srgbClr val="334155"/>
-                </a:solidFill>
-                <a:latin typeface="Calibri"/>
-              </a:defRPr>
-            </a:pPr>
-            <a:r>
-              <a:t>(5-Cycle Mean &amp; Std)</a:t>
+            <a:br/>
+            <a:r>
+              <a:t>(5-Cycle Mean &amp; Std Dev)</a:t>
             </a:r>
           </a:p>
         </p:txBody>
@@ -10946,7 +11128,7 @@
             <a:avLst/>
           </a:prstGeom>
           <a:solidFill>
-            <a:srgbClr val="0284C7"/>
+            <a:srgbClr val="8B5CF6"/>
           </a:solidFill>
           <a:ln>
             <a:noFill/>
@@ -10989,11 +11171,11 @@
             <a:avLst/>
           </a:prstGeom>
           <a:solidFill>
-            <a:srgbClr val="F1F5F9"/>
+            <a:srgbClr val="E0F2FE"/>
           </a:solidFill>
-          <a:ln w="19050">
+          <a:ln w="31750">
             <a:solidFill>
-              <a:srgbClr val="0284C7"/>
+              <a:srgbClr val="0D6EFD"/>
             </a:solidFill>
           </a:ln>
         </p:spPr>
@@ -11012,7 +11194,7 @@
           </a:fontRef>
         </p:style>
         <p:txBody>
-          <a:bodyPr rtlCol="0" anchor="ctr" wrap="square"/>
+          <a:bodyPr rtlCol="0" anchor="ctr" wrap="square" lIns="45720" rIns="45720"/>
           <a:lstStyle/>
           <a:p>
             <a:pPr algn="ctr">
@@ -11042,7 +11224,7 @@
           </a:p>
           <a:p>
             <a:pPr algn="ctr">
-              <a:defRPr sz="1400" b="1">
+              <a:defRPr sz="1300" b="0">
                 <a:solidFill>
                   <a:srgbClr val="0F172A"/>
                 </a:solidFill>
@@ -11052,16 +11234,7 @@
             <a:r>
               <a:t>Multicollinearity Filter</a:t>
             </a:r>
-          </a:p>
-          <a:p>
-            <a:pPr algn="ctr">
-              <a:defRPr sz="1200">
-                <a:solidFill>
-                  <a:srgbClr val="334155"/>
-                </a:solidFill>
-                <a:latin typeface="Calibri"/>
-              </a:defRPr>
-            </a:pPr>
+            <a:br/>
             <a:r>
               <a:t>(Correlation Reduction r&gt;0.80)</a:t>
             </a:r>
@@ -11083,11 +11256,11 @@
             <a:avLst/>
           </a:prstGeom>
           <a:solidFill>
-            <a:srgbClr val="F1F5F9"/>
+            <a:srgbClr val="E0F2FE"/>
           </a:solidFill>
-          <a:ln w="19050">
+          <a:ln w="31750">
             <a:solidFill>
-              <a:srgbClr val="0284C7"/>
+              <a:srgbClr val="0F172A"/>
             </a:solidFill>
           </a:ln>
         </p:spPr>
@@ -11106,7 +11279,7 @@
           </a:fontRef>
         </p:style>
         <p:txBody>
-          <a:bodyPr rtlCol="0" anchor="ctr" wrap="square"/>
+          <a:bodyPr rtlCol="0" anchor="ctr" wrap="square" lIns="45720" rIns="45720"/>
           <a:lstStyle/>
           <a:p>
             <a:pPr algn="ctr">
@@ -11136,7 +11309,7 @@
           </a:p>
           <a:p>
             <a:pPr algn="ctr">
-              <a:defRPr sz="1400" b="1">
+              <a:defRPr sz="1300" b="0">
                 <a:solidFill>
                   <a:srgbClr val="0F172A"/>
                 </a:solidFill>
@@ -11146,16 +11319,7 @@
             <a:r>
               <a:t>RUL Regression Net</a:t>
             </a:r>
-          </a:p>
-          <a:p>
-            <a:pPr algn="ctr">
-              <a:defRPr sz="1200">
-                <a:solidFill>
-                  <a:srgbClr val="334155"/>
-                </a:solidFill>
-                <a:latin typeface="Calibri"/>
-              </a:defRPr>
-            </a:pPr>
+            <a:br/>
             <a:r>
               <a:t>(Random Forest Regressor)</a:t>
             </a:r>
@@ -11170,14 +11334,14 @@
         </p:nvSpPr>
         <p:spPr>
           <a:xfrm>
-            <a:off x="2788920" y="4251960"/>
+            <a:off x="2788920" y="4251959"/>
             <a:ext cx="457200" cy="274320"/>
           </a:xfrm>
           <a:prstGeom prst="rightArrow">
             <a:avLst/>
           </a:prstGeom>
           <a:solidFill>
-            <a:srgbClr val="0284C7"/>
+            <a:srgbClr val="0F172A"/>
           </a:solidFill>
           <a:ln>
             <a:noFill/>
@@ -11220,11 +11384,11 @@
             <a:avLst/>
           </a:prstGeom>
           <a:solidFill>
-            <a:srgbClr val="F1F5F9"/>
+            <a:srgbClr val="E0F2FE"/>
           </a:solidFill>
-          <a:ln w="19050">
+          <a:ln w="31750">
             <a:solidFill>
-              <a:srgbClr val="0284C7"/>
+              <a:srgbClr val="8B5CF6"/>
             </a:solidFill>
           </a:ln>
         </p:spPr>
@@ -11243,7 +11407,7 @@
           </a:fontRef>
         </p:style>
         <p:txBody>
-          <a:bodyPr rtlCol="0" anchor="ctr" wrap="square"/>
+          <a:bodyPr rtlCol="0" anchor="ctr" wrap="square" lIns="45720" rIns="45720"/>
           <a:lstStyle/>
           <a:p>
             <a:pPr algn="ctr">
@@ -11273,7 +11437,7 @@
           </a:p>
           <a:p>
             <a:pPr algn="ctr">
-              <a:defRPr sz="1400" b="1">
+              <a:defRPr sz="1300" b="0">
                 <a:solidFill>
                   <a:srgbClr val="0F172A"/>
                 </a:solidFill>
@@ -11283,16 +11447,7 @@
             <a:r>
               <a:t>Binary 30d Classifier</a:t>
             </a:r>
-          </a:p>
-          <a:p>
-            <a:pPr algn="ctr">
-              <a:defRPr sz="1200">
-                <a:solidFill>
-                  <a:srgbClr val="334155"/>
-                </a:solidFill>
-                <a:latin typeface="Calibri"/>
-              </a:defRPr>
-            </a:pPr>
+            <a:br/>
             <a:r>
               <a:t>(98.45% AUC-ROC Model)</a:t>
             </a:r>
@@ -11307,14 +11462,14 @@
         </p:nvSpPr>
         <p:spPr>
           <a:xfrm>
-            <a:off x="5532120" y="4251960"/>
+            <a:off x="5532120" y="4251959"/>
             <a:ext cx="457200" cy="274320"/>
           </a:xfrm>
           <a:prstGeom prst="rightArrow">
             <a:avLst/>
           </a:prstGeom>
           <a:solidFill>
-            <a:srgbClr val="0284C7"/>
+            <a:srgbClr val="8B5CF6"/>
           </a:solidFill>
           <a:ln>
             <a:noFill/>
@@ -11357,11 +11512,11 @@
             <a:avLst/>
           </a:prstGeom>
           <a:solidFill>
-            <a:srgbClr val="F1F5F9"/>
+            <a:srgbClr val="E0F2FE"/>
           </a:solidFill>
-          <a:ln w="19050">
+          <a:ln w="31750">
             <a:solidFill>
-              <a:srgbClr val="0284C7"/>
+              <a:srgbClr val="10B981"/>
             </a:solidFill>
           </a:ln>
         </p:spPr>
@@ -11380,7 +11535,7 @@
           </a:fontRef>
         </p:style>
         <p:txBody>
-          <a:bodyPr rtlCol="0" anchor="ctr" wrap="square"/>
+          <a:bodyPr rtlCol="0" anchor="ctr" wrap="square" lIns="45720" rIns="45720"/>
           <a:lstStyle/>
           <a:p>
             <a:pPr algn="ctr">
@@ -11410,7 +11565,7 @@
           </a:p>
           <a:p>
             <a:pPr algn="ctr">
-              <a:defRPr sz="1400" b="1">
+              <a:defRPr sz="1300" b="0">
                 <a:solidFill>
                   <a:srgbClr val="0F172A"/>
                 </a:solidFill>
@@ -11420,16 +11575,7 @@
             <a:r>
               <a:t>Multi-Class Neural MLP</a:t>
             </a:r>
-          </a:p>
-          <a:p>
-            <a:pPr algn="ctr">
-              <a:defRPr sz="1200">
-                <a:solidFill>
-                  <a:srgbClr val="334155"/>
-                </a:solidFill>
-                <a:latin typeface="Calibri"/>
-              </a:defRPr>
-            </a:pPr>
+            <a:br/>
             <a:r>
               <a:t>(3-Tier Risk Hazard Dispatch)</a:t>
             </a:r>
@@ -11551,7 +11697,7 @@
             <a:pPr algn="r">
               <a:defRPr sz="1400">
                 <a:solidFill>
-                  <a:srgbClr val="64748B"/>
+                  <a:srgbClr val="334155"/>
                 </a:solidFill>
                 <a:latin typeface="Calibri"/>
               </a:defRPr>
@@ -11579,7 +11725,7 @@
           <a:noFill/>
         </p:spPr>
         <p:txBody>
-          <a:bodyPr wrap="square" lIns="0" tIns="0" rIns="0" bIns="0">
+          <a:bodyPr wrap="square">
             <a:spAutoFit/>
           </a:bodyPr>
           <a:lstStyle/>
@@ -11596,7 +11742,7 @@
               </a:defRPr>
             </a:pPr>
             <a:r>
-              <a:rPr sz="1800" b="1">
+              <a:rPr sz="2000" b="1">
                 <a:solidFill>
                   <a:srgbClr val="0F172A"/>
                 </a:solidFill>
@@ -11605,7 +11751,7 @@
               <a:t>• Rolling Window Aggregations: </a:t>
             </a:r>
             <a:r>
-              <a:rPr sz="1800" b="0">
+              <a:rPr sz="2000" b="0">
                 <a:solidFill>
                   <a:srgbClr val="334155"/>
                 </a:solidFill>
@@ -11673,16 +11819,16 @@
               </a:spcAft>
             </a:pPr>
             <a:r>
-              <a:rPr sz="1800" b="1">
-                <a:solidFill>
-                  <a:srgbClr val="0F172A"/>
-                </a:solidFill>
-                <a:latin typeface="Calibri"/>
-              </a:rPr>
-              <a:t>• Noise Reduction: </a:t>
-            </a:r>
-            <a:r>
-              <a:rPr sz="1800" b="0">
+              <a:rPr sz="2000" b="1">
+                <a:solidFill>
+                  <a:srgbClr val="0F172A"/>
+                </a:solidFill>
+                <a:latin typeface="Calibri"/>
+              </a:rPr>
+              <a:t>• Signal Noise Reduction: </a:t>
+            </a:r>
+            <a:r>
+              <a:rPr sz="2000" b="0">
                 <a:solidFill>
                   <a:srgbClr val="334155"/>
                 </a:solidFill>
@@ -11698,7 +11844,7 @@
               </a:spcAft>
             </a:pPr>
             <a:r>
-              <a:rPr sz="1800" b="1">
+              <a:rPr sz="2000" b="1">
                 <a:solidFill>
                   <a:srgbClr val="0F172A"/>
                 </a:solidFill>
@@ -11707,7 +11853,7 @@
               <a:t>• Multicollinearity Filtering: </a:t>
             </a:r>
             <a:r>
-              <a:rPr sz="1800" b="0">
+              <a:rPr sz="2000" b="0">
                 <a:solidFill>
                   <a:srgbClr val="334155"/>
                 </a:solidFill>
@@ -11723,22 +11869,47 @@
               </a:spcAft>
             </a:pPr>
             <a:r>
-              <a:rPr sz="1800" b="1">
-                <a:solidFill>
-                  <a:srgbClr val="0F172A"/>
-                </a:solidFill>
-                <a:latin typeface="Calibri"/>
-              </a:rPr>
-              <a:t>• Expanded Feature Space: </a:t>
-            </a:r>
-            <a:r>
-              <a:rPr sz="1800" b="0">
+              <a:rPr sz="2000" b="1">
+                <a:solidFill>
+                  <a:srgbClr val="0F172A"/>
+                </a:solidFill>
+                <a:latin typeface="Calibri"/>
+              </a:rPr>
+              <a:t>• Scale &amp; Position Normalization: </a:t>
+            </a:r>
+            <a:r>
+              <a:rPr sz="2000" b="0">
                 <a:solidFill>
                   <a:srgbClr val="334155"/>
                 </a:solidFill>
                 <a:latin typeface="Calibri"/>
               </a:rPr>
-              <a:t>Generates 45 total input attributes for machine learning model training.</a:t>
+              <a:t>StandardScaler normalization ensures robustness across operating settings.</a:t>
+            </a:r>
+          </a:p>
+          <a:p>
+            <a:pPr>
+              <a:spcAft>
+                <a:spcPts val="1400"/>
+              </a:spcAft>
+            </a:pPr>
+            <a:r>
+              <a:rPr sz="2000" b="1">
+                <a:solidFill>
+                  <a:srgbClr val="0F172A"/>
+                </a:solidFill>
+                <a:latin typeface="Calibri"/>
+              </a:rPr>
+              <a:t>• Compact Feature Dimension: </a:t>
+            </a:r>
+            <a:r>
+              <a:rPr sz="2000" b="0">
+                <a:solidFill>
+                  <a:srgbClr val="334155"/>
+                </a:solidFill>
+                <a:latin typeface="Calibri"/>
+              </a:rPr>
+              <a:t>Expands raw telemetry data into a structured 45-element feature vector.</a:t>
             </a:r>
           </a:p>
         </p:txBody>
@@ -11822,7 +11993,7 @@
             <a:pPr algn="r">
               <a:defRPr sz="1400">
                 <a:solidFill>
-                  <a:srgbClr val="64748B"/>
+                  <a:srgbClr val="334155"/>
                 </a:solidFill>
                 <a:latin typeface="Calibri"/>
               </a:defRPr>
@@ -11850,7 +12021,7 @@
           <a:noFill/>
         </p:spPr>
         <p:txBody>
-          <a:bodyPr wrap="square" lIns="0" tIns="0" rIns="0" bIns="0">
+          <a:bodyPr wrap="square">
             <a:spAutoFit/>
           </a:bodyPr>
           <a:lstStyle/>
@@ -11867,22 +12038,22 @@
               </a:defRPr>
             </a:pPr>
             <a:r>
-              <a:rPr sz="1800" b="1">
-                <a:solidFill>
-                  <a:srgbClr val="0F172A"/>
-                </a:solidFill>
-                <a:latin typeface="Calibri"/>
-              </a:rPr>
-              <a:t>• Data Provider: </a:t>
-            </a:r>
-            <a:r>
-              <a:rPr sz="1800" b="0">
+              <a:rPr sz="2000" b="1">
+                <a:solidFill>
+                  <a:srgbClr val="0F172A"/>
+                </a:solidFill>
+                <a:latin typeface="Calibri"/>
+              </a:rPr>
+              <a:t>• Dataset Size &amp; Support: </a:t>
+            </a:r>
+            <a:r>
+              <a:rPr sz="2000" b="0">
                 <a:solidFill>
                   <a:srgbClr val="334155"/>
                 </a:solidFill>
                 <a:latin typeface="Calibri"/>
               </a:rPr>
-              <a:t>NASA Ames Prognostics Center of Excellence C-MAPSS Simulation Dataset.</a:t>
+              <a:t>NASA Ames Prognostics Center of Excellence C-MAPSS Turbofan Simulation Dataset.</a:t>
             </a:r>
           </a:p>
           <a:p>
@@ -11944,7 +12115,7 @@
               </a:spcAft>
             </a:pPr>
             <a:r>
-              <a:rPr sz="1800" b="1">
+              <a:rPr sz="2000" b="1">
                 <a:solidFill>
                   <a:srgbClr val="0F172A"/>
                 </a:solidFill>
@@ -11953,7 +12124,7 @@
               <a:t>• Training Fleet Size: </a:t>
             </a:r>
             <a:r>
-              <a:rPr sz="1800" b="0">
+              <a:rPr sz="2000" b="0">
                 <a:solidFill>
                   <a:srgbClr val="334155"/>
                 </a:solidFill>
@@ -11969,7 +12140,7 @@
               </a:spcAft>
             </a:pPr>
             <a:r>
-              <a:rPr sz="1800" b="1">
+              <a:rPr sz="2000" b="1">
                 <a:solidFill>
                   <a:srgbClr val="0F172A"/>
                 </a:solidFill>
@@ -11978,7 +12149,7 @@
               <a:t>• Testing Fleet Size: </a:t>
             </a:r>
             <a:r>
-              <a:rPr sz="1800" b="0">
+              <a:rPr sz="2000" b="0">
                 <a:solidFill>
                   <a:srgbClr val="334155"/>
                 </a:solidFill>
@@ -11994,7 +12165,32 @@
               </a:spcAft>
             </a:pPr>
             <a:r>
-              <a:rPr sz="1800" b="1">
+              <a:rPr sz="2000" b="1">
+                <a:solidFill>
+                  <a:srgbClr val="0F172A"/>
+                </a:solidFill>
+                <a:latin typeface="Calibri"/>
+              </a:rPr>
+              <a:t>• Target Classification Windows: </a:t>
+            </a:r>
+            <a:r>
+              <a:rPr sz="2000" b="0">
+                <a:solidFill>
+                  <a:srgbClr val="334155"/>
+                </a:solidFill>
+                <a:latin typeface="Calibri"/>
+              </a:rPr>
+              <a:t>30-cycle failure warning window (w1 = 30) and 15-cycle urgent window (w0 = 15).</a:t>
+            </a:r>
+          </a:p>
+          <a:p>
+            <a:pPr>
+              <a:spcAft>
+                <a:spcPts val="1400"/>
+              </a:spcAft>
+            </a:pPr>
+            <a:r>
+              <a:rPr sz="2000" b="1">
                 <a:solidFill>
                   <a:srgbClr val="0F172A"/>
                 </a:solidFill>
@@ -12003,7 +12199,7 @@
               <a:t>• Dataset Quality: </a:t>
             </a:r>
             <a:r>
-              <a:rPr sz="1800" b="0">
+              <a:rPr sz="2000" b="0">
                 <a:solidFill>
                   <a:srgbClr val="334155"/>
                 </a:solidFill>
@@ -12093,7 +12289,7 @@
             <a:pPr algn="r">
               <a:defRPr sz="1400">
                 <a:solidFill>
-                  <a:srgbClr val="64748B"/>
+                  <a:srgbClr val="334155"/>
                 </a:solidFill>
                 <a:latin typeface="Calibri"/>
               </a:defRPr>
@@ -12121,7 +12317,7 @@
           <a:noFill/>
         </p:spPr>
         <p:txBody>
-          <a:bodyPr wrap="square" lIns="0" tIns="0" rIns="0" bIns="0">
+          <a:bodyPr wrap="square">
             <a:spAutoFit/>
           </a:bodyPr>
           <a:lstStyle/>
@@ -12138,7 +12334,7 @@
               </a:defRPr>
             </a:pPr>
             <a:r>
-              <a:rPr sz="1800" b="1">
+              <a:rPr sz="2000" b="1">
                 <a:solidFill>
                   <a:srgbClr val="0F172A"/>
                 </a:solidFill>
@@ -12147,13 +12343,13 @@
               <a:t>• 1. RUL Regression Model: </a:t>
             </a:r>
             <a:r>
-              <a:rPr sz="1800" b="0">
+              <a:rPr sz="2000" b="0">
                 <a:solidFill>
                   <a:srgbClr val="334155"/>
                 </a:solidFill>
                 <a:latin typeface="Calibri"/>
               </a:rPr>
-              <a:t>Random Forest Regressor predicting exact cycles left before failure.</a:t>
+              <a:t>Random Forest Regressor predicting exact cycles remaining before failure.</a:t>
             </a:r>
           </a:p>
           <a:p>
@@ -12215,7 +12411,7 @@
               </a:spcAft>
             </a:pPr>
             <a:r>
-              <a:rPr sz="1800" b="1">
+              <a:rPr sz="2000" b="1">
                 <a:solidFill>
                   <a:srgbClr val="0F172A"/>
                 </a:solidFill>
@@ -12224,7 +12420,7 @@
               <a:t>• 2. Binary 30-Cycle Warning Classifier: </a:t>
             </a:r>
             <a:r>
-              <a:rPr sz="1800" b="0">
+              <a:rPr sz="2000" b="0">
                 <a:solidFill>
                   <a:srgbClr val="334155"/>
                 </a:solidFill>
@@ -12240,7 +12436,7 @@
               </a:spcAft>
             </a:pPr>
             <a:r>
-              <a:rPr sz="1800" b="1">
+              <a:rPr sz="2000" b="1">
                 <a:solidFill>
                   <a:srgbClr val="0F172A"/>
                 </a:solidFill>
@@ -12249,7 +12445,7 @@
               <a:t>• 3. Multi-Class Neural MLP: </a:t>
             </a:r>
             <a:r>
-              <a:rPr sz="1800" b="0">
+              <a:rPr sz="2000" b="0">
                 <a:solidFill>
                   <a:srgbClr val="334155"/>
                 </a:solidFill>
@@ -12265,22 +12461,47 @@
               </a:spcAft>
             </a:pPr>
             <a:r>
-              <a:rPr sz="1800" b="1">
-                <a:solidFill>
-                  <a:srgbClr val="0F172A"/>
-                </a:solidFill>
-                <a:latin typeface="Calibri"/>
-              </a:rPr>
-              <a:t>• Multi-Tier Risk Classes: </a:t>
-            </a:r>
-            <a:r>
-              <a:rPr sz="1800" b="0">
+              <a:rPr sz="2000" b="1">
+                <a:solidFill>
+                  <a:srgbClr val="0F172A"/>
+                </a:solidFill>
+                <a:latin typeface="Calibri"/>
+              </a:rPr>
+              <a:t>• Multi-Tier Hazard Classes: </a:t>
+            </a:r>
+            <a:r>
+              <a:rPr sz="2000" b="0">
                 <a:solidFill>
                   <a:srgbClr val="334155"/>
                 </a:solidFill>
                 <a:latin typeface="Calibri"/>
               </a:rPr>
               <a:t>Healthy (&gt;30 cycles), Warning (15-30 cycles), Critical (&lt;=15 cycles).</a:t>
+            </a:r>
+          </a:p>
+          <a:p>
+            <a:pPr>
+              <a:spcAft>
+                <a:spcPts val="1400"/>
+              </a:spcAft>
+            </a:pPr>
+            <a:r>
+              <a:rPr sz="2000" b="1">
+                <a:solidFill>
+                  <a:srgbClr val="0F172A"/>
+                </a:solidFill>
+                <a:latin typeface="Calibri"/>
+              </a:rPr>
+              <a:t>• Softmax Risk Output: </a:t>
+            </a:r>
+            <a:r>
+              <a:rPr sz="2000" b="0">
+                <a:solidFill>
+                  <a:srgbClr val="334155"/>
+                </a:solidFill>
+                <a:latin typeface="Calibri"/>
+              </a:rPr>
+              <a:t>Neural net produces normalized probability distributions over risk categories.</a:t>
             </a:r>
           </a:p>
         </p:txBody>

</xml_diff>

<commit_message>
Update presentation with Image 4 matching vertical flowchart and zero text box overflow
</commit_message>
<xml_diff>
--- a/Internship Presentation PPTs Template Final.pptx
+++ b/Internship Presentation PPTs Template Final.pptx
@@ -5557,7 +5557,7 @@
         <p:spPr>
           <a:xfrm>
             <a:off x="548640" y="365760"/>
-            <a:ext cx="8046720" cy="731520"/>
+            <a:ext cx="8046720" cy="640080"/>
           </a:xfrm>
           <a:prstGeom prst="rect">
             <a:avLst/>
@@ -5609,7 +5609,7 @@
             <a:pPr algn="r">
               <a:defRPr sz="1400">
                 <a:solidFill>
-                  <a:srgbClr val="334155"/>
+                  <a:srgbClr val="64748B"/>
                 </a:solidFill>
                 <a:latin typeface="Calibri"/>
               </a:defRPr>
@@ -5628,8 +5628,8 @@
         </p:nvSpPr>
         <p:spPr>
           <a:xfrm>
-            <a:off x="548640" y="1188720"/>
-            <a:ext cx="8046720" cy="4846320"/>
+            <a:off x="548640" y="1097280"/>
+            <a:ext cx="8046720" cy="4754880"/>
           </a:xfrm>
           <a:prstGeom prst="rect">
             <a:avLst/>
@@ -5637,14 +5637,14 @@
           <a:noFill/>
         </p:spPr>
         <p:txBody>
-          <a:bodyPr wrap="square">
+          <a:bodyPr wrap="square" lIns="0" tIns="0" rIns="0" bIns="0">
             <a:spAutoFit/>
           </a:bodyPr>
           <a:lstStyle/>
           <a:p>
             <a:pPr>
               <a:spcAft>
-                <a:spcPts val="1400"/>
+                <a:spcPts val="1200"/>
               </a:spcAft>
               <a:defRPr sz="2000" b="1">
                 <a:solidFill>
@@ -5654,7 +5654,7 @@
               </a:defRPr>
             </a:pPr>
             <a:r>
-              <a:rPr sz="2000" b="1">
+              <a:rPr sz="1800" b="1">
                 <a:solidFill>
                   <a:srgbClr val="0F172A"/>
                 </a:solidFill>
@@ -5663,7 +5663,7 @@
               <a:t>• Command-Line Diagnostic Tool: </a:t>
             </a:r>
             <a:r>
-              <a:rPr sz="2000" b="0">
+              <a:rPr sz="1800" b="0">
                 <a:solidFill>
                   <a:srgbClr val="334155"/>
                 </a:solidFill>
@@ -5727,11 +5727,11 @@
           <a:p>
             <a:pPr>
               <a:spcAft>
-                <a:spcPts val="1400"/>
-              </a:spcAft>
-            </a:pPr>
-            <a:r>
-              <a:rPr sz="2000" b="1">
+                <a:spcPts val="1200"/>
+              </a:spcAft>
+            </a:pPr>
+            <a:r>
+              <a:rPr sz="1800" b="1">
                 <a:solidFill>
                   <a:srgbClr val="0F172A"/>
                 </a:solidFill>
@@ -5740,7 +5740,7 @@
               <a:t>• Execution Command: </a:t>
             </a:r>
             <a:r>
-              <a:rPr sz="2000" b="0">
+              <a:rPr sz="1800" b="0">
                 <a:solidFill>
                   <a:srgbClr val="334155"/>
                 </a:solidFill>
@@ -5752,11 +5752,11 @@
           <a:p>
             <a:pPr>
               <a:spcAft>
-                <a:spcPts val="1400"/>
-              </a:spcAft>
-            </a:pPr>
-            <a:r>
-              <a:rPr sz="2000" b="1">
+                <a:spcPts val="1200"/>
+              </a:spcAft>
+            </a:pPr>
+            <a:r>
+              <a:rPr sz="1800" b="1">
                 <a:solidFill>
                   <a:srgbClr val="0F172A"/>
                 </a:solidFill>
@@ -5765,7 +5765,7 @@
               <a:t>• Diagnostic Output Parameters: </a:t>
             </a:r>
             <a:r>
-              <a:rPr sz="2000" b="0">
+              <a:rPr sz="1800" b="0">
                 <a:solidFill>
                   <a:srgbClr val="334155"/>
                 </a:solidFill>
@@ -5777,11 +5777,11 @@
           <a:p>
             <a:pPr>
               <a:spcAft>
-                <a:spcPts val="1400"/>
-              </a:spcAft>
-            </a:pPr>
-            <a:r>
-              <a:rPr sz="2000" b="1">
+                <a:spcPts val="1200"/>
+              </a:spcAft>
+            </a:pPr>
+            <a:r>
+              <a:rPr sz="1800" b="1">
                 <a:solidFill>
                   <a:srgbClr val="0F172A"/>
                 </a:solidFill>
@@ -5790,7 +5790,7 @@
               <a:t>• Risk Rating Formatting: </a:t>
             </a:r>
             <a:r>
-              <a:rPr sz="2000" b="0">
+              <a:rPr sz="1800" b="0">
                 <a:solidFill>
                   <a:srgbClr val="334155"/>
                 </a:solidFill>
@@ -5802,11 +5802,11 @@
           <a:p>
             <a:pPr>
               <a:spcAft>
-                <a:spcPts val="1400"/>
-              </a:spcAft>
-            </a:pPr>
-            <a:r>
-              <a:rPr sz="2000" b="1">
+                <a:spcPts val="1200"/>
+              </a:spcAft>
+            </a:pPr>
+            <a:r>
+              <a:rPr sz="1800" b="1">
                 <a:solidFill>
                   <a:srgbClr val="0F172A"/>
                 </a:solidFill>
@@ -5815,7 +5815,7 @@
               <a:t>• Actionable Maintenance Recommendation: </a:t>
             </a:r>
             <a:r>
-              <a:rPr sz="2000" b="0">
+              <a:rPr sz="1800" b="0">
                 <a:solidFill>
                   <a:srgbClr val="334155"/>
                 </a:solidFill>
@@ -5853,7 +5853,7 @@
         <p:spPr>
           <a:xfrm>
             <a:off x="548640" y="365760"/>
-            <a:ext cx="8046720" cy="731520"/>
+            <a:ext cx="8046720" cy="640080"/>
           </a:xfrm>
           <a:prstGeom prst="rect">
             <a:avLst/>
@@ -5905,7 +5905,7 @@
             <a:pPr algn="r">
               <a:defRPr sz="1400">
                 <a:solidFill>
-                  <a:srgbClr val="334155"/>
+                  <a:srgbClr val="64748B"/>
                 </a:solidFill>
                 <a:latin typeface="Calibri"/>
               </a:defRPr>
@@ -5924,8 +5924,8 @@
         </p:nvSpPr>
         <p:spPr>
           <a:xfrm>
-            <a:off x="548640" y="1188720"/>
-            <a:ext cx="8046720" cy="4846320"/>
+            <a:off x="548640" y="1097280"/>
+            <a:ext cx="8046720" cy="4754880"/>
           </a:xfrm>
           <a:prstGeom prst="rect">
             <a:avLst/>
@@ -5933,14 +5933,14 @@
           <a:noFill/>
         </p:spPr>
         <p:txBody>
-          <a:bodyPr wrap="square">
+          <a:bodyPr wrap="square" lIns="0" tIns="0" rIns="0" bIns="0">
             <a:spAutoFit/>
           </a:bodyPr>
           <a:lstStyle/>
           <a:p>
             <a:pPr>
               <a:spcAft>
-                <a:spcPts val="1400"/>
+                <a:spcPts val="1200"/>
               </a:spcAft>
               <a:defRPr sz="2000" b="1">
                 <a:solidFill>
@@ -5950,7 +5950,7 @@
               </a:defRPr>
             </a:pPr>
             <a:r>
-              <a:rPr sz="2000" b="1">
+              <a:rPr sz="1800" b="1">
                 <a:solidFill>
                   <a:srgbClr val="0F172A"/>
                 </a:solidFill>
@@ -5959,7 +5959,7 @@
               <a:t>• Operational Thresholding: </a:t>
             </a:r>
             <a:r>
-              <a:rPr sz="2000" b="0">
+              <a:rPr sz="1800" b="0">
                 <a:solidFill>
                   <a:srgbClr val="334155"/>
                 </a:solidFill>
@@ -6023,11 +6023,11 @@
           <a:p>
             <a:pPr>
               <a:spcAft>
-                <a:spcPts val="1400"/>
-              </a:spcAft>
-            </a:pPr>
-            <a:r>
-              <a:rPr sz="2000" b="1">
+                <a:spcPts val="1200"/>
+              </a:spcAft>
+            </a:pPr>
+            <a:r>
+              <a:rPr sz="1800" b="1">
                 <a:solidFill>
                   <a:srgbClr val="0F172A"/>
                 </a:solidFill>
@@ -6036,7 +6036,7 @@
               <a:t>• Healthy State (Green): </a:t>
             </a:r>
             <a:r>
-              <a:rPr sz="2000" b="0">
+              <a:rPr sz="1800" b="0">
                 <a:solidFill>
                   <a:srgbClr val="334155"/>
                 </a:solidFill>
@@ -6048,11 +6048,11 @@
           <a:p>
             <a:pPr>
               <a:spcAft>
-                <a:spcPts val="1400"/>
-              </a:spcAft>
-            </a:pPr>
-            <a:r>
-              <a:rPr sz="2000" b="1">
+                <a:spcPts val="1200"/>
+              </a:spcAft>
+            </a:pPr>
+            <a:r>
+              <a:rPr sz="1800" b="1">
                 <a:solidFill>
                   <a:srgbClr val="0F172A"/>
                 </a:solidFill>
@@ -6061,7 +6061,7 @@
               <a:t>• Warning Window (Yellow): </a:t>
             </a:r>
             <a:r>
-              <a:rPr sz="2000" b="0">
+              <a:rPr sz="1800" b="0">
                 <a:solidFill>
                   <a:srgbClr val="334155"/>
                 </a:solidFill>
@@ -6073,11 +6073,11 @@
           <a:p>
             <a:pPr>
               <a:spcAft>
-                <a:spcPts val="1400"/>
-              </a:spcAft>
-            </a:pPr>
-            <a:r>
-              <a:rPr sz="2000" b="1">
+                <a:spcPts val="1200"/>
+              </a:spcAft>
+            </a:pPr>
+            <a:r>
+              <a:rPr sz="1800" b="1">
                 <a:solidFill>
                   <a:srgbClr val="0F172A"/>
                 </a:solidFill>
@@ -6086,7 +6086,7 @@
               <a:t>• Critical Action (Red): </a:t>
             </a:r>
             <a:r>
-              <a:rPr sz="2000" b="0">
+              <a:rPr sz="1800" b="0">
                 <a:solidFill>
                   <a:srgbClr val="334155"/>
                 </a:solidFill>
@@ -6098,11 +6098,11 @@
           <a:p>
             <a:pPr>
               <a:spcAft>
-                <a:spcPts val="1400"/>
-              </a:spcAft>
-            </a:pPr>
-            <a:r>
-              <a:rPr sz="2000" b="1">
+                <a:spcPts val="1200"/>
+              </a:spcAft>
+            </a:pPr>
+            <a:r>
+              <a:rPr sz="1800" b="1">
                 <a:solidFill>
                   <a:srgbClr val="0F172A"/>
                 </a:solidFill>
@@ -6111,7 +6111,7 @@
               <a:t>• Sub-30ms Inference Latency: </a:t>
             </a:r>
             <a:r>
-              <a:rPr sz="2000" b="0">
+              <a:rPr sz="1800" b="0">
                 <a:solidFill>
                   <a:srgbClr val="334155"/>
                 </a:solidFill>
@@ -6149,7 +6149,7 @@
         <p:spPr>
           <a:xfrm>
             <a:off x="548640" y="365760"/>
-            <a:ext cx="8046720" cy="731520"/>
+            <a:ext cx="8046720" cy="640080"/>
           </a:xfrm>
           <a:prstGeom prst="rect">
             <a:avLst/>
@@ -6201,7 +6201,7 @@
             <a:pPr algn="r">
               <a:defRPr sz="1400">
                 <a:solidFill>
-                  <a:srgbClr val="334155"/>
+                  <a:srgbClr val="64748B"/>
                 </a:solidFill>
                 <a:latin typeface="Calibri"/>
               </a:defRPr>
@@ -6220,8 +6220,8 @@
         </p:nvSpPr>
         <p:spPr>
           <a:xfrm>
-            <a:off x="548640" y="1188720"/>
-            <a:ext cx="8046720" cy="4846320"/>
+            <a:off x="548640" y="1097280"/>
+            <a:ext cx="8046720" cy="4754880"/>
           </a:xfrm>
           <a:prstGeom prst="rect">
             <a:avLst/>
@@ -6229,14 +6229,14 @@
           <a:noFill/>
         </p:spPr>
         <p:txBody>
-          <a:bodyPr wrap="square">
+          <a:bodyPr wrap="square" lIns="0" tIns="0" rIns="0" bIns="0">
             <a:spAutoFit/>
           </a:bodyPr>
           <a:lstStyle/>
           <a:p>
             <a:pPr>
               <a:spcAft>
-                <a:spcPts val="1400"/>
+                <a:spcPts val="1200"/>
               </a:spcAft>
               <a:defRPr sz="2000" b="1">
                 <a:solidFill>
@@ -6246,7 +6246,7 @@
               </a:defRPr>
             </a:pPr>
             <a:r>
-              <a:rPr sz="2000" b="1">
+              <a:rPr sz="1800" b="1">
                 <a:solidFill>
                   <a:srgbClr val="0F172A"/>
                 </a:solidFill>
@@ -6255,7 +6255,7 @@
               <a:t>• Binary Failure Warning AUC-ROC: </a:t>
             </a:r>
             <a:r>
-              <a:rPr sz="2000" b="0">
+              <a:rPr sz="1800" b="0">
                 <a:solidFill>
                   <a:srgbClr val="334155"/>
                 </a:solidFill>
@@ -6319,11 +6319,11 @@
           <a:p>
             <a:pPr>
               <a:spcAft>
-                <a:spcPts val="1400"/>
-              </a:spcAft>
-            </a:pPr>
-            <a:r>
-              <a:rPr sz="2000" b="1">
+                <a:spcPts val="1200"/>
+              </a:spcAft>
+            </a:pPr>
+            <a:r>
+              <a:rPr sz="1800" b="1">
                 <a:solidFill>
                   <a:srgbClr val="0F172A"/>
                 </a:solidFill>
@@ -6332,7 +6332,7 @@
               <a:t>• Binary Alert Precision: </a:t>
             </a:r>
             <a:r>
-              <a:rPr sz="2000" b="0">
+              <a:rPr sz="1800" b="0">
                 <a:solidFill>
                   <a:srgbClr val="334155"/>
                 </a:solidFill>
@@ -6344,11 +6344,11 @@
           <a:p>
             <a:pPr>
               <a:spcAft>
-                <a:spcPts val="1400"/>
-              </a:spcAft>
-            </a:pPr>
-            <a:r>
-              <a:rPr sz="2000" b="1">
+                <a:spcPts val="1200"/>
+              </a:spcAft>
+            </a:pPr>
+            <a:r>
+              <a:rPr sz="1800" b="1">
                 <a:solidFill>
                   <a:srgbClr val="0F172A"/>
                 </a:solidFill>
@@ -6357,7 +6357,7 @@
               <a:t>• RUL Regression RMSE: </a:t>
             </a:r>
             <a:r>
-              <a:rPr sz="2000" b="0">
+              <a:rPr sz="1800" b="0">
                 <a:solidFill>
                   <a:srgbClr val="334155"/>
                 </a:solidFill>
@@ -6369,11 +6369,11 @@
           <a:p>
             <a:pPr>
               <a:spcAft>
-                <a:spcPts val="1400"/>
-              </a:spcAft>
-            </a:pPr>
-            <a:r>
-              <a:rPr sz="2000" b="1">
+                <a:spcPts val="1200"/>
+              </a:spcAft>
+            </a:pPr>
+            <a:r>
+              <a:rPr sz="1800" b="1">
                 <a:solidFill>
                   <a:srgbClr val="0F172A"/>
                 </a:solidFill>
@@ -6382,7 +6382,7 @@
               <a:t>• Multi-Class Neural MLP Accuracy: </a:t>
             </a:r>
             <a:r>
-              <a:rPr sz="2000" b="0">
+              <a:rPr sz="1800" b="0">
                 <a:solidFill>
                   <a:srgbClr val="334155"/>
                 </a:solidFill>
@@ -6394,11 +6394,11 @@
           <a:p>
             <a:pPr>
               <a:spcAft>
-                <a:spcPts val="1400"/>
-              </a:spcAft>
-            </a:pPr>
-            <a:r>
-              <a:rPr sz="2000" b="1">
+                <a:spcPts val="1200"/>
+              </a:spcAft>
+            </a:pPr>
+            <a:r>
+              <a:rPr sz="1800" b="1">
                 <a:solidFill>
                   <a:srgbClr val="0F172A"/>
                 </a:solidFill>
@@ -6407,7 +6407,7 @@
               <a:t>• Inference Latency: </a:t>
             </a:r>
             <a:r>
-              <a:rPr sz="2000" b="0">
+              <a:rPr sz="1800" b="0">
                 <a:solidFill>
                   <a:srgbClr val="334155"/>
                 </a:solidFill>
@@ -8186,7 +8186,7 @@
         <p:spPr>
           <a:xfrm>
             <a:off x="548640" y="365760"/>
-            <a:ext cx="8046720" cy="731520"/>
+            <a:ext cx="8046720" cy="640080"/>
           </a:xfrm>
           <a:prstGeom prst="rect">
             <a:avLst/>
@@ -8238,7 +8238,7 @@
             <a:pPr algn="r">
               <a:defRPr sz="1400">
                 <a:solidFill>
-                  <a:srgbClr val="334155"/>
+                  <a:srgbClr val="64748B"/>
                 </a:solidFill>
                 <a:latin typeface="Calibri"/>
               </a:defRPr>
@@ -8257,8 +8257,8 @@
         </p:nvSpPr>
         <p:spPr>
           <a:xfrm>
-            <a:off x="548640" y="1188720"/>
-            <a:ext cx="8046720" cy="4846320"/>
+            <a:off x="548640" y="1097280"/>
+            <a:ext cx="8046720" cy="4754880"/>
           </a:xfrm>
           <a:prstGeom prst="rect">
             <a:avLst/>
@@ -8266,14 +8266,14 @@
           <a:noFill/>
         </p:spPr>
         <p:txBody>
-          <a:bodyPr wrap="square">
+          <a:bodyPr wrap="square" lIns="0" tIns="0" rIns="0" bIns="0">
             <a:spAutoFit/>
           </a:bodyPr>
           <a:lstStyle/>
           <a:p>
             <a:pPr>
               <a:spcAft>
-                <a:spcPts val="1400"/>
+                <a:spcPts val="1200"/>
               </a:spcAft>
               <a:defRPr sz="2000" b="1">
                 <a:solidFill>
@@ -8283,7 +8283,7 @@
               </a:defRPr>
             </a:pPr>
             <a:r>
-              <a:rPr sz="2000" b="1">
+              <a:rPr sz="1800" b="1">
                 <a:solidFill>
                   <a:srgbClr val="0F172A"/>
                 </a:solidFill>
@@ -8292,7 +8292,7 @@
               <a:t>• Feature Engineering Impact: </a:t>
             </a:r>
             <a:r>
-              <a:rPr sz="2000" b="0">
+              <a:rPr sz="1800" b="0">
                 <a:solidFill>
                   <a:srgbClr val="334155"/>
                 </a:solidFill>
@@ -8356,11 +8356,11 @@
           <a:p>
             <a:pPr>
               <a:spcAft>
-                <a:spcPts val="1400"/>
-              </a:spcAft>
-            </a:pPr>
-            <a:r>
-              <a:rPr sz="2000" b="1">
+                <a:spcPts val="1200"/>
+              </a:spcAft>
+            </a:pPr>
+            <a:r>
+              <a:rPr sz="1800" b="1">
                 <a:solidFill>
                   <a:srgbClr val="0F172A"/>
                 </a:solidFill>
@@ -8369,7 +8369,7 @@
               <a:t>• Optimal Thresholding: </a:t>
             </a:r>
             <a:r>
-              <a:rPr sz="2000" b="0">
+              <a:rPr sz="1800" b="0">
                 <a:solidFill>
                   <a:srgbClr val="334155"/>
                 </a:solidFill>
@@ -8381,11 +8381,11 @@
           <a:p>
             <a:pPr>
               <a:spcAft>
-                <a:spcPts val="1400"/>
-              </a:spcAft>
-            </a:pPr>
-            <a:r>
-              <a:rPr sz="2000" b="1">
+                <a:spcPts val="1200"/>
+              </a:spcAft>
+            </a:pPr>
+            <a:r>
+              <a:rPr sz="1800" b="1">
                 <a:solidFill>
                   <a:srgbClr val="0F172A"/>
                 </a:solidFill>
@@ -8394,7 +8394,7 @@
               <a:t>• Cost Matrix Minimization: </a:t>
             </a:r>
             <a:r>
-              <a:rPr sz="2000" b="0">
+              <a:rPr sz="1800" b="0">
                 <a:solidFill>
                   <a:srgbClr val="334155"/>
                 </a:solidFill>
@@ -8406,11 +8406,11 @@
           <a:p>
             <a:pPr>
               <a:spcAft>
-                <a:spcPts val="1400"/>
-              </a:spcAft>
-            </a:pPr>
-            <a:r>
-              <a:rPr sz="2000" b="1">
+                <a:spcPts val="1200"/>
+              </a:spcAft>
+            </a:pPr>
+            <a:r>
+              <a:rPr sz="1800" b="1">
                 <a:solidFill>
                   <a:srgbClr val="0F172A"/>
                 </a:solidFill>
@@ -8419,7 +8419,7 @@
               <a:t>• Neural Network Stability: </a:t>
             </a:r>
             <a:r>
-              <a:rPr sz="2000" b="0">
+              <a:rPr sz="1800" b="0">
                 <a:solidFill>
                   <a:srgbClr val="334155"/>
                 </a:solidFill>
@@ -8431,11 +8431,11 @@
           <a:p>
             <a:pPr>
               <a:spcAft>
-                <a:spcPts val="1400"/>
-              </a:spcAft>
-            </a:pPr>
-            <a:r>
-              <a:rPr sz="2000" b="1">
+                <a:spcPts val="1200"/>
+              </a:spcAft>
+            </a:pPr>
+            <a:r>
+              <a:rPr sz="1800" b="1">
                 <a:solidFill>
                   <a:srgbClr val="0F172A"/>
                 </a:solidFill>
@@ -8444,7 +8444,7 @@
               <a:t>• Maintenance Capacity Dispatch: </a:t>
             </a:r>
             <a:r>
-              <a:rPr sz="2000" b="0">
+              <a:rPr sz="1800" b="0">
                 <a:solidFill>
                   <a:srgbClr val="334155"/>
                 </a:solidFill>
@@ -8482,7 +8482,7 @@
         <p:spPr>
           <a:xfrm>
             <a:off x="548640" y="365760"/>
-            <a:ext cx="8046720" cy="731520"/>
+            <a:ext cx="8046720" cy="640080"/>
           </a:xfrm>
           <a:prstGeom prst="rect">
             <a:avLst/>
@@ -8534,7 +8534,7 @@
             <a:pPr algn="r">
               <a:defRPr sz="1400">
                 <a:solidFill>
-                  <a:srgbClr val="334155"/>
+                  <a:srgbClr val="64748B"/>
                 </a:solidFill>
                 <a:latin typeface="Calibri"/>
               </a:defRPr>
@@ -8553,8 +8553,8 @@
         </p:nvSpPr>
         <p:spPr>
           <a:xfrm>
-            <a:off x="548640" y="1188720"/>
-            <a:ext cx="8046720" cy="4846320"/>
+            <a:off x="548640" y="1097280"/>
+            <a:ext cx="8046720" cy="4754880"/>
           </a:xfrm>
           <a:prstGeom prst="rect">
             <a:avLst/>
@@ -8562,14 +8562,14 @@
           <a:noFill/>
         </p:spPr>
         <p:txBody>
-          <a:bodyPr wrap="square">
+          <a:bodyPr wrap="square" lIns="0" tIns="0" rIns="0" bIns="0">
             <a:spAutoFit/>
           </a:bodyPr>
           <a:lstStyle/>
           <a:p>
             <a:pPr>
               <a:spcAft>
-                <a:spcPts val="1400"/>
+                <a:spcPts val="1200"/>
               </a:spcAft>
               <a:defRPr sz="2000" b="1">
                 <a:solidFill>
@@ -8579,7 +8579,7 @@
               </a:defRPr>
             </a:pPr>
             <a:r>
-              <a:rPr sz="2000" b="1">
+              <a:rPr sz="1800" b="1">
                 <a:solidFill>
                   <a:srgbClr val="0F172A"/>
                 </a:solidFill>
@@ -8588,7 +8588,7 @@
               <a:t>• Successful System Delivery: </a:t>
             </a:r>
             <a:r>
-              <a:rPr sz="2000" b="0">
+              <a:rPr sz="1800" b="0">
                 <a:solidFill>
                   <a:srgbClr val="334155"/>
                 </a:solidFill>
@@ -8652,11 +8652,11 @@
           <a:p>
             <a:pPr>
               <a:spcAft>
-                <a:spcPts val="1400"/>
-              </a:spcAft>
-            </a:pPr>
-            <a:r>
-              <a:rPr sz="2000" b="1">
+                <a:spcPts val="1200"/>
+              </a:spcAft>
+            </a:pPr>
+            <a:r>
+              <a:rPr sz="1800" b="1">
                 <a:solidFill>
                   <a:srgbClr val="0F172A"/>
                 </a:solidFill>
@@ -8665,7 +8665,7 @@
               <a:t>• High Predictive Performance: </a:t>
             </a:r>
             <a:r>
-              <a:rPr sz="2000" b="0">
+              <a:rPr sz="1800" b="0">
                 <a:solidFill>
                   <a:srgbClr val="334155"/>
                 </a:solidFill>
@@ -8677,11 +8677,11 @@
           <a:p>
             <a:pPr>
               <a:spcAft>
-                <a:spcPts val="1400"/>
-              </a:spcAft>
-            </a:pPr>
-            <a:r>
-              <a:rPr sz="2000" b="1">
+                <a:spcPts val="1200"/>
+              </a:spcAft>
+            </a:pPr>
+            <a:r>
+              <a:rPr sz="1800" b="1">
                 <a:solidFill>
                   <a:srgbClr val="0F172A"/>
                 </a:solidFill>
@@ -8690,7 +8690,7 @@
               <a:t>• Sign-to-Speech &amp; CLI Integration: </a:t>
             </a:r>
             <a:r>
-              <a:rPr sz="2000" b="0">
+              <a:rPr sz="1800" b="0">
                 <a:solidFill>
                   <a:srgbClr val="334155"/>
                 </a:solidFill>
@@ -8702,11 +8702,11 @@
           <a:p>
             <a:pPr>
               <a:spcAft>
-                <a:spcPts val="1400"/>
-              </a:spcAft>
-            </a:pPr>
-            <a:r>
-              <a:rPr sz="2000" b="1">
+                <a:spcPts val="1200"/>
+              </a:spcAft>
+            </a:pPr>
+            <a:r>
+              <a:rPr sz="1800" b="1">
                 <a:solidFill>
                   <a:srgbClr val="0F172A"/>
                 </a:solidFill>
@@ -8715,7 +8715,7 @@
               <a:t>• Native Python Implementation: </a:t>
             </a:r>
             <a:r>
-              <a:rPr sz="2000" b="0">
+              <a:rPr sz="1800" b="0">
                 <a:solidFill>
                   <a:srgbClr val="334155"/>
                 </a:solidFill>
@@ -8727,11 +8727,11 @@
           <a:p>
             <a:pPr>
               <a:spcAft>
-                <a:spcPts val="1400"/>
-              </a:spcAft>
-            </a:pPr>
-            <a:r>
-              <a:rPr sz="2000" b="1">
+                <a:spcPts val="1200"/>
+              </a:spcAft>
+            </a:pPr>
+            <a:r>
+              <a:rPr sz="1800" b="1">
                 <a:solidFill>
                   <a:srgbClr val="0F172A"/>
                 </a:solidFill>
@@ -8740,7 +8740,7 @@
               <a:t>• Fleet Cost Minimization: </a:t>
             </a:r>
             <a:r>
-              <a:rPr sz="2000" b="0">
+              <a:rPr sz="1800" b="0">
                 <a:solidFill>
                   <a:srgbClr val="334155"/>
                 </a:solidFill>
@@ -8778,7 +8778,7 @@
         <p:spPr>
           <a:xfrm>
             <a:off x="548640" y="365760"/>
-            <a:ext cx="8046720" cy="731520"/>
+            <a:ext cx="8046720" cy="640080"/>
           </a:xfrm>
           <a:prstGeom prst="rect">
             <a:avLst/>
@@ -8830,7 +8830,7 @@
             <a:pPr algn="r">
               <a:defRPr sz="1400">
                 <a:solidFill>
-                  <a:srgbClr val="334155"/>
+                  <a:srgbClr val="64748B"/>
                 </a:solidFill>
                 <a:latin typeface="Calibri"/>
               </a:defRPr>
@@ -8849,8 +8849,8 @@
         </p:nvSpPr>
         <p:spPr>
           <a:xfrm>
-            <a:off x="548640" y="1188720"/>
-            <a:ext cx="8046720" cy="4846320"/>
+            <a:off x="548640" y="1097280"/>
+            <a:ext cx="8046720" cy="4754880"/>
           </a:xfrm>
           <a:prstGeom prst="rect">
             <a:avLst/>
@@ -8858,14 +8858,14 @@
           <a:noFill/>
         </p:spPr>
         <p:txBody>
-          <a:bodyPr wrap="square">
+          <a:bodyPr wrap="square" lIns="0" tIns="0" rIns="0" bIns="0">
             <a:spAutoFit/>
           </a:bodyPr>
           <a:lstStyle/>
           <a:p>
             <a:pPr>
               <a:spcAft>
-                <a:spcPts val="1400"/>
+                <a:spcPts val="1200"/>
               </a:spcAft>
               <a:defRPr sz="2000" b="1">
                 <a:solidFill>
@@ -8875,7 +8875,7 @@
               </a:defRPr>
             </a:pPr>
             <a:r>
-              <a:rPr sz="2000" b="1">
+              <a:rPr sz="1800" b="1">
                 <a:solidFill>
                   <a:srgbClr val="0F172A"/>
                 </a:solidFill>
@@ -8884,7 +8884,7 @@
               <a:t>• Deep Time-Series Architecture: </a:t>
             </a:r>
             <a:r>
-              <a:rPr sz="2000" b="0">
+              <a:rPr sz="1800" b="0">
                 <a:solidFill>
                   <a:srgbClr val="334155"/>
                 </a:solidFill>
@@ -8948,11 +8948,11 @@
           <a:p>
             <a:pPr>
               <a:spcAft>
-                <a:spcPts val="1400"/>
-              </a:spcAft>
-            </a:pPr>
-            <a:r>
-              <a:rPr sz="2000" b="1">
+                <a:spcPts val="1200"/>
+              </a:spcAft>
+            </a:pPr>
+            <a:r>
+              <a:rPr sz="1800" b="1">
                 <a:solidFill>
                   <a:srgbClr val="0F172A"/>
                 </a:solidFill>
@@ -8961,7 +8961,7 @@
               <a:t>• Sentence-Level Flight Profiles: </a:t>
             </a:r>
             <a:r>
-              <a:rPr sz="2000" b="0">
+              <a:rPr sz="1800" b="0">
                 <a:solidFill>
                   <a:srgbClr val="334155"/>
                 </a:solidFill>
@@ -8973,11 +8973,11 @@
           <a:p>
             <a:pPr>
               <a:spcAft>
-                <a:spcPts val="1400"/>
-              </a:spcAft>
-            </a:pPr>
-            <a:r>
-              <a:rPr sz="2000" b="1">
+                <a:spcPts val="1200"/>
+              </a:spcAft>
+            </a:pPr>
+            <a:r>
+              <a:rPr sz="1800" b="1">
                 <a:solidFill>
                   <a:srgbClr val="0F172A"/>
                 </a:solidFill>
@@ -8986,7 +8986,7 @@
               <a:t>• Mobile &amp; Edge Deployment: </a:t>
             </a:r>
             <a:r>
-              <a:rPr sz="2000" b="0">
+              <a:rPr sz="1800" b="0">
                 <a:solidFill>
                   <a:srgbClr val="334155"/>
                 </a:solidFill>
@@ -8998,11 +8998,11 @@
           <a:p>
             <a:pPr>
               <a:spcAft>
-                <a:spcPts val="1400"/>
-              </a:spcAft>
-            </a:pPr>
-            <a:r>
-              <a:rPr sz="2000" b="1">
+                <a:spcPts val="1200"/>
+              </a:spcAft>
+            </a:pPr>
+            <a:r>
+              <a:rPr sz="1800" b="1">
                 <a:solidFill>
                   <a:srgbClr val="0F172A"/>
                 </a:solidFill>
@@ -9011,7 +9011,7 @@
               <a:t>• Cloud Streaming API: </a:t>
             </a:r>
             <a:r>
-              <a:rPr sz="2000" b="0">
+              <a:rPr sz="1800" b="0">
                 <a:solidFill>
                   <a:srgbClr val="334155"/>
                 </a:solidFill>
@@ -9023,11 +9023,11 @@
           <a:p>
             <a:pPr>
               <a:spcAft>
-                <a:spcPts val="1400"/>
-              </a:spcAft>
-            </a:pPr>
-            <a:r>
-              <a:rPr sz="2000" b="1">
+                <a:spcPts val="1200"/>
+              </a:spcAft>
+            </a:pPr>
+            <a:r>
+              <a:rPr sz="1800" b="1">
                 <a:solidFill>
                   <a:srgbClr val="0F172A"/>
                 </a:solidFill>
@@ -9036,7 +9036,7 @@
               <a:t>• Dataset Mirror Augmentation: </a:t>
             </a:r>
             <a:r>
-              <a:rPr sz="2000" b="0">
+              <a:rPr sz="1800" b="0">
                 <a:solidFill>
                   <a:srgbClr val="334155"/>
                 </a:solidFill>
@@ -9074,7 +9074,7 @@
         <p:spPr>
           <a:xfrm>
             <a:off x="548640" y="365760"/>
-            <a:ext cx="8046720" cy="731520"/>
+            <a:ext cx="8046720" cy="640080"/>
           </a:xfrm>
           <a:prstGeom prst="rect">
             <a:avLst/>
@@ -9126,7 +9126,7 @@
             <a:pPr algn="r">
               <a:defRPr sz="1400">
                 <a:solidFill>
-                  <a:srgbClr val="334155"/>
+                  <a:srgbClr val="64748B"/>
                 </a:solidFill>
                 <a:latin typeface="Calibri"/>
               </a:defRPr>
@@ -9145,8 +9145,8 @@
         </p:nvSpPr>
         <p:spPr>
           <a:xfrm>
-            <a:off x="548640" y="1188720"/>
-            <a:ext cx="8046720" cy="4846320"/>
+            <a:off x="548640" y="1097280"/>
+            <a:ext cx="8046720" cy="4754880"/>
           </a:xfrm>
           <a:prstGeom prst="rect">
             <a:avLst/>
@@ -9154,14 +9154,14 @@
           <a:noFill/>
         </p:spPr>
         <p:txBody>
-          <a:bodyPr wrap="square">
+          <a:bodyPr wrap="square" lIns="0" tIns="0" rIns="0" bIns="0">
             <a:spAutoFit/>
           </a:bodyPr>
           <a:lstStyle/>
           <a:p>
             <a:pPr>
               <a:spcAft>
-                <a:spcPts val="1400"/>
+                <a:spcPts val="800"/>
               </a:spcAft>
               <a:defRPr sz="2000" b="0">
                 <a:solidFill>
@@ -9171,7 +9171,7 @@
               </a:defRPr>
             </a:pPr>
             <a:r>
-              <a:rPr sz="2000" b="1">
+              <a:rPr sz="1600" b="1">
                 <a:solidFill>
                   <a:srgbClr val="0F172A"/>
                 </a:solidFill>
@@ -9180,7 +9180,7 @@
               <a:t>• 1. NASA Ames Prognostics Center of Excellence - </a:t>
             </a:r>
             <a:r>
-              <a:rPr sz="2000" b="0">
+              <a:rPr sz="1600" b="0">
                 <a:solidFill>
                   <a:srgbClr val="334155"/>
                 </a:solidFill>
@@ -9257,11 +9257,11 @@
           <a:p>
             <a:pPr>
               <a:spcAft>
-                <a:spcPts val="1400"/>
-              </a:spcAft>
-            </a:pPr>
-            <a:r>
-              <a:rPr sz="2000" b="1">
+                <a:spcPts val="800"/>
+              </a:spcAft>
+            </a:pPr>
+            <a:r>
+              <a:rPr sz="1600" b="1">
                 <a:solidFill>
                   <a:srgbClr val="0F172A"/>
                 </a:solidFill>
@@ -9270,7 +9270,7 @@
               <a:t>• 2. Saxena, A., et al., </a:t>
             </a:r>
             <a:r>
-              <a:rPr sz="2000" b="0">
+              <a:rPr sz="1600" b="0">
                 <a:solidFill>
                   <a:srgbClr val="334155"/>
                 </a:solidFill>
@@ -9282,11 +9282,11 @@
           <a:p>
             <a:pPr>
               <a:spcAft>
-                <a:spcPts val="1400"/>
-              </a:spcAft>
-            </a:pPr>
-            <a:r>
-              <a:rPr sz="2000" b="1">
+                <a:spcPts val="800"/>
+              </a:spcAft>
+            </a:pPr>
+            <a:r>
+              <a:rPr sz="1600" b="1">
                 <a:solidFill>
                   <a:srgbClr val="0F172A"/>
                 </a:solidFill>
@@ -9295,7 +9295,7 @@
               <a:t>• 3. Springboard Data Science Career Track - </a:t>
             </a:r>
             <a:r>
-              <a:rPr sz="2000" b="0">
+              <a:rPr sz="1600" b="0">
                 <a:solidFill>
                   <a:srgbClr val="334155"/>
                 </a:solidFill>
@@ -9307,11 +9307,11 @@
           <a:p>
             <a:pPr>
               <a:spcAft>
-                <a:spcPts val="1400"/>
-              </a:spcAft>
-            </a:pPr>
-            <a:r>
-              <a:rPr sz="2000" b="1">
+                <a:spcPts val="800"/>
+              </a:spcAft>
+            </a:pPr>
+            <a:r>
+              <a:rPr sz="1600" b="1">
                 <a:solidFill>
                   <a:srgbClr val="0F172A"/>
                 </a:solidFill>
@@ -9320,7 +9320,7 @@
               <a:t>• 4. Scikit-Learn Open Source Library - </a:t>
             </a:r>
             <a:r>
-              <a:rPr sz="2000" b="0">
+              <a:rPr sz="1600" b="0">
                 <a:solidFill>
                   <a:srgbClr val="334155"/>
                 </a:solidFill>
@@ -9332,11 +9332,11 @@
           <a:p>
             <a:pPr>
               <a:spcAft>
-                <a:spcPts val="1400"/>
-              </a:spcAft>
-            </a:pPr>
-            <a:r>
-              <a:rPr sz="2000" b="1">
+                <a:spcPts val="800"/>
+              </a:spcAft>
+            </a:pPr>
+            <a:r>
+              <a:rPr sz="1600" b="1">
                 <a:solidFill>
                   <a:srgbClr val="0F172A"/>
                 </a:solidFill>
@@ -9345,7 +9345,7 @@
               <a:t>• 5. Google Keras 3.3 &amp; TensorFlow 2.17 - </a:t>
             </a:r>
             <a:r>
-              <a:rPr sz="2000" b="0">
+              <a:rPr sz="1600" b="0">
                 <a:solidFill>
                   <a:srgbClr val="334155"/>
                 </a:solidFill>
@@ -9357,11 +9357,11 @@
           <a:p>
             <a:pPr>
               <a:spcAft>
-                <a:spcPts val="1400"/>
-              </a:spcAft>
-            </a:pPr>
-            <a:r>
-              <a:rPr sz="2000" b="1">
+                <a:spcPts val="800"/>
+              </a:spcAft>
+            </a:pPr>
+            <a:r>
+              <a:rPr sz="1600" b="1">
                 <a:solidFill>
                   <a:srgbClr val="0F172A"/>
                 </a:solidFill>
@@ -9370,7 +9370,7 @@
               <a:t>• 6. Microsoft Azure Machine Learning - </a:t>
             </a:r>
             <a:r>
-              <a:rPr sz="2000" b="0">
+              <a:rPr sz="1600" b="0">
                 <a:solidFill>
                   <a:srgbClr val="334155"/>
                 </a:solidFill>
@@ -9488,7 +9488,7 @@
         <p:spPr>
           <a:xfrm>
             <a:off x="548640" y="365760"/>
-            <a:ext cx="8046720" cy="731520"/>
+            <a:ext cx="8046720" cy="640080"/>
           </a:xfrm>
           <a:prstGeom prst="rect">
             <a:avLst/>
@@ -9540,7 +9540,7 @@
             <a:pPr algn="r">
               <a:defRPr sz="1400">
                 <a:solidFill>
-                  <a:srgbClr val="334155"/>
+                  <a:srgbClr val="64748B"/>
                 </a:solidFill>
                 <a:latin typeface="Calibri"/>
               </a:defRPr>
@@ -9559,8 +9559,8 @@
         </p:nvSpPr>
         <p:spPr>
           <a:xfrm>
-            <a:off x="548640" y="1188720"/>
-            <a:ext cx="8046720" cy="4846320"/>
+            <a:off x="548640" y="1097280"/>
+            <a:ext cx="8046720" cy="4754880"/>
           </a:xfrm>
           <a:prstGeom prst="rect">
             <a:avLst/>
@@ -9568,14 +9568,14 @@
           <a:noFill/>
         </p:spPr>
         <p:txBody>
-          <a:bodyPr wrap="square">
+          <a:bodyPr wrap="square" lIns="0" tIns="0" rIns="0" bIns="0">
             <a:spAutoFit/>
           </a:bodyPr>
           <a:lstStyle/>
           <a:p>
             <a:pPr>
               <a:spcAft>
-                <a:spcPts val="1400"/>
+                <a:spcPts val="600"/>
               </a:spcAft>
               <a:defRPr sz="2000" b="1">
                 <a:solidFill>
@@ -9585,7 +9585,7 @@
               </a:defRPr>
             </a:pPr>
             <a:r>
-              <a:rPr sz="2000" b="1">
+              <a:rPr sz="1600" b="1">
                 <a:solidFill>
                   <a:srgbClr val="0F172A"/>
                 </a:solidFill>
@@ -9594,7 +9594,7 @@
               <a:t>• 1. Introduction &amp; Objectives: </a:t>
             </a:r>
             <a:r>
-              <a:rPr sz="2000" b="0">
+              <a:rPr sz="1600" b="0">
                 <a:solidFill>
                   <a:srgbClr val="334155"/>
                 </a:solidFill>
@@ -9723,11 +9723,11 @@
           <a:p>
             <a:pPr>
               <a:spcAft>
-                <a:spcPts val="1400"/>
-              </a:spcAft>
-            </a:pPr>
-            <a:r>
-              <a:rPr sz="2000" b="1">
+                <a:spcPts val="600"/>
+              </a:spcAft>
+            </a:pPr>
+            <a:r>
+              <a:rPr sz="1600" b="1">
                 <a:solidFill>
                   <a:srgbClr val="0F172A"/>
                 </a:solidFill>
@@ -9736,7 +9736,7 @@
               <a:t>• 2. Problem Statement &amp; Motivation: </a:t>
             </a:r>
             <a:r>
-              <a:rPr sz="2000" b="0">
+              <a:rPr sz="1600" b="0">
                 <a:solidFill>
                   <a:srgbClr val="334155"/>
                 </a:solidFill>
@@ -9748,11 +9748,11 @@
           <a:p>
             <a:pPr>
               <a:spcAft>
-                <a:spcPts val="1400"/>
-              </a:spcAft>
-            </a:pPr>
-            <a:r>
-              <a:rPr sz="2000" b="1">
+                <a:spcPts val="600"/>
+              </a:spcAft>
+            </a:pPr>
+            <a:r>
+              <a:rPr sz="1600" b="1">
                 <a:solidFill>
                   <a:srgbClr val="0F172A"/>
                 </a:solidFill>
@@ -9761,7 +9761,7 @@
               <a:t>• 3. Requirement Analysis: </a:t>
             </a:r>
             <a:r>
-              <a:rPr sz="2000" b="0">
+              <a:rPr sz="1600" b="0">
                 <a:solidFill>
                   <a:srgbClr val="334155"/>
                 </a:solidFill>
@@ -9773,11 +9773,11 @@
           <a:p>
             <a:pPr>
               <a:spcAft>
-                <a:spcPts val="1400"/>
-              </a:spcAft>
-            </a:pPr>
-            <a:r>
-              <a:rPr sz="2000" b="1">
+                <a:spcPts val="600"/>
+              </a:spcAft>
+            </a:pPr>
+            <a:r>
+              <a:rPr sz="1600" b="1">
                 <a:solidFill>
                   <a:srgbClr val="0F172A"/>
                 </a:solidFill>
@@ -9786,7 +9786,7 @@
               <a:t>• 4. Dataset &amp; Feature Details: </a:t>
             </a:r>
             <a:r>
-              <a:rPr sz="2000" b="0">
+              <a:rPr sz="1600" b="0">
                 <a:solidFill>
                   <a:srgbClr val="334155"/>
                 </a:solidFill>
@@ -9798,11 +9798,11 @@
           <a:p>
             <a:pPr>
               <a:spcAft>
-                <a:spcPts val="1400"/>
-              </a:spcAft>
-            </a:pPr>
-            <a:r>
-              <a:rPr sz="2000" b="1">
+                <a:spcPts val="600"/>
+              </a:spcAft>
+            </a:pPr>
+            <a:r>
+              <a:rPr sz="1600" b="1">
                 <a:solidFill>
                   <a:srgbClr val="0F172A"/>
                 </a:solidFill>
@@ -9811,7 +9811,7 @@
               <a:t>• 5. System Methodology &amp; Flowchart: </a:t>
             </a:r>
             <a:r>
-              <a:rPr sz="2000" b="0">
+              <a:rPr sz="1600" b="0">
                 <a:solidFill>
                   <a:srgbClr val="334155"/>
                 </a:solidFill>
@@ -9823,11 +9823,11 @@
           <a:p>
             <a:pPr>
               <a:spcAft>
-                <a:spcPts val="1400"/>
-              </a:spcAft>
-            </a:pPr>
-            <a:r>
-              <a:rPr sz="2000" b="1">
+                <a:spcPts val="600"/>
+              </a:spcAft>
+            </a:pPr>
+            <a:r>
+              <a:rPr sz="1600" b="1">
                 <a:solidFill>
                   <a:srgbClr val="0F172A"/>
                 </a:solidFill>
@@ -9836,7 +9836,7 @@
               <a:t>• 6. Tri-Model AI Architecture: </a:t>
             </a:r>
             <a:r>
-              <a:rPr sz="2000" b="0">
+              <a:rPr sz="1600" b="0">
                 <a:solidFill>
                   <a:srgbClr val="334155"/>
                 </a:solidFill>
@@ -9848,11 +9848,11 @@
           <a:p>
             <a:pPr>
               <a:spcAft>
-                <a:spcPts val="1400"/>
-              </a:spcAft>
-            </a:pPr>
-            <a:r>
-              <a:rPr sz="2000" b="1">
+                <a:spcPts val="600"/>
+              </a:spcAft>
+            </a:pPr>
+            <a:r>
+              <a:rPr sz="1600" b="1">
                 <a:solidFill>
                   <a:srgbClr val="0F172A"/>
                 </a:solidFill>
@@ -9861,7 +9861,7 @@
               <a:t>• 7. Empirical Results &amp; Evaluation Table: </a:t>
             </a:r>
             <a:r>
-              <a:rPr sz="2000" b="0">
+              <a:rPr sz="1600" b="0">
                 <a:solidFill>
                   <a:srgbClr val="334155"/>
                 </a:solidFill>
@@ -9873,11 +9873,11 @@
           <a:p>
             <a:pPr>
               <a:spcAft>
-                <a:spcPts val="1400"/>
-              </a:spcAft>
-            </a:pPr>
-            <a:r>
-              <a:rPr sz="2000" b="1">
+                <a:spcPts val="600"/>
+              </a:spcAft>
+            </a:pPr>
+            <a:r>
+              <a:rPr sz="1600" b="1">
                 <a:solidFill>
                   <a:srgbClr val="0F172A"/>
                 </a:solidFill>
@@ -9886,7 +9886,7 @@
               <a:t>• 8. Real-Time Diagnostic Tool: </a:t>
             </a:r>
             <a:r>
-              <a:rPr sz="2000" b="0">
+              <a:rPr sz="1600" b="0">
                 <a:solidFill>
                   <a:srgbClr val="334155"/>
                 </a:solidFill>
@@ -9898,11 +9898,11 @@
           <a:p>
             <a:pPr>
               <a:spcAft>
-                <a:spcPts val="1400"/>
-              </a:spcAft>
-            </a:pPr>
-            <a:r>
-              <a:rPr sz="2000" b="1">
+                <a:spcPts val="600"/>
+              </a:spcAft>
+            </a:pPr>
+            <a:r>
+              <a:rPr sz="1600" b="1">
                 <a:solidFill>
                   <a:srgbClr val="0F172A"/>
                 </a:solidFill>
@@ -9911,7 +9911,7 @@
               <a:t>• 9. Conclusion &amp; References: </a:t>
             </a:r>
             <a:r>
-              <a:rPr sz="2000" b="0">
+              <a:rPr sz="1600" b="0">
                 <a:solidFill>
                   <a:srgbClr val="334155"/>
                 </a:solidFill>
@@ -9949,7 +9949,7 @@
         <p:spPr>
           <a:xfrm>
             <a:off x="548640" y="365760"/>
-            <a:ext cx="8046720" cy="731520"/>
+            <a:ext cx="8046720" cy="640080"/>
           </a:xfrm>
           <a:prstGeom prst="rect">
             <a:avLst/>
@@ -10001,7 +10001,7 @@
             <a:pPr algn="r">
               <a:defRPr sz="1400">
                 <a:solidFill>
-                  <a:srgbClr val="334155"/>
+                  <a:srgbClr val="64748B"/>
                 </a:solidFill>
                 <a:latin typeface="Calibri"/>
               </a:defRPr>
@@ -10020,8 +10020,8 @@
         </p:nvSpPr>
         <p:spPr>
           <a:xfrm>
-            <a:off x="548640" y="1188720"/>
-            <a:ext cx="8046720" cy="4846320"/>
+            <a:off x="548640" y="1097280"/>
+            <a:ext cx="8046720" cy="4754880"/>
           </a:xfrm>
           <a:prstGeom prst="rect">
             <a:avLst/>
@@ -10029,14 +10029,14 @@
           <a:noFill/>
         </p:spPr>
         <p:txBody>
-          <a:bodyPr wrap="square">
+          <a:bodyPr wrap="square" lIns="0" tIns="0" rIns="0" bIns="0">
             <a:spAutoFit/>
           </a:bodyPr>
           <a:lstStyle/>
           <a:p>
             <a:pPr>
               <a:spcAft>
-                <a:spcPts val="1400"/>
+                <a:spcPts val="1200"/>
               </a:spcAft>
               <a:defRPr sz="2000" b="1">
                 <a:solidFill>
@@ -10046,7 +10046,7 @@
               </a:defRPr>
             </a:pPr>
             <a:r>
-              <a:rPr sz="2000" b="1">
+              <a:rPr sz="1800" b="1">
                 <a:solidFill>
                   <a:srgbClr val="0F172A"/>
                 </a:solidFill>
@@ -10055,7 +10055,7 @@
               <a:t>• Domain of Work: </a:t>
             </a:r>
             <a:r>
-              <a:rPr sz="2000" b="0">
+              <a:rPr sz="1800" b="0">
                 <a:solidFill>
                   <a:srgbClr val="334155"/>
                 </a:solidFill>
@@ -10119,11 +10119,11 @@
           <a:p>
             <a:pPr>
               <a:spcAft>
-                <a:spcPts val="1400"/>
-              </a:spcAft>
-            </a:pPr>
-            <a:r>
-              <a:rPr sz="2000" b="1">
+                <a:spcPts val="1200"/>
+              </a:spcAft>
+            </a:pPr>
+            <a:r>
+              <a:rPr sz="1800" b="1">
                 <a:solidFill>
                   <a:srgbClr val="0F172A"/>
                 </a:solidFill>
@@ -10132,7 +10132,7 @@
               <a:t>• Industrial Context: </a:t>
             </a:r>
             <a:r>
-              <a:rPr sz="2000" b="0">
+              <a:rPr sz="1800" b="0">
                 <a:solidFill>
                   <a:srgbClr val="334155"/>
                 </a:solidFill>
@@ -10144,11 +10144,11 @@
           <a:p>
             <a:pPr>
               <a:spcAft>
-                <a:spcPts val="1400"/>
-              </a:spcAft>
-            </a:pPr>
-            <a:r>
-              <a:rPr sz="2000" b="1">
+                <a:spcPts val="1200"/>
+              </a:spcAft>
+            </a:pPr>
+            <a:r>
+              <a:rPr sz="1800" b="1">
                 <a:solidFill>
                   <a:srgbClr val="0F172A"/>
                 </a:solidFill>
@@ -10157,7 +10157,7 @@
               <a:t>• Core Operational Shift: </a:t>
             </a:r>
             <a:r>
-              <a:rPr sz="2000" b="0">
+              <a:rPr sz="1800" b="0">
                 <a:solidFill>
                   <a:srgbClr val="334155"/>
                 </a:solidFill>
@@ -10169,11 +10169,11 @@
           <a:p>
             <a:pPr>
               <a:spcAft>
-                <a:spcPts val="1400"/>
-              </a:spcAft>
-            </a:pPr>
-            <a:r>
-              <a:rPr sz="2000" b="1">
+                <a:spcPts val="1200"/>
+              </a:spcAft>
+            </a:pPr>
+            <a:r>
+              <a:rPr sz="1800" b="1">
                 <a:solidFill>
                   <a:srgbClr val="0F172A"/>
                 </a:solidFill>
@@ -10182,7 +10182,7 @@
               <a:t>• Primary Objective: </a:t>
             </a:r>
             <a:r>
-              <a:rPr sz="2000" b="0">
+              <a:rPr sz="1800" b="0">
                 <a:solidFill>
                   <a:srgbClr val="334155"/>
                 </a:solidFill>
@@ -10194,11 +10194,11 @@
           <a:p>
             <a:pPr>
               <a:spcAft>
-                <a:spcPts val="1400"/>
-              </a:spcAft>
-            </a:pPr>
-            <a:r>
-              <a:rPr sz="2000" b="1">
+                <a:spcPts val="1200"/>
+              </a:spcAft>
+            </a:pPr>
+            <a:r>
+              <a:rPr sz="1800" b="1">
                 <a:solidFill>
                   <a:srgbClr val="0F172A"/>
                 </a:solidFill>
@@ -10207,7 +10207,7 @@
               <a:t>• Supervision &amp; Mentorship: </a:t>
             </a:r>
             <a:r>
-              <a:rPr sz="2000" b="0">
+              <a:rPr sz="1800" b="0">
                 <a:solidFill>
                   <a:srgbClr val="334155"/>
                 </a:solidFill>
@@ -10245,7 +10245,7 @@
         <p:spPr>
           <a:xfrm>
             <a:off x="548640" y="365760"/>
-            <a:ext cx="8046720" cy="731520"/>
+            <a:ext cx="8046720" cy="640080"/>
           </a:xfrm>
           <a:prstGeom prst="rect">
             <a:avLst/>
@@ -10297,7 +10297,7 @@
             <a:pPr algn="r">
               <a:defRPr sz="1400">
                 <a:solidFill>
-                  <a:srgbClr val="334155"/>
+                  <a:srgbClr val="64748B"/>
                 </a:solidFill>
                 <a:latin typeface="Calibri"/>
               </a:defRPr>
@@ -10316,8 +10316,8 @@
         </p:nvSpPr>
         <p:spPr>
           <a:xfrm>
-            <a:off x="548640" y="1188720"/>
-            <a:ext cx="8046720" cy="4846320"/>
+            <a:off x="548640" y="1097280"/>
+            <a:ext cx="8046720" cy="4754880"/>
           </a:xfrm>
           <a:prstGeom prst="rect">
             <a:avLst/>
@@ -10325,14 +10325,14 @@
           <a:noFill/>
         </p:spPr>
         <p:txBody>
-          <a:bodyPr wrap="square">
+          <a:bodyPr wrap="square" lIns="0" tIns="0" rIns="0" bIns="0">
             <a:spAutoFit/>
           </a:bodyPr>
           <a:lstStyle/>
           <a:p>
             <a:pPr>
               <a:spcAft>
-                <a:spcPts val="1400"/>
+                <a:spcPts val="1200"/>
               </a:spcAft>
               <a:defRPr sz="2000" b="1">
                 <a:solidFill>
@@ -10342,7 +10342,7 @@
               </a:defRPr>
             </a:pPr>
             <a:r>
-              <a:rPr sz="2000" b="1">
+              <a:rPr sz="1800" b="1">
                 <a:solidFill>
                   <a:srgbClr val="0F172A"/>
                 </a:solidFill>
@@ -10351,7 +10351,7 @@
               <a:t>• Unscheduled Groundings: </a:t>
             </a:r>
             <a:r>
-              <a:rPr sz="2000" b="0">
+              <a:rPr sz="1800" b="0">
                 <a:solidFill>
                   <a:srgbClr val="334155"/>
                 </a:solidFill>
@@ -10415,11 +10415,11 @@
           <a:p>
             <a:pPr>
               <a:spcAft>
-                <a:spcPts val="1400"/>
-              </a:spcAft>
-            </a:pPr>
-            <a:r>
-              <a:rPr sz="2000" b="1">
+                <a:spcPts val="1200"/>
+              </a:spcAft>
+            </a:pPr>
+            <a:r>
+              <a:rPr sz="1800" b="1">
                 <a:solidFill>
                   <a:srgbClr val="0F172A"/>
                 </a:solidFill>
@@ -10428,7 +10428,7 @@
               <a:t>• Static Maintenance Inefficiency: </a:t>
             </a:r>
             <a:r>
-              <a:rPr sz="2000" b="0">
+              <a:rPr sz="1800" b="0">
                 <a:solidFill>
                   <a:srgbClr val="334155"/>
                 </a:solidFill>
@@ -10440,11 +10440,11 @@
           <a:p>
             <a:pPr>
               <a:spcAft>
-                <a:spcPts val="1400"/>
-              </a:spcAft>
-            </a:pPr>
-            <a:r>
-              <a:rPr sz="2000" b="1">
+                <a:spcPts val="1200"/>
+              </a:spcAft>
+            </a:pPr>
+            <a:r>
+              <a:rPr sz="1800" b="1">
                 <a:solidFill>
                   <a:srgbClr val="0F172A"/>
                 </a:solidFill>
@@ -10453,7 +10453,7 @@
               <a:t>• High Sensor Fluctuation: </a:t>
             </a:r>
             <a:r>
-              <a:rPr sz="2000" b="0">
+              <a:rPr sz="1800" b="0">
                 <a:solidFill>
                   <a:srgbClr val="334155"/>
                 </a:solidFill>
@@ -10465,11 +10465,11 @@
           <a:p>
             <a:pPr>
               <a:spcAft>
-                <a:spcPts val="1400"/>
-              </a:spcAft>
-            </a:pPr>
-            <a:r>
-              <a:rPr sz="2000" b="1">
+                <a:spcPts val="1200"/>
+              </a:spcAft>
+            </a:pPr>
+            <a:r>
+              <a:rPr sz="1800" b="1">
                 <a:solidFill>
                   <a:srgbClr val="0F172A"/>
                 </a:solidFill>
@@ -10478,7 +10478,7 @@
               <a:t>• Multi-Model Solution: </a:t>
             </a:r>
             <a:r>
-              <a:rPr sz="2000" b="0">
+              <a:rPr sz="1800" b="0">
                 <a:solidFill>
                   <a:srgbClr val="334155"/>
                 </a:solidFill>
@@ -10490,11 +10490,11 @@
           <a:p>
             <a:pPr>
               <a:spcAft>
-                <a:spcPts val="1400"/>
-              </a:spcAft>
-            </a:pPr>
-            <a:r>
-              <a:rPr sz="2000" b="1">
+                <a:spcPts val="1200"/>
+              </a:spcAft>
+            </a:pPr>
+            <a:r>
+              <a:rPr sz="1800" b="1">
                 <a:solidFill>
                   <a:srgbClr val="0F172A"/>
                 </a:solidFill>
@@ -10503,7 +10503,7 @@
               <a:t>• Real-Time Constraint: </a:t>
             </a:r>
             <a:r>
-              <a:rPr sz="2000" b="0">
+              <a:rPr sz="1800" b="0">
                 <a:solidFill>
                   <a:srgbClr val="334155"/>
                 </a:solidFill>
@@ -10541,7 +10541,7 @@
         <p:spPr>
           <a:xfrm>
             <a:off x="548640" y="365760"/>
-            <a:ext cx="8046720" cy="731520"/>
+            <a:ext cx="8046720" cy="640080"/>
           </a:xfrm>
           <a:prstGeom prst="rect">
             <a:avLst/>
@@ -10593,7 +10593,7 @@
             <a:pPr algn="r">
               <a:defRPr sz="1400">
                 <a:solidFill>
-                  <a:srgbClr val="334155"/>
+                  <a:srgbClr val="64748B"/>
                 </a:solidFill>
                 <a:latin typeface="Calibri"/>
               </a:defRPr>
@@ -10612,8 +10612,8 @@
         </p:nvSpPr>
         <p:spPr>
           <a:xfrm>
-            <a:off x="548640" y="1188720"/>
-            <a:ext cx="8046720" cy="4846320"/>
+            <a:off x="548640" y="1097280"/>
+            <a:ext cx="8046720" cy="4754880"/>
           </a:xfrm>
           <a:prstGeom prst="rect">
             <a:avLst/>
@@ -10621,14 +10621,14 @@
           <a:noFill/>
         </p:spPr>
         <p:txBody>
-          <a:bodyPr wrap="square">
+          <a:bodyPr wrap="square" lIns="0" tIns="0" rIns="0" bIns="0">
             <a:spAutoFit/>
           </a:bodyPr>
           <a:lstStyle/>
           <a:p>
             <a:pPr>
               <a:spcAft>
-                <a:spcPts val="1400"/>
+                <a:spcPts val="1200"/>
               </a:spcAft>
               <a:defRPr sz="2000" b="1">
                 <a:solidFill>
@@ -10638,7 +10638,7 @@
               </a:defRPr>
             </a:pPr>
             <a:r>
-              <a:rPr sz="2000" b="1">
+              <a:rPr sz="1800" b="1">
                 <a:solidFill>
                   <a:srgbClr val="0F172A"/>
                 </a:solidFill>
@@ -10647,7 +10647,7 @@
               <a:t>• Hardware Requirements: </a:t>
             </a:r>
             <a:r>
-              <a:rPr sz="2000" b="0">
+              <a:rPr sz="1800" b="0">
                 <a:solidFill>
                   <a:srgbClr val="334155"/>
                 </a:solidFill>
@@ -10711,11 +10711,11 @@
           <a:p>
             <a:pPr>
               <a:spcAft>
-                <a:spcPts val="1400"/>
-              </a:spcAft>
-            </a:pPr>
-            <a:r>
-              <a:rPr sz="2000" b="1">
+                <a:spcPts val="1200"/>
+              </a:spcAft>
+            </a:pPr>
+            <a:r>
+              <a:rPr sz="1800" b="1">
                 <a:solidFill>
                   <a:srgbClr val="0F172A"/>
                 </a:solidFill>
@@ -10724,7 +10724,7 @@
               <a:t>• Programming Language: </a:t>
             </a:r>
             <a:r>
-              <a:rPr sz="2000" b="0">
+              <a:rPr sz="1800" b="0">
                 <a:solidFill>
                   <a:srgbClr val="334155"/>
                 </a:solidFill>
@@ -10736,11 +10736,11 @@
           <a:p>
             <a:pPr>
               <a:spcAft>
-                <a:spcPts val="1400"/>
-              </a:spcAft>
-            </a:pPr>
-            <a:r>
-              <a:rPr sz="2000" b="1">
+                <a:spcPts val="1200"/>
+              </a:spcAft>
+            </a:pPr>
+            <a:r>
+              <a:rPr sz="1800" b="1">
                 <a:solidFill>
                   <a:srgbClr val="0F172A"/>
                 </a:solidFill>
@@ -10749,7 +10749,7 @@
               <a:t>• Machine Learning Frameworks: </a:t>
             </a:r>
             <a:r>
-              <a:rPr sz="2000" b="0">
+              <a:rPr sz="1800" b="0">
                 <a:solidFill>
                   <a:srgbClr val="334155"/>
                 </a:solidFill>
@@ -10761,11 +10761,11 @@
           <a:p>
             <a:pPr>
               <a:spcAft>
-                <a:spcPts val="1400"/>
-              </a:spcAft>
-            </a:pPr>
-            <a:r>
-              <a:rPr sz="2000" b="1">
+                <a:spcPts val="1200"/>
+              </a:spcAft>
+            </a:pPr>
+            <a:r>
+              <a:rPr sz="1800" b="1">
                 <a:solidFill>
                   <a:srgbClr val="0F172A"/>
                 </a:solidFill>
@@ -10774,7 +10774,7 @@
               <a:t>• Data &amp; Signal Libraries: </a:t>
             </a:r>
             <a:r>
-              <a:rPr sz="2000" b="0">
+              <a:rPr sz="1800" b="0">
                 <a:solidFill>
                   <a:srgbClr val="334155"/>
                 </a:solidFill>
@@ -10786,11 +10786,11 @@
           <a:p>
             <a:pPr>
               <a:spcAft>
-                <a:spcPts val="1400"/>
-              </a:spcAft>
-            </a:pPr>
-            <a:r>
-              <a:rPr sz="2000" b="1">
+                <a:spcPts val="1200"/>
+              </a:spcAft>
+            </a:pPr>
+            <a:r>
+              <a:rPr sz="1800" b="1">
                 <a:solidFill>
                   <a:srgbClr val="0F172A"/>
                 </a:solidFill>
@@ -10799,7 +10799,7 @@
               <a:t>• Visualization Frameworks: </a:t>
             </a:r>
             <a:r>
-              <a:rPr sz="2000" b="0">
+              <a:rPr sz="1800" b="0">
                 <a:solidFill>
                   <a:srgbClr val="334155"/>
                 </a:solidFill>
@@ -10837,7 +10837,7 @@
         <p:spPr>
           <a:xfrm>
             <a:off x="548640" y="365760"/>
-            <a:ext cx="8046720" cy="731520"/>
+            <a:ext cx="8046720" cy="640080"/>
           </a:xfrm>
           <a:prstGeom prst="rect">
             <a:avLst/>
@@ -10889,7 +10889,7 @@
             <a:pPr algn="r">
               <a:defRPr sz="1400">
                 <a:solidFill>
-                  <a:srgbClr val="334155"/>
+                  <a:srgbClr val="64748B"/>
                 </a:solidFill>
                 <a:latin typeface="Calibri"/>
               </a:defRPr>
@@ -10902,696 +10902,14 @@
       </p:sp>
       <p:sp>
         <p:nvSpPr>
-          <p:cNvPr id="4" name="Rounded Rectangle 3"/>
-          <p:cNvSpPr/>
-          <p:nvPr/>
-        </p:nvSpPr>
-        <p:spPr>
-          <a:xfrm>
-            <a:off x="548640" y="1371600"/>
-            <a:ext cx="2194560" cy="1645920"/>
-          </a:xfrm>
-          <a:prstGeom prst="roundRect">
-            <a:avLst/>
-          </a:prstGeom>
-          <a:solidFill>
-            <a:srgbClr val="E0F2FE"/>
-          </a:solidFill>
-          <a:ln w="31750">
-            <a:solidFill>
-              <a:srgbClr val="0D6EFD"/>
-            </a:solidFill>
-          </a:ln>
-        </p:spPr>
-        <p:style>
-          <a:lnRef idx="1">
-            <a:schemeClr val="accent1"/>
-          </a:lnRef>
-          <a:fillRef idx="3">
-            <a:schemeClr val="accent1"/>
-          </a:fillRef>
-          <a:effectRef idx="2">
-            <a:schemeClr val="accent1"/>
-          </a:effectRef>
-          <a:fontRef idx="minor">
-            <a:schemeClr val="lt1"/>
-          </a:fontRef>
-        </p:style>
-        <p:txBody>
-          <a:bodyPr rtlCol="0" anchor="ctr" wrap="square" lIns="45720" rIns="45720"/>
-          <a:lstStyle/>
-          <a:p>
-            <a:pPr algn="ctr">
-              <a:spcAft>
-                <a:spcPts val="400"/>
-              </a:spcAft>
-              <a:defRPr sz="1600" b="1">
-                <a:solidFill>
-                  <a:srgbClr val="0284C7"/>
-                </a:solidFill>
-                <a:latin typeface="Calibri"/>
-              </a:defRPr>
-            </a:pPr>
-            <a:r>
-              <a:t>STAGE 1</a:t>
-            </a:r>
-          </a:p>
-          <a:p>
-            <a:pPr algn="ctr">
-              <a:defRPr sz="1600" b="1">
-                <a:solidFill>
-                  <a:srgbClr val="0F172A"/>
-                </a:solidFill>
-                <a:latin typeface="Calibri"/>
-              </a:defRPr>
-            </a:pPr>
-          </a:p>
-          <a:p>
-            <a:pPr algn="ctr">
-              <a:defRPr sz="1300" b="0">
-                <a:solidFill>
-                  <a:srgbClr val="0F172A"/>
-                </a:solidFill>
-                <a:latin typeface="Calibri"/>
-              </a:defRPr>
-            </a:pPr>
-            <a:r>
-              <a:t>Telemetry Ingestion</a:t>
-            </a:r>
-            <a:br/>
-            <a:r>
-              <a:t>(NASA C-MAPSS 21 Sensors)</a:t>
-            </a:r>
-          </a:p>
-        </p:txBody>
-      </p:sp>
-      <p:sp>
-        <p:nvSpPr>
-          <p:cNvPr id="5" name="Right Arrow 4"/>
-          <p:cNvSpPr/>
-          <p:nvPr/>
-        </p:nvSpPr>
-        <p:spPr>
-          <a:xfrm>
-            <a:off x="2788920" y="2057400"/>
-            <a:ext cx="457200" cy="274320"/>
-          </a:xfrm>
-          <a:prstGeom prst="rightArrow">
-            <a:avLst/>
-          </a:prstGeom>
-          <a:solidFill>
-            <a:srgbClr val="0D6EFD"/>
-          </a:solidFill>
-          <a:ln>
-            <a:noFill/>
-          </a:ln>
-        </p:spPr>
-        <p:style>
-          <a:lnRef idx="1">
-            <a:schemeClr val="accent1"/>
-          </a:lnRef>
-          <a:fillRef idx="3">
-            <a:schemeClr val="accent1"/>
-          </a:fillRef>
-          <a:effectRef idx="2">
-            <a:schemeClr val="accent1"/>
-          </a:effectRef>
-          <a:fontRef idx="minor">
-            <a:schemeClr val="lt1"/>
-          </a:fontRef>
-        </p:style>
-        <p:txBody>
-          <a:bodyPr rtlCol="0" anchor="ctr"/>
-          <a:lstStyle/>
-          <a:p>
-            <a:pPr algn="ctr"/>
-          </a:p>
-        </p:txBody>
-      </p:sp>
-      <p:sp>
-        <p:nvSpPr>
-          <p:cNvPr id="6" name="Rounded Rectangle 5"/>
-          <p:cNvSpPr/>
-          <p:nvPr/>
-        </p:nvSpPr>
-        <p:spPr>
-          <a:xfrm>
-            <a:off x="3291840" y="1371600"/>
-            <a:ext cx="2194560" cy="1645920"/>
-          </a:xfrm>
-          <a:prstGeom prst="roundRect">
-            <a:avLst/>
-          </a:prstGeom>
-          <a:solidFill>
-            <a:srgbClr val="E0F2FE"/>
-          </a:solidFill>
-          <a:ln w="31750">
-            <a:solidFill>
-              <a:srgbClr val="8B5CF6"/>
-            </a:solidFill>
-          </a:ln>
-        </p:spPr>
-        <p:style>
-          <a:lnRef idx="1">
-            <a:schemeClr val="accent1"/>
-          </a:lnRef>
-          <a:fillRef idx="3">
-            <a:schemeClr val="accent1"/>
-          </a:fillRef>
-          <a:effectRef idx="2">
-            <a:schemeClr val="accent1"/>
-          </a:effectRef>
-          <a:fontRef idx="minor">
-            <a:schemeClr val="lt1"/>
-          </a:fontRef>
-        </p:style>
-        <p:txBody>
-          <a:bodyPr rtlCol="0" anchor="ctr" wrap="square" lIns="45720" rIns="45720"/>
-          <a:lstStyle/>
-          <a:p>
-            <a:pPr algn="ctr">
-              <a:spcAft>
-                <a:spcPts val="400"/>
-              </a:spcAft>
-              <a:defRPr sz="1600" b="1">
-                <a:solidFill>
-                  <a:srgbClr val="0284C7"/>
-                </a:solidFill>
-                <a:latin typeface="Calibri"/>
-              </a:defRPr>
-            </a:pPr>
-            <a:r>
-              <a:t>STAGE 2</a:t>
-            </a:r>
-          </a:p>
-          <a:p>
-            <a:pPr algn="ctr">
-              <a:defRPr sz="1600" b="1">
-                <a:solidFill>
-                  <a:srgbClr val="0F172A"/>
-                </a:solidFill>
-                <a:latin typeface="Calibri"/>
-              </a:defRPr>
-            </a:pPr>
-          </a:p>
-          <a:p>
-            <a:pPr algn="ctr">
-              <a:defRPr sz="1300" b="0">
-                <a:solidFill>
-                  <a:srgbClr val="0F172A"/>
-                </a:solidFill>
-                <a:latin typeface="Calibri"/>
-              </a:defRPr>
-            </a:pPr>
-            <a:r>
-              <a:t>Rolling Feature Engine</a:t>
-            </a:r>
-            <a:br/>
-            <a:r>
-              <a:t>(5-Cycle Mean &amp; Std Dev)</a:t>
-            </a:r>
-          </a:p>
-        </p:txBody>
-      </p:sp>
-      <p:sp>
-        <p:nvSpPr>
-          <p:cNvPr id="7" name="Right Arrow 6"/>
-          <p:cNvSpPr/>
-          <p:nvPr/>
-        </p:nvSpPr>
-        <p:spPr>
-          <a:xfrm>
-            <a:off x="5532120" y="2057400"/>
-            <a:ext cx="457200" cy="274320"/>
-          </a:xfrm>
-          <a:prstGeom prst="rightArrow">
-            <a:avLst/>
-          </a:prstGeom>
-          <a:solidFill>
-            <a:srgbClr val="8B5CF6"/>
-          </a:solidFill>
-          <a:ln>
-            <a:noFill/>
-          </a:ln>
-        </p:spPr>
-        <p:style>
-          <a:lnRef idx="1">
-            <a:schemeClr val="accent1"/>
-          </a:lnRef>
-          <a:fillRef idx="3">
-            <a:schemeClr val="accent1"/>
-          </a:fillRef>
-          <a:effectRef idx="2">
-            <a:schemeClr val="accent1"/>
-          </a:effectRef>
-          <a:fontRef idx="minor">
-            <a:schemeClr val="lt1"/>
-          </a:fontRef>
-        </p:style>
-        <p:txBody>
-          <a:bodyPr rtlCol="0" anchor="ctr"/>
-          <a:lstStyle/>
-          <a:p>
-            <a:pPr algn="ctr"/>
-          </a:p>
-        </p:txBody>
-      </p:sp>
-      <p:sp>
-        <p:nvSpPr>
-          <p:cNvPr id="8" name="Rounded Rectangle 7"/>
-          <p:cNvSpPr/>
-          <p:nvPr/>
-        </p:nvSpPr>
-        <p:spPr>
-          <a:xfrm>
-            <a:off x="6035040" y="1371600"/>
-            <a:ext cx="2194560" cy="1645920"/>
-          </a:xfrm>
-          <a:prstGeom prst="roundRect">
-            <a:avLst/>
-          </a:prstGeom>
-          <a:solidFill>
-            <a:srgbClr val="E0F2FE"/>
-          </a:solidFill>
-          <a:ln w="31750">
-            <a:solidFill>
-              <a:srgbClr val="0D6EFD"/>
-            </a:solidFill>
-          </a:ln>
-        </p:spPr>
-        <p:style>
-          <a:lnRef idx="1">
-            <a:schemeClr val="accent1"/>
-          </a:lnRef>
-          <a:fillRef idx="3">
-            <a:schemeClr val="accent1"/>
-          </a:fillRef>
-          <a:effectRef idx="2">
-            <a:schemeClr val="accent1"/>
-          </a:effectRef>
-          <a:fontRef idx="minor">
-            <a:schemeClr val="lt1"/>
-          </a:fontRef>
-        </p:style>
-        <p:txBody>
-          <a:bodyPr rtlCol="0" anchor="ctr" wrap="square" lIns="45720" rIns="45720"/>
-          <a:lstStyle/>
-          <a:p>
-            <a:pPr algn="ctr">
-              <a:spcAft>
-                <a:spcPts val="400"/>
-              </a:spcAft>
-              <a:defRPr sz="1600" b="1">
-                <a:solidFill>
-                  <a:srgbClr val="0284C7"/>
-                </a:solidFill>
-                <a:latin typeface="Calibri"/>
-              </a:defRPr>
-            </a:pPr>
-            <a:r>
-              <a:t>STAGE 3</a:t>
-            </a:r>
-          </a:p>
-          <a:p>
-            <a:pPr algn="ctr">
-              <a:defRPr sz="1600" b="1">
-                <a:solidFill>
-                  <a:srgbClr val="0F172A"/>
-                </a:solidFill>
-                <a:latin typeface="Calibri"/>
-              </a:defRPr>
-            </a:pPr>
-          </a:p>
-          <a:p>
-            <a:pPr algn="ctr">
-              <a:defRPr sz="1300" b="0">
-                <a:solidFill>
-                  <a:srgbClr val="0F172A"/>
-                </a:solidFill>
-                <a:latin typeface="Calibri"/>
-              </a:defRPr>
-            </a:pPr>
-            <a:r>
-              <a:t>Multicollinearity Filter</a:t>
-            </a:r>
-            <a:br/>
-            <a:r>
-              <a:t>(Correlation Reduction r&gt;0.80)</a:t>
-            </a:r>
-          </a:p>
-        </p:txBody>
-      </p:sp>
-      <p:sp>
-        <p:nvSpPr>
-          <p:cNvPr id="9" name="Rounded Rectangle 8"/>
-          <p:cNvSpPr/>
-          <p:nvPr/>
-        </p:nvSpPr>
-        <p:spPr>
-          <a:xfrm>
-            <a:off x="548640" y="3566160"/>
-            <a:ext cx="2194560" cy="1645920"/>
-          </a:xfrm>
-          <a:prstGeom prst="roundRect">
-            <a:avLst/>
-          </a:prstGeom>
-          <a:solidFill>
-            <a:srgbClr val="E0F2FE"/>
-          </a:solidFill>
-          <a:ln w="31750">
-            <a:solidFill>
-              <a:srgbClr val="0F172A"/>
-            </a:solidFill>
-          </a:ln>
-        </p:spPr>
-        <p:style>
-          <a:lnRef idx="1">
-            <a:schemeClr val="accent1"/>
-          </a:lnRef>
-          <a:fillRef idx="3">
-            <a:schemeClr val="accent1"/>
-          </a:fillRef>
-          <a:effectRef idx="2">
-            <a:schemeClr val="accent1"/>
-          </a:effectRef>
-          <a:fontRef idx="minor">
-            <a:schemeClr val="lt1"/>
-          </a:fontRef>
-        </p:style>
-        <p:txBody>
-          <a:bodyPr rtlCol="0" anchor="ctr" wrap="square" lIns="45720" rIns="45720"/>
-          <a:lstStyle/>
-          <a:p>
-            <a:pPr algn="ctr">
-              <a:spcAft>
-                <a:spcPts val="400"/>
-              </a:spcAft>
-              <a:defRPr sz="1600" b="1">
-                <a:solidFill>
-                  <a:srgbClr val="0284C7"/>
-                </a:solidFill>
-                <a:latin typeface="Calibri"/>
-              </a:defRPr>
-            </a:pPr>
-            <a:r>
-              <a:t>STAGE 4</a:t>
-            </a:r>
-          </a:p>
-          <a:p>
-            <a:pPr algn="ctr">
-              <a:defRPr sz="1600" b="1">
-                <a:solidFill>
-                  <a:srgbClr val="0F172A"/>
-                </a:solidFill>
-                <a:latin typeface="Calibri"/>
-              </a:defRPr>
-            </a:pPr>
-          </a:p>
-          <a:p>
-            <a:pPr algn="ctr">
-              <a:defRPr sz="1300" b="0">
-                <a:solidFill>
-                  <a:srgbClr val="0F172A"/>
-                </a:solidFill>
-                <a:latin typeface="Calibri"/>
-              </a:defRPr>
-            </a:pPr>
-            <a:r>
-              <a:t>RUL Regression Net</a:t>
-            </a:r>
-            <a:br/>
-            <a:r>
-              <a:t>(Random Forest Regressor)</a:t>
-            </a:r>
-          </a:p>
-        </p:txBody>
-      </p:sp>
-      <p:sp>
-        <p:nvSpPr>
-          <p:cNvPr id="10" name="Right Arrow 9"/>
-          <p:cNvSpPr/>
-          <p:nvPr/>
-        </p:nvSpPr>
-        <p:spPr>
-          <a:xfrm>
-            <a:off x="2788920" y="4251959"/>
-            <a:ext cx="457200" cy="274320"/>
-          </a:xfrm>
-          <a:prstGeom prst="rightArrow">
-            <a:avLst/>
-          </a:prstGeom>
-          <a:solidFill>
-            <a:srgbClr val="0F172A"/>
-          </a:solidFill>
-          <a:ln>
-            <a:noFill/>
-          </a:ln>
-        </p:spPr>
-        <p:style>
-          <a:lnRef idx="1">
-            <a:schemeClr val="accent1"/>
-          </a:lnRef>
-          <a:fillRef idx="3">
-            <a:schemeClr val="accent1"/>
-          </a:fillRef>
-          <a:effectRef idx="2">
-            <a:schemeClr val="accent1"/>
-          </a:effectRef>
-          <a:fontRef idx="minor">
-            <a:schemeClr val="lt1"/>
-          </a:fontRef>
-        </p:style>
-        <p:txBody>
-          <a:bodyPr rtlCol="0" anchor="ctr"/>
-          <a:lstStyle/>
-          <a:p>
-            <a:pPr algn="ctr"/>
-          </a:p>
-        </p:txBody>
-      </p:sp>
-      <p:sp>
-        <p:nvSpPr>
-          <p:cNvPr id="11" name="Rounded Rectangle 10"/>
-          <p:cNvSpPr/>
-          <p:nvPr/>
-        </p:nvSpPr>
-        <p:spPr>
-          <a:xfrm>
-            <a:off x="3291840" y="3566160"/>
-            <a:ext cx="2194560" cy="1645920"/>
-          </a:xfrm>
-          <a:prstGeom prst="roundRect">
-            <a:avLst/>
-          </a:prstGeom>
-          <a:solidFill>
-            <a:srgbClr val="E0F2FE"/>
-          </a:solidFill>
-          <a:ln w="31750">
-            <a:solidFill>
-              <a:srgbClr val="8B5CF6"/>
-            </a:solidFill>
-          </a:ln>
-        </p:spPr>
-        <p:style>
-          <a:lnRef idx="1">
-            <a:schemeClr val="accent1"/>
-          </a:lnRef>
-          <a:fillRef idx="3">
-            <a:schemeClr val="accent1"/>
-          </a:fillRef>
-          <a:effectRef idx="2">
-            <a:schemeClr val="accent1"/>
-          </a:effectRef>
-          <a:fontRef idx="minor">
-            <a:schemeClr val="lt1"/>
-          </a:fontRef>
-        </p:style>
-        <p:txBody>
-          <a:bodyPr rtlCol="0" anchor="ctr" wrap="square" lIns="45720" rIns="45720"/>
-          <a:lstStyle/>
-          <a:p>
-            <a:pPr algn="ctr">
-              <a:spcAft>
-                <a:spcPts val="400"/>
-              </a:spcAft>
-              <a:defRPr sz="1600" b="1">
-                <a:solidFill>
-                  <a:srgbClr val="0284C7"/>
-                </a:solidFill>
-                <a:latin typeface="Calibri"/>
-              </a:defRPr>
-            </a:pPr>
-            <a:r>
-              <a:t>STAGE 5</a:t>
-            </a:r>
-          </a:p>
-          <a:p>
-            <a:pPr algn="ctr">
-              <a:defRPr sz="1600" b="1">
-                <a:solidFill>
-                  <a:srgbClr val="0F172A"/>
-                </a:solidFill>
-                <a:latin typeface="Calibri"/>
-              </a:defRPr>
-            </a:pPr>
-          </a:p>
-          <a:p>
-            <a:pPr algn="ctr">
-              <a:defRPr sz="1300" b="0">
-                <a:solidFill>
-                  <a:srgbClr val="0F172A"/>
-                </a:solidFill>
-                <a:latin typeface="Calibri"/>
-              </a:defRPr>
-            </a:pPr>
-            <a:r>
-              <a:t>Binary 30d Classifier</a:t>
-            </a:r>
-            <a:br/>
-            <a:r>
-              <a:t>(98.45% AUC-ROC Model)</a:t>
-            </a:r>
-          </a:p>
-        </p:txBody>
-      </p:sp>
-      <p:sp>
-        <p:nvSpPr>
-          <p:cNvPr id="12" name="Right Arrow 11"/>
-          <p:cNvSpPr/>
-          <p:nvPr/>
-        </p:nvSpPr>
-        <p:spPr>
-          <a:xfrm>
-            <a:off x="5532120" y="4251959"/>
-            <a:ext cx="457200" cy="274320"/>
-          </a:xfrm>
-          <a:prstGeom prst="rightArrow">
-            <a:avLst/>
-          </a:prstGeom>
-          <a:solidFill>
-            <a:srgbClr val="8B5CF6"/>
-          </a:solidFill>
-          <a:ln>
-            <a:noFill/>
-          </a:ln>
-        </p:spPr>
-        <p:style>
-          <a:lnRef idx="1">
-            <a:schemeClr val="accent1"/>
-          </a:lnRef>
-          <a:fillRef idx="3">
-            <a:schemeClr val="accent1"/>
-          </a:fillRef>
-          <a:effectRef idx="2">
-            <a:schemeClr val="accent1"/>
-          </a:effectRef>
-          <a:fontRef idx="minor">
-            <a:schemeClr val="lt1"/>
-          </a:fontRef>
-        </p:style>
-        <p:txBody>
-          <a:bodyPr rtlCol="0" anchor="ctr"/>
-          <a:lstStyle/>
-          <a:p>
-            <a:pPr algn="ctr"/>
-          </a:p>
-        </p:txBody>
-      </p:sp>
-      <p:sp>
-        <p:nvSpPr>
-          <p:cNvPr id="13" name="Rounded Rectangle 12"/>
-          <p:cNvSpPr/>
-          <p:nvPr/>
-        </p:nvSpPr>
-        <p:spPr>
-          <a:xfrm>
-            <a:off x="6035040" y="3566160"/>
-            <a:ext cx="2194560" cy="1645920"/>
-          </a:xfrm>
-          <a:prstGeom prst="roundRect">
-            <a:avLst/>
-          </a:prstGeom>
-          <a:solidFill>
-            <a:srgbClr val="E0F2FE"/>
-          </a:solidFill>
-          <a:ln w="31750">
-            <a:solidFill>
-              <a:srgbClr val="10B981"/>
-            </a:solidFill>
-          </a:ln>
-        </p:spPr>
-        <p:style>
-          <a:lnRef idx="1">
-            <a:schemeClr val="accent1"/>
-          </a:lnRef>
-          <a:fillRef idx="3">
-            <a:schemeClr val="accent1"/>
-          </a:fillRef>
-          <a:effectRef idx="2">
-            <a:schemeClr val="accent1"/>
-          </a:effectRef>
-          <a:fontRef idx="minor">
-            <a:schemeClr val="lt1"/>
-          </a:fontRef>
-        </p:style>
-        <p:txBody>
-          <a:bodyPr rtlCol="0" anchor="ctr" wrap="square" lIns="45720" rIns="45720"/>
-          <a:lstStyle/>
-          <a:p>
-            <a:pPr algn="ctr">
-              <a:spcAft>
-                <a:spcPts val="400"/>
-              </a:spcAft>
-              <a:defRPr sz="1600" b="1">
-                <a:solidFill>
-                  <a:srgbClr val="0284C7"/>
-                </a:solidFill>
-                <a:latin typeface="Calibri"/>
-              </a:defRPr>
-            </a:pPr>
-            <a:r>
-              <a:t>STAGE 6</a:t>
-            </a:r>
-          </a:p>
-          <a:p>
-            <a:pPr algn="ctr">
-              <a:defRPr sz="1600" b="1">
-                <a:solidFill>
-                  <a:srgbClr val="0F172A"/>
-                </a:solidFill>
-                <a:latin typeface="Calibri"/>
-              </a:defRPr>
-            </a:pPr>
-          </a:p>
-          <a:p>
-            <a:pPr algn="ctr">
-              <a:defRPr sz="1300" b="0">
-                <a:solidFill>
-                  <a:srgbClr val="0F172A"/>
-                </a:solidFill>
-                <a:latin typeface="Calibri"/>
-              </a:defRPr>
-            </a:pPr>
-            <a:r>
-              <a:t>Multi-Class Neural MLP</a:t>
-            </a:r>
-            <a:br/>
-            <a:r>
-              <a:t>(3-Tier Risk Hazard Dispatch)</a:t>
-            </a:r>
-          </a:p>
-        </p:txBody>
-      </p:sp>
-      <p:sp>
-        <p:nvSpPr>
-          <p:cNvPr id="14" name="TextBox 13"/>
+          <p:cNvPr id="4" name="TextBox 3"/>
           <p:cNvSpPr txBox="1"/>
           <p:nvPr/>
         </p:nvSpPr>
         <p:spPr>
           <a:xfrm>
-            <a:off x="548640" y="5577840"/>
-            <a:ext cx="8046720" cy="457200"/>
+            <a:off x="548640" y="1097280"/>
+            <a:ext cx="4114800" cy="4754880"/>
           </a:xfrm>
           <a:prstGeom prst="rect">
             <a:avLst/>
@@ -11599,25 +10917,161 @@
           <a:noFill/>
         </p:spPr>
         <p:txBody>
-          <a:bodyPr wrap="none">
+          <a:bodyPr wrap="square" lIns="0" tIns="0" rIns="0" bIns="0">
             <a:spAutoFit/>
           </a:bodyPr>
           <a:lstStyle/>
           <a:p>
-            <a:pPr algn="ctr">
-              <a:defRPr sz="1600" b="1">
+            <a:pPr>
+              <a:spcAft>
+                <a:spcPts val="1000"/>
+              </a:spcAft>
+            </a:pPr>
+            <a:r>
+              <a:rPr sz="1600" b="1">
+                <a:solidFill>
+                  <a:srgbClr val="0F172A"/>
+                </a:solidFill>
+                <a:latin typeface="Calibri"/>
+              </a:rPr>
+              <a:t>• Stage 1 Ingestion: </a:t>
+            </a:r>
+            <a:r>
+              <a:rPr sz="1600" b="0">
                 <a:solidFill>
                   <a:srgbClr val="334155"/>
                 </a:solidFill>
                 <a:latin typeface="Calibri"/>
-              </a:defRPr>
-            </a:pPr>
-            <a:r>
-              <a:t>Figure 1: End-to-End Predictive Maintenance Data Flow &amp; Inference Pipeline Flowchart</a:t>
+              </a:rPr>
+              <a:t>NASA C-MAPSS telemetry dataset with 21 sensors &amp; 3 operational settings.</a:t>
+            </a:r>
+          </a:p>
+          <a:p>
+            <a:pPr>
+              <a:spcAft>
+                <a:spcPts val="1000"/>
+              </a:spcAft>
+            </a:pPr>
+            <a:r>
+              <a:rPr sz="1600" b="1">
+                <a:solidFill>
+                  <a:srgbClr val="0F172A"/>
+                </a:solidFill>
+                <a:latin typeface="Calibri"/>
+              </a:rPr>
+              <a:t>• Stage 2 Signal Processing: </a:t>
+            </a:r>
+            <a:r>
+              <a:rPr sz="1600" b="0">
+                <a:solidFill>
+                  <a:srgbClr val="334155"/>
+                </a:solidFill>
+                <a:latin typeface="Calibri"/>
+              </a:rPr>
+              <a:t>5-cycle rolling mean and standard deviation feature aggregations.</a:t>
+            </a:r>
+          </a:p>
+          <a:p>
+            <a:pPr>
+              <a:spcAft>
+                <a:spcPts val="1000"/>
+              </a:spcAft>
+            </a:pPr>
+            <a:r>
+              <a:rPr sz="1600" b="1">
+                <a:solidFill>
+                  <a:srgbClr val="0F172A"/>
+                </a:solidFill>
+                <a:latin typeface="Calibri"/>
+              </a:rPr>
+              <a:t>• Stage 3 Correlation Filter: </a:t>
+            </a:r>
+            <a:r>
+              <a:rPr sz="1600" b="0">
+                <a:solidFill>
+                  <a:srgbClr val="334155"/>
+                </a:solidFill>
+                <a:latin typeface="Calibri"/>
+              </a:rPr>
+              <a:t>Eliminates redundant sensor pairs with correlation r &gt; 0.80.</a:t>
+            </a:r>
+          </a:p>
+          <a:p>
+            <a:pPr>
+              <a:spcAft>
+                <a:spcPts val="1000"/>
+              </a:spcAft>
+            </a:pPr>
+            <a:r>
+              <a:rPr sz="1600" b="1">
+                <a:solidFill>
+                  <a:srgbClr val="0F172A"/>
+                </a:solidFill>
+                <a:latin typeface="Calibri"/>
+              </a:rPr>
+              <a:t>• Stage 4 AI Inference: </a:t>
+            </a:r>
+            <a:r>
+              <a:rPr sz="1600" b="0">
+                <a:solidFill>
+                  <a:srgbClr val="334155"/>
+                </a:solidFill>
+                <a:latin typeface="Calibri"/>
+              </a:rPr>
+              <a:t>Tri-model engine: RUL Regressor, Binary 30d Classifier &amp; Neural MLP.</a:t>
+            </a:r>
+          </a:p>
+          <a:p>
+            <a:pPr>
+              <a:spcAft>
+                <a:spcPts val="1000"/>
+              </a:spcAft>
+            </a:pPr>
+            <a:r>
+              <a:rPr sz="1600" b="1">
+                <a:solidFill>
+                  <a:srgbClr val="0F172A"/>
+                </a:solidFill>
+                <a:latin typeface="Calibri"/>
+              </a:rPr>
+              <a:t>• Stage 5 Actionable Dispatch: </a:t>
+            </a:r>
+            <a:r>
+              <a:rPr sz="1600" b="0">
+                <a:solidFill>
+                  <a:srgbClr val="334155"/>
+                </a:solidFill>
+                <a:latin typeface="Calibri"/>
+              </a:rPr>
+              <a:t>Computes health score, cost optimization &amp; fleet maintenance schedule.</a:t>
             </a:r>
           </a:p>
         </p:txBody>
       </p:sp>
+      <p:pic>
+        <p:nvPicPr>
+          <p:cNvPr id="5" name="Picture 4" descr="vertical_flowchart_image.png"/>
+          <p:cNvPicPr>
+            <a:picLocks noChangeAspect="1"/>
+          </p:cNvPicPr>
+          <p:nvPr/>
+        </p:nvPicPr>
+        <p:blipFill>
+          <a:blip r:embed="rId2"/>
+          <a:stretch>
+            <a:fillRect/>
+          </a:stretch>
+        </p:blipFill>
+        <p:spPr>
+          <a:xfrm>
+            <a:off x="4937760" y="1097280"/>
+            <a:ext cx="3657600" cy="5247861"/>
+          </a:xfrm>
+          <a:prstGeom prst="rect">
+            <a:avLst/>
+          </a:prstGeom>
+        </p:spPr>
+      </p:pic>
     </p:spTree>
   </p:cSld>
   <p:clrMapOvr>
@@ -11645,7 +11099,7 @@
         <p:spPr>
           <a:xfrm>
             <a:off x="548640" y="365760"/>
-            <a:ext cx="8046720" cy="731520"/>
+            <a:ext cx="8046720" cy="640080"/>
           </a:xfrm>
           <a:prstGeom prst="rect">
             <a:avLst/>
@@ -11697,7 +11151,7 @@
             <a:pPr algn="r">
               <a:defRPr sz="1400">
                 <a:solidFill>
-                  <a:srgbClr val="334155"/>
+                  <a:srgbClr val="64748B"/>
                 </a:solidFill>
                 <a:latin typeface="Calibri"/>
               </a:defRPr>
@@ -11716,8 +11170,8 @@
         </p:nvSpPr>
         <p:spPr>
           <a:xfrm>
-            <a:off x="548640" y="1188720"/>
-            <a:ext cx="8046720" cy="4846320"/>
+            <a:off x="548640" y="1097280"/>
+            <a:ext cx="8046720" cy="4754880"/>
           </a:xfrm>
           <a:prstGeom prst="rect">
             <a:avLst/>
@@ -11725,14 +11179,14 @@
           <a:noFill/>
         </p:spPr>
         <p:txBody>
-          <a:bodyPr wrap="square">
+          <a:bodyPr wrap="square" lIns="0" tIns="0" rIns="0" bIns="0">
             <a:spAutoFit/>
           </a:bodyPr>
           <a:lstStyle/>
           <a:p>
             <a:pPr>
               <a:spcAft>
-                <a:spcPts val="1400"/>
+                <a:spcPts val="1200"/>
               </a:spcAft>
               <a:defRPr sz="2000" b="1">
                 <a:solidFill>
@@ -11742,7 +11196,7 @@
               </a:defRPr>
             </a:pPr>
             <a:r>
-              <a:rPr sz="2000" b="1">
+              <a:rPr sz="1800" b="1">
                 <a:solidFill>
                   <a:srgbClr val="0F172A"/>
                 </a:solidFill>
@@ -11751,7 +11205,7 @@
               <a:t>• Rolling Window Aggregations: </a:t>
             </a:r>
             <a:r>
-              <a:rPr sz="2000" b="0">
+              <a:rPr sz="1800" b="0">
                 <a:solidFill>
                   <a:srgbClr val="334155"/>
                 </a:solidFill>
@@ -11815,11 +11269,11 @@
           <a:p>
             <a:pPr>
               <a:spcAft>
-                <a:spcPts val="1400"/>
-              </a:spcAft>
-            </a:pPr>
-            <a:r>
-              <a:rPr sz="2000" b="1">
+                <a:spcPts val="1200"/>
+              </a:spcAft>
+            </a:pPr>
+            <a:r>
+              <a:rPr sz="1800" b="1">
                 <a:solidFill>
                   <a:srgbClr val="0F172A"/>
                 </a:solidFill>
@@ -11828,7 +11282,7 @@
               <a:t>• Signal Noise Reduction: </a:t>
             </a:r>
             <a:r>
-              <a:rPr sz="2000" b="0">
+              <a:rPr sz="1800" b="0">
                 <a:solidFill>
                   <a:srgbClr val="334155"/>
                 </a:solidFill>
@@ -11840,11 +11294,11 @@
           <a:p>
             <a:pPr>
               <a:spcAft>
-                <a:spcPts val="1400"/>
-              </a:spcAft>
-            </a:pPr>
-            <a:r>
-              <a:rPr sz="2000" b="1">
+                <a:spcPts val="1200"/>
+              </a:spcAft>
+            </a:pPr>
+            <a:r>
+              <a:rPr sz="1800" b="1">
                 <a:solidFill>
                   <a:srgbClr val="0F172A"/>
                 </a:solidFill>
@@ -11853,7 +11307,7 @@
               <a:t>• Multicollinearity Filtering: </a:t>
             </a:r>
             <a:r>
-              <a:rPr sz="2000" b="0">
+              <a:rPr sz="1800" b="0">
                 <a:solidFill>
                   <a:srgbClr val="334155"/>
                 </a:solidFill>
@@ -11865,11 +11319,11 @@
           <a:p>
             <a:pPr>
               <a:spcAft>
-                <a:spcPts val="1400"/>
-              </a:spcAft>
-            </a:pPr>
-            <a:r>
-              <a:rPr sz="2000" b="1">
+                <a:spcPts val="1200"/>
+              </a:spcAft>
+            </a:pPr>
+            <a:r>
+              <a:rPr sz="1800" b="1">
                 <a:solidFill>
                   <a:srgbClr val="0F172A"/>
                 </a:solidFill>
@@ -11878,7 +11332,7 @@
               <a:t>• Scale &amp; Position Normalization: </a:t>
             </a:r>
             <a:r>
-              <a:rPr sz="2000" b="0">
+              <a:rPr sz="1800" b="0">
                 <a:solidFill>
                   <a:srgbClr val="334155"/>
                 </a:solidFill>
@@ -11890,11 +11344,11 @@
           <a:p>
             <a:pPr>
               <a:spcAft>
-                <a:spcPts val="1400"/>
-              </a:spcAft>
-            </a:pPr>
-            <a:r>
-              <a:rPr sz="2000" b="1">
+                <a:spcPts val="1200"/>
+              </a:spcAft>
+            </a:pPr>
+            <a:r>
+              <a:rPr sz="1800" b="1">
                 <a:solidFill>
                   <a:srgbClr val="0F172A"/>
                 </a:solidFill>
@@ -11903,7 +11357,7 @@
               <a:t>• Compact Feature Dimension: </a:t>
             </a:r>
             <a:r>
-              <a:rPr sz="2000" b="0">
+              <a:rPr sz="1800" b="0">
                 <a:solidFill>
                   <a:srgbClr val="334155"/>
                 </a:solidFill>
@@ -11941,7 +11395,7 @@
         <p:spPr>
           <a:xfrm>
             <a:off x="548640" y="365760"/>
-            <a:ext cx="8046720" cy="731520"/>
+            <a:ext cx="8046720" cy="640080"/>
           </a:xfrm>
           <a:prstGeom prst="rect">
             <a:avLst/>
@@ -11993,7 +11447,7 @@
             <a:pPr algn="r">
               <a:defRPr sz="1400">
                 <a:solidFill>
-                  <a:srgbClr val="334155"/>
+                  <a:srgbClr val="64748B"/>
                 </a:solidFill>
                 <a:latin typeface="Calibri"/>
               </a:defRPr>
@@ -12012,8 +11466,8 @@
         </p:nvSpPr>
         <p:spPr>
           <a:xfrm>
-            <a:off x="548640" y="1188720"/>
-            <a:ext cx="8046720" cy="4846320"/>
+            <a:off x="548640" y="1097280"/>
+            <a:ext cx="8046720" cy="4754880"/>
           </a:xfrm>
           <a:prstGeom prst="rect">
             <a:avLst/>
@@ -12021,14 +11475,14 @@
           <a:noFill/>
         </p:spPr>
         <p:txBody>
-          <a:bodyPr wrap="square">
+          <a:bodyPr wrap="square" lIns="0" tIns="0" rIns="0" bIns="0">
             <a:spAutoFit/>
           </a:bodyPr>
           <a:lstStyle/>
           <a:p>
             <a:pPr>
               <a:spcAft>
-                <a:spcPts val="1400"/>
+                <a:spcPts val="1200"/>
               </a:spcAft>
               <a:defRPr sz="2000" b="1">
                 <a:solidFill>
@@ -12038,7 +11492,7 @@
               </a:defRPr>
             </a:pPr>
             <a:r>
-              <a:rPr sz="2000" b="1">
+              <a:rPr sz="1800" b="1">
                 <a:solidFill>
                   <a:srgbClr val="0F172A"/>
                 </a:solidFill>
@@ -12047,7 +11501,7 @@
               <a:t>• Dataset Size &amp; Support: </a:t>
             </a:r>
             <a:r>
-              <a:rPr sz="2000" b="0">
+              <a:rPr sz="1800" b="0">
                 <a:solidFill>
                   <a:srgbClr val="334155"/>
                 </a:solidFill>
@@ -12111,11 +11565,11 @@
           <a:p>
             <a:pPr>
               <a:spcAft>
-                <a:spcPts val="1400"/>
-              </a:spcAft>
-            </a:pPr>
-            <a:r>
-              <a:rPr sz="2000" b="1">
+                <a:spcPts val="1200"/>
+              </a:spcAft>
+            </a:pPr>
+            <a:r>
+              <a:rPr sz="1800" b="1">
                 <a:solidFill>
                   <a:srgbClr val="0F172A"/>
                 </a:solidFill>
@@ -12124,7 +11578,7 @@
               <a:t>• Training Fleet Size: </a:t>
             </a:r>
             <a:r>
-              <a:rPr sz="2000" b="0">
+              <a:rPr sz="1800" b="0">
                 <a:solidFill>
                   <a:srgbClr val="334155"/>
                 </a:solidFill>
@@ -12136,11 +11590,11 @@
           <a:p>
             <a:pPr>
               <a:spcAft>
-                <a:spcPts val="1400"/>
-              </a:spcAft>
-            </a:pPr>
-            <a:r>
-              <a:rPr sz="2000" b="1">
+                <a:spcPts val="1200"/>
+              </a:spcAft>
+            </a:pPr>
+            <a:r>
+              <a:rPr sz="1800" b="1">
                 <a:solidFill>
                   <a:srgbClr val="0F172A"/>
                 </a:solidFill>
@@ -12149,7 +11603,7 @@
               <a:t>• Testing Fleet Size: </a:t>
             </a:r>
             <a:r>
-              <a:rPr sz="2000" b="0">
+              <a:rPr sz="1800" b="0">
                 <a:solidFill>
                   <a:srgbClr val="334155"/>
                 </a:solidFill>
@@ -12161,11 +11615,11 @@
           <a:p>
             <a:pPr>
               <a:spcAft>
-                <a:spcPts val="1400"/>
-              </a:spcAft>
-            </a:pPr>
-            <a:r>
-              <a:rPr sz="2000" b="1">
+                <a:spcPts val="1200"/>
+              </a:spcAft>
+            </a:pPr>
+            <a:r>
+              <a:rPr sz="1800" b="1">
                 <a:solidFill>
                   <a:srgbClr val="0F172A"/>
                 </a:solidFill>
@@ -12174,7 +11628,7 @@
               <a:t>• Target Classification Windows: </a:t>
             </a:r>
             <a:r>
-              <a:rPr sz="2000" b="0">
+              <a:rPr sz="1800" b="0">
                 <a:solidFill>
                   <a:srgbClr val="334155"/>
                 </a:solidFill>
@@ -12186,11 +11640,11 @@
           <a:p>
             <a:pPr>
               <a:spcAft>
-                <a:spcPts val="1400"/>
-              </a:spcAft>
-            </a:pPr>
-            <a:r>
-              <a:rPr sz="2000" b="1">
+                <a:spcPts val="1200"/>
+              </a:spcAft>
+            </a:pPr>
+            <a:r>
+              <a:rPr sz="1800" b="1">
                 <a:solidFill>
                   <a:srgbClr val="0F172A"/>
                 </a:solidFill>
@@ -12199,7 +11653,7 @@
               <a:t>• Dataset Quality: </a:t>
             </a:r>
             <a:r>
-              <a:rPr sz="2000" b="0">
+              <a:rPr sz="1800" b="0">
                 <a:solidFill>
                   <a:srgbClr val="334155"/>
                 </a:solidFill>
@@ -12237,7 +11691,7 @@
         <p:spPr>
           <a:xfrm>
             <a:off x="548640" y="365760"/>
-            <a:ext cx="8046720" cy="731520"/>
+            <a:ext cx="8046720" cy="640080"/>
           </a:xfrm>
           <a:prstGeom prst="rect">
             <a:avLst/>
@@ -12289,7 +11743,7 @@
             <a:pPr algn="r">
               <a:defRPr sz="1400">
                 <a:solidFill>
-                  <a:srgbClr val="334155"/>
+                  <a:srgbClr val="64748B"/>
                 </a:solidFill>
                 <a:latin typeface="Calibri"/>
               </a:defRPr>
@@ -12308,8 +11762,8 @@
         </p:nvSpPr>
         <p:spPr>
           <a:xfrm>
-            <a:off x="548640" y="1188720"/>
-            <a:ext cx="8046720" cy="4846320"/>
+            <a:off x="548640" y="1097280"/>
+            <a:ext cx="8046720" cy="4754880"/>
           </a:xfrm>
           <a:prstGeom prst="rect">
             <a:avLst/>
@@ -12317,14 +11771,14 @@
           <a:noFill/>
         </p:spPr>
         <p:txBody>
-          <a:bodyPr wrap="square">
+          <a:bodyPr wrap="square" lIns="0" tIns="0" rIns="0" bIns="0">
             <a:spAutoFit/>
           </a:bodyPr>
           <a:lstStyle/>
           <a:p>
             <a:pPr>
               <a:spcAft>
-                <a:spcPts val="1400"/>
+                <a:spcPts val="1200"/>
               </a:spcAft>
               <a:defRPr sz="2000" b="1">
                 <a:solidFill>
@@ -12334,7 +11788,7 @@
               </a:defRPr>
             </a:pPr>
             <a:r>
-              <a:rPr sz="2000" b="1">
+              <a:rPr sz="1800" b="1">
                 <a:solidFill>
                   <a:srgbClr val="0F172A"/>
                 </a:solidFill>
@@ -12343,7 +11797,7 @@
               <a:t>• 1. RUL Regression Model: </a:t>
             </a:r>
             <a:r>
-              <a:rPr sz="2000" b="0">
+              <a:rPr sz="1800" b="0">
                 <a:solidFill>
                   <a:srgbClr val="334155"/>
                 </a:solidFill>
@@ -12407,11 +11861,11 @@
           <a:p>
             <a:pPr>
               <a:spcAft>
-                <a:spcPts val="1400"/>
-              </a:spcAft>
-            </a:pPr>
-            <a:r>
-              <a:rPr sz="2000" b="1">
+                <a:spcPts val="1200"/>
+              </a:spcAft>
+            </a:pPr>
+            <a:r>
+              <a:rPr sz="1800" b="1">
                 <a:solidFill>
                   <a:srgbClr val="0F172A"/>
                 </a:solidFill>
@@ -12420,7 +11874,7 @@
               <a:t>• 2. Binary 30-Cycle Warning Classifier: </a:t>
             </a:r>
             <a:r>
-              <a:rPr sz="2000" b="0">
+              <a:rPr sz="1800" b="0">
                 <a:solidFill>
                   <a:srgbClr val="334155"/>
                 </a:solidFill>
@@ -12432,11 +11886,11 @@
           <a:p>
             <a:pPr>
               <a:spcAft>
-                <a:spcPts val="1400"/>
-              </a:spcAft>
-            </a:pPr>
-            <a:r>
-              <a:rPr sz="2000" b="1">
+                <a:spcPts val="1200"/>
+              </a:spcAft>
+            </a:pPr>
+            <a:r>
+              <a:rPr sz="1800" b="1">
                 <a:solidFill>
                   <a:srgbClr val="0F172A"/>
                 </a:solidFill>
@@ -12445,7 +11899,7 @@
               <a:t>• 3. Multi-Class Neural MLP: </a:t>
             </a:r>
             <a:r>
-              <a:rPr sz="2000" b="0">
+              <a:rPr sz="1800" b="0">
                 <a:solidFill>
                   <a:srgbClr val="334155"/>
                 </a:solidFill>
@@ -12457,11 +11911,11 @@
           <a:p>
             <a:pPr>
               <a:spcAft>
-                <a:spcPts val="1400"/>
-              </a:spcAft>
-            </a:pPr>
-            <a:r>
-              <a:rPr sz="2000" b="1">
+                <a:spcPts val="1200"/>
+              </a:spcAft>
+            </a:pPr>
+            <a:r>
+              <a:rPr sz="1800" b="1">
                 <a:solidFill>
                   <a:srgbClr val="0F172A"/>
                 </a:solidFill>
@@ -12470,7 +11924,7 @@
               <a:t>• Multi-Tier Hazard Classes: </a:t>
             </a:r>
             <a:r>
-              <a:rPr sz="2000" b="0">
+              <a:rPr sz="1800" b="0">
                 <a:solidFill>
                   <a:srgbClr val="334155"/>
                 </a:solidFill>
@@ -12482,11 +11936,11 @@
           <a:p>
             <a:pPr>
               <a:spcAft>
-                <a:spcPts val="1400"/>
-              </a:spcAft>
-            </a:pPr>
-            <a:r>
-              <a:rPr sz="2000" b="1">
+                <a:spcPts val="1200"/>
+              </a:spcAft>
+            </a:pPr>
+            <a:r>
+              <a:rPr sz="1800" b="1">
                 <a:solidFill>
                   <a:srgbClr val="0F172A"/>
                 </a:solidFill>
@@ -12495,7 +11949,7 @@
               <a:t>• Softmax Risk Output: </a:t>
             </a:r>
             <a:r>
-              <a:rPr sz="2000" b="0">
+              <a:rPr sz="1800" b="0">
                 <a:solidFill>
                   <a:srgbClr val="334155"/>
                 </a:solidFill>

</xml_diff>

<commit_message>
Fix Slide 1 text overlap and Slide 6 vertical flowchart aspect ratio matching Image 4
</commit_message>
<xml_diff>
--- a/Internship Presentation PPTs Template Final.pptx
+++ b/Internship Presentation PPTs Template Final.pptx
@@ -5476,8 +5476,8 @@
         </p:nvSpPr>
         <p:spPr>
           <a:xfrm>
-            <a:off x="2667000" y="2057400"/>
-            <a:ext cx="3733800" cy="646113"/>
+            <a:off x="2286000" y="1691640"/>
+            <a:ext cx="4389120" cy="822960"/>
           </a:xfrm>
           <a:prstGeom prst="rect">
             <a:avLst/>
@@ -5488,20 +5488,20 @@
           </a:ln>
         </p:spPr>
         <p:txBody>
-          <a:bodyPr>
+          <a:bodyPr wrap="square" tIns="0" bIns="0" lIns="0" rIns="0">
             <a:spAutoFit/>
           </a:bodyPr>
           <a:lstStyle/>
           <a:p>
             <a:pPr algn="ctr"/>
             <a:r>
-              <a:rPr lang="en-US" altLang="x-none" b="1" dirty="0">
-                <a:solidFill>
-                  <a:schemeClr val="tx1"/>
-                </a:solidFill>
-                <a:latin typeface="Arial" panose="020B0604020202020204" pitchFamily="34" charset="0"/>
-              </a:rPr>
-              <a:t>On</a:t>
+              <a:rPr sz="2000" b="1">
+                <a:solidFill>
+                  <a:srgbClr val="0F172A"/>
+                </a:solidFill>
+                <a:latin typeface="Calibri"/>
+              </a:rPr>
+              <a:t>On Predictive Maintenance for Jet Engines Using Machine Learning</a:t>
             </a:r>
           </a:p>
           <a:p>
@@ -5515,9 +5515,12 @@
             </a:pPr>
             <a:r>
               <a:rPr sz="2000" b="1">
-                <a:latin typeface="Times New Roman"/>
-              </a:rPr>
-              <a:t>Predictive Maintenance for Jet Engines Using Machine Learning</a:t>
+                <a:solidFill>
+                  <a:srgbClr val="0F172A"/>
+                </a:solidFill>
+                <a:latin typeface="Calibri"/>
+              </a:rPr>
+              <a:t>On Predictive Maintenance for Jet Engines Using Machine Learning</a:t>
             </a:r>
           </a:p>
         </p:txBody>
@@ -5628,7 +5631,7 @@
         </p:nvSpPr>
         <p:spPr>
           <a:xfrm>
-            <a:off x="548640" y="1097280"/>
+            <a:off x="548640" y="1143000"/>
             <a:ext cx="8046720" cy="4754880"/>
           </a:xfrm>
           <a:prstGeom prst="rect">
@@ -5644,7 +5647,7 @@
           <a:p>
             <a:pPr>
               <a:spcAft>
-                <a:spcPts val="1200"/>
+                <a:spcPts val="1000"/>
               </a:spcAft>
               <a:defRPr sz="2000" b="1">
                 <a:solidFill>
@@ -5727,7 +5730,7 @@
           <a:p>
             <a:pPr>
               <a:spcAft>
-                <a:spcPts val="1200"/>
+                <a:spcPts val="1000"/>
               </a:spcAft>
             </a:pPr>
             <a:r>
@@ -5752,7 +5755,7 @@
           <a:p>
             <a:pPr>
               <a:spcAft>
-                <a:spcPts val="1200"/>
+                <a:spcPts val="1000"/>
               </a:spcAft>
             </a:pPr>
             <a:r>
@@ -5777,7 +5780,7 @@
           <a:p>
             <a:pPr>
               <a:spcAft>
-                <a:spcPts val="1200"/>
+                <a:spcPts val="1000"/>
               </a:spcAft>
             </a:pPr>
             <a:r>
@@ -5802,7 +5805,7 @@
           <a:p>
             <a:pPr>
               <a:spcAft>
-                <a:spcPts val="1200"/>
+                <a:spcPts val="1000"/>
               </a:spcAft>
             </a:pPr>
             <a:r>
@@ -5924,7 +5927,7 @@
         </p:nvSpPr>
         <p:spPr>
           <a:xfrm>
-            <a:off x="548640" y="1097280"/>
+            <a:off x="548640" y="1143000"/>
             <a:ext cx="8046720" cy="4754880"/>
           </a:xfrm>
           <a:prstGeom prst="rect">
@@ -5940,7 +5943,7 @@
           <a:p>
             <a:pPr>
               <a:spcAft>
-                <a:spcPts val="1200"/>
+                <a:spcPts val="1000"/>
               </a:spcAft>
               <a:defRPr sz="2000" b="1">
                 <a:solidFill>
@@ -6023,7 +6026,7 @@
           <a:p>
             <a:pPr>
               <a:spcAft>
-                <a:spcPts val="1200"/>
+                <a:spcPts val="1000"/>
               </a:spcAft>
             </a:pPr>
             <a:r>
@@ -6048,7 +6051,7 @@
           <a:p>
             <a:pPr>
               <a:spcAft>
-                <a:spcPts val="1200"/>
+                <a:spcPts val="1000"/>
               </a:spcAft>
             </a:pPr>
             <a:r>
@@ -6073,7 +6076,7 @@
           <a:p>
             <a:pPr>
               <a:spcAft>
-                <a:spcPts val="1200"/>
+                <a:spcPts val="1000"/>
               </a:spcAft>
             </a:pPr>
             <a:r>
@@ -6098,7 +6101,7 @@
           <a:p>
             <a:pPr>
               <a:spcAft>
-                <a:spcPts val="1200"/>
+                <a:spcPts val="1000"/>
               </a:spcAft>
             </a:pPr>
             <a:r>
@@ -6220,7 +6223,7 @@
         </p:nvSpPr>
         <p:spPr>
           <a:xfrm>
-            <a:off x="548640" y="1097280"/>
+            <a:off x="548640" y="1143000"/>
             <a:ext cx="8046720" cy="4754880"/>
           </a:xfrm>
           <a:prstGeom prst="rect">
@@ -6236,7 +6239,7 @@
           <a:p>
             <a:pPr>
               <a:spcAft>
-                <a:spcPts val="1200"/>
+                <a:spcPts val="1000"/>
               </a:spcAft>
               <a:defRPr sz="2000" b="1">
                 <a:solidFill>
@@ -6319,7 +6322,7 @@
           <a:p>
             <a:pPr>
               <a:spcAft>
-                <a:spcPts val="1200"/>
+                <a:spcPts val="1000"/>
               </a:spcAft>
             </a:pPr>
             <a:r>
@@ -6344,7 +6347,7 @@
           <a:p>
             <a:pPr>
               <a:spcAft>
-                <a:spcPts val="1200"/>
+                <a:spcPts val="1000"/>
               </a:spcAft>
             </a:pPr>
             <a:r>
@@ -6369,7 +6372,7 @@
           <a:p>
             <a:pPr>
               <a:spcAft>
-                <a:spcPts val="1200"/>
+                <a:spcPts val="1000"/>
               </a:spcAft>
             </a:pPr>
             <a:r>
@@ -6394,7 +6397,7 @@
           <a:p>
             <a:pPr>
               <a:spcAft>
-                <a:spcPts val="1200"/>
+                <a:spcPts val="1000"/>
               </a:spcAft>
             </a:pPr>
             <a:r>
@@ -8257,7 +8260,7 @@
         </p:nvSpPr>
         <p:spPr>
           <a:xfrm>
-            <a:off x="548640" y="1097280"/>
+            <a:off x="548640" y="1143000"/>
             <a:ext cx="8046720" cy="4754880"/>
           </a:xfrm>
           <a:prstGeom prst="rect">
@@ -8273,7 +8276,7 @@
           <a:p>
             <a:pPr>
               <a:spcAft>
-                <a:spcPts val="1200"/>
+                <a:spcPts val="1000"/>
               </a:spcAft>
               <a:defRPr sz="2000" b="1">
                 <a:solidFill>
@@ -8356,7 +8359,7 @@
           <a:p>
             <a:pPr>
               <a:spcAft>
-                <a:spcPts val="1200"/>
+                <a:spcPts val="1000"/>
               </a:spcAft>
             </a:pPr>
             <a:r>
@@ -8381,7 +8384,7 @@
           <a:p>
             <a:pPr>
               <a:spcAft>
-                <a:spcPts val="1200"/>
+                <a:spcPts val="1000"/>
               </a:spcAft>
             </a:pPr>
             <a:r>
@@ -8406,7 +8409,7 @@
           <a:p>
             <a:pPr>
               <a:spcAft>
-                <a:spcPts val="1200"/>
+                <a:spcPts val="1000"/>
               </a:spcAft>
             </a:pPr>
             <a:r>
@@ -8431,7 +8434,7 @@
           <a:p>
             <a:pPr>
               <a:spcAft>
-                <a:spcPts val="1200"/>
+                <a:spcPts val="1000"/>
               </a:spcAft>
             </a:pPr>
             <a:r>
@@ -8553,7 +8556,7 @@
         </p:nvSpPr>
         <p:spPr>
           <a:xfrm>
-            <a:off x="548640" y="1097280"/>
+            <a:off x="548640" y="1143000"/>
             <a:ext cx="8046720" cy="4754880"/>
           </a:xfrm>
           <a:prstGeom prst="rect">
@@ -8569,7 +8572,7 @@
           <a:p>
             <a:pPr>
               <a:spcAft>
-                <a:spcPts val="1200"/>
+                <a:spcPts val="1000"/>
               </a:spcAft>
               <a:defRPr sz="2000" b="1">
                 <a:solidFill>
@@ -8652,7 +8655,7 @@
           <a:p>
             <a:pPr>
               <a:spcAft>
-                <a:spcPts val="1200"/>
+                <a:spcPts val="1000"/>
               </a:spcAft>
             </a:pPr>
             <a:r>
@@ -8677,7 +8680,7 @@
           <a:p>
             <a:pPr>
               <a:spcAft>
-                <a:spcPts val="1200"/>
+                <a:spcPts val="1000"/>
               </a:spcAft>
             </a:pPr>
             <a:r>
@@ -8702,7 +8705,7 @@
           <a:p>
             <a:pPr>
               <a:spcAft>
-                <a:spcPts val="1200"/>
+                <a:spcPts val="1000"/>
               </a:spcAft>
             </a:pPr>
             <a:r>
@@ -8727,7 +8730,7 @@
           <a:p>
             <a:pPr>
               <a:spcAft>
-                <a:spcPts val="1200"/>
+                <a:spcPts val="1000"/>
               </a:spcAft>
             </a:pPr>
             <a:r>
@@ -8849,7 +8852,7 @@
         </p:nvSpPr>
         <p:spPr>
           <a:xfrm>
-            <a:off x="548640" y="1097280"/>
+            <a:off x="548640" y="1143000"/>
             <a:ext cx="8046720" cy="4754880"/>
           </a:xfrm>
           <a:prstGeom prst="rect">
@@ -8865,7 +8868,7 @@
           <a:p>
             <a:pPr>
               <a:spcAft>
-                <a:spcPts val="1200"/>
+                <a:spcPts val="1000"/>
               </a:spcAft>
               <a:defRPr sz="2000" b="1">
                 <a:solidFill>
@@ -8948,7 +8951,7 @@
           <a:p>
             <a:pPr>
               <a:spcAft>
-                <a:spcPts val="1200"/>
+                <a:spcPts val="1000"/>
               </a:spcAft>
             </a:pPr>
             <a:r>
@@ -8973,7 +8976,7 @@
           <a:p>
             <a:pPr>
               <a:spcAft>
-                <a:spcPts val="1200"/>
+                <a:spcPts val="1000"/>
               </a:spcAft>
             </a:pPr>
             <a:r>
@@ -8998,7 +9001,7 @@
           <a:p>
             <a:pPr>
               <a:spcAft>
-                <a:spcPts val="1200"/>
+                <a:spcPts val="1000"/>
               </a:spcAft>
             </a:pPr>
             <a:r>
@@ -9023,7 +9026,7 @@
           <a:p>
             <a:pPr>
               <a:spcAft>
-                <a:spcPts val="1200"/>
+                <a:spcPts val="1000"/>
               </a:spcAft>
             </a:pPr>
             <a:r>
@@ -9145,7 +9148,7 @@
         </p:nvSpPr>
         <p:spPr>
           <a:xfrm>
-            <a:off x="548640" y="1097280"/>
+            <a:off x="548640" y="1143000"/>
             <a:ext cx="8046720" cy="4754880"/>
           </a:xfrm>
           <a:prstGeom prst="rect">
@@ -9559,7 +9562,7 @@
         </p:nvSpPr>
         <p:spPr>
           <a:xfrm>
-            <a:off x="548640" y="1097280"/>
+            <a:off x="548640" y="1143000"/>
             <a:ext cx="8046720" cy="4754880"/>
           </a:xfrm>
           <a:prstGeom prst="rect">
@@ -10020,7 +10023,7 @@
         </p:nvSpPr>
         <p:spPr>
           <a:xfrm>
-            <a:off x="548640" y="1097280"/>
+            <a:off x="548640" y="1143000"/>
             <a:ext cx="8046720" cy="4754880"/>
           </a:xfrm>
           <a:prstGeom prst="rect">
@@ -10036,7 +10039,7 @@
           <a:p>
             <a:pPr>
               <a:spcAft>
-                <a:spcPts val="1200"/>
+                <a:spcPts val="1000"/>
               </a:spcAft>
               <a:defRPr sz="2000" b="1">
                 <a:solidFill>
@@ -10119,7 +10122,7 @@
           <a:p>
             <a:pPr>
               <a:spcAft>
-                <a:spcPts val="1200"/>
+                <a:spcPts val="1000"/>
               </a:spcAft>
             </a:pPr>
             <a:r>
@@ -10144,7 +10147,7 @@
           <a:p>
             <a:pPr>
               <a:spcAft>
-                <a:spcPts val="1200"/>
+                <a:spcPts val="1000"/>
               </a:spcAft>
             </a:pPr>
             <a:r>
@@ -10169,7 +10172,7 @@
           <a:p>
             <a:pPr>
               <a:spcAft>
-                <a:spcPts val="1200"/>
+                <a:spcPts val="1000"/>
               </a:spcAft>
             </a:pPr>
             <a:r>
@@ -10194,7 +10197,7 @@
           <a:p>
             <a:pPr>
               <a:spcAft>
-                <a:spcPts val="1200"/>
+                <a:spcPts val="1000"/>
               </a:spcAft>
             </a:pPr>
             <a:r>
@@ -10316,7 +10319,7 @@
         </p:nvSpPr>
         <p:spPr>
           <a:xfrm>
-            <a:off x="548640" y="1097280"/>
+            <a:off x="548640" y="1143000"/>
             <a:ext cx="8046720" cy="4754880"/>
           </a:xfrm>
           <a:prstGeom prst="rect">
@@ -10332,7 +10335,7 @@
           <a:p>
             <a:pPr>
               <a:spcAft>
-                <a:spcPts val="1200"/>
+                <a:spcPts val="1000"/>
               </a:spcAft>
               <a:defRPr sz="2000" b="1">
                 <a:solidFill>
@@ -10415,7 +10418,7 @@
           <a:p>
             <a:pPr>
               <a:spcAft>
-                <a:spcPts val="1200"/>
+                <a:spcPts val="1000"/>
               </a:spcAft>
             </a:pPr>
             <a:r>
@@ -10440,7 +10443,7 @@
           <a:p>
             <a:pPr>
               <a:spcAft>
-                <a:spcPts val="1200"/>
+                <a:spcPts val="1000"/>
               </a:spcAft>
             </a:pPr>
             <a:r>
@@ -10465,7 +10468,7 @@
           <a:p>
             <a:pPr>
               <a:spcAft>
-                <a:spcPts val="1200"/>
+                <a:spcPts val="1000"/>
               </a:spcAft>
             </a:pPr>
             <a:r>
@@ -10490,7 +10493,7 @@
           <a:p>
             <a:pPr>
               <a:spcAft>
-                <a:spcPts val="1200"/>
+                <a:spcPts val="1000"/>
               </a:spcAft>
             </a:pPr>
             <a:r>
@@ -10612,7 +10615,7 @@
         </p:nvSpPr>
         <p:spPr>
           <a:xfrm>
-            <a:off x="548640" y="1097280"/>
+            <a:off x="548640" y="1143000"/>
             <a:ext cx="8046720" cy="4754880"/>
           </a:xfrm>
           <a:prstGeom prst="rect">
@@ -10628,7 +10631,7 @@
           <a:p>
             <a:pPr>
               <a:spcAft>
-                <a:spcPts val="1200"/>
+                <a:spcPts val="1000"/>
               </a:spcAft>
               <a:defRPr sz="2000" b="1">
                 <a:solidFill>
@@ -10711,7 +10714,7 @@
           <a:p>
             <a:pPr>
               <a:spcAft>
-                <a:spcPts val="1200"/>
+                <a:spcPts val="1000"/>
               </a:spcAft>
             </a:pPr>
             <a:r>
@@ -10736,7 +10739,7 @@
           <a:p>
             <a:pPr>
               <a:spcAft>
-                <a:spcPts val="1200"/>
+                <a:spcPts val="1000"/>
               </a:spcAft>
             </a:pPr>
             <a:r>
@@ -10761,7 +10764,7 @@
           <a:p>
             <a:pPr>
               <a:spcAft>
-                <a:spcPts val="1200"/>
+                <a:spcPts val="1000"/>
               </a:spcAft>
             </a:pPr>
             <a:r>
@@ -10786,7 +10789,7 @@
           <a:p>
             <a:pPr>
               <a:spcAft>
-                <a:spcPts val="1200"/>
+                <a:spcPts val="1000"/>
               </a:spcAft>
             </a:pPr>
             <a:r>
@@ -10909,7 +10912,7 @@
         <p:spPr>
           <a:xfrm>
             <a:off x="548640" y="1097280"/>
-            <a:ext cx="4114800" cy="4754880"/>
+            <a:ext cx="3657600" cy="4754880"/>
           </a:xfrm>
           <a:prstGeom prst="rect">
             <a:avLst/>
@@ -10924,11 +10927,11 @@
           <a:p>
             <a:pPr>
               <a:spcAft>
-                <a:spcPts val="1000"/>
-              </a:spcAft>
-            </a:pPr>
-            <a:r>
-              <a:rPr sz="1600" b="1">
+                <a:spcPts val="800"/>
+              </a:spcAft>
+            </a:pPr>
+            <a:r>
+              <a:rPr sz="1500" b="1">
                 <a:solidFill>
                   <a:srgbClr val="0F172A"/>
                 </a:solidFill>
@@ -10937,57 +10940,57 @@
               <a:t>• Stage 1 Ingestion: </a:t>
             </a:r>
             <a:r>
-              <a:rPr sz="1600" b="0">
+              <a:rPr sz="1500" b="0">
                 <a:solidFill>
                   <a:srgbClr val="334155"/>
                 </a:solidFill>
                 <a:latin typeface="Calibri"/>
               </a:rPr>
-              <a:t>NASA C-MAPSS telemetry dataset with 21 sensors &amp; 3 operational settings.</a:t>
-            </a:r>
-          </a:p>
-          <a:p>
-            <a:pPr>
-              <a:spcAft>
-                <a:spcPts val="1000"/>
-              </a:spcAft>
-            </a:pPr>
-            <a:r>
-              <a:rPr sz="1600" b="1">
-                <a:solidFill>
-                  <a:srgbClr val="0F172A"/>
-                </a:solidFill>
-                <a:latin typeface="Calibri"/>
-              </a:rPr>
-              <a:t>• Stage 2 Signal Processing: </a:t>
-            </a:r>
-            <a:r>
-              <a:rPr sz="1600" b="0">
+              <a:t>NASA C-MAPSS telemetry dataset with 21 sensors &amp; 3 settings.</a:t>
+            </a:r>
+          </a:p>
+          <a:p>
+            <a:pPr>
+              <a:spcAft>
+                <a:spcPts val="800"/>
+              </a:spcAft>
+            </a:pPr>
+            <a:r>
+              <a:rPr sz="1500" b="1">
+                <a:solidFill>
+                  <a:srgbClr val="0F172A"/>
+                </a:solidFill>
+                <a:latin typeface="Calibri"/>
+              </a:rPr>
+              <a:t>• Stage 2 Preprocessing: </a:t>
+            </a:r>
+            <a:r>
+              <a:rPr sz="1500" b="0">
                 <a:solidFill>
                   <a:srgbClr val="334155"/>
                 </a:solidFill>
                 <a:latin typeface="Calibri"/>
               </a:rPr>
-              <a:t>5-cycle rolling mean and standard deviation feature aggregations.</a:t>
-            </a:r>
-          </a:p>
-          <a:p>
-            <a:pPr>
-              <a:spcAft>
-                <a:spcPts val="1000"/>
-              </a:spcAft>
-            </a:pPr>
-            <a:r>
-              <a:rPr sz="1600" b="1">
-                <a:solidFill>
-                  <a:srgbClr val="0F172A"/>
-                </a:solidFill>
-                <a:latin typeface="Calibri"/>
-              </a:rPr>
-              <a:t>• Stage 3 Correlation Filter: </a:t>
-            </a:r>
-            <a:r>
-              <a:rPr sz="1600" b="0">
+              <a:t>5-cycle rolling mean &amp; standard deviation aggregations.</a:t>
+            </a:r>
+          </a:p>
+          <a:p>
+            <a:pPr>
+              <a:spcAft>
+                <a:spcPts val="800"/>
+              </a:spcAft>
+            </a:pPr>
+            <a:r>
+              <a:rPr sz="1500" b="1">
+                <a:solidFill>
+                  <a:srgbClr val="0F172A"/>
+                </a:solidFill>
+                <a:latin typeface="Calibri"/>
+              </a:rPr>
+              <a:t>• Stage 3 Filter: </a:t>
+            </a:r>
+            <a:r>
+              <a:rPr sz="1500" b="0">
                 <a:solidFill>
                   <a:srgbClr val="334155"/>
                 </a:solidFill>
@@ -10999,11 +11002,11 @@
           <a:p>
             <a:pPr>
               <a:spcAft>
-                <a:spcPts val="1000"/>
-              </a:spcAft>
-            </a:pPr>
-            <a:r>
-              <a:rPr sz="1600" b="1">
+                <a:spcPts val="800"/>
+              </a:spcAft>
+            </a:pPr>
+            <a:r>
+              <a:rPr sz="1500" b="1">
                 <a:solidFill>
                   <a:srgbClr val="0F172A"/>
                 </a:solidFill>
@@ -11012,7 +11015,7 @@
               <a:t>• Stage 4 AI Inference: </a:t>
             </a:r>
             <a:r>
-              <a:rPr sz="1600" b="0">
+              <a:rPr sz="1500" b="0">
                 <a:solidFill>
                   <a:srgbClr val="334155"/>
                 </a:solidFill>
@@ -11024,20 +11027,20 @@
           <a:p>
             <a:pPr>
               <a:spcAft>
-                <a:spcPts val="1000"/>
-              </a:spcAft>
-            </a:pPr>
-            <a:r>
-              <a:rPr sz="1600" b="1">
-                <a:solidFill>
-                  <a:srgbClr val="0F172A"/>
-                </a:solidFill>
-                <a:latin typeface="Calibri"/>
-              </a:rPr>
-              <a:t>• Stage 5 Actionable Dispatch: </a:t>
-            </a:r>
-            <a:r>
-              <a:rPr sz="1600" b="0">
+                <a:spcPts val="800"/>
+              </a:spcAft>
+            </a:pPr>
+            <a:r>
+              <a:rPr sz="1500" b="1">
+                <a:solidFill>
+                  <a:srgbClr val="0F172A"/>
+                </a:solidFill>
+                <a:latin typeface="Calibri"/>
+              </a:rPr>
+              <a:t>• Stage 5 Actionable Report: </a:t>
+            </a:r>
+            <a:r>
+              <a:rPr sz="1500" b="0">
                 <a:solidFill>
                   <a:srgbClr val="334155"/>
                 </a:solidFill>
@@ -11050,7 +11053,7 @@
       </p:sp>
       <p:pic>
         <p:nvPicPr>
-          <p:cNvPr id="5" name="Picture 4" descr="vertical_flowchart_image.png"/>
+          <p:cNvPr id="5" name="Picture 4" descr="vertical_flowchart_v2.png"/>
           <p:cNvPicPr>
             <a:picLocks noChangeAspect="1"/>
           </p:cNvPicPr>
@@ -11064,8 +11067,8 @@
         </p:blipFill>
         <p:spPr>
           <a:xfrm>
-            <a:off x="4937760" y="1097280"/>
-            <a:ext cx="3657600" cy="5247861"/>
+            <a:off x="4389120" y="1005840"/>
+            <a:ext cx="4389120" cy="5303520"/>
           </a:xfrm>
           <a:prstGeom prst="rect">
             <a:avLst/>
@@ -11170,7 +11173,7 @@
         </p:nvSpPr>
         <p:spPr>
           <a:xfrm>
-            <a:off x="548640" y="1097280"/>
+            <a:off x="548640" y="1143000"/>
             <a:ext cx="8046720" cy="4754880"/>
           </a:xfrm>
           <a:prstGeom prst="rect">
@@ -11186,7 +11189,7 @@
           <a:p>
             <a:pPr>
               <a:spcAft>
-                <a:spcPts val="1200"/>
+                <a:spcPts val="1000"/>
               </a:spcAft>
               <a:defRPr sz="2000" b="1">
                 <a:solidFill>
@@ -11269,7 +11272,7 @@
           <a:p>
             <a:pPr>
               <a:spcAft>
-                <a:spcPts val="1200"/>
+                <a:spcPts val="1000"/>
               </a:spcAft>
             </a:pPr>
             <a:r>
@@ -11294,7 +11297,7 @@
           <a:p>
             <a:pPr>
               <a:spcAft>
-                <a:spcPts val="1200"/>
+                <a:spcPts val="1000"/>
               </a:spcAft>
             </a:pPr>
             <a:r>
@@ -11319,7 +11322,7 @@
           <a:p>
             <a:pPr>
               <a:spcAft>
-                <a:spcPts val="1200"/>
+                <a:spcPts val="1000"/>
               </a:spcAft>
             </a:pPr>
             <a:r>
@@ -11344,7 +11347,7 @@
           <a:p>
             <a:pPr>
               <a:spcAft>
-                <a:spcPts val="1200"/>
+                <a:spcPts val="1000"/>
               </a:spcAft>
             </a:pPr>
             <a:r>
@@ -11466,7 +11469,7 @@
         </p:nvSpPr>
         <p:spPr>
           <a:xfrm>
-            <a:off x="548640" y="1097280"/>
+            <a:off x="548640" y="1143000"/>
             <a:ext cx="8046720" cy="4754880"/>
           </a:xfrm>
           <a:prstGeom prst="rect">
@@ -11482,7 +11485,7 @@
           <a:p>
             <a:pPr>
               <a:spcAft>
-                <a:spcPts val="1200"/>
+                <a:spcPts val="1000"/>
               </a:spcAft>
               <a:defRPr sz="2000" b="1">
                 <a:solidFill>
@@ -11565,7 +11568,7 @@
           <a:p>
             <a:pPr>
               <a:spcAft>
-                <a:spcPts val="1200"/>
+                <a:spcPts val="1000"/>
               </a:spcAft>
             </a:pPr>
             <a:r>
@@ -11590,7 +11593,7 @@
           <a:p>
             <a:pPr>
               <a:spcAft>
-                <a:spcPts val="1200"/>
+                <a:spcPts val="1000"/>
               </a:spcAft>
             </a:pPr>
             <a:r>
@@ -11615,7 +11618,7 @@
           <a:p>
             <a:pPr>
               <a:spcAft>
-                <a:spcPts val="1200"/>
+                <a:spcPts val="1000"/>
               </a:spcAft>
             </a:pPr>
             <a:r>
@@ -11640,7 +11643,7 @@
           <a:p>
             <a:pPr>
               <a:spcAft>
-                <a:spcPts val="1200"/>
+                <a:spcPts val="1000"/>
               </a:spcAft>
             </a:pPr>
             <a:r>
@@ -11762,7 +11765,7 @@
         </p:nvSpPr>
         <p:spPr>
           <a:xfrm>
-            <a:off x="548640" y="1097280"/>
+            <a:off x="548640" y="1143000"/>
             <a:ext cx="8046720" cy="4754880"/>
           </a:xfrm>
           <a:prstGeom prst="rect">
@@ -11778,7 +11781,7 @@
           <a:p>
             <a:pPr>
               <a:spcAft>
-                <a:spcPts val="1200"/>
+                <a:spcPts val="1000"/>
               </a:spcAft>
               <a:defRPr sz="2000" b="1">
                 <a:solidFill>
@@ -11861,7 +11864,7 @@
           <a:p>
             <a:pPr>
               <a:spcAft>
-                <a:spcPts val="1200"/>
+                <a:spcPts val="1000"/>
               </a:spcAft>
             </a:pPr>
             <a:r>
@@ -11886,7 +11889,7 @@
           <a:p>
             <a:pPr>
               <a:spcAft>
-                <a:spcPts val="1200"/>
+                <a:spcPts val="1000"/>
               </a:spcAft>
             </a:pPr>
             <a:r>
@@ -11911,7 +11914,7 @@
           <a:p>
             <a:pPr>
               <a:spcAft>
-                <a:spcPts val="1200"/>
+                <a:spcPts val="1000"/>
               </a:spcAft>
             </a:pPr>
             <a:r>
@@ -11936,7 +11939,7 @@
           <a:p>
             <a:pPr>
               <a:spcAft>
-                <a:spcPts val="1200"/>
+                <a:spcPts val="1000"/>
               </a:spcAft>
             </a:pPr>
             <a:r>

</xml_diff>

<commit_message>
Re-format presentation to ultra-clean Fortune 500 standard with 60%+ whitespace and max 10 words per bullet
</commit_message>
<xml_diff>
--- a/Internship Presentation PPTs Template Final.pptx
+++ b/Internship Presentation PPTs Template Final.pptx
@@ -5559,7 +5559,7 @@
         </p:nvSpPr>
         <p:spPr>
           <a:xfrm>
-            <a:off x="548640" y="365760"/>
+            <a:off x="548640" y="457200"/>
             <a:ext cx="8046720" cy="685800"/>
           </a:xfrm>
           <a:prstGeom prst="rect">
@@ -5574,7 +5574,7 @@
           <a:lstStyle/>
           <a:p>
             <a:pPr>
-              <a:defRPr sz="3400" b="1">
+              <a:defRPr sz="3600" b="1">
                 <a:solidFill>
                   <a:srgbClr val="0F172A"/>
                 </a:solidFill>
@@ -5582,7 +5582,7 @@
               </a:defRPr>
             </a:pPr>
             <a:r>
-              <a:t>Interactive Terminal Diagnostic Engine (predict.py)</a:t>
+              <a:t>Terminal Diagnostic Engine</a:t>
             </a:r>
           </a:p>
         </p:txBody>
@@ -5631,8 +5631,8 @@
         </p:nvSpPr>
         <p:spPr>
           <a:xfrm>
-            <a:off x="548640" y="1143000"/>
-            <a:ext cx="8046720" cy="4800600"/>
+            <a:off x="548640" y="1280160"/>
+            <a:ext cx="8046720" cy="4389120"/>
           </a:xfrm>
           <a:prstGeom prst="rect">
             <a:avLst/>
@@ -5647,7 +5647,7 @@
           <a:p>
             <a:pPr>
               <a:spcAft>
-                <a:spcPts val="1000"/>
+                <a:spcPts val="1400"/>
               </a:spcAft>
               <a:defRPr sz="2000" b="1">
                 <a:solidFill>
@@ -5657,22 +5657,22 @@
               </a:defRPr>
             </a:pPr>
             <a:r>
-              <a:rPr sz="1800" b="1">
+              <a:rPr sz="2000" b="1">
                 <a:solidFill>
                   <a:srgbClr val="2563EB"/>
                 </a:solidFill>
                 <a:latin typeface="Calibri"/>
               </a:rPr>
-              <a:t>• Command-Line Diagnostic Tool: </a:t>
-            </a:r>
-            <a:r>
-              <a:rPr sz="1800" b="0">
+              <a:t>• CLI Diagnostic Tool: </a:t>
+            </a:r>
+            <a:r>
+              <a:rPr sz="2000" b="0">
                 <a:solidFill>
                   <a:srgbClr val="334155"/>
                 </a:solidFill>
                 <a:latin typeface="Calibri"/>
               </a:rPr>
-              <a:t>Built using Python argparse &amp; serialized model pickle files.</a:t>
+              <a:t>Built using argparse and serialized models.</a:t>
             </a:r>
           </a:p>
           <a:p>
@@ -5730,11 +5730,11 @@
           <a:p>
             <a:pPr>
               <a:spcAft>
-                <a:spcPts val="1000"/>
-              </a:spcAft>
-            </a:pPr>
-            <a:r>
-              <a:rPr sz="1800" b="1">
+                <a:spcPts val="1400"/>
+              </a:spcAft>
+            </a:pPr>
+            <a:r>
+              <a:rPr sz="2000" b="1">
                 <a:solidFill>
                   <a:srgbClr val="2563EB"/>
                 </a:solidFill>
@@ -5743,88 +5743,88 @@
               <a:t>• Execution Command: </a:t>
             </a:r>
             <a:r>
-              <a:rPr sz="1800" b="0">
+              <a:rPr sz="2000" b="0">
                 <a:solidFill>
                   <a:srgbClr val="334155"/>
                 </a:solidFill>
                 <a:latin typeface="Calibri"/>
               </a:rPr>
-              <a:t>python predict.py --engine_id 81 (Evaluates any engine from fleet 1-100).</a:t>
-            </a:r>
-          </a:p>
-          <a:p>
-            <a:pPr>
-              <a:spcAft>
-                <a:spcPts val="1000"/>
-              </a:spcAft>
-            </a:pPr>
-            <a:r>
-              <a:rPr sz="1800" b="1">
+              <a:t>python predict.py --engine_id 81</a:t>
+            </a:r>
+          </a:p>
+          <a:p>
+            <a:pPr>
+              <a:spcAft>
+                <a:spcPts val="1400"/>
+              </a:spcAft>
+            </a:pPr>
+            <a:r>
+              <a:rPr sz="2000" b="1">
                 <a:solidFill>
                   <a:srgbClr val="2563EB"/>
                 </a:solidFill>
                 <a:latin typeface="Calibri"/>
               </a:rPr>
-              <a:t>• Diagnostic Output Parameters: </a:t>
-            </a:r>
-            <a:r>
-              <a:rPr sz="1800" b="0">
+              <a:t>• Output Parameters: </a:t>
+            </a:r>
+            <a:r>
+              <a:rPr sz="2000" b="0">
                 <a:solidFill>
                   <a:srgbClr val="334155"/>
                 </a:solidFill>
                 <a:latin typeface="Calibri"/>
               </a:rPr>
-              <a:t>Estimated Remaining RUL, 30-cycle failure probability, risk rating.</a:t>
-            </a:r>
-          </a:p>
-          <a:p>
-            <a:pPr>
-              <a:spcAft>
-                <a:spcPts val="1000"/>
-              </a:spcAft>
-            </a:pPr>
-            <a:r>
-              <a:rPr sz="1800" b="1">
+              <a:t>Estimated RUL, failure probability, and rating.</a:t>
+            </a:r>
+          </a:p>
+          <a:p>
+            <a:pPr>
+              <a:spcAft>
+                <a:spcPts val="1400"/>
+              </a:spcAft>
+            </a:pPr>
+            <a:r>
+              <a:rPr sz="2000" b="1">
                 <a:solidFill>
                   <a:srgbClr val="2563EB"/>
                 </a:solidFill>
                 <a:latin typeface="Calibri"/>
               </a:rPr>
-              <a:t>• Risk Rating Formatting: </a:t>
-            </a:r>
-            <a:r>
-              <a:rPr sz="1800" b="0">
+              <a:t>• Status Formatting: </a:t>
+            </a:r>
+            <a:r>
+              <a:rPr sz="2000" b="0">
                 <a:solidFill>
                   <a:srgbClr val="334155"/>
                 </a:solidFill>
                 <a:latin typeface="Calibri"/>
               </a:rPr>
-              <a:t>Displays GREEN (Healthy), YELLOW (Warning), and RED (Critical) status.</a:t>
-            </a:r>
-          </a:p>
-          <a:p>
-            <a:pPr>
-              <a:spcAft>
-                <a:spcPts val="1000"/>
-              </a:spcAft>
-            </a:pPr>
-            <a:r>
-              <a:rPr sz="1800" b="1">
+              <a:t>Displays GREEN, YELLOW, and RED indicators.</a:t>
+            </a:r>
+          </a:p>
+          <a:p>
+            <a:pPr>
+              <a:spcAft>
+                <a:spcPts val="1400"/>
+              </a:spcAft>
+            </a:pPr>
+            <a:r>
+              <a:rPr sz="2000" b="1">
                 <a:solidFill>
                   <a:srgbClr val="2563EB"/>
                 </a:solidFill>
                 <a:latin typeface="Calibri"/>
               </a:rPr>
-              <a:t>• Actionable Maintenance Recommendation: </a:t>
-            </a:r>
-            <a:r>
-              <a:rPr sz="1800" b="0">
+              <a:t>• Actionable Guidance: </a:t>
+            </a:r>
+            <a:r>
+              <a:rPr sz="2000" b="0">
                 <a:solidFill>
                   <a:srgbClr val="334155"/>
                 </a:solidFill>
                 <a:latin typeface="Calibri"/>
               </a:rPr>
-              <a:t>Instructs fleet managers to ground aircraft or schedule service.</a:t>
+              <a:t>Instructs managers to schedule service or ground.</a:t>
             </a:r>
           </a:p>
         </p:txBody>
@@ -5855,7 +5855,7 @@
         </p:nvSpPr>
         <p:spPr>
           <a:xfrm>
-            <a:off x="548640" y="365760"/>
+            <a:off x="548640" y="457200"/>
             <a:ext cx="8046720" cy="685800"/>
           </a:xfrm>
           <a:prstGeom prst="rect">
@@ -5870,7 +5870,7 @@
           <a:lstStyle/>
           <a:p>
             <a:pPr>
-              <a:defRPr sz="3400" b="1">
+              <a:defRPr sz="3600" b="1">
                 <a:solidFill>
                   <a:srgbClr val="0F172A"/>
                 </a:solidFill>
@@ -5878,7 +5878,7 @@
               </a:defRPr>
             </a:pPr>
             <a:r>
-              <a:t>Fleet Hazard Gating &amp; Alert Dispatch</a:t>
+              <a:t>Fleet Hazard Gating</a:t>
             </a:r>
           </a:p>
         </p:txBody>
@@ -5927,8 +5927,8 @@
         </p:nvSpPr>
         <p:spPr>
           <a:xfrm>
-            <a:off x="548640" y="1143000"/>
-            <a:ext cx="8046720" cy="4800600"/>
+            <a:off x="548640" y="1280160"/>
+            <a:ext cx="8046720" cy="4389120"/>
           </a:xfrm>
           <a:prstGeom prst="rect">
             <a:avLst/>
@@ -5943,7 +5943,7 @@
           <a:p>
             <a:pPr>
               <a:spcAft>
-                <a:spcPts val="1000"/>
+                <a:spcPts val="1400"/>
               </a:spcAft>
               <a:defRPr sz="2000" b="1">
                 <a:solidFill>
@@ -5953,22 +5953,22 @@
               </a:defRPr>
             </a:pPr>
             <a:r>
-              <a:rPr sz="1800" b="1">
+              <a:rPr sz="2000" b="1">
                 <a:solidFill>
                   <a:srgbClr val="2563EB"/>
                 </a:solidFill>
                 <a:latin typeface="Calibri"/>
               </a:rPr>
-              <a:t>• Operational Thresholding: </a:t>
-            </a:r>
-            <a:r>
-              <a:rPr sz="1800" b="0">
+              <a:t>• Healthy State (Green): </a:t>
+            </a:r>
+            <a:r>
+              <a:rPr sz="2000" b="0">
                 <a:solidFill>
                   <a:srgbClr val="334155"/>
                 </a:solidFill>
                 <a:latin typeface="Calibri"/>
               </a:rPr>
-              <a:t>Categorizes engine hazard state into 3 distinct operational buckets.</a:t>
+              <a:t>RUL &gt; 30 cycles; normal flight service.</a:t>
             </a:r>
           </a:p>
           <a:p>
@@ -6026,101 +6026,101 @@
           <a:p>
             <a:pPr>
               <a:spcAft>
-                <a:spcPts val="1000"/>
-              </a:spcAft>
-            </a:pPr>
-            <a:r>
-              <a:rPr sz="1800" b="1">
+                <a:spcPts val="1400"/>
+              </a:spcAft>
+            </a:pPr>
+            <a:r>
+              <a:rPr sz="2000" b="1">
                 <a:solidFill>
                   <a:srgbClr val="2563EB"/>
                 </a:solidFill>
                 <a:latin typeface="Calibri"/>
               </a:rPr>
-              <a:t>• Healthy State (Green): </a:t>
-            </a:r>
-            <a:r>
-              <a:rPr sz="1800" b="0">
+              <a:t>• Warning State (Yellow): </a:t>
+            </a:r>
+            <a:r>
+              <a:rPr sz="2000" b="0">
                 <a:solidFill>
                   <a:srgbClr val="334155"/>
                 </a:solidFill>
                 <a:latin typeface="Calibri"/>
               </a:rPr>
-              <a:t>RUL &gt; 30 cycles; engine remains in normal operational flight status.</a:t>
-            </a:r>
-          </a:p>
-          <a:p>
-            <a:pPr>
-              <a:spcAft>
-                <a:spcPts val="1000"/>
-              </a:spcAft>
-            </a:pPr>
-            <a:r>
-              <a:rPr sz="1800" b="1">
+              <a:t>15 &lt; RUL &lt;= 30 cycles; schedule service.</a:t>
+            </a:r>
+          </a:p>
+          <a:p>
+            <a:pPr>
+              <a:spcAft>
+                <a:spcPts val="1400"/>
+              </a:spcAft>
+            </a:pPr>
+            <a:r>
+              <a:rPr sz="2000" b="1">
                 <a:solidFill>
                   <a:srgbClr val="2563EB"/>
                 </a:solidFill>
                 <a:latin typeface="Calibri"/>
               </a:rPr>
-              <a:t>• Warning Window (Yellow): </a:t>
-            </a:r>
-            <a:r>
-              <a:rPr sz="1800" b="0">
+              <a:t>• Critical Action (Red): </a:t>
+            </a:r>
+            <a:r>
+              <a:rPr sz="2000" b="0">
                 <a:solidFill>
                   <a:srgbClr val="334155"/>
                 </a:solidFill>
                 <a:latin typeface="Calibri"/>
               </a:rPr>
-              <a:t>15 &lt; RUL &lt;= 30 cycles; schedule preventive maintenance within 5 cycles.</a:t>
-            </a:r>
-          </a:p>
-          <a:p>
-            <a:pPr>
-              <a:spcAft>
-                <a:spcPts val="1000"/>
-              </a:spcAft>
-            </a:pPr>
-            <a:r>
-              <a:rPr sz="1800" b="1">
+              <a:t>RUL &lt;= 15 cycles; ground engine within 24h.</a:t>
+            </a:r>
+          </a:p>
+          <a:p>
+            <a:pPr>
+              <a:spcAft>
+                <a:spcPts val="1400"/>
+              </a:spcAft>
+            </a:pPr>
+            <a:r>
+              <a:rPr sz="2000" b="1">
                 <a:solidFill>
                   <a:srgbClr val="2563EB"/>
                 </a:solidFill>
                 <a:latin typeface="Calibri"/>
               </a:rPr>
-              <a:t>• Critical Action (Red): </a:t>
-            </a:r>
-            <a:r>
-              <a:rPr sz="1800" b="0">
+              <a:t>• Low Latency: </a:t>
+            </a:r>
+            <a:r>
+              <a:rPr sz="2000" b="0">
                 <a:solidFill>
                   <a:srgbClr val="334155"/>
                 </a:solidFill>
                 <a:latin typeface="Calibri"/>
               </a:rPr>
-              <a:t>RUL &lt;= 15 cycles; ground aircraft for immediate engine overhaul within 24h.</a:t>
-            </a:r>
-          </a:p>
-          <a:p>
-            <a:pPr>
-              <a:spcAft>
-                <a:spcPts val="1000"/>
-              </a:spcAft>
-            </a:pPr>
-            <a:r>
-              <a:rPr sz="1800" b="1">
+              <a:t>Sub-30ms execution for live diagnostic reports.</a:t>
+            </a:r>
+          </a:p>
+          <a:p>
+            <a:pPr>
+              <a:spcAft>
+                <a:spcPts val="1400"/>
+              </a:spcAft>
+            </a:pPr>
+            <a:r>
+              <a:rPr sz="2000" b="1">
                 <a:solidFill>
                   <a:srgbClr val="2563EB"/>
                 </a:solidFill>
                 <a:latin typeface="Calibri"/>
               </a:rPr>
-              <a:t>• Sub-30ms Inference Latency: </a:t>
-            </a:r>
-            <a:r>
-              <a:rPr sz="1800" b="0">
+              <a:t>• Queue Dispatch: </a:t>
+            </a:r>
+            <a:r>
+              <a:rPr sz="2000" b="0">
                 <a:solidFill>
                   <a:srgbClr val="334155"/>
                 </a:solidFill>
                 <a:latin typeface="Calibri"/>
               </a:rPr>
-              <a:t>Ensures smooth live diagnostic reporting without latency or delay.</a:t>
+              <a:t>Prioritizes maintenance by urgency rank.</a:t>
             </a:r>
           </a:p>
         </p:txBody>
@@ -6151,7 +6151,7 @@
         </p:nvSpPr>
         <p:spPr>
           <a:xfrm>
-            <a:off x="548640" y="365760"/>
+            <a:off x="548640" y="457200"/>
             <a:ext cx="8046720" cy="685800"/>
           </a:xfrm>
           <a:prstGeom prst="rect">
@@ -6166,7 +6166,7 @@
           <a:lstStyle/>
           <a:p>
             <a:pPr>
-              <a:defRPr sz="3400" b="1">
+              <a:defRPr sz="3600" b="1">
                 <a:solidFill>
                   <a:srgbClr val="0F172A"/>
                 </a:solidFill>
@@ -6174,7 +6174,7 @@
               </a:defRPr>
             </a:pPr>
             <a:r>
-              <a:t>Empirical Results &amp; Model Evaluation</a:t>
+              <a:t>Benchmark Results</a:t>
             </a:r>
           </a:p>
         </p:txBody>
@@ -6223,8 +6223,8 @@
         </p:nvSpPr>
         <p:spPr>
           <a:xfrm>
-            <a:off x="548640" y="1143000"/>
-            <a:ext cx="8046720" cy="4800600"/>
+            <a:off x="548640" y="1280160"/>
+            <a:ext cx="8046720" cy="4389120"/>
           </a:xfrm>
           <a:prstGeom prst="rect">
             <a:avLst/>
@@ -6239,7 +6239,7 @@
           <a:p>
             <a:pPr>
               <a:spcAft>
-                <a:spcPts val="1000"/>
+                <a:spcPts val="1400"/>
               </a:spcAft>
               <a:defRPr sz="2000" b="1">
                 <a:solidFill>
@@ -6249,22 +6249,22 @@
               </a:defRPr>
             </a:pPr>
             <a:r>
-              <a:rPr sz="1800" b="1">
+              <a:rPr sz="2000" b="1">
                 <a:solidFill>
                   <a:srgbClr val="2563EB"/>
                 </a:solidFill>
                 <a:latin typeface="Calibri"/>
               </a:rPr>
-              <a:t>• Binary Failure Warning AUC-ROC: </a:t>
-            </a:r>
-            <a:r>
-              <a:rPr sz="1800" b="0">
+              <a:t>• Binary Warning AUC: </a:t>
+            </a:r>
+            <a:r>
+              <a:rPr sz="2000" b="0">
                 <a:solidFill>
                   <a:srgbClr val="334155"/>
                 </a:solidFill>
                 <a:latin typeface="Calibri"/>
               </a:rPr>
-              <a:t>Achieved 98.45% (0.9845) AUC-ROC score on test evaluation set.</a:t>
+              <a:t>Achieved 98.45% AUC-ROC score on test set.</a:t>
             </a:r>
           </a:p>
           <a:p>
@@ -6322,11 +6322,11 @@
           <a:p>
             <a:pPr>
               <a:spcAft>
-                <a:spcPts val="1000"/>
-              </a:spcAft>
-            </a:pPr>
-            <a:r>
-              <a:rPr sz="1800" b="1">
+                <a:spcPts val="1400"/>
+              </a:spcAft>
+            </a:pPr>
+            <a:r>
+              <a:rPr sz="2000" b="1">
                 <a:solidFill>
                   <a:srgbClr val="2563EB"/>
                 </a:solidFill>
@@ -6335,23 +6335,23 @@
               <a:t>• Binary Alert Precision: </a:t>
             </a:r>
             <a:r>
-              <a:rPr sz="1800" b="0">
+              <a:rPr sz="2000" b="0">
                 <a:solidFill>
                   <a:srgbClr val="334155"/>
                 </a:solidFill>
                 <a:latin typeface="Calibri"/>
               </a:rPr>
-              <a:t>Achieved 94.44% Precision on positive failure window warnings.</a:t>
-            </a:r>
-          </a:p>
-          <a:p>
-            <a:pPr>
-              <a:spcAft>
-                <a:spcPts val="1000"/>
-              </a:spcAft>
-            </a:pPr>
-            <a:r>
-              <a:rPr sz="1800" b="1">
+              <a:t>Achieved 94.44% precision on failure alerts.</a:t>
+            </a:r>
+          </a:p>
+          <a:p>
+            <a:pPr>
+              <a:spcAft>
+                <a:spcPts val="1400"/>
+              </a:spcAft>
+            </a:pPr>
+            <a:r>
+              <a:rPr sz="2000" b="1">
                 <a:solidFill>
                   <a:srgbClr val="2563EB"/>
                 </a:solidFill>
@@ -6360,63 +6360,63 @@
               <a:t>• RUL Regression RMSE: </a:t>
             </a:r>
             <a:r>
-              <a:rPr sz="1800" b="0">
+              <a:rPr sz="2000" b="0">
                 <a:solidFill>
                   <a:srgbClr val="334155"/>
                 </a:solidFill>
                 <a:latin typeface="Calibri"/>
               </a:rPr>
-              <a:t>Achieved 33.39 cycles Root Mean Squared Error (MAE: 22.90 cycles).</a:t>
-            </a:r>
-          </a:p>
-          <a:p>
-            <a:pPr>
-              <a:spcAft>
-                <a:spcPts val="1000"/>
-              </a:spcAft>
-            </a:pPr>
-            <a:r>
-              <a:rPr sz="1800" b="1">
+              <a:t>Achieved 33.39 cycles Root Mean Squared Error.</a:t>
+            </a:r>
+          </a:p>
+          <a:p>
+            <a:pPr>
+              <a:spcAft>
+                <a:spcPts val="1400"/>
+              </a:spcAft>
+            </a:pPr>
+            <a:r>
+              <a:rPr sz="2000" b="1">
                 <a:solidFill>
                   <a:srgbClr val="2563EB"/>
                 </a:solidFill>
                 <a:latin typeface="Calibri"/>
               </a:rPr>
-              <a:t>• Multi-Class Neural MLP Accuracy: </a:t>
-            </a:r>
-            <a:r>
-              <a:rPr sz="1800" b="0">
+              <a:t>• Neural MLP Accuracy: </a:t>
+            </a:r>
+            <a:r>
+              <a:rPr sz="2000" b="0">
                 <a:solidFill>
                   <a:srgbClr val="334155"/>
                 </a:solidFill>
                 <a:latin typeface="Calibri"/>
               </a:rPr>
-              <a:t>Achieved 75.00% exact multi-class categorization accuracy.</a:t>
-            </a:r>
-          </a:p>
-          <a:p>
-            <a:pPr>
-              <a:spcAft>
-                <a:spcPts val="1000"/>
-              </a:spcAft>
-            </a:pPr>
-            <a:r>
-              <a:rPr sz="1800" b="1">
+              <a:t>Achieved 75.00% exact hazard rating accuracy.</a:t>
+            </a:r>
+          </a:p>
+          <a:p>
+            <a:pPr>
+              <a:spcAft>
+                <a:spcPts val="1400"/>
+              </a:spcAft>
+            </a:pPr>
+            <a:r>
+              <a:rPr sz="2000" b="1">
                 <a:solidFill>
                   <a:srgbClr val="2563EB"/>
                 </a:solidFill>
                 <a:latin typeface="Calibri"/>
               </a:rPr>
-              <a:t>• Inference Latency: </a:t>
-            </a:r>
-            <a:r>
-              <a:rPr sz="1800" b="0">
+              <a:t>• Inference Speed: </a:t>
+            </a:r>
+            <a:r>
+              <a:rPr sz="2000" b="0">
                 <a:solidFill>
                   <a:srgbClr val="334155"/>
                 </a:solidFill>
                 <a:latin typeface="Calibri"/>
               </a:rPr>
-              <a:t>Average diagnostic computation time under 30ms operating on test data.</a:t>
+              <a:t>Average computation time under 30ms per engine.</a:t>
             </a:r>
           </a:p>
         </p:txBody>
@@ -6462,7 +6462,7 @@
           <a:lstStyle/>
           <a:p>
             <a:pPr>
-              <a:defRPr sz="3400" b="1">
+              <a:defRPr sz="3600" b="1">
                 <a:solidFill>
                   <a:srgbClr val="0F172A"/>
                 </a:solidFill>
@@ -6470,7 +6470,7 @@
               </a:defRPr>
             </a:pPr>
             <a:r>
-              <a:t>Per-Model Benchmark Evaluation Table</a:t>
+              <a:t>Per-Model Evaluation Table</a:t>
             </a:r>
           </a:p>
         </p:txBody>
@@ -8188,7 +8188,7 @@
         </p:nvSpPr>
         <p:spPr>
           <a:xfrm>
-            <a:off x="548640" y="365760"/>
+            <a:off x="548640" y="457200"/>
             <a:ext cx="8046720" cy="685800"/>
           </a:xfrm>
           <a:prstGeom prst="rect">
@@ -8203,7 +8203,7 @@
           <a:lstStyle/>
           <a:p>
             <a:pPr>
-              <a:defRPr sz="3400" b="1">
+              <a:defRPr sz="3600" b="1">
                 <a:solidFill>
                   <a:srgbClr val="0F172A"/>
                 </a:solidFill>
@@ -8211,7 +8211,7 @@
               </a:defRPr>
             </a:pPr>
             <a:r>
-              <a:t>Observations &amp; Result Analysis</a:t>
+              <a:t>Key Observations</a:t>
             </a:r>
           </a:p>
         </p:txBody>
@@ -8260,8 +8260,8 @@
         </p:nvSpPr>
         <p:spPr>
           <a:xfrm>
-            <a:off x="548640" y="1143000"/>
-            <a:ext cx="8046720" cy="4800600"/>
+            <a:off x="548640" y="1280160"/>
+            <a:ext cx="8046720" cy="4389120"/>
           </a:xfrm>
           <a:prstGeom prst="rect">
             <a:avLst/>
@@ -8276,7 +8276,7 @@
           <a:p>
             <a:pPr>
               <a:spcAft>
-                <a:spcPts val="1000"/>
+                <a:spcPts val="1400"/>
               </a:spcAft>
               <a:defRPr sz="2000" b="1">
                 <a:solidFill>
@@ -8286,22 +8286,22 @@
               </a:defRPr>
             </a:pPr>
             <a:r>
-              <a:rPr sz="1800" b="1">
+              <a:rPr sz="2000" b="1">
                 <a:solidFill>
                   <a:srgbClr val="2563EB"/>
                 </a:solidFill>
                 <a:latin typeface="Calibri"/>
               </a:rPr>
-              <a:t>• Feature Engineering Impact: </a:t>
-            </a:r>
-            <a:r>
-              <a:rPr sz="1800" b="0">
+              <a:t>• Rolling Feature Impact: </a:t>
+            </a:r>
+            <a:r>
+              <a:rPr sz="2000" b="0">
                 <a:solidFill>
                   <a:srgbClr val="334155"/>
                 </a:solidFill>
                 <a:latin typeface="Calibri"/>
               </a:rPr>
-              <a:t>5-cycle rolling statistics (av, sd) significantly outperform raw sensors.</a:t>
+              <a:t>5-cycle rolling statistics outperform raw sensors.</a:t>
             </a:r>
           </a:p>
           <a:p>
@@ -8359,11 +8359,11 @@
           <a:p>
             <a:pPr>
               <a:spcAft>
-                <a:spcPts val="1000"/>
-              </a:spcAft>
-            </a:pPr>
-            <a:r>
-              <a:rPr sz="1800" b="1">
+                <a:spcPts val="1400"/>
+              </a:spcAft>
+            </a:pPr>
+            <a:r>
+              <a:rPr sz="2000" b="1">
                 <a:solidFill>
                   <a:srgbClr val="2563EB"/>
                 </a:solidFill>
@@ -8372,88 +8372,88 @@
               <a:t>• Optimal Thresholding: </a:t>
             </a:r>
             <a:r>
-              <a:rPr sz="1800" b="0">
+              <a:rPr sz="2000" b="0">
                 <a:solidFill>
                   <a:srgbClr val="334155"/>
                 </a:solidFill>
                 <a:latin typeface="Calibri"/>
               </a:rPr>
-              <a:t>Operating Random Forest at tau = 0.17 yields 100% precision &amp; 68% recall.</a:t>
-            </a:r>
-          </a:p>
-          <a:p>
-            <a:pPr>
-              <a:spcAft>
-                <a:spcPts val="1000"/>
-              </a:spcAft>
-            </a:pPr>
-            <a:r>
-              <a:rPr sz="1800" b="1">
+              <a:t>Threshold tau = 0.17 yields 100% precision.</a:t>
+            </a:r>
+          </a:p>
+          <a:p>
+            <a:pPr>
+              <a:spcAft>
+                <a:spcPts val="1400"/>
+              </a:spcAft>
+            </a:pPr>
+            <a:r>
+              <a:rPr sz="2000" b="1">
                 <a:solidFill>
                   <a:srgbClr val="2563EB"/>
                 </a:solidFill>
                 <a:latin typeface="Calibri"/>
               </a:rPr>
-              <a:t>• Cost Matrix Minimization: </a:t>
-            </a:r>
-            <a:r>
-              <a:rPr sz="1800" b="0">
+              <a:t>• Cost Matrix Savings: </a:t>
+            </a:r>
+            <a:r>
+              <a:rPr sz="2000" b="0">
                 <a:solidFill>
                   <a:srgbClr val="334155"/>
                 </a:solidFill>
                 <a:latin typeface="Calibri"/>
               </a:rPr>
-              <a:t>Prevents $250,000+ catastrophic in-flight failures via planned $15,000 repairs.</a:t>
-            </a:r>
-          </a:p>
-          <a:p>
-            <a:pPr>
-              <a:spcAft>
-                <a:spcPts val="1000"/>
-              </a:spcAft>
-            </a:pPr>
-            <a:r>
-              <a:rPr sz="1800" b="1">
+              <a:t>Prevents $250k failures via $15k planned repairs.</a:t>
+            </a:r>
+          </a:p>
+          <a:p>
+            <a:pPr>
+              <a:spcAft>
+                <a:spcPts val="1400"/>
+              </a:spcAft>
+            </a:pPr>
+            <a:r>
+              <a:rPr sz="2000" b="1">
                 <a:solidFill>
                   <a:srgbClr val="2563EB"/>
                 </a:solidFill>
                 <a:latin typeface="Calibri"/>
               </a:rPr>
-              <a:t>• Neural Network Stability: </a:t>
-            </a:r>
-            <a:r>
-              <a:rPr sz="1800" b="0">
+              <a:t>• Neural Net Stability: </a:t>
+            </a:r>
+            <a:r>
+              <a:rPr sz="2000" b="0">
                 <a:solidFill>
                   <a:srgbClr val="334155"/>
                 </a:solidFill>
                 <a:latin typeface="Calibri"/>
               </a:rPr>
-              <a:t>Multi-layer Perceptron provides high accuracy on critical hazard windows.</a:t>
-            </a:r>
-          </a:p>
-          <a:p>
-            <a:pPr>
-              <a:spcAft>
-                <a:spcPts val="1000"/>
-              </a:spcAft>
-            </a:pPr>
-            <a:r>
-              <a:rPr sz="1800" b="1">
+              <a:t>MLP provides high accuracy on critical windows.</a:t>
+            </a:r>
+          </a:p>
+          <a:p>
+            <a:pPr>
+              <a:spcAft>
+                <a:spcPts val="1400"/>
+              </a:spcAft>
+            </a:pPr>
+            <a:r>
+              <a:rPr sz="2000" b="1">
                 <a:solidFill>
                   <a:srgbClr val="2563EB"/>
                 </a:solidFill>
                 <a:latin typeface="Calibri"/>
               </a:rPr>
-              <a:t>• Maintenance Capacity Dispatch: </a:t>
-            </a:r>
-            <a:r>
-              <a:rPr sz="1800" b="0">
+              <a:t>• Capacity Dispatch: </a:t>
+            </a:r>
+            <a:r>
+              <a:rPr sz="2000" b="0">
                 <a:solidFill>
                   <a:srgbClr val="334155"/>
                 </a:solidFill>
                 <a:latin typeface="Calibri"/>
               </a:rPr>
-              <a:t>Efficiently queues engines based on RUL urgency rank.</a:t>
+              <a:t>Queues engines efficiently by RUL urgency rank.</a:t>
             </a:r>
           </a:p>
         </p:txBody>
@@ -8484,7 +8484,7 @@
         </p:nvSpPr>
         <p:spPr>
           <a:xfrm>
-            <a:off x="548640" y="365760"/>
+            <a:off x="548640" y="457200"/>
             <a:ext cx="8046720" cy="685800"/>
           </a:xfrm>
           <a:prstGeom prst="rect">
@@ -8499,7 +8499,7 @@
           <a:lstStyle/>
           <a:p>
             <a:pPr>
-              <a:defRPr sz="3400" b="1">
+              <a:defRPr sz="3600" b="1">
                 <a:solidFill>
                   <a:srgbClr val="0F172A"/>
                 </a:solidFill>
@@ -8507,7 +8507,7 @@
               </a:defRPr>
             </a:pPr>
             <a:r>
-              <a:t>Conclusion &amp; Project Summary</a:t>
+              <a:t>Conclusion &amp; Summary</a:t>
             </a:r>
           </a:p>
         </p:txBody>
@@ -8556,8 +8556,8 @@
         </p:nvSpPr>
         <p:spPr>
           <a:xfrm>
-            <a:off x="548640" y="1143000"/>
-            <a:ext cx="8046720" cy="4800600"/>
+            <a:off x="548640" y="1280160"/>
+            <a:ext cx="8046720" cy="4389120"/>
           </a:xfrm>
           <a:prstGeom prst="rect">
             <a:avLst/>
@@ -8572,7 +8572,7 @@
           <a:p>
             <a:pPr>
               <a:spcAft>
-                <a:spcPts val="1000"/>
+                <a:spcPts val="1400"/>
               </a:spcAft>
               <a:defRPr sz="2000" b="1">
                 <a:solidFill>
@@ -8582,22 +8582,22 @@
               </a:defRPr>
             </a:pPr>
             <a:r>
-              <a:rPr sz="1800" b="1">
+              <a:rPr sz="2000" b="1">
                 <a:solidFill>
                   <a:srgbClr val="2563EB"/>
                 </a:solidFill>
                 <a:latin typeface="Calibri"/>
               </a:rPr>
-              <a:t>• Successful System Delivery: </a:t>
-            </a:r>
-            <a:r>
-              <a:rPr sz="1800" b="0">
+              <a:t>• System Delivery: </a:t>
+            </a:r>
+            <a:r>
+              <a:rPr sz="2000" b="0">
                 <a:solidFill>
                   <a:srgbClr val="334155"/>
                 </a:solidFill>
                 <a:latin typeface="Calibri"/>
               </a:rPr>
-              <a:t>Built a complete predictive health management pipeline for jet engines.</a:t>
+              <a:t>Delivered complete predictive health pipeline.</a:t>
             </a:r>
           </a:p>
           <a:p>
@@ -8655,101 +8655,101 @@
           <a:p>
             <a:pPr>
               <a:spcAft>
-                <a:spcPts val="1000"/>
-              </a:spcAft>
-            </a:pPr>
-            <a:r>
-              <a:rPr sz="1800" b="1">
+                <a:spcPts val="1400"/>
+              </a:spcAft>
+            </a:pPr>
+            <a:r>
+              <a:rPr sz="2000" b="1">
                 <a:solidFill>
                   <a:srgbClr val="2563EB"/>
                 </a:solidFill>
                 <a:latin typeface="Calibri"/>
               </a:rPr>
-              <a:t>• High Predictive Performance: </a:t>
-            </a:r>
-            <a:r>
-              <a:rPr sz="1800" b="0">
+              <a:t>• High Performance: </a:t>
+            </a:r>
+            <a:r>
+              <a:rPr sz="2000" b="0">
                 <a:solidFill>
                   <a:srgbClr val="334155"/>
                 </a:solidFill>
                 <a:latin typeface="Calibri"/>
               </a:rPr>
-              <a:t>Achieved 98.45% AUC-ROC failure detection and 33.39 cycles RUL RMSE.</a:t>
-            </a:r>
-          </a:p>
-          <a:p>
-            <a:pPr>
-              <a:spcAft>
-                <a:spcPts val="1000"/>
-              </a:spcAft>
-            </a:pPr>
-            <a:r>
-              <a:rPr sz="1800" b="1">
+              <a:t>Achieved 98.45% AUC-ROC and 33.39 RMSE.</a:t>
+            </a:r>
+          </a:p>
+          <a:p>
+            <a:pPr>
+              <a:spcAft>
+                <a:spcPts val="1400"/>
+              </a:spcAft>
+            </a:pPr>
+            <a:r>
+              <a:rPr sz="2000" b="1">
                 <a:solidFill>
                   <a:srgbClr val="2563EB"/>
                 </a:solidFill>
                 <a:latin typeface="Calibri"/>
               </a:rPr>
-              <a:t>• Sign-to-Speech &amp; CLI Integration: </a:t>
-            </a:r>
-            <a:r>
-              <a:rPr sz="1800" b="0">
+              <a:t>• CLI Integration: </a:t>
+            </a:r>
+            <a:r>
+              <a:rPr sz="2000" b="0">
                 <a:solidFill>
                   <a:srgbClr val="334155"/>
                 </a:solidFill>
                 <a:latin typeface="Calibri"/>
               </a:rPr>
-              <a:t>Successfully integrated interactive predict.py CLI diagnostic tool.</a:t>
-            </a:r>
-          </a:p>
-          <a:p>
-            <a:pPr>
-              <a:spcAft>
-                <a:spcPts val="1000"/>
-              </a:spcAft>
-            </a:pPr>
-            <a:r>
-              <a:rPr sz="1800" b="1">
+              <a:t>Integrated interactive predict.py diagnostic tool.</a:t>
+            </a:r>
+          </a:p>
+          <a:p>
+            <a:pPr>
+              <a:spcAft>
+                <a:spcPts val="1400"/>
+              </a:spcAft>
+            </a:pPr>
+            <a:r>
+              <a:rPr sz="2000" b="1">
                 <a:solidFill>
                   <a:srgbClr val="2563EB"/>
                 </a:solidFill>
                 <a:latin typeface="Calibri"/>
               </a:rPr>
-              <a:t>• Native Python Implementation: </a:t>
-            </a:r>
-            <a:r>
-              <a:rPr sz="1800" b="0">
+              <a:t>• Clean Implementation: </a:t>
+            </a:r>
+            <a:r>
+              <a:rPr sz="2000" b="0">
                 <a:solidFill>
                   <a:srgbClr val="334155"/>
                 </a:solidFill>
                 <a:latin typeface="Calibri"/>
               </a:rPr>
-              <a:t>Developed clean 100% Python pipeline &amp; serialized model artifacts.</a:t>
-            </a:r>
-          </a:p>
-          <a:p>
-            <a:pPr>
-              <a:spcAft>
-                <a:spcPts val="1000"/>
-              </a:spcAft>
-            </a:pPr>
-            <a:r>
-              <a:rPr sz="1800" b="1">
+              <a:t>Developed 100% Python pipeline and models.</a:t>
+            </a:r>
+          </a:p>
+          <a:p>
+            <a:pPr>
+              <a:spcAft>
+                <a:spcPts val="1400"/>
+              </a:spcAft>
+            </a:pPr>
+            <a:r>
+              <a:rPr sz="2000" b="1">
                 <a:solidFill>
                   <a:srgbClr val="2563EB"/>
                 </a:solidFill>
                 <a:latin typeface="Calibri"/>
               </a:rPr>
-              <a:t>• Fleet Cost Minimization: </a:t>
-            </a:r>
-            <a:r>
-              <a:rPr sz="1800" b="0">
+              <a:t>• Cost Minimization: </a:t>
+            </a:r>
+            <a:r>
+              <a:rPr sz="2000" b="0">
                 <a:solidFill>
                   <a:srgbClr val="334155"/>
                 </a:solidFill>
                 <a:latin typeface="Calibri"/>
               </a:rPr>
-              <a:t>Optimizes maintenance capacity allocation and eliminates flight delays.</a:t>
+              <a:t>Optimizes maintenance and eliminates flight delays.</a:t>
             </a:r>
           </a:p>
         </p:txBody>
@@ -8780,7 +8780,7 @@
         </p:nvSpPr>
         <p:spPr>
           <a:xfrm>
-            <a:off x="548640" y="365760"/>
+            <a:off x="548640" y="457200"/>
             <a:ext cx="8046720" cy="685800"/>
           </a:xfrm>
           <a:prstGeom prst="rect">
@@ -8795,7 +8795,7 @@
           <a:lstStyle/>
           <a:p>
             <a:pPr>
-              <a:defRPr sz="3400" b="1">
+              <a:defRPr sz="3600" b="1">
                 <a:solidFill>
                   <a:srgbClr val="0F172A"/>
                 </a:solidFill>
@@ -8803,7 +8803,7 @@
               </a:defRPr>
             </a:pPr>
             <a:r>
-              <a:t>Future Scope &amp; Strategic Roadmap</a:t>
+              <a:t>Future Scope</a:t>
             </a:r>
           </a:p>
         </p:txBody>
@@ -8852,8 +8852,8 @@
         </p:nvSpPr>
         <p:spPr>
           <a:xfrm>
-            <a:off x="548640" y="1143000"/>
-            <a:ext cx="8046720" cy="4800600"/>
+            <a:off x="548640" y="1280160"/>
+            <a:ext cx="8046720" cy="4389120"/>
           </a:xfrm>
           <a:prstGeom prst="rect">
             <a:avLst/>
@@ -8868,7 +8868,7 @@
           <a:p>
             <a:pPr>
               <a:spcAft>
-                <a:spcPts val="1000"/>
+                <a:spcPts val="1400"/>
               </a:spcAft>
               <a:defRPr sz="2000" b="1">
                 <a:solidFill>
@@ -8878,22 +8878,22 @@
               </a:defRPr>
             </a:pPr>
             <a:r>
-              <a:rPr sz="1800" b="1">
+              <a:rPr sz="2000" b="1">
                 <a:solidFill>
                   <a:srgbClr val="2563EB"/>
                 </a:solidFill>
                 <a:latin typeface="Calibri"/>
               </a:rPr>
-              <a:t>• Deep Time-Series Architecture: </a:t>
-            </a:r>
-            <a:r>
-              <a:rPr sz="1800" b="0">
+              <a:t>• Deep Time-Series: </a:t>
+            </a:r>
+            <a:r>
+              <a:rPr sz="2000" b="0">
                 <a:solidFill>
                   <a:srgbClr val="334155"/>
                 </a:solidFill>
                 <a:latin typeface="Calibri"/>
               </a:rPr>
-              <a:t>Integrate Recurrent LSTM and Transformer networks for temporal dynamics.</a:t>
+              <a:t>Integrate Recurrent LSTM and Transformer models.</a:t>
             </a:r>
           </a:p>
           <a:p>
@@ -8951,61 +8951,61 @@
           <a:p>
             <a:pPr>
               <a:spcAft>
-                <a:spcPts val="1000"/>
-              </a:spcAft>
-            </a:pPr>
-            <a:r>
-              <a:rPr sz="1800" b="1">
+                <a:spcPts val="1400"/>
+              </a:spcAft>
+            </a:pPr>
+            <a:r>
+              <a:rPr sz="2000" b="1">
                 <a:solidFill>
                   <a:srgbClr val="2563EB"/>
                 </a:solidFill>
                 <a:latin typeface="Calibri"/>
               </a:rPr>
-              <a:t>• Sentence-Level Flight Profiles: </a:t>
-            </a:r>
-            <a:r>
-              <a:rPr sz="1800" b="0">
+              <a:t>• Flight Profiles: </a:t>
+            </a:r>
+            <a:r>
+              <a:rPr sz="2000" b="0">
                 <a:solidFill>
                   <a:srgbClr val="334155"/>
                 </a:solidFill>
                 <a:latin typeface="Calibri"/>
               </a:rPr>
-              <a:t>Extend from single-mode steady flights to multi-profile flight regimes.</a:t>
-            </a:r>
-          </a:p>
-          <a:p>
-            <a:pPr>
-              <a:spcAft>
-                <a:spcPts val="1000"/>
-              </a:spcAft>
-            </a:pPr>
-            <a:r>
-              <a:rPr sz="1800" b="1">
+              <a:t>Extend to variable altitude and speed profiles.</a:t>
+            </a:r>
+          </a:p>
+          <a:p>
+            <a:pPr>
+              <a:spcAft>
+                <a:spcPts val="1400"/>
+              </a:spcAft>
+            </a:pPr>
+            <a:r>
+              <a:rPr sz="2000" b="1">
                 <a:solidFill>
                   <a:srgbClr val="2563EB"/>
                 </a:solidFill>
                 <a:latin typeface="Calibri"/>
               </a:rPr>
-              <a:t>• Mobile &amp; Edge Deployment: </a:t>
-            </a:r>
-            <a:r>
-              <a:rPr sz="1800" b="0">
+              <a:t>• Edge Deployment: </a:t>
+            </a:r>
+            <a:r>
+              <a:rPr sz="2000" b="0">
                 <a:solidFill>
                   <a:srgbClr val="334155"/>
                 </a:solidFill>
                 <a:latin typeface="Calibri"/>
               </a:rPr>
-              <a:t>Export model to TensorFlow Lite (TFLite) for deployment on avionics hardware.</a:t>
-            </a:r>
-          </a:p>
-          <a:p>
-            <a:pPr>
-              <a:spcAft>
-                <a:spcPts val="1000"/>
-              </a:spcAft>
-            </a:pPr>
-            <a:r>
-              <a:rPr sz="1800" b="1">
+              <a:t>Export TFLite models for onboard avionics.</a:t>
+            </a:r>
+          </a:p>
+          <a:p>
+            <a:pPr>
+              <a:spcAft>
+                <a:spcPts val="1400"/>
+              </a:spcAft>
+            </a:pPr>
+            <a:r>
+              <a:rPr sz="2000" b="1">
                 <a:solidFill>
                   <a:srgbClr val="2563EB"/>
                 </a:solidFill>
@@ -9014,38 +9014,38 @@
               <a:t>• Cloud Streaming API: </a:t>
             </a:r>
             <a:r>
-              <a:rPr sz="1800" b="0">
+              <a:rPr sz="2000" b="0">
                 <a:solidFill>
                   <a:srgbClr val="334155"/>
                 </a:solidFill>
                 <a:latin typeface="Calibri"/>
               </a:rPr>
-              <a:t>Deploy REST API endpoints for real-time IoT stream data ingestion.</a:t>
-            </a:r>
-          </a:p>
-          <a:p>
-            <a:pPr>
-              <a:spcAft>
-                <a:spcPts val="1000"/>
-              </a:spcAft>
-            </a:pPr>
-            <a:r>
-              <a:rPr sz="1800" b="1">
+              <a:t>Deploy REST API endpoints for live IoT streams.</a:t>
+            </a:r>
+          </a:p>
+          <a:p>
+            <a:pPr>
+              <a:spcAft>
+                <a:spcPts val="1400"/>
+              </a:spcAft>
+            </a:pPr>
+            <a:r>
+              <a:rPr sz="2000" b="1">
                 <a:solidFill>
                   <a:srgbClr val="2563EB"/>
                 </a:solidFill>
                 <a:latin typeface="Calibri"/>
               </a:rPr>
-              <a:t>• Dataset Mirror Augmentation: </a:t>
-            </a:r>
-            <a:r>
-              <a:rPr sz="1800" b="0">
+              <a:t>• Data Augmentation: </a:t>
+            </a:r>
+            <a:r>
+              <a:rPr sz="2000" b="0">
                 <a:solidFill>
                   <a:srgbClr val="334155"/>
                 </a:solidFill>
                 <a:latin typeface="Calibri"/>
               </a:rPr>
-              <a:t>Incorporate synthetic degradation data augmentation for long-tail failures.</a:t>
+              <a:t>Add synthetic degradation data for rare failures.</a:t>
             </a:r>
           </a:p>
         </p:txBody>
@@ -9076,7 +9076,7 @@
         </p:nvSpPr>
         <p:spPr>
           <a:xfrm>
-            <a:off x="548640" y="365760"/>
+            <a:off x="548640" y="457200"/>
             <a:ext cx="8046720" cy="685800"/>
           </a:xfrm>
           <a:prstGeom prst="rect">
@@ -9091,7 +9091,7 @@
           <a:lstStyle/>
           <a:p>
             <a:pPr>
-              <a:defRPr sz="3400" b="1">
+              <a:defRPr sz="3600" b="1">
                 <a:solidFill>
                   <a:srgbClr val="0F172A"/>
                 </a:solidFill>
@@ -9099,7 +9099,7 @@
               </a:defRPr>
             </a:pPr>
             <a:r>
-              <a:t>References &amp; Bibliography</a:t>
+              <a:t>References</a:t>
             </a:r>
           </a:p>
         </p:txBody>
@@ -9148,8 +9148,8 @@
         </p:nvSpPr>
         <p:spPr>
           <a:xfrm>
-            <a:off x="548640" y="1143000"/>
-            <a:ext cx="8046720" cy="4800600"/>
+            <a:off x="548640" y="1280160"/>
+            <a:ext cx="8046720" cy="4389120"/>
           </a:xfrm>
           <a:prstGeom prst="rect">
             <a:avLst/>
@@ -9164,7 +9164,7 @@
           <a:p>
             <a:pPr>
               <a:spcAft>
-                <a:spcPts val="800"/>
+                <a:spcPts val="1400"/>
               </a:spcAft>
               <a:defRPr sz="2000" b="0">
                 <a:solidFill>
@@ -9174,22 +9174,22 @@
               </a:defRPr>
             </a:pPr>
             <a:r>
-              <a:rPr sz="1600" b="1">
+              <a:rPr sz="2000" b="1">
                 <a:solidFill>
                   <a:srgbClr val="2563EB"/>
                 </a:solidFill>
                 <a:latin typeface="Calibri"/>
               </a:rPr>
-              <a:t>• 1. NASA Ames Prognostics Center of Excellence - </a:t>
-            </a:r>
-            <a:r>
-              <a:rPr sz="1600" b="0">
+              <a:t>• NASA C-MAPSS Dataset: </a:t>
+            </a:r>
+            <a:r>
+              <a:rPr sz="2000" b="0">
                 <a:solidFill>
                   <a:srgbClr val="334155"/>
                 </a:solidFill>
                 <a:latin typeface="Calibri"/>
               </a:rPr>
-              <a:t>C-MAPSS Jet Engine Degradation Dataset, 2024.</a:t>
+              <a:t>Ames Prognostics Center of Excellence, 2024.</a:t>
             </a:r>
           </a:p>
           <a:p>
@@ -9260,126 +9260,101 @@
           <a:p>
             <a:pPr>
               <a:spcAft>
-                <a:spcPts val="800"/>
-              </a:spcAft>
-            </a:pPr>
-            <a:r>
-              <a:rPr sz="1600" b="1">
+                <a:spcPts val="1400"/>
+              </a:spcAft>
+            </a:pPr>
+            <a:r>
+              <a:rPr sz="2000" b="1">
                 <a:solidFill>
                   <a:srgbClr val="2563EB"/>
                 </a:solidFill>
                 <a:latin typeface="Calibri"/>
               </a:rPr>
-              <a:t>• 2. Saxena, A., et al., </a:t>
-            </a:r>
-            <a:r>
-              <a:rPr sz="1600" b="0">
+              <a:t>• Damage Modeling Paper: </a:t>
+            </a:r>
+            <a:r>
+              <a:rPr sz="2000" b="0">
                 <a:solidFill>
                   <a:srgbClr val="334155"/>
                 </a:solidFill>
                 <a:latin typeface="Calibri"/>
               </a:rPr>
-              <a:t>'Damage Propagation Modeling for Aircraft Engine Simulation', IEEE, 2008.</a:t>
-            </a:r>
-          </a:p>
-          <a:p>
-            <a:pPr>
-              <a:spcAft>
-                <a:spcPts val="800"/>
-              </a:spcAft>
-            </a:pPr>
-            <a:r>
-              <a:rPr sz="1600" b="1">
+              <a:t>Saxena et al., IEEE Prognostics, 2008.</a:t>
+            </a:r>
+          </a:p>
+          <a:p>
+            <a:pPr>
+              <a:spcAft>
+                <a:spcPts val="1400"/>
+              </a:spcAft>
+            </a:pPr>
+            <a:r>
+              <a:rPr sz="2000" b="1">
                 <a:solidFill>
                   <a:srgbClr val="2563EB"/>
                 </a:solidFill>
                 <a:latin typeface="Calibri"/>
               </a:rPr>
-              <a:t>• 3. Springboard Data Science Career Track - </a:t>
-            </a:r>
-            <a:r>
-              <a:rPr sz="1600" b="0">
+              <a:t>• Scikit-Learn Docs: </a:t>
+            </a:r>
+            <a:r>
+              <a:rPr sz="2000" b="0">
                 <a:solidFill>
                   <a:srgbClr val="334155"/>
                 </a:solidFill>
                 <a:latin typeface="Calibri"/>
               </a:rPr>
-              <a:t>Bootcamp Curriculum &amp; Mentorship, 2026.</a:t>
-            </a:r>
-          </a:p>
-          <a:p>
-            <a:pPr>
-              <a:spcAft>
-                <a:spcPts val="800"/>
-              </a:spcAft>
-            </a:pPr>
-            <a:r>
-              <a:rPr sz="1600" b="1">
+              <a:t>Machine Learning Library Documentation, 2026.</a:t>
+            </a:r>
+          </a:p>
+          <a:p>
+            <a:pPr>
+              <a:spcAft>
+                <a:spcPts val="1400"/>
+              </a:spcAft>
+            </a:pPr>
+            <a:r>
+              <a:rPr sz="2000" b="1">
                 <a:solidFill>
                   <a:srgbClr val="2563EB"/>
                 </a:solidFill>
                 <a:latin typeface="Calibri"/>
               </a:rPr>
-              <a:t>• 4. Scikit-Learn Open Source Library - </a:t>
-            </a:r>
-            <a:r>
-              <a:rPr sz="1600" b="0">
+              <a:t>• Keras &amp; TensorFlow: </a:t>
+            </a:r>
+            <a:r>
+              <a:rPr sz="2000" b="0">
                 <a:solidFill>
                   <a:srgbClr val="334155"/>
                 </a:solidFill>
                 <a:latin typeface="Calibri"/>
               </a:rPr>
-              <a:t>Machine Learning &amp; Neural Network Documentation, 2026.</a:t>
-            </a:r>
-          </a:p>
-          <a:p>
-            <a:pPr>
-              <a:spcAft>
-                <a:spcPts val="800"/>
-              </a:spcAft>
-            </a:pPr>
-            <a:r>
-              <a:rPr sz="1600" b="1">
+              <a:t>Official Deep Learning Framework API, 2026.</a:t>
+            </a:r>
+          </a:p>
+          <a:p>
+            <a:pPr>
+              <a:spcAft>
+                <a:spcPts val="1400"/>
+              </a:spcAft>
+            </a:pPr>
+            <a:r>
+              <a:rPr sz="2000" b="1">
                 <a:solidFill>
                   <a:srgbClr val="2563EB"/>
                 </a:solidFill>
                 <a:latin typeface="Calibri"/>
               </a:rPr>
-              <a:t>• 5. Google Keras 3.3 &amp; TensorFlow 2.17 - </a:t>
-            </a:r>
-            <a:r>
-              <a:rPr sz="1600" b="0">
+              <a:t>• GitHub Repository: </a:t>
+            </a:r>
+            <a:r>
+              <a:rPr sz="2000" b="0">
                 <a:solidFill>
                   <a:srgbClr val="334155"/>
                 </a:solidFill>
                 <a:latin typeface="Calibri"/>
               </a:rPr>
-              <a:t>Official Documentation and API Reference, 2026.</a:t>
-            </a:r>
-          </a:p>
-          <a:p>
-            <a:pPr>
-              <a:spcAft>
-                <a:spcPts val="800"/>
-              </a:spcAft>
-            </a:pPr>
-            <a:r>
-              <a:rPr sz="1600" b="1">
-                <a:solidFill>
-                  <a:srgbClr val="2563EB"/>
-                </a:solidFill>
-                <a:latin typeface="Calibri"/>
-              </a:rPr>
-              <a:t>• 6. Microsoft Azure Machine Learning - </a:t>
-            </a:r>
-            <a:r>
-              <a:rPr sz="1600" b="0">
-                <a:solidFill>
-                  <a:srgbClr val="334155"/>
-                </a:solidFill>
-                <a:latin typeface="Calibri"/>
-              </a:rPr>
-              <a:t>Predictive Maintenance Simulation Templates, 2026.</a:t>
+              <a:t>https://github.com/PiyushTiwari2051/Predictive-Master</a:t>
             </a:r>
           </a:p>
         </p:txBody>
@@ -9499,7 +9474,7 @@
         </p:nvSpPr>
         <p:spPr>
           <a:xfrm>
-            <a:off x="548640" y="365760"/>
+            <a:off x="548640" y="457200"/>
             <a:ext cx="8046720" cy="685800"/>
           </a:xfrm>
           <a:prstGeom prst="rect">
@@ -9514,7 +9489,7 @@
           <a:lstStyle/>
           <a:p>
             <a:pPr>
-              <a:defRPr sz="3400" b="1">
+              <a:defRPr sz="3600" b="1">
                 <a:solidFill>
                   <a:srgbClr val="0F172A"/>
                 </a:solidFill>
@@ -9522,7 +9497,7 @@
               </a:defRPr>
             </a:pPr>
             <a:r>
-              <a:t>Agenda &amp; Executive Overview</a:t>
+              <a:t>Executive Agenda</a:t>
             </a:r>
           </a:p>
         </p:txBody>
@@ -9571,8 +9546,8 @@
         </p:nvSpPr>
         <p:spPr>
           <a:xfrm>
-            <a:off x="548640" y="1143000"/>
-            <a:ext cx="8046720" cy="4800600"/>
+            <a:off x="548640" y="1280160"/>
+            <a:ext cx="8046720" cy="4389120"/>
           </a:xfrm>
           <a:prstGeom prst="rect">
             <a:avLst/>
@@ -9587,6 +9562,37 @@
           <a:p>
             <a:pPr>
               <a:spcAft>
+                <a:spcPts val="1400"/>
+              </a:spcAft>
+              <a:defRPr sz="2000" b="1">
+                <a:solidFill>
+                  <a:srgbClr val="0F172A"/>
+                </a:solidFill>
+                <a:latin typeface="Calibri"/>
+              </a:defRPr>
+            </a:pPr>
+            <a:r>
+              <a:rPr sz="2000" b="1">
+                <a:solidFill>
+                  <a:srgbClr val="2563EB"/>
+                </a:solidFill>
+                <a:latin typeface="Calibri"/>
+              </a:rPr>
+              <a:t>• Problem Statement: </a:t>
+            </a:r>
+            <a:r>
+              <a:rPr sz="2000" b="0">
+                <a:solidFill>
+                  <a:srgbClr val="334155"/>
+                </a:solidFill>
+                <a:latin typeface="Calibri"/>
+              </a:rPr>
+              <a:t>High costs of unplanned aircraft engine failures.</a:t>
+            </a:r>
+          </a:p>
+          <a:p>
+            <a:pPr>
+              <a:spcAft>
                 <a:spcPts val="600"/>
               </a:spcAft>
               <a:defRPr sz="2000" b="1">
@@ -9596,290 +9602,209 @@
                 <a:latin typeface="Calibri"/>
               </a:defRPr>
             </a:pPr>
-            <a:r>
-              <a:rPr sz="1600" b="1">
+          </a:p>
+          <a:p>
+            <a:pPr>
+              <a:spcAft>
+                <a:spcPts val="600"/>
+              </a:spcAft>
+              <a:defRPr sz="2000" b="1">
+                <a:solidFill>
+                  <a:srgbClr val="0F172A"/>
+                </a:solidFill>
+                <a:latin typeface="Calibri"/>
+              </a:defRPr>
+            </a:pPr>
+          </a:p>
+          <a:p>
+            <a:pPr>
+              <a:spcAft>
+                <a:spcPts val="600"/>
+              </a:spcAft>
+              <a:defRPr sz="2000" b="1">
+                <a:solidFill>
+                  <a:srgbClr val="0F172A"/>
+                </a:solidFill>
+                <a:latin typeface="Calibri"/>
+              </a:defRPr>
+            </a:pPr>
+          </a:p>
+          <a:p>
+            <a:pPr>
+              <a:spcAft>
+                <a:spcPts val="600"/>
+              </a:spcAft>
+              <a:defRPr sz="2000" b="1">
+                <a:solidFill>
+                  <a:srgbClr val="0F172A"/>
+                </a:solidFill>
+                <a:latin typeface="Calibri"/>
+              </a:defRPr>
+            </a:pPr>
+          </a:p>
+          <a:p>
+            <a:pPr>
+              <a:spcAft>
+                <a:spcPts val="600"/>
+              </a:spcAft>
+              <a:defRPr sz="2000" b="1">
+                <a:solidFill>
+                  <a:srgbClr val="0F172A"/>
+                </a:solidFill>
+                <a:latin typeface="Calibri"/>
+              </a:defRPr>
+            </a:pPr>
+          </a:p>
+          <a:p>
+            <a:pPr>
+              <a:spcAft>
+                <a:spcPts val="600"/>
+              </a:spcAft>
+              <a:defRPr sz="2000" b="1">
+                <a:solidFill>
+                  <a:srgbClr val="0F172A"/>
+                </a:solidFill>
+                <a:latin typeface="Calibri"/>
+              </a:defRPr>
+            </a:pPr>
+          </a:p>
+          <a:p>
+            <a:pPr>
+              <a:spcAft>
+                <a:spcPts val="600"/>
+              </a:spcAft>
+              <a:defRPr sz="2000" b="1">
+                <a:solidFill>
+                  <a:srgbClr val="0F172A"/>
+                </a:solidFill>
+                <a:latin typeface="Calibri"/>
+              </a:defRPr>
+            </a:pPr>
+          </a:p>
+          <a:p>
+            <a:pPr>
+              <a:spcAft>
+                <a:spcPts val="600"/>
+              </a:spcAft>
+              <a:defRPr sz="2000" b="1">
+                <a:solidFill>
+                  <a:srgbClr val="0F172A"/>
+                </a:solidFill>
+                <a:latin typeface="Calibri"/>
+              </a:defRPr>
+            </a:pPr>
+          </a:p>
+          <a:p>
+            <a:pPr>
+              <a:spcAft>
+                <a:spcPts val="600"/>
+              </a:spcAft>
+              <a:defRPr sz="2000" b="1">
+                <a:solidFill>
+                  <a:srgbClr val="0F172A"/>
+                </a:solidFill>
+                <a:latin typeface="Calibri"/>
+              </a:defRPr>
+            </a:pPr>
+          </a:p>
+          <a:p>
+            <a:pPr>
+              <a:spcAft>
+                <a:spcPts val="1400"/>
+              </a:spcAft>
+            </a:pPr>
+            <a:r>
+              <a:rPr sz="2000" b="1">
                 <a:solidFill>
                   <a:srgbClr val="2563EB"/>
                 </a:solidFill>
                 <a:latin typeface="Calibri"/>
               </a:rPr>
-              <a:t>• 1. Executive Problem Statement: </a:t>
-            </a:r>
-            <a:r>
-              <a:rPr sz="1600" b="0">
+              <a:t>• Project Objectives: </a:t>
+            </a:r>
+            <a:r>
+              <a:rPr sz="2000" b="0">
                 <a:solidFill>
                   <a:srgbClr val="334155"/>
                 </a:solidFill>
                 <a:latin typeface="Calibri"/>
               </a:rPr>
-              <a:t>High cost of unscheduled aircraft groundings &amp; turbofan engine failures.</a:t>
-            </a:r>
-          </a:p>
-          <a:p>
-            <a:pPr>
-              <a:spcAft>
-                <a:spcPts val="600"/>
-              </a:spcAft>
-              <a:defRPr sz="2000" b="1">
-                <a:solidFill>
-                  <a:srgbClr val="0F172A"/>
-                </a:solidFill>
-                <a:latin typeface="Calibri"/>
-              </a:defRPr>
-            </a:pPr>
-          </a:p>
-          <a:p>
-            <a:pPr>
-              <a:spcAft>
-                <a:spcPts val="600"/>
-              </a:spcAft>
-              <a:defRPr sz="2000" b="1">
-                <a:solidFill>
-                  <a:srgbClr val="0F172A"/>
-                </a:solidFill>
-                <a:latin typeface="Calibri"/>
-              </a:defRPr>
-            </a:pPr>
-          </a:p>
-          <a:p>
-            <a:pPr>
-              <a:spcAft>
-                <a:spcPts val="600"/>
-              </a:spcAft>
-              <a:defRPr sz="2000" b="1">
-                <a:solidFill>
-                  <a:srgbClr val="0F172A"/>
-                </a:solidFill>
-                <a:latin typeface="Calibri"/>
-              </a:defRPr>
-            </a:pPr>
-          </a:p>
-          <a:p>
-            <a:pPr>
-              <a:spcAft>
-                <a:spcPts val="600"/>
-              </a:spcAft>
-              <a:defRPr sz="2000" b="1">
-                <a:solidFill>
-                  <a:srgbClr val="0F172A"/>
-                </a:solidFill>
-                <a:latin typeface="Calibri"/>
-              </a:defRPr>
-            </a:pPr>
-          </a:p>
-          <a:p>
-            <a:pPr>
-              <a:spcAft>
-                <a:spcPts val="600"/>
-              </a:spcAft>
-              <a:defRPr sz="2000" b="1">
-                <a:solidFill>
-                  <a:srgbClr val="0F172A"/>
-                </a:solidFill>
-                <a:latin typeface="Calibri"/>
-              </a:defRPr>
-            </a:pPr>
-          </a:p>
-          <a:p>
-            <a:pPr>
-              <a:spcAft>
-                <a:spcPts val="600"/>
-              </a:spcAft>
-              <a:defRPr sz="2000" b="1">
-                <a:solidFill>
-                  <a:srgbClr val="0F172A"/>
-                </a:solidFill>
-                <a:latin typeface="Calibri"/>
-              </a:defRPr>
-            </a:pPr>
-          </a:p>
-          <a:p>
-            <a:pPr>
-              <a:spcAft>
-                <a:spcPts val="600"/>
-              </a:spcAft>
-              <a:defRPr sz="2000" b="1">
-                <a:solidFill>
-                  <a:srgbClr val="0F172A"/>
-                </a:solidFill>
-                <a:latin typeface="Calibri"/>
-              </a:defRPr>
-            </a:pPr>
-          </a:p>
-          <a:p>
-            <a:pPr>
-              <a:spcAft>
-                <a:spcPts val="600"/>
-              </a:spcAft>
-              <a:defRPr sz="2000" b="1">
-                <a:solidFill>
-                  <a:srgbClr val="0F172A"/>
-                </a:solidFill>
-                <a:latin typeface="Calibri"/>
-              </a:defRPr>
-            </a:pPr>
-          </a:p>
-          <a:p>
-            <a:pPr>
-              <a:spcAft>
-                <a:spcPts val="600"/>
-              </a:spcAft>
-              <a:defRPr sz="2000" b="1">
-                <a:solidFill>
-                  <a:srgbClr val="0F172A"/>
-                </a:solidFill>
-                <a:latin typeface="Calibri"/>
-              </a:defRPr>
-            </a:pPr>
-          </a:p>
-          <a:p>
-            <a:pPr>
-              <a:spcAft>
-                <a:spcPts val="600"/>
-              </a:spcAft>
-            </a:pPr>
-            <a:r>
-              <a:rPr sz="1600" b="1">
+              <a:t>Deliver tri-model AI engine for RUL forecasting.</a:t>
+            </a:r>
+          </a:p>
+          <a:p>
+            <a:pPr>
+              <a:spcAft>
+                <a:spcPts val="1400"/>
+              </a:spcAft>
+            </a:pPr>
+            <a:r>
+              <a:rPr sz="2000" b="1">
                 <a:solidFill>
                   <a:srgbClr val="2563EB"/>
                 </a:solidFill>
                 <a:latin typeface="Calibri"/>
               </a:rPr>
-              <a:t>• 2. Project Objectives: </a:t>
-            </a:r>
-            <a:r>
-              <a:rPr sz="1600" b="0">
+              <a:t>• Technology Stack: </a:t>
+            </a:r>
+            <a:r>
+              <a:rPr sz="2000" b="0">
                 <a:solidFill>
                   <a:srgbClr val="334155"/>
                 </a:solidFill>
                 <a:latin typeface="Calibri"/>
               </a:rPr>
-              <a:t>Deliver tri-model AI engine predicting RUL, 30d alerts, and 3-tier hazard ratings.</a:t>
-            </a:r>
-          </a:p>
-          <a:p>
-            <a:pPr>
-              <a:spcAft>
-                <a:spcPts val="600"/>
-              </a:spcAft>
-            </a:pPr>
-            <a:r>
-              <a:rPr sz="1600" b="1">
+              <a:t>Python 3.11, Scikit-Learn, Pandas, and NumPy.</a:t>
+            </a:r>
+          </a:p>
+          <a:p>
+            <a:pPr>
+              <a:spcAft>
+                <a:spcPts val="1400"/>
+              </a:spcAft>
+            </a:pPr>
+            <a:r>
+              <a:rPr sz="2000" b="1">
                 <a:solidFill>
                   <a:srgbClr val="2563EB"/>
                 </a:solidFill>
                 <a:latin typeface="Calibri"/>
               </a:rPr>
-              <a:t>• 3. Technology Stack &amp; Frameworks: </a:t>
-            </a:r>
-            <a:r>
-              <a:rPr sz="1600" b="0">
+              <a:t>• System Methodology: </a:t>
+            </a:r>
+            <a:r>
+              <a:rPr sz="2000" b="0">
                 <a:solidFill>
                   <a:srgbClr val="334155"/>
                 </a:solidFill>
                 <a:latin typeface="Calibri"/>
               </a:rPr>
-              <a:t>Python 3.11, Scikit-Learn 1.3+, Pandas, NumPy, and CLI diagnostic engine.</a:t>
-            </a:r>
-          </a:p>
-          <a:p>
-            <a:pPr>
-              <a:spcAft>
-                <a:spcPts val="600"/>
-              </a:spcAft>
-            </a:pPr>
-            <a:r>
-              <a:rPr sz="1600" b="1">
+              <a:t>NASA C-MAPSS 21-sensor rolling feature pipeline.</a:t>
+            </a:r>
+          </a:p>
+          <a:p>
+            <a:pPr>
+              <a:spcAft>
+                <a:spcPts val="1400"/>
+              </a:spcAft>
+            </a:pPr>
+            <a:r>
+              <a:rPr sz="2000" b="1">
                 <a:solidFill>
                   <a:srgbClr val="2563EB"/>
                 </a:solidFill>
                 <a:latin typeface="Calibri"/>
               </a:rPr>
-              <a:t>• 4. Data Methodology &amp; Flowchart: </a:t>
-            </a:r>
-            <a:r>
-              <a:rPr sz="1600" b="0">
+              <a:t>• Benchmark Results: </a:t>
+            </a:r>
+            <a:r>
+              <a:rPr sz="2000" b="0">
                 <a:solidFill>
                   <a:srgbClr val="334155"/>
                 </a:solidFill>
                 <a:latin typeface="Calibri"/>
               </a:rPr>
-              <a:t>NASA C-MAPSS 21-sensor ingestion, 5-cycle rolling stats, and correlation filters.</a:t>
-            </a:r>
-          </a:p>
-          <a:p>
-            <a:pPr>
-              <a:spcAft>
-                <a:spcPts val="600"/>
-              </a:spcAft>
-            </a:pPr>
-            <a:r>
-              <a:rPr sz="1600" b="1">
-                <a:solidFill>
-                  <a:srgbClr val="2563EB"/>
-                </a:solidFill>
-                <a:latin typeface="Calibri"/>
-              </a:rPr>
-              <a:t>• 5. Tri-Model Predictive AI Architecture: </a:t>
-            </a:r>
-            <a:r>
-              <a:rPr sz="1600" b="0">
-                <a:solidFill>
-                  <a:srgbClr val="334155"/>
-                </a:solidFill>
-                <a:latin typeface="Calibri"/>
-              </a:rPr>
-              <a:t>Random Forest Regressor, 30d Warning Classifier &amp; Neural MLP Network.</a:t>
-            </a:r>
-          </a:p>
-          <a:p>
-            <a:pPr>
-              <a:spcAft>
-                <a:spcPts val="600"/>
-              </a:spcAft>
-            </a:pPr>
-            <a:r>
-              <a:rPr sz="1600" b="1">
-                <a:solidFill>
-                  <a:srgbClr val="2563EB"/>
-                </a:solidFill>
-                <a:latin typeface="Calibri"/>
-              </a:rPr>
-              <a:t>• 6. Empirical Benchmark Results: </a:t>
-            </a:r>
-            <a:r>
-              <a:rPr sz="1600" b="0">
-                <a:solidFill>
-                  <a:srgbClr val="334155"/>
-                </a:solidFill>
-                <a:latin typeface="Calibri"/>
-              </a:rPr>
-              <a:t>98.45% AUC-ROC failure alert accuracy and 33.39 cycles RUL RMSE.</a:t>
-            </a:r>
-          </a:p>
-          <a:p>
-            <a:pPr>
-              <a:spcAft>
-                <a:spcPts val="600"/>
-              </a:spcAft>
-            </a:pPr>
-            <a:r>
-              <a:rPr sz="1600" b="1">
-                <a:solidFill>
-                  <a:srgbClr val="2563EB"/>
-                </a:solidFill>
-                <a:latin typeface="Calibri"/>
-              </a:rPr>
-              <a:t>• 7. Deployment &amp; Real-World ROI: </a:t>
-            </a:r>
-            <a:r>
-              <a:rPr sz="1600" b="0">
-                <a:solidFill>
-                  <a:srgbClr val="334155"/>
-                </a:solidFill>
-                <a:latin typeface="Calibri"/>
-              </a:rPr>
-              <a:t>Interactive predict.py diagnostic tool, cost matrix reduction &amp; future roadmap.</a:t>
+              <a:t>98.45% AUC-ROC score and 33.39 cycles RMSE.</a:t>
             </a:r>
           </a:p>
         </p:txBody>
@@ -9910,7 +9835,7 @@
         </p:nvSpPr>
         <p:spPr>
           <a:xfrm>
-            <a:off x="548640" y="365760"/>
+            <a:off x="548640" y="457200"/>
             <a:ext cx="8046720" cy="685800"/>
           </a:xfrm>
           <a:prstGeom prst="rect">
@@ -9925,7 +9850,7 @@
           <a:lstStyle/>
           <a:p>
             <a:pPr>
-              <a:defRPr sz="3400" b="1">
+              <a:defRPr sz="3600" b="1">
                 <a:solidFill>
                   <a:srgbClr val="0F172A"/>
                 </a:solidFill>
@@ -9933,7 +9858,7 @@
               </a:defRPr>
             </a:pPr>
             <a:r>
-              <a:t>Problem Statement &amp; Business Impact</a:t>
+              <a:t>Problem Statement</a:t>
             </a:r>
           </a:p>
         </p:txBody>
@@ -9982,8 +9907,8 @@
         </p:nvSpPr>
         <p:spPr>
           <a:xfrm>
-            <a:off x="548640" y="1143000"/>
-            <a:ext cx="8046720" cy="4800600"/>
+            <a:off x="548640" y="1280160"/>
+            <a:ext cx="8046720" cy="4389120"/>
           </a:xfrm>
           <a:prstGeom prst="rect">
             <a:avLst/>
@@ -9998,7 +9923,7 @@
           <a:p>
             <a:pPr>
               <a:spcAft>
-                <a:spcPts val="1000"/>
+                <a:spcPts val="1400"/>
               </a:spcAft>
               <a:defRPr sz="2000" b="1">
                 <a:solidFill>
@@ -10008,22 +9933,22 @@
               </a:defRPr>
             </a:pPr>
             <a:r>
-              <a:rPr sz="1800" b="1">
+              <a:rPr sz="2000" b="1">
                 <a:solidFill>
                   <a:srgbClr val="2563EB"/>
                 </a:solidFill>
                 <a:latin typeface="Calibri"/>
               </a:rPr>
-              <a:t>• Unscheduled Aircraft Groundings: </a:t>
-            </a:r>
-            <a:r>
-              <a:rPr sz="1800" b="0">
+              <a:t>• Unscheduled Groundings: </a:t>
+            </a:r>
+            <a:r>
+              <a:rPr sz="2000" b="0">
                 <a:solidFill>
                   <a:srgbClr val="334155"/>
                 </a:solidFill>
                 <a:latin typeface="Calibri"/>
               </a:rPr>
-              <a:t>Sudden turbofan breakdowns cause severe flight cancellations &amp; passenger delays.</a:t>
+              <a:t>Sudden turbofan breakdowns cause severe flight cancellations.</a:t>
             </a:r>
           </a:p>
           <a:p>
@@ -10081,101 +10006,101 @@
           <a:p>
             <a:pPr>
               <a:spcAft>
-                <a:spcPts val="1000"/>
-              </a:spcAft>
-            </a:pPr>
-            <a:r>
-              <a:rPr sz="1800" b="1">
+                <a:spcPts val="1400"/>
+              </a:spcAft>
+            </a:pPr>
+            <a:r>
+              <a:rPr sz="2000" b="1">
                 <a:solidFill>
                   <a:srgbClr val="2563EB"/>
                 </a:solidFill>
                 <a:latin typeface="Calibri"/>
               </a:rPr>
-              <a:t>• High Industry Cost: </a:t>
-            </a:r>
-            <a:r>
-              <a:rPr sz="1800" b="0">
+              <a:t>• High Operational Cost: </a:t>
+            </a:r>
+            <a:r>
+              <a:rPr sz="2000" b="0">
                 <a:solidFill>
                   <a:srgbClr val="334155"/>
                 </a:solidFill>
                 <a:latin typeface="Calibri"/>
               </a:rPr>
-              <a:t>A single unplanned engine diversion costs airline operators upwards of $250,000.</a:t>
-            </a:r>
-          </a:p>
-          <a:p>
-            <a:pPr>
-              <a:spcAft>
-                <a:spcPts val="1000"/>
-              </a:spcAft>
-            </a:pPr>
-            <a:r>
-              <a:rPr sz="1800" b="1">
+              <a:t>Unplanned engine diversions cost operators $250,000 each.</a:t>
+            </a:r>
+          </a:p>
+          <a:p>
+            <a:pPr>
+              <a:spcAft>
+                <a:spcPts val="1400"/>
+              </a:spcAft>
+            </a:pPr>
+            <a:r>
+              <a:rPr sz="2000" b="1">
                 <a:solidFill>
                   <a:srgbClr val="2563EB"/>
                 </a:solidFill>
                 <a:latin typeface="Calibri"/>
               </a:rPr>
-              <a:t>• Traditional Servicing Flaws: </a:t>
-            </a:r>
-            <a:r>
-              <a:rPr sz="1800" b="0">
+              <a:t>• Static Servicing Flaws: </a:t>
+            </a:r>
+            <a:r>
+              <a:rPr sz="2000" b="0">
                 <a:solidFill>
                   <a:srgbClr val="334155"/>
                 </a:solidFill>
                 <a:latin typeface="Calibri"/>
               </a:rPr>
-              <a:t>Fixed-interval maintenance replaces healthy parts early or misses catastrophic failure.</a:t>
-            </a:r>
-          </a:p>
-          <a:p>
-            <a:pPr>
-              <a:spcAft>
-                <a:spcPts val="1000"/>
-              </a:spcAft>
-            </a:pPr>
-            <a:r>
-              <a:rPr sz="1800" b="1">
+              <a:t>Fixed schedules replace healthy parts or miss breakdown.</a:t>
+            </a:r>
+          </a:p>
+          <a:p>
+            <a:pPr>
+              <a:spcAft>
+                <a:spcPts val="1400"/>
+              </a:spcAft>
+            </a:pPr>
+            <a:r>
+              <a:rPr sz="2000" b="1">
                 <a:solidFill>
                   <a:srgbClr val="2563EB"/>
                 </a:solidFill>
                 <a:latin typeface="Calibri"/>
               </a:rPr>
-              <a:t>• Complex Sensor Telemetry: </a:t>
-            </a:r>
-            <a:r>
-              <a:rPr sz="1800" b="0">
+              <a:t>• Sensor Noise Challenge: </a:t>
+            </a:r>
+            <a:r>
+              <a:rPr sz="2000" b="0">
                 <a:solidFill>
                   <a:srgbClr val="334155"/>
                 </a:solidFill>
                 <a:latin typeface="Calibri"/>
               </a:rPr>
-              <a:t>21 continuous sensor streams exhibit non-linear degradation and high signal noise.</a:t>
-            </a:r>
-          </a:p>
-          <a:p>
-            <a:pPr>
-              <a:spcAft>
-                <a:spcPts val="1000"/>
-              </a:spcAft>
-            </a:pPr>
-            <a:r>
-              <a:rPr sz="1800" b="1">
+              <a:t>21 continuous sensor streams show non-linear wear.</a:t>
+            </a:r>
+          </a:p>
+          <a:p>
+            <a:pPr>
+              <a:spcAft>
+                <a:spcPts val="1400"/>
+              </a:spcAft>
+            </a:pPr>
+            <a:r>
+              <a:rPr sz="2000" b="1">
                 <a:solidFill>
                   <a:srgbClr val="2563EB"/>
                 </a:solidFill>
                 <a:latin typeface="Calibri"/>
               </a:rPr>
-              <a:t>• Prognostic Solution Need: </a:t>
-            </a:r>
-            <a:r>
-              <a:rPr sz="1800" b="0">
+              <a:t>• Prognostic Solution: </a:t>
+            </a:r>
+            <a:r>
+              <a:rPr sz="2000" b="0">
                 <a:solidFill>
                   <a:srgbClr val="334155"/>
                 </a:solidFill>
                 <a:latin typeface="Calibri"/>
               </a:rPr>
-              <a:t>Requires real-time AI to forecast exact Remaining Useful Life (RUL) cycles.</a:t>
+              <a:t>Requires real-time AI to forecast remaining life.</a:t>
             </a:r>
           </a:p>
         </p:txBody>
@@ -10206,7 +10131,7 @@
         </p:nvSpPr>
         <p:spPr>
           <a:xfrm>
-            <a:off x="548640" y="365760"/>
+            <a:off x="548640" y="457200"/>
             <a:ext cx="8046720" cy="685800"/>
           </a:xfrm>
           <a:prstGeom prst="rect">
@@ -10221,7 +10146,7 @@
           <a:lstStyle/>
           <a:p>
             <a:pPr>
-              <a:defRPr sz="3400" b="1">
+              <a:defRPr sz="3600" b="1">
                 <a:solidFill>
                   <a:srgbClr val="0F172A"/>
                 </a:solidFill>
@@ -10229,7 +10154,7 @@
               </a:defRPr>
             </a:pPr>
             <a:r>
-              <a:t>Project Objectives &amp; Scope</a:t>
+              <a:t>Project Objectives</a:t>
             </a:r>
           </a:p>
         </p:txBody>
@@ -10278,8 +10203,8 @@
         </p:nvSpPr>
         <p:spPr>
           <a:xfrm>
-            <a:off x="548640" y="1143000"/>
-            <a:ext cx="8046720" cy="4800600"/>
+            <a:off x="548640" y="1280160"/>
+            <a:ext cx="8046720" cy="4389120"/>
           </a:xfrm>
           <a:prstGeom prst="rect">
             <a:avLst/>
@@ -10294,7 +10219,7 @@
           <a:p>
             <a:pPr>
               <a:spcAft>
-                <a:spcPts val="1000"/>
+                <a:spcPts val="1400"/>
               </a:spcAft>
               <a:defRPr sz="2000" b="1">
                 <a:solidFill>
@@ -10304,22 +10229,22 @@
               </a:defRPr>
             </a:pPr>
             <a:r>
-              <a:rPr sz="1800" b="1">
+              <a:rPr sz="2000" b="1">
                 <a:solidFill>
                   <a:srgbClr val="2563EB"/>
                 </a:solidFill>
                 <a:latin typeface="Calibri"/>
               </a:rPr>
-              <a:t>• RUL Regression Forecasting: </a:t>
-            </a:r>
-            <a:r>
-              <a:rPr sz="1800" b="0">
+              <a:t>• RUL Forecasting: </a:t>
+            </a:r>
+            <a:r>
+              <a:rPr sz="2000" b="0">
                 <a:solidFill>
                   <a:srgbClr val="334155"/>
                 </a:solidFill>
                 <a:latin typeface="Calibri"/>
               </a:rPr>
-              <a:t>Train ML models to predict exact operational cycles remaining before breakdown.</a:t>
+              <a:t>Predict exact operational cycles remaining before failure.</a:t>
             </a:r>
           </a:p>
           <a:p>
@@ -10377,101 +10302,101 @@
           <a:p>
             <a:pPr>
               <a:spcAft>
-                <a:spcPts val="1000"/>
-              </a:spcAft>
-            </a:pPr>
-            <a:r>
-              <a:rPr sz="1800" b="1">
+                <a:spcPts val="1400"/>
+              </a:spcAft>
+            </a:pPr>
+            <a:r>
+              <a:rPr sz="2000" b="1">
                 <a:solidFill>
                   <a:srgbClr val="2563EB"/>
                 </a:solidFill>
                 <a:latin typeface="Calibri"/>
               </a:rPr>
-              <a:t>• 30-Day Failure Warning Alert: </a:t>
-            </a:r>
-            <a:r>
-              <a:rPr sz="1800" b="0">
+              <a:t>• 30-Day Warning Alert: </a:t>
+            </a:r>
+            <a:r>
+              <a:rPr sz="2000" b="0">
                 <a:solidFill>
                   <a:srgbClr val="334155"/>
                 </a:solidFill>
                 <a:latin typeface="Calibri"/>
               </a:rPr>
-              <a:t>Achieve &gt;95% precision on binary classification warnings for 30-cycle windows.</a:t>
-            </a:r>
-          </a:p>
-          <a:p>
-            <a:pPr>
-              <a:spcAft>
-                <a:spcPts val="1000"/>
-              </a:spcAft>
-            </a:pPr>
-            <a:r>
-              <a:rPr sz="1800" b="1">
+              <a:t>Achieve 98.45% AUC-ROC on binary warning alerts.</a:t>
+            </a:r>
+          </a:p>
+          <a:p>
+            <a:pPr>
+              <a:spcAft>
+                <a:spcPts val="1400"/>
+              </a:spcAft>
+            </a:pPr>
+            <a:r>
+              <a:rPr sz="2000" b="1">
                 <a:solidFill>
                   <a:srgbClr val="2563EB"/>
                 </a:solidFill>
                 <a:latin typeface="Calibri"/>
               </a:rPr>
-              <a:t>• 3-Tier Hazard Risk Net: </a:t>
-            </a:r>
-            <a:r>
-              <a:rPr sz="1800" b="0">
+              <a:t>• 3-Tier Hazard Net: </a:t>
+            </a:r>
+            <a:r>
+              <a:rPr sz="2000" b="0">
                 <a:solidFill>
                   <a:srgbClr val="334155"/>
                 </a:solidFill>
                 <a:latin typeface="Calibri"/>
               </a:rPr>
-              <a:t>Deploy Neural MLP classifying fleet health into Healthy, Warning, and Critical.</a:t>
-            </a:r>
-          </a:p>
-          <a:p>
-            <a:pPr>
-              <a:spcAft>
-                <a:spcPts val="1000"/>
-              </a:spcAft>
-            </a:pPr>
-            <a:r>
-              <a:rPr sz="1800" b="1">
+              <a:t>Classify fleet health into Healthy, Warning, Critical.</a:t>
+            </a:r>
+          </a:p>
+          <a:p>
+            <a:pPr>
+              <a:spcAft>
+                <a:spcPts val="1400"/>
+              </a:spcAft>
+            </a:pPr>
+            <a:r>
+              <a:rPr sz="2000" b="1">
                 <a:solidFill>
                   <a:srgbClr val="2563EB"/>
                 </a:solidFill>
                 <a:latin typeface="Calibri"/>
               </a:rPr>
-              <a:t>• Sub-30ms Real-Time Inference: </a:t>
-            </a:r>
-            <a:r>
-              <a:rPr sz="1800" b="0">
+              <a:t>• Real-Time Diagnostics: </a:t>
+            </a:r>
+            <a:r>
+              <a:rPr sz="2000" b="0">
                 <a:solidFill>
                   <a:srgbClr val="334155"/>
                 </a:solidFill>
                 <a:latin typeface="Calibri"/>
               </a:rPr>
-              <a:t>Build lightweight CLI runner (predict.py) for instantaneous field diagnostics.</a:t>
-            </a:r>
-          </a:p>
-          <a:p>
-            <a:pPr>
-              <a:spcAft>
-                <a:spcPts val="1000"/>
-              </a:spcAft>
-            </a:pPr>
-            <a:r>
-              <a:rPr sz="1800" b="1">
+              <a:t>Deliver sub-30ms CLI runner for instant diagnostics.</a:t>
+            </a:r>
+          </a:p>
+          <a:p>
+            <a:pPr>
+              <a:spcAft>
+                <a:spcPts val="1400"/>
+              </a:spcAft>
+            </a:pPr>
+            <a:r>
+              <a:rPr sz="2000" b="1">
                 <a:solidFill>
                   <a:srgbClr val="2563EB"/>
                 </a:solidFill>
                 <a:latin typeface="Calibri"/>
               </a:rPr>
-              <a:t>• Fleet Cost Optimization: </a:t>
-            </a:r>
-            <a:r>
-              <a:rPr sz="1800" b="0">
+              <a:t>• Cost Optimization: </a:t>
+            </a:r>
+            <a:r>
+              <a:rPr sz="2000" b="0">
                 <a:solidFill>
                   <a:srgbClr val="334155"/>
                 </a:solidFill>
                 <a:latin typeface="Calibri"/>
               </a:rPr>
-              <a:t>Provide actionable decision tools to eliminate unscheduled engine overhauls.</a:t>
+              <a:t>Eliminate unscheduled engine overhauls and diversions.</a:t>
             </a:r>
           </a:p>
         </p:txBody>
@@ -10502,7 +10427,7 @@
         </p:nvSpPr>
         <p:spPr>
           <a:xfrm>
-            <a:off x="548640" y="365760"/>
+            <a:off x="548640" y="457200"/>
             <a:ext cx="8046720" cy="685800"/>
           </a:xfrm>
           <a:prstGeom prst="rect">
@@ -10517,7 +10442,7 @@
           <a:lstStyle/>
           <a:p>
             <a:pPr>
-              <a:defRPr sz="3400" b="1">
+              <a:defRPr sz="3600" b="1">
                 <a:solidFill>
                   <a:srgbClr val="0F172A"/>
                 </a:solidFill>
@@ -10525,7 +10450,7 @@
               </a:defRPr>
             </a:pPr>
             <a:r>
-              <a:t>Existing System vs. AI Predictive Maintenance</a:t>
+              <a:t>Existing vs. Proposed System</a:t>
             </a:r>
           </a:p>
         </p:txBody>
@@ -10574,8 +10499,8 @@
         </p:nvSpPr>
         <p:spPr>
           <a:xfrm>
-            <a:off x="548640" y="1143000"/>
-            <a:ext cx="8046720" cy="4800600"/>
+            <a:off x="548640" y="1280160"/>
+            <a:ext cx="8046720" cy="4389120"/>
           </a:xfrm>
           <a:prstGeom prst="rect">
             <a:avLst/>
@@ -10590,7 +10515,7 @@
           <a:p>
             <a:pPr>
               <a:spcAft>
-                <a:spcPts val="1000"/>
+                <a:spcPts val="1400"/>
               </a:spcAft>
               <a:defRPr sz="2000" b="1">
                 <a:solidFill>
@@ -10600,22 +10525,22 @@
               </a:defRPr>
             </a:pPr>
             <a:r>
-              <a:rPr sz="1800" b="1">
+              <a:rPr sz="2000" b="1">
                 <a:solidFill>
                   <a:srgbClr val="2563EB"/>
                 </a:solidFill>
                 <a:latin typeface="Calibri"/>
               </a:rPr>
-              <a:t>• Traditional Static Servicing: </a:t>
-            </a:r>
-            <a:r>
-              <a:rPr sz="1800" b="0">
+              <a:t>• Traditional Servicing: </a:t>
+            </a:r>
+            <a:r>
+              <a:rPr sz="2000" b="0">
                 <a:solidFill>
                   <a:srgbClr val="334155"/>
                 </a:solidFill>
                 <a:latin typeface="Calibri"/>
               </a:rPr>
-              <a:t>Relies on fixed flight-hour intervals regardless of actual engine health.</a:t>
+              <a:t>Fixed flight-hour intervals ignore actual engine wear.</a:t>
             </a:r>
           </a:p>
           <a:p>
@@ -10673,101 +10598,101 @@
           <a:p>
             <a:pPr>
               <a:spcAft>
-                <a:spcPts val="1000"/>
-              </a:spcAft>
-            </a:pPr>
-            <a:r>
-              <a:rPr sz="1800" b="1">
+                <a:spcPts val="1400"/>
+              </a:spcAft>
+            </a:pPr>
+            <a:r>
+              <a:rPr sz="2000" b="1">
                 <a:solidFill>
                   <a:srgbClr val="2563EB"/>
                 </a:solidFill>
                 <a:latin typeface="Calibri"/>
               </a:rPr>
-              <a:t>• Reactive Break-Fix Model: </a:t>
-            </a:r>
-            <a:r>
-              <a:rPr sz="1800" b="0">
+              <a:t>• Reactive Maintenance: </a:t>
+            </a:r>
+            <a:r>
+              <a:rPr sz="2000" b="0">
                 <a:solidFill>
                   <a:srgbClr val="334155"/>
                 </a:solidFill>
                 <a:latin typeface="Calibri"/>
               </a:rPr>
-              <a:t>Triggers maintenance only after catastrophic engine failure occurs in flight.</a:t>
-            </a:r>
-          </a:p>
-          <a:p>
-            <a:pPr>
-              <a:spcAft>
-                <a:spcPts val="1000"/>
-              </a:spcAft>
-            </a:pPr>
-            <a:r>
-              <a:rPr sz="1800" b="1">
+              <a:t>Triggers repair only after catastrophic in-flight failure.</a:t>
+            </a:r>
+          </a:p>
+          <a:p>
+            <a:pPr>
+              <a:spcAft>
+                <a:spcPts val="1400"/>
+              </a:spcAft>
+            </a:pPr>
+            <a:r>
+              <a:rPr sz="2000" b="1">
                 <a:solidFill>
                   <a:srgbClr val="2563EB"/>
                 </a:solidFill>
                 <a:latin typeface="Calibri"/>
               </a:rPr>
-              <a:t>• AI Predictive Maintenance (Proposed): </a:t>
-            </a:r>
-            <a:r>
-              <a:rPr sz="1800" b="0">
+              <a:t>• Proposed AI System: </a:t>
+            </a:r>
+            <a:r>
+              <a:rPr sz="2000" b="0">
                 <a:solidFill>
                   <a:srgbClr val="334155"/>
                 </a:solidFill>
                 <a:latin typeface="Calibri"/>
               </a:rPr>
-              <a:t>Continuously monitors 21 telemetry streams to forecast RUL.</a:t>
-            </a:r>
-          </a:p>
-          <a:p>
-            <a:pPr>
-              <a:spcAft>
-                <a:spcPts val="1000"/>
-              </a:spcAft>
-            </a:pPr>
-            <a:r>
-              <a:rPr sz="1800" b="1">
+              <a:t>Monitors 21 live telemetry streams continuously.</a:t>
+            </a:r>
+          </a:p>
+          <a:p>
+            <a:pPr>
+              <a:spcAft>
+                <a:spcPts val="1400"/>
+              </a:spcAft>
+            </a:pPr>
+            <a:r>
+              <a:rPr sz="2000" b="1">
                 <a:solidFill>
                   <a:srgbClr val="2563EB"/>
                 </a:solidFill>
                 <a:latin typeface="Calibri"/>
               </a:rPr>
-              <a:t>• Proactive Hazard Scheduling: </a:t>
-            </a:r>
-            <a:r>
-              <a:rPr sz="1800" b="0">
+              <a:t>• Proactive Scheduling: </a:t>
+            </a:r>
+            <a:r>
+              <a:rPr sz="2000" b="0">
                 <a:solidFill>
                   <a:srgbClr val="334155"/>
                 </a:solidFill>
                 <a:latin typeface="Calibri"/>
               </a:rPr>
-              <a:t>Schedules minor $15,000 preventive maintenance before major breakdown.</a:t>
-            </a:r>
-          </a:p>
-          <a:p>
-            <a:pPr>
-              <a:spcAft>
-                <a:spcPts val="1000"/>
-              </a:spcAft>
-            </a:pPr>
-            <a:r>
-              <a:rPr sz="1800" b="1">
+              <a:t>Schedules minor $15k repairs before breakdown.</a:t>
+            </a:r>
+          </a:p>
+          <a:p>
+            <a:pPr>
+              <a:spcAft>
+                <a:spcPts val="1400"/>
+              </a:spcAft>
+            </a:pPr>
+            <a:r>
+              <a:rPr sz="2000" b="1">
                 <a:solidFill>
                   <a:srgbClr val="2563EB"/>
                 </a:solidFill>
                 <a:latin typeface="Calibri"/>
               </a:rPr>
-              <a:t>• Key Operational Advantage: </a:t>
-            </a:r>
-            <a:r>
-              <a:rPr sz="1800" b="0">
+              <a:t>• Cost Savings: </a:t>
+            </a:r>
+            <a:r>
+              <a:rPr sz="2000" b="0">
                 <a:solidFill>
                   <a:srgbClr val="334155"/>
                 </a:solidFill>
                 <a:latin typeface="Calibri"/>
               </a:rPr>
-              <a:t>Eliminates $250k emergency diversions and extends overall fleet engine lifespan.</a:t>
+              <a:t>Prevents $250k emergency diversions and flight delays.</a:t>
             </a:r>
           </a:p>
         </p:txBody>
@@ -10798,8 +10723,8 @@
         </p:nvSpPr>
         <p:spPr>
           <a:xfrm>
-            <a:off x="548640" y="365760"/>
-            <a:ext cx="8046720" cy="640080"/>
+            <a:off x="548640" y="457200"/>
+            <a:ext cx="8046720" cy="685800"/>
           </a:xfrm>
           <a:prstGeom prst="rect">
             <a:avLst/>
@@ -10813,7 +10738,7 @@
           <a:lstStyle/>
           <a:p>
             <a:pPr>
-              <a:defRPr sz="3400" b="1">
+              <a:defRPr sz="3600" b="1">
                 <a:solidFill>
                   <a:srgbClr val="0F172A"/>
                 </a:solidFill>
@@ -10870,8 +10795,8 @@
         </p:nvSpPr>
         <p:spPr>
           <a:xfrm>
-            <a:off x="548640" y="1097280"/>
-            <a:ext cx="3657600" cy="4754880"/>
+            <a:off x="548640" y="1280160"/>
+            <a:ext cx="3657600" cy="4389120"/>
           </a:xfrm>
           <a:prstGeom prst="rect">
             <a:avLst/>
@@ -10886,11 +10811,11 @@
           <a:p>
             <a:pPr>
               <a:spcAft>
-                <a:spcPts val="800"/>
-              </a:spcAft>
-            </a:pPr>
-            <a:r>
-              <a:rPr sz="1500" b="1">
+                <a:spcPts val="1200"/>
+              </a:spcAft>
+            </a:pPr>
+            <a:r>
+              <a:rPr sz="1800" b="1">
                 <a:solidFill>
                   <a:srgbClr val="2563EB"/>
                 </a:solidFill>
@@ -10899,23 +10824,23 @@
               <a:t>• Stage 1 Ingestion: </a:t>
             </a:r>
             <a:r>
-              <a:rPr sz="1500" b="0">
+              <a:rPr sz="1800" b="0">
                 <a:solidFill>
                   <a:srgbClr val="334155"/>
                 </a:solidFill>
                 <a:latin typeface="Calibri"/>
               </a:rPr>
-              <a:t>NASA C-MAPSS telemetry dataset with 21 sensors &amp; 3 settings.</a:t>
-            </a:r>
-          </a:p>
-          <a:p>
-            <a:pPr>
-              <a:spcAft>
-                <a:spcPts val="800"/>
-              </a:spcAft>
-            </a:pPr>
-            <a:r>
-              <a:rPr sz="1500" b="1">
+              <a:t>NASA C-MAPSS telemetry dataset.</a:t>
+            </a:r>
+          </a:p>
+          <a:p>
+            <a:pPr>
+              <a:spcAft>
+                <a:spcPts val="1200"/>
+              </a:spcAft>
+            </a:pPr>
+            <a:r>
+              <a:rPr sz="1800" b="1">
                 <a:solidFill>
                   <a:srgbClr val="2563EB"/>
                 </a:solidFill>
@@ -10924,23 +10849,23 @@
               <a:t>• Stage 2 Preprocessing: </a:t>
             </a:r>
             <a:r>
-              <a:rPr sz="1500" b="0">
+              <a:rPr sz="1800" b="0">
                 <a:solidFill>
                   <a:srgbClr val="334155"/>
                 </a:solidFill>
                 <a:latin typeface="Calibri"/>
               </a:rPr>
-              <a:t>5-cycle rolling mean &amp; standard deviation aggregations.</a:t>
-            </a:r>
-          </a:p>
-          <a:p>
-            <a:pPr>
-              <a:spcAft>
-                <a:spcPts val="800"/>
-              </a:spcAft>
-            </a:pPr>
-            <a:r>
-              <a:rPr sz="1500" b="1">
+              <a:t>5-cycle rolling mean and std.</a:t>
+            </a:r>
+          </a:p>
+          <a:p>
+            <a:pPr>
+              <a:spcAft>
+                <a:spcPts val="1200"/>
+              </a:spcAft>
+            </a:pPr>
+            <a:r>
+              <a:rPr sz="1800" b="1">
                 <a:solidFill>
                   <a:srgbClr val="2563EB"/>
                 </a:solidFill>
@@ -10949,48 +10874,48 @@
               <a:t>• Stage 3 Filter: </a:t>
             </a:r>
             <a:r>
-              <a:rPr sz="1500" b="0">
+              <a:rPr sz="1800" b="0">
                 <a:solidFill>
                   <a:srgbClr val="334155"/>
                 </a:solidFill>
                 <a:latin typeface="Calibri"/>
               </a:rPr>
-              <a:t>Eliminates redundant sensor pairs with correlation r &gt; 0.80.</a:t>
-            </a:r>
-          </a:p>
-          <a:p>
-            <a:pPr>
-              <a:spcAft>
-                <a:spcPts val="800"/>
-              </a:spcAft>
-            </a:pPr>
-            <a:r>
-              <a:rPr sz="1500" b="1">
+              <a:t>Removes correlation pairs r &gt; 0.80.</a:t>
+            </a:r>
+          </a:p>
+          <a:p>
+            <a:pPr>
+              <a:spcAft>
+                <a:spcPts val="1200"/>
+              </a:spcAft>
+            </a:pPr>
+            <a:r>
+              <a:rPr sz="1800" b="1">
                 <a:solidFill>
                   <a:srgbClr val="2563EB"/>
                 </a:solidFill>
                 <a:latin typeface="Calibri"/>
               </a:rPr>
-              <a:t>• Stage 4 AI Inference: </a:t>
-            </a:r>
-            <a:r>
-              <a:rPr sz="1500" b="0">
+              <a:t>• Stage 4 AI Engine: </a:t>
+            </a:r>
+            <a:r>
+              <a:rPr sz="1800" b="0">
                 <a:solidFill>
                   <a:srgbClr val="334155"/>
                 </a:solidFill>
                 <a:latin typeface="Calibri"/>
               </a:rPr>
-              <a:t>Tri-model engine: RUL Regressor, Binary 30d Classifier &amp; Neural MLP.</a:t>
-            </a:r>
-          </a:p>
-          <a:p>
-            <a:pPr>
-              <a:spcAft>
-                <a:spcPts val="800"/>
-              </a:spcAft>
-            </a:pPr>
-            <a:r>
-              <a:rPr sz="1500" b="1">
+              <a:t>Tri-model regression and classifier.</a:t>
+            </a:r>
+          </a:p>
+          <a:p>
+            <a:pPr>
+              <a:spcAft>
+                <a:spcPts val="1200"/>
+              </a:spcAft>
+            </a:pPr>
+            <a:r>
+              <a:rPr sz="1800" b="1">
                 <a:solidFill>
                   <a:srgbClr val="2563EB"/>
                 </a:solidFill>
@@ -10999,13 +10924,13 @@
               <a:t>• Stage 5 Actionable Report: </a:t>
             </a:r>
             <a:r>
-              <a:rPr sz="1500" b="0">
+              <a:rPr sz="1800" b="0">
                 <a:solidFill>
                   <a:srgbClr val="334155"/>
                 </a:solidFill>
                 <a:latin typeface="Calibri"/>
               </a:rPr>
-              <a:t>Computes health score, cost optimization &amp; fleet maintenance schedule.</a:t>
+              <a:t>Fleet health score and dispatch.</a:t>
             </a:r>
           </a:p>
         </p:txBody>
@@ -11060,8 +10985,8 @@
         </p:nvSpPr>
         <p:spPr>
           <a:xfrm>
-            <a:off x="548640" y="365760"/>
-            <a:ext cx="8046720" cy="640080"/>
+            <a:off x="548640" y="457200"/>
+            <a:ext cx="8046720" cy="685800"/>
           </a:xfrm>
           <a:prstGeom prst="rect">
             <a:avLst/>
@@ -11075,7 +11000,7 @@
           <a:lstStyle/>
           <a:p>
             <a:pPr>
-              <a:defRPr sz="3400" b="1">
+              <a:defRPr sz="3600" b="1">
                 <a:solidFill>
                   <a:srgbClr val="0F172A"/>
                 </a:solidFill>
@@ -11083,7 +11008,7 @@
               </a:defRPr>
             </a:pPr>
             <a:r>
-              <a:t>Technology Stack &amp; Layer Architecture</a:t>
+              <a:t>Technology Stack</a:t>
             </a:r>
           </a:p>
         </p:txBody>
@@ -11133,8 +11058,8 @@
           <p:nvPr/>
         </p:nvGraphicFramePr>
         <p:xfrm>
-          <a:off x="548640" y="1188720"/>
-          <a:ext cx="8046720" cy="4572000"/>
+          <a:off x="548640" y="1280160"/>
+          <a:ext cx="8046720" cy="4389120"/>
         </p:xfrm>
         <a:graphic>
           <a:graphicData uri="http://schemas.openxmlformats.org/drawingml/2006/table">
@@ -11148,7 +11073,7 @@
                 <a:gridCol w="2468880"/>
                 <a:gridCol w="1645920"/>
               </a:tblGrid>
-              <a:tr h="653142">
+              <a:tr h="627017">
                 <a:tc>
                   <a:txBody>
                     <a:bodyPr/>
@@ -11187,7 +11112,7 @@
                         </a:defRPr>
                       </a:pPr>
                       <a:r>
-                        <a:t>Technology / Library</a:t>
+                        <a:t>Technology</a:t>
                       </a:r>
                     </a:p>
                   </a:txBody>
@@ -11235,7 +11160,7 @@
                         </a:defRPr>
                       </a:pPr>
                       <a:r>
-                        <a:t>Version / Spec</a:t>
+                        <a:t>Version</a:t>
                       </a:r>
                     </a:p>
                   </a:txBody>
@@ -11246,7 +11171,7 @@
                   </a:tcPr>
                 </a:tc>
               </a:tr>
-              <a:tr h="653142">
+              <a:tr h="627017">
                 <a:tc>
                   <a:txBody>
                     <a:bodyPr/>
@@ -11261,7 +11186,7 @@
                         </a:defRPr>
                       </a:pPr>
                       <a:r>
-                        <a:t>Programming Language</a:t>
+                        <a:t>Language</a:t>
                       </a:r>
                     </a:p>
                   </a:txBody>
@@ -11309,7 +11234,7 @@
                         </a:defRPr>
                       </a:pPr>
                       <a:r>
-                        <a:t>Engine logic, wrangling, predictive algorithms</a:t>
+                        <a:t>Engine logic and predictive algorithms</a:t>
                       </a:r>
                     </a:p>
                   </a:txBody>
@@ -11333,7 +11258,7 @@
                         </a:defRPr>
                       </a:pPr>
                       <a:r>
-                        <a:t>Python 3.11+</a:t>
+                        <a:t>3.11+</a:t>
                       </a:r>
                     </a:p>
                   </a:txBody>
@@ -11344,7 +11269,7 @@
                   </a:tcPr>
                 </a:tc>
               </a:tr>
-              <a:tr h="653142">
+              <a:tr h="627017">
                 <a:tc>
                   <a:txBody>
                     <a:bodyPr/>
@@ -11383,7 +11308,7 @@
                         </a:defRPr>
                       </a:pPr>
                       <a:r>
-                        <a:t>Scikit-Learn framework</a:t>
+                        <a:t>Scikit-Learn</a:t>
                       </a:r>
                     </a:p>
                   </a:txBody>
@@ -11442,7 +11367,7 @@
                   </a:tcPr>
                 </a:tc>
               </a:tr>
-              <a:tr h="653142">
+              <a:tr h="627017">
                 <a:tc>
                   <a:txBody>
                     <a:bodyPr/>
@@ -11505,7 +11430,7 @@
                         </a:defRPr>
                       </a:pPr>
                       <a:r>
-                        <a:t>5-cycle rolling aggregations &amp; matrix ops</a:t>
+                        <a:t>5-cycle rolling aggregations</a:t>
                       </a:r>
                     </a:p>
                   </a:txBody>
@@ -11529,7 +11454,7 @@
                         </a:defRPr>
                       </a:pPr>
                       <a:r>
-                        <a:t>Pandas 2.2</a:t>
+                        <a:t>v2.2.0</a:t>
                       </a:r>
                     </a:p>
                   </a:txBody>
@@ -11540,7 +11465,7 @@
                   </a:tcPr>
                 </a:tc>
               </a:tr>
-              <a:tr h="653142">
+              <a:tr h="627017">
                 <a:tc>
                   <a:txBody>
                     <a:bodyPr/>
@@ -11579,7 +11504,7 @@
                         </a:defRPr>
                       </a:pPr>
                       <a:r>
-                        <a:t>SciPy Signal Package</a:t>
+                        <a:t>SciPy Signal</a:t>
                       </a:r>
                     </a:p>
                   </a:txBody>
@@ -11603,7 +11528,7 @@
                         </a:defRPr>
                       </a:pPr>
                       <a:r>
-                        <a:t>Noise reduction &amp; correlation matrix filter</a:t>
+                        <a:t>Noise reduction and correlation filter</a:t>
                       </a:r>
                     </a:p>
                   </a:txBody>
@@ -11627,7 +11552,7 @@
                         </a:defRPr>
                       </a:pPr>
                       <a:r>
-                        <a:t>SciPy 1.11</a:t>
+                        <a:t>v1.11</a:t>
                       </a:r>
                     </a:p>
                   </a:txBody>
@@ -11638,7 +11563,7 @@
                   </a:tcPr>
                 </a:tc>
               </a:tr>
-              <a:tr h="653142">
+              <a:tr h="627017">
                 <a:tc>
                   <a:txBody>
                     <a:bodyPr/>
@@ -11701,7 +11626,7 @@
                         </a:defRPr>
                       </a:pPr>
                       <a:r>
-                        <a:t>Serialized model execution runner (predict.py)</a:t>
+                        <a:t>Serialized model runner predict.py</a:t>
                       </a:r>
                     </a:p>
                   </a:txBody>
@@ -11725,7 +11650,7 @@
                         </a:defRPr>
                       </a:pPr>
                       <a:r>
-                        <a:t>Native Standard</a:t>
+                        <a:t>Native</a:t>
                       </a:r>
                     </a:p>
                   </a:txBody>
@@ -11736,7 +11661,7 @@
                   </a:tcPr>
                 </a:tc>
               </a:tr>
-              <a:tr h="653148">
+              <a:tr h="627018">
                 <a:tc>
                   <a:txBody>
                     <a:bodyPr/>
@@ -11799,7 +11724,7 @@
                         </a:defRPr>
                       </a:pPr>
                       <a:r>
-                        <a:t>Publication-grade metrics, ROC/PR curves</a:t>
+                        <a:t>ROC and Precision-Recall curves</a:t>
                       </a:r>
                     </a:p>
                   </a:txBody>
@@ -11864,7 +11789,7 @@
         </p:nvSpPr>
         <p:spPr>
           <a:xfrm>
-            <a:off x="548640" y="365760"/>
+            <a:off x="548640" y="457200"/>
             <a:ext cx="8046720" cy="685800"/>
           </a:xfrm>
           <a:prstGeom prst="rect">
@@ -11879,7 +11804,7 @@
           <a:lstStyle/>
           <a:p>
             <a:pPr>
-              <a:defRPr sz="3400" b="1">
+              <a:defRPr sz="3600" b="1">
                 <a:solidFill>
                   <a:srgbClr val="0F172A"/>
                 </a:solidFill>
@@ -11887,7 +11812,7 @@
               </a:defRPr>
             </a:pPr>
             <a:r>
-              <a:t>Dataset &amp; Feature Engineering Details</a:t>
+              <a:t>Dataset Details</a:t>
             </a:r>
           </a:p>
         </p:txBody>
@@ -11936,8 +11861,8 @@
         </p:nvSpPr>
         <p:spPr>
           <a:xfrm>
-            <a:off x="548640" y="1143000"/>
-            <a:ext cx="8046720" cy="4800600"/>
+            <a:off x="548640" y="1280160"/>
+            <a:ext cx="8046720" cy="4389120"/>
           </a:xfrm>
           <a:prstGeom prst="rect">
             <a:avLst/>
@@ -11952,7 +11877,7 @@
           <a:p>
             <a:pPr>
               <a:spcAft>
-                <a:spcPts val="1000"/>
+                <a:spcPts val="1400"/>
               </a:spcAft>
               <a:defRPr sz="2000" b="1">
                 <a:solidFill>
@@ -11962,22 +11887,22 @@
               </a:defRPr>
             </a:pPr>
             <a:r>
-              <a:rPr sz="1800" b="1">
+              <a:rPr sz="2000" b="1">
                 <a:solidFill>
                   <a:srgbClr val="2563EB"/>
                 </a:solidFill>
                 <a:latin typeface="Calibri"/>
               </a:rPr>
-              <a:t>• Dataset Provider: </a:t>
-            </a:r>
-            <a:r>
-              <a:rPr sz="1800" b="0">
+              <a:t>• Data Provider: </a:t>
+            </a:r>
+            <a:r>
+              <a:rPr sz="2000" b="0">
                 <a:solidFill>
                   <a:srgbClr val="334155"/>
                 </a:solidFill>
                 <a:latin typeface="Calibri"/>
               </a:rPr>
-              <a:t>NASA Ames Prognostics Center of Excellence C-MAPSS Turbofan Dataset.</a:t>
+              <a:t>NASA Ames Prognostics C-MAPSS dataset.</a:t>
             </a:r>
           </a:p>
           <a:p>
@@ -12035,86 +11960,86 @@
           <a:p>
             <a:pPr>
               <a:spcAft>
-                <a:spcPts val="1000"/>
-              </a:spcAft>
-            </a:pPr>
-            <a:r>
-              <a:rPr sz="1800" b="1">
+                <a:spcPts val="1400"/>
+              </a:spcAft>
+            </a:pPr>
+            <a:r>
+              <a:rPr sz="2000" b="1">
                 <a:solidFill>
                   <a:srgbClr val="2563EB"/>
                 </a:solidFill>
                 <a:latin typeface="Calibri"/>
               </a:rPr>
-              <a:t>• Training Fleet Size: </a:t>
-            </a:r>
-            <a:r>
-              <a:rPr sz="1800" b="0">
+              <a:t>• Training Fleet: </a:t>
+            </a:r>
+            <a:r>
+              <a:rPr sz="2000" b="0">
                 <a:solidFill>
                   <a:srgbClr val="334155"/>
                 </a:solidFill>
                 <a:latin typeface="Calibri"/>
               </a:rPr>
-              <a:t>100 turbofan engines run-to-failure containing 20,631 operational cycles.</a:t>
-            </a:r>
-          </a:p>
-          <a:p>
-            <a:pPr>
-              <a:spcAft>
-                <a:spcPts val="1000"/>
-              </a:spcAft>
-            </a:pPr>
-            <a:r>
-              <a:rPr sz="1800" b="1">
+              <a:t>100 turbofan engines run to failure.</a:t>
+            </a:r>
+          </a:p>
+          <a:p>
+            <a:pPr>
+              <a:spcAft>
+                <a:spcPts val="1400"/>
+              </a:spcAft>
+            </a:pPr>
+            <a:r>
+              <a:rPr sz="2000" b="1">
                 <a:solidFill>
                   <a:srgbClr val="2563EB"/>
                 </a:solidFill>
                 <a:latin typeface="Calibri"/>
               </a:rPr>
-              <a:t>• Testing Fleet Size: </a:t>
-            </a:r>
-            <a:r>
-              <a:rPr sz="1800" b="0">
+              <a:t>• Testing Fleet: </a:t>
+            </a:r>
+            <a:r>
+              <a:rPr sz="2000" b="0">
                 <a:solidFill>
                   <a:srgbClr val="334155"/>
                 </a:solidFill>
                 <a:latin typeface="Calibri"/>
               </a:rPr>
-              <a:t>100 engines with ground-truth Remaining Useful Life (TTF) validation labels.</a:t>
-            </a:r>
-          </a:p>
-          <a:p>
-            <a:pPr>
-              <a:spcAft>
-                <a:spcPts val="1000"/>
-              </a:spcAft>
-            </a:pPr>
-            <a:r>
-              <a:rPr sz="1800" b="1">
+              <a:t>100 test engines with ground truth labels.</a:t>
+            </a:r>
+          </a:p>
+          <a:p>
+            <a:pPr>
+              <a:spcAft>
+                <a:spcPts val="1400"/>
+              </a:spcAft>
+            </a:pPr>
+            <a:r>
+              <a:rPr sz="2000" b="1">
                 <a:solidFill>
                   <a:srgbClr val="2563EB"/>
                 </a:solidFill>
                 <a:latin typeface="Calibri"/>
               </a:rPr>
-              <a:t>• Target Classification Windows: </a:t>
-            </a:r>
-            <a:r>
-              <a:rPr sz="1800" b="0">
+              <a:t>• Failure Windows: </a:t>
+            </a:r>
+            <a:r>
+              <a:rPr sz="2000" b="0">
                 <a:solidFill>
                   <a:srgbClr val="334155"/>
                 </a:solidFill>
                 <a:latin typeface="Calibri"/>
               </a:rPr>
-              <a:t>30-cycle failure warning window (w1 = 30) and 15-cycle urgent window (w0 = 15).</a:t>
-            </a:r>
-          </a:p>
-          <a:p>
-            <a:pPr>
-              <a:spcAft>
-                <a:spcPts val="1000"/>
-              </a:spcAft>
-            </a:pPr>
-            <a:r>
-              <a:rPr sz="1800" b="1">
+              <a:t>30-cycle warning and 15-cycle urgent window.</a:t>
+            </a:r>
+          </a:p>
+          <a:p>
+            <a:pPr>
+              <a:spcAft>
+                <a:spcPts val="1400"/>
+              </a:spcAft>
+            </a:pPr>
+            <a:r>
+              <a:rPr sz="2000" b="1">
                 <a:solidFill>
                   <a:srgbClr val="2563EB"/>
                 </a:solidFill>
@@ -12123,13 +12048,13 @@
               <a:t>• Dataset Quality: </a:t>
             </a:r>
             <a:r>
-              <a:rPr sz="1800" b="0">
+              <a:rPr sz="2000" b="0">
                 <a:solidFill>
                   <a:srgbClr val="334155"/>
                 </a:solidFill>
                 <a:latin typeface="Calibri"/>
               </a:rPr>
-              <a:t>Zero missing values, numeric sensor streams, preprocessed clean target series.</a:t>
+              <a:t>Zero missing values and clean numeric series.</a:t>
             </a:r>
           </a:p>
         </p:txBody>
@@ -12160,7 +12085,7 @@
         </p:nvSpPr>
         <p:spPr>
           <a:xfrm>
-            <a:off x="548640" y="365760"/>
+            <a:off x="548640" y="457200"/>
             <a:ext cx="8046720" cy="685800"/>
           </a:xfrm>
           <a:prstGeom prst="rect">
@@ -12175,7 +12100,7 @@
           <a:lstStyle/>
           <a:p>
             <a:pPr>
-              <a:defRPr sz="3400" b="1">
+              <a:defRPr sz="3600" b="1">
                 <a:solidFill>
                   <a:srgbClr val="0F172A"/>
                 </a:solidFill>
@@ -12183,7 +12108,7 @@
               </a:defRPr>
             </a:pPr>
             <a:r>
-              <a:t>Tri-Model Predictive AI Architecture</a:t>
+              <a:t>Tri-Model AI Architecture</a:t>
             </a:r>
           </a:p>
         </p:txBody>
@@ -12232,8 +12157,8 @@
         </p:nvSpPr>
         <p:spPr>
           <a:xfrm>
-            <a:off x="548640" y="1143000"/>
-            <a:ext cx="8046720" cy="4800600"/>
+            <a:off x="548640" y="1280160"/>
+            <a:ext cx="8046720" cy="4389120"/>
           </a:xfrm>
           <a:prstGeom prst="rect">
             <a:avLst/>
@@ -12248,7 +12173,7 @@
           <a:p>
             <a:pPr>
               <a:spcAft>
-                <a:spcPts val="1000"/>
+                <a:spcPts val="1400"/>
               </a:spcAft>
               <a:defRPr sz="2000" b="1">
                 <a:solidFill>
@@ -12258,22 +12183,22 @@
               </a:defRPr>
             </a:pPr>
             <a:r>
-              <a:rPr sz="1800" b="1">
+              <a:rPr sz="2000" b="1">
                 <a:solidFill>
                   <a:srgbClr val="2563EB"/>
                 </a:solidFill>
                 <a:latin typeface="Calibri"/>
               </a:rPr>
-              <a:t>• 1. RUL Regression Model: </a:t>
-            </a:r>
-            <a:r>
-              <a:rPr sz="1800" b="0">
+              <a:t>• RUL Regression: </a:t>
+            </a:r>
+            <a:r>
+              <a:rPr sz="2000" b="0">
                 <a:solidFill>
                   <a:srgbClr val="334155"/>
                 </a:solidFill>
                 <a:latin typeface="Calibri"/>
               </a:rPr>
-              <a:t>Random Forest Regressor predicting exact cycles remaining before failure.</a:t>
+              <a:t>Random Forest predicting exact remaining cycles.</a:t>
             </a:r>
           </a:p>
           <a:p>
@@ -12331,101 +12256,101 @@
           <a:p>
             <a:pPr>
               <a:spcAft>
-                <a:spcPts val="1000"/>
-              </a:spcAft>
-            </a:pPr>
-            <a:r>
-              <a:rPr sz="1800" b="1">
+                <a:spcPts val="1400"/>
+              </a:spcAft>
+            </a:pPr>
+            <a:r>
+              <a:rPr sz="2000" b="1">
                 <a:solidFill>
                   <a:srgbClr val="2563EB"/>
                 </a:solidFill>
                 <a:latin typeface="Calibri"/>
               </a:rPr>
-              <a:t>• 2. Binary 30-Cycle Warning Classifier: </a:t>
-            </a:r>
-            <a:r>
-              <a:rPr sz="1800" b="0">
+              <a:t>• Binary Classifier: </a:t>
+            </a:r>
+            <a:r>
+              <a:rPr sz="2000" b="0">
                 <a:solidFill>
                   <a:srgbClr val="334155"/>
                 </a:solidFill>
                 <a:latin typeface="Calibri"/>
               </a:rPr>
-              <a:t>Random Forest Classifier predicting 30d failure window.</a:t>
-            </a:r>
-          </a:p>
-          <a:p>
-            <a:pPr>
-              <a:spcAft>
-                <a:spcPts val="1000"/>
-              </a:spcAft>
-            </a:pPr>
-            <a:r>
-              <a:rPr sz="1800" b="1">
+              <a:t>Random Forest flagging 30-day failure warning.</a:t>
+            </a:r>
+          </a:p>
+          <a:p>
+            <a:pPr>
+              <a:spcAft>
+                <a:spcPts val="1400"/>
+              </a:spcAft>
+            </a:pPr>
+            <a:r>
+              <a:rPr sz="2000" b="1">
                 <a:solidFill>
                   <a:srgbClr val="2563EB"/>
                 </a:solidFill>
                 <a:latin typeface="Calibri"/>
               </a:rPr>
-              <a:t>• 3. Multi-Class Neural MLP: </a:t>
-            </a:r>
-            <a:r>
-              <a:rPr sz="1800" b="0">
+              <a:t>• Neural MLP Net: </a:t>
+            </a:r>
+            <a:r>
+              <a:rPr sz="2000" b="0">
                 <a:solidFill>
                   <a:srgbClr val="334155"/>
                 </a:solidFill>
                 <a:latin typeface="Calibri"/>
               </a:rPr>
-              <a:t>Multi-Layer Perceptron (100, 50 hidden neurons) for 3-tier hazard rating.</a:t>
-            </a:r>
-          </a:p>
-          <a:p>
-            <a:pPr>
-              <a:spcAft>
-                <a:spcPts val="1000"/>
-              </a:spcAft>
-            </a:pPr>
-            <a:r>
-              <a:rPr sz="1800" b="1">
+              <a:t>Multi-Layer Perceptron for 3-tier risk rating.</a:t>
+            </a:r>
+          </a:p>
+          <a:p>
+            <a:pPr>
+              <a:spcAft>
+                <a:spcPts val="1400"/>
+              </a:spcAft>
+            </a:pPr>
+            <a:r>
+              <a:rPr sz="2000" b="1">
                 <a:solidFill>
                   <a:srgbClr val="2563EB"/>
                 </a:solidFill>
                 <a:latin typeface="Calibri"/>
               </a:rPr>
-              <a:t>• Multi-Tier Hazard Classes: </a:t>
-            </a:r>
-            <a:r>
-              <a:rPr sz="1800" b="0">
+              <a:t>• Risk Classes: </a:t>
+            </a:r>
+            <a:r>
+              <a:rPr sz="2000" b="0">
                 <a:solidFill>
                   <a:srgbClr val="334155"/>
                 </a:solidFill>
                 <a:latin typeface="Calibri"/>
               </a:rPr>
-              <a:t>Healthy (&gt;30 cycles), Warning (15-30 cycles), Critical (&lt;=15 cycles).</a:t>
-            </a:r>
-          </a:p>
-          <a:p>
-            <a:pPr>
-              <a:spcAft>
-                <a:spcPts val="1000"/>
-              </a:spcAft>
-            </a:pPr>
-            <a:r>
-              <a:rPr sz="1800" b="1">
+              <a:t>Healthy (&gt;30d), Warning (15-30d), Critical (&lt;=15d).</a:t>
+            </a:r>
+          </a:p>
+          <a:p>
+            <a:pPr>
+              <a:spcAft>
+                <a:spcPts val="1400"/>
+              </a:spcAft>
+            </a:pPr>
+            <a:r>
+              <a:rPr sz="2000" b="1">
                 <a:solidFill>
                   <a:srgbClr val="2563EB"/>
                 </a:solidFill>
                 <a:latin typeface="Calibri"/>
               </a:rPr>
-              <a:t>• Softmax Risk Output: </a:t>
-            </a:r>
-            <a:r>
-              <a:rPr sz="1800" b="0">
+              <a:t>• Softmax Output: </a:t>
+            </a:r>
+            <a:r>
+              <a:rPr sz="2000" b="0">
                 <a:solidFill>
                   <a:srgbClr val="334155"/>
                 </a:solidFill>
                 <a:latin typeface="Calibri"/>
               </a:rPr>
-              <a:t>Neural net produces normalized probability distributions over risk categories.</a:t>
+              <a:t>Produces normalized probability distributions.</a:t>
             </a:r>
           </a:p>
         </p:txBody>

</xml_diff>

<commit_message>
Apply PowerPoint Designer AI layout engine rules with card grids, icon indicators, and zero blank space
</commit_message>
<xml_diff>
--- a/Internship Presentation PPTs Template Final.pptx
+++ b/Internship Presentation PPTs Template Final.pptx
@@ -5666,13 +5666,22 @@
           <a:p>
             <a:pPr algn="ctr"/>
             <a:r>
+              <a:rPr sz="1600" b="1">
+                <a:solidFill>
+                  <a:srgbClr val="38BDF8"/>
+                </a:solidFill>
+                <a:latin typeface="Calibri"/>
+              </a:rPr>
+              <a:t>[MODULE]  </a:t>
+            </a:r>
+            <a:r>
               <a:rPr sz="1800" b="1">
                 <a:solidFill>
                   <a:srgbClr val="2563EB"/>
                 </a:solidFill>
                 <a:latin typeface="Calibri"/>
               </a:rPr>
-              <a:t>• CLI Diagnostic Tool: </a:t>
+              <a:t>CLI Diagnostic Tool: </a:t>
             </a:r>
             <a:r>
               <a:rPr sz="1800" b="0">
@@ -5729,13 +5738,22 @@
           <a:p>
             <a:pPr algn="ctr"/>
             <a:r>
+              <a:rPr sz="1600" b="1">
+                <a:solidFill>
+                  <a:srgbClr val="38BDF8"/>
+                </a:solidFill>
+                <a:latin typeface="Calibri"/>
+              </a:rPr>
+              <a:t>[RUN]  </a:t>
+            </a:r>
+            <a:r>
               <a:rPr sz="1800" b="1">
                 <a:solidFill>
                   <a:srgbClr val="2563EB"/>
                 </a:solidFill>
                 <a:latin typeface="Calibri"/>
               </a:rPr>
-              <a:t>• Execution Command: </a:t>
+              <a:t>Execution Command: </a:t>
             </a:r>
             <a:r>
               <a:rPr sz="1800" b="0">
@@ -5792,13 +5810,22 @@
           <a:p>
             <a:pPr algn="ctr"/>
             <a:r>
+              <a:rPr sz="1600" b="1">
+                <a:solidFill>
+                  <a:srgbClr val="38BDF8"/>
+                </a:solidFill>
+                <a:latin typeface="Calibri"/>
+              </a:rPr>
+              <a:t>[PARAMS]  </a:t>
+            </a:r>
+            <a:r>
               <a:rPr sz="1800" b="1">
                 <a:solidFill>
                   <a:srgbClr val="2563EB"/>
                 </a:solidFill>
                 <a:latin typeface="Calibri"/>
               </a:rPr>
-              <a:t>• Output Parameters: </a:t>
+              <a:t>Output Parameters: </a:t>
             </a:r>
             <a:r>
               <a:rPr sz="1800" b="0">
@@ -5855,13 +5882,22 @@
           <a:p>
             <a:pPr algn="ctr"/>
             <a:r>
+              <a:rPr sz="1600" b="1">
+                <a:solidFill>
+                  <a:srgbClr val="38BDF8"/>
+                </a:solidFill>
+                <a:latin typeface="Calibri"/>
+              </a:rPr>
+              <a:t>[STATUS]  </a:t>
+            </a:r>
+            <a:r>
               <a:rPr sz="1800" b="1">
                 <a:solidFill>
                   <a:srgbClr val="2563EB"/>
                 </a:solidFill>
                 <a:latin typeface="Calibri"/>
               </a:rPr>
-              <a:t>• Status Formatting: </a:t>
+              <a:t>Status Formatting: </a:t>
             </a:r>
             <a:r>
               <a:rPr sz="1800" b="0">
@@ -5918,13 +5954,22 @@
           <a:p>
             <a:pPr algn="ctr"/>
             <a:r>
+              <a:rPr sz="1600" b="1">
+                <a:solidFill>
+                  <a:srgbClr val="38BDF8"/>
+                </a:solidFill>
+                <a:latin typeface="Calibri"/>
+              </a:rPr>
+              <a:t>[ACTION]  </a:t>
+            </a:r>
+            <a:r>
               <a:rPr sz="1800" b="1">
                 <a:solidFill>
                   <a:srgbClr val="2563EB"/>
                 </a:solidFill>
                 <a:latin typeface="Calibri"/>
               </a:rPr>
-              <a:t>• Actionable Guidance: </a:t>
+              <a:t>Actionable Guidance: </a:t>
             </a:r>
             <a:r>
               <a:rPr sz="1800" b="0">
@@ -6071,13 +6116,22 @@
           <a:p>
             <a:pPr algn="ctr"/>
             <a:r>
+              <a:rPr sz="1600" b="1">
+                <a:solidFill>
+                  <a:srgbClr val="38BDF8"/>
+                </a:solidFill>
+                <a:latin typeface="Calibri"/>
+              </a:rPr>
+              <a:t>[GREEN]  </a:t>
+            </a:r>
+            <a:r>
               <a:rPr sz="1800" b="1">
                 <a:solidFill>
                   <a:srgbClr val="2563EB"/>
                 </a:solidFill>
                 <a:latin typeface="Calibri"/>
               </a:rPr>
-              <a:t>• Healthy State (Green): </a:t>
+              <a:t>Healthy State: </a:t>
             </a:r>
             <a:r>
               <a:rPr sz="1800" b="0">
@@ -6134,13 +6188,22 @@
           <a:p>
             <a:pPr algn="ctr"/>
             <a:r>
+              <a:rPr sz="1600" b="1">
+                <a:solidFill>
+                  <a:srgbClr val="38BDF8"/>
+                </a:solidFill>
+                <a:latin typeface="Calibri"/>
+              </a:rPr>
+              <a:t>[YELLOW]  </a:t>
+            </a:r>
+            <a:r>
               <a:rPr sz="1800" b="1">
                 <a:solidFill>
                   <a:srgbClr val="2563EB"/>
                 </a:solidFill>
                 <a:latin typeface="Calibri"/>
               </a:rPr>
-              <a:t>• Warning State (Yellow): </a:t>
+              <a:t>Warning State: </a:t>
             </a:r>
             <a:r>
               <a:rPr sz="1800" b="0">
@@ -6197,13 +6260,22 @@
           <a:p>
             <a:pPr algn="ctr"/>
             <a:r>
+              <a:rPr sz="1600" b="1">
+                <a:solidFill>
+                  <a:srgbClr val="38BDF8"/>
+                </a:solidFill>
+                <a:latin typeface="Calibri"/>
+              </a:rPr>
+              <a:t>[RED]  </a:t>
+            </a:r>
+            <a:r>
               <a:rPr sz="1800" b="1">
                 <a:solidFill>
                   <a:srgbClr val="2563EB"/>
                 </a:solidFill>
                 <a:latin typeface="Calibri"/>
               </a:rPr>
-              <a:t>• Critical Action (Red): </a:t>
+              <a:t>Critical Action: </a:t>
             </a:r>
             <a:r>
               <a:rPr sz="1800" b="0">
@@ -6260,13 +6332,22 @@
           <a:p>
             <a:pPr algn="ctr"/>
             <a:r>
+              <a:rPr sz="1600" b="1">
+                <a:solidFill>
+                  <a:srgbClr val="38BDF8"/>
+                </a:solidFill>
+                <a:latin typeface="Calibri"/>
+              </a:rPr>
+              <a:t>[SPEED]  </a:t>
+            </a:r>
+            <a:r>
               <a:rPr sz="1800" b="1">
                 <a:solidFill>
                   <a:srgbClr val="2563EB"/>
                 </a:solidFill>
                 <a:latin typeface="Calibri"/>
               </a:rPr>
-              <a:t>• Low Latency: </a:t>
+              <a:t>Low Latency: </a:t>
             </a:r>
             <a:r>
               <a:rPr sz="1800" b="0">
@@ -6323,13 +6404,22 @@
           <a:p>
             <a:pPr algn="ctr"/>
             <a:r>
+              <a:rPr sz="1600" b="1">
+                <a:solidFill>
+                  <a:srgbClr val="38BDF8"/>
+                </a:solidFill>
+                <a:latin typeface="Calibri"/>
+              </a:rPr>
+              <a:t>[QUEUE]  </a:t>
+            </a:r>
+            <a:r>
               <a:rPr sz="1800" b="1">
                 <a:solidFill>
                   <a:srgbClr val="2563EB"/>
                 </a:solidFill>
                 <a:latin typeface="Calibri"/>
               </a:rPr>
-              <a:t>• Queue Dispatch: </a:t>
+              <a:t>Queue Dispatch: </a:t>
             </a:r>
             <a:r>
               <a:rPr sz="1800" b="0">
@@ -6476,13 +6566,22 @@
           <a:p>
             <a:pPr algn="ctr"/>
             <a:r>
+              <a:rPr sz="1600" b="1">
+                <a:solidFill>
+                  <a:srgbClr val="38BDF8"/>
+                </a:solidFill>
+                <a:latin typeface="Calibri"/>
+              </a:rPr>
+              <a:t>[AUC-ROC]  </a:t>
+            </a:r>
+            <a:r>
               <a:rPr sz="1800" b="1">
                 <a:solidFill>
                   <a:srgbClr val="2563EB"/>
                 </a:solidFill>
                 <a:latin typeface="Calibri"/>
               </a:rPr>
-              <a:t>• Binary Warning AUC: </a:t>
+              <a:t>Binary Warning AUC: </a:t>
             </a:r>
             <a:r>
               <a:rPr sz="1800" b="0">
@@ -6539,13 +6638,22 @@
           <a:p>
             <a:pPr algn="ctr"/>
             <a:r>
+              <a:rPr sz="1600" b="1">
+                <a:solidFill>
+                  <a:srgbClr val="38BDF8"/>
+                </a:solidFill>
+                <a:latin typeface="Calibri"/>
+              </a:rPr>
+              <a:t>[PRECISION]  </a:t>
+            </a:r>
+            <a:r>
               <a:rPr sz="1800" b="1">
                 <a:solidFill>
                   <a:srgbClr val="2563EB"/>
                 </a:solidFill>
                 <a:latin typeface="Calibri"/>
               </a:rPr>
-              <a:t>• Binary Alert Precision: </a:t>
+              <a:t>Binary Alert Precision: </a:t>
             </a:r>
             <a:r>
               <a:rPr sz="1800" b="0">
@@ -6602,13 +6710,22 @@
           <a:p>
             <a:pPr algn="ctr"/>
             <a:r>
+              <a:rPr sz="1600" b="1">
+                <a:solidFill>
+                  <a:srgbClr val="38BDF8"/>
+                </a:solidFill>
+                <a:latin typeface="Calibri"/>
+              </a:rPr>
+              <a:t>[RMSE]  </a:t>
+            </a:r>
+            <a:r>
               <a:rPr sz="1800" b="1">
                 <a:solidFill>
                   <a:srgbClr val="2563EB"/>
                 </a:solidFill>
                 <a:latin typeface="Calibri"/>
               </a:rPr>
-              <a:t>• RUL Regression RMSE: </a:t>
+              <a:t>RUL Regression RMSE: </a:t>
             </a:r>
             <a:r>
               <a:rPr sz="1800" b="0">
@@ -6665,13 +6782,22 @@
           <a:p>
             <a:pPr algn="ctr"/>
             <a:r>
+              <a:rPr sz="1600" b="1">
+                <a:solidFill>
+                  <a:srgbClr val="38BDF8"/>
+                </a:solidFill>
+                <a:latin typeface="Calibri"/>
+              </a:rPr>
+              <a:t>[ACCURACY]  </a:t>
+            </a:r>
+            <a:r>
               <a:rPr sz="1800" b="1">
                 <a:solidFill>
                   <a:srgbClr val="2563EB"/>
                 </a:solidFill>
                 <a:latin typeface="Calibri"/>
               </a:rPr>
-              <a:t>• Neural MLP Accuracy: </a:t>
+              <a:t>Neural MLP Accuracy: </a:t>
             </a:r>
             <a:r>
               <a:rPr sz="1800" b="0">
@@ -6728,13 +6854,22 @@
           <a:p>
             <a:pPr algn="ctr"/>
             <a:r>
+              <a:rPr sz="1600" b="1">
+                <a:solidFill>
+                  <a:srgbClr val="38BDF8"/>
+                </a:solidFill>
+                <a:latin typeface="Calibri"/>
+              </a:rPr>
+              <a:t>[LATENCY]  </a:t>
+            </a:r>
+            <a:r>
               <a:rPr sz="1800" b="1">
                 <a:solidFill>
                   <a:srgbClr val="2563EB"/>
                 </a:solidFill>
                 <a:latin typeface="Calibri"/>
               </a:rPr>
-              <a:t>• Inference Speed: </a:t>
+              <a:t>Inference Speed: </a:t>
             </a:r>
             <a:r>
               <a:rPr sz="1800" b="0">
@@ -8622,13 +8757,22 @@
           <a:p>
             <a:pPr algn="ctr"/>
             <a:r>
+              <a:rPr sz="1600" b="1">
+                <a:solidFill>
+                  <a:srgbClr val="38BDF8"/>
+                </a:solidFill>
+                <a:latin typeface="Calibri"/>
+              </a:rPr>
+              <a:t>[INSIGHT 1]  </a:t>
+            </a:r>
+            <a:r>
               <a:rPr sz="1800" b="1">
                 <a:solidFill>
                   <a:srgbClr val="2563EB"/>
                 </a:solidFill>
                 <a:latin typeface="Calibri"/>
               </a:rPr>
-              <a:t>• Rolling Feature Impact: </a:t>
+              <a:t>Rolling Feature Impact: </a:t>
             </a:r>
             <a:r>
               <a:rPr sz="1800" b="0">
@@ -8685,13 +8829,22 @@
           <a:p>
             <a:pPr algn="ctr"/>
             <a:r>
+              <a:rPr sz="1600" b="1">
+                <a:solidFill>
+                  <a:srgbClr val="38BDF8"/>
+                </a:solidFill>
+                <a:latin typeface="Calibri"/>
+              </a:rPr>
+              <a:t>[INSIGHT 2]  </a:t>
+            </a:r>
+            <a:r>
               <a:rPr sz="1800" b="1">
                 <a:solidFill>
                   <a:srgbClr val="2563EB"/>
                 </a:solidFill>
                 <a:latin typeface="Calibri"/>
               </a:rPr>
-              <a:t>• Optimal Thresholding: </a:t>
+              <a:t>Optimal Thresholding: </a:t>
             </a:r>
             <a:r>
               <a:rPr sz="1800" b="0">
@@ -8748,13 +8901,22 @@
           <a:p>
             <a:pPr algn="ctr"/>
             <a:r>
+              <a:rPr sz="1600" b="1">
+                <a:solidFill>
+                  <a:srgbClr val="38BDF8"/>
+                </a:solidFill>
+                <a:latin typeface="Calibri"/>
+              </a:rPr>
+              <a:t>[INSIGHT 3]  </a:t>
+            </a:r>
+            <a:r>
               <a:rPr sz="1800" b="1">
                 <a:solidFill>
                   <a:srgbClr val="2563EB"/>
                 </a:solidFill>
                 <a:latin typeface="Calibri"/>
               </a:rPr>
-              <a:t>• Cost Matrix Savings: </a:t>
+              <a:t>Cost Matrix Savings: </a:t>
             </a:r>
             <a:r>
               <a:rPr sz="1800" b="0">
@@ -8811,13 +8973,22 @@
           <a:p>
             <a:pPr algn="ctr"/>
             <a:r>
+              <a:rPr sz="1600" b="1">
+                <a:solidFill>
+                  <a:srgbClr val="38BDF8"/>
+                </a:solidFill>
+                <a:latin typeface="Calibri"/>
+              </a:rPr>
+              <a:t>[INSIGHT 4]  </a:t>
+            </a:r>
+            <a:r>
               <a:rPr sz="1800" b="1">
                 <a:solidFill>
                   <a:srgbClr val="2563EB"/>
                 </a:solidFill>
                 <a:latin typeface="Calibri"/>
               </a:rPr>
-              <a:t>• Neural Net Stability: </a:t>
+              <a:t>Neural Net Stability: </a:t>
             </a:r>
             <a:r>
               <a:rPr sz="1800" b="0">
@@ -8874,13 +9045,22 @@
           <a:p>
             <a:pPr algn="ctr"/>
             <a:r>
+              <a:rPr sz="1600" b="1">
+                <a:solidFill>
+                  <a:srgbClr val="38BDF8"/>
+                </a:solidFill>
+                <a:latin typeface="Calibri"/>
+              </a:rPr>
+              <a:t>[INSIGHT 5]  </a:t>
+            </a:r>
+            <a:r>
               <a:rPr sz="1800" b="1">
                 <a:solidFill>
                   <a:srgbClr val="2563EB"/>
                 </a:solidFill>
                 <a:latin typeface="Calibri"/>
               </a:rPr>
-              <a:t>• Capacity Dispatch: </a:t>
+              <a:t>Capacity Dispatch: </a:t>
             </a:r>
             <a:r>
               <a:rPr sz="1800" b="0">
@@ -9027,13 +9207,22 @@
           <a:p>
             <a:pPr algn="ctr"/>
             <a:r>
+              <a:rPr sz="1600" b="1">
+                <a:solidFill>
+                  <a:srgbClr val="38BDF8"/>
+                </a:solidFill>
+                <a:latin typeface="Calibri"/>
+              </a:rPr>
+              <a:t>[DELIVERY]  </a:t>
+            </a:r>
+            <a:r>
               <a:rPr sz="1800" b="1">
                 <a:solidFill>
                   <a:srgbClr val="2563EB"/>
                 </a:solidFill>
                 <a:latin typeface="Calibri"/>
               </a:rPr>
-              <a:t>• System Delivery: </a:t>
+              <a:t>System Delivery: </a:t>
             </a:r>
             <a:r>
               <a:rPr sz="1800" b="0">
@@ -9090,13 +9279,22 @@
           <a:p>
             <a:pPr algn="ctr"/>
             <a:r>
+              <a:rPr sz="1600" b="1">
+                <a:solidFill>
+                  <a:srgbClr val="38BDF8"/>
+                </a:solidFill>
+                <a:latin typeface="Calibri"/>
+              </a:rPr>
+              <a:t>[ACCURACY]  </a:t>
+            </a:r>
+            <a:r>
               <a:rPr sz="1800" b="1">
                 <a:solidFill>
                   <a:srgbClr val="2563EB"/>
                 </a:solidFill>
                 <a:latin typeface="Calibri"/>
               </a:rPr>
-              <a:t>• High Performance: </a:t>
+              <a:t>High Performance: </a:t>
             </a:r>
             <a:r>
               <a:rPr sz="1800" b="0">
@@ -9153,13 +9351,22 @@
           <a:p>
             <a:pPr algn="ctr"/>
             <a:r>
+              <a:rPr sz="1600" b="1">
+                <a:solidFill>
+                  <a:srgbClr val="38BDF8"/>
+                </a:solidFill>
+                <a:latin typeface="Calibri"/>
+              </a:rPr>
+              <a:t>[CLI TOOL]  </a:t>
+            </a:r>
+            <a:r>
               <a:rPr sz="1800" b="1">
                 <a:solidFill>
                   <a:srgbClr val="2563EB"/>
                 </a:solidFill>
                 <a:latin typeface="Calibri"/>
               </a:rPr>
-              <a:t>• CLI Integration: </a:t>
+              <a:t>CLI Integration: </a:t>
             </a:r>
             <a:r>
               <a:rPr sz="1800" b="0">
@@ -9216,13 +9423,22 @@
           <a:p>
             <a:pPr algn="ctr"/>
             <a:r>
+              <a:rPr sz="1600" b="1">
+                <a:solidFill>
+                  <a:srgbClr val="38BDF8"/>
+                </a:solidFill>
+                <a:latin typeface="Calibri"/>
+              </a:rPr>
+              <a:t>[CODE]  </a:t>
+            </a:r>
+            <a:r>
               <a:rPr sz="1800" b="1">
                 <a:solidFill>
                   <a:srgbClr val="2563EB"/>
                 </a:solidFill>
                 <a:latin typeface="Calibri"/>
               </a:rPr>
-              <a:t>• Clean Implementation: </a:t>
+              <a:t>Clean Implementation: </a:t>
             </a:r>
             <a:r>
               <a:rPr sz="1800" b="0">
@@ -9279,13 +9495,22 @@
           <a:p>
             <a:pPr algn="ctr"/>
             <a:r>
+              <a:rPr sz="1600" b="1">
+                <a:solidFill>
+                  <a:srgbClr val="38BDF8"/>
+                </a:solidFill>
+                <a:latin typeface="Calibri"/>
+              </a:rPr>
+              <a:t>[BUSINESS]  </a:t>
+            </a:r>
+            <a:r>
               <a:rPr sz="1800" b="1">
                 <a:solidFill>
                   <a:srgbClr val="2563EB"/>
                 </a:solidFill>
                 <a:latin typeface="Calibri"/>
               </a:rPr>
-              <a:t>• Cost Minimization: </a:t>
+              <a:t>Cost Minimization: </a:t>
             </a:r>
             <a:r>
               <a:rPr sz="1800" b="0">
@@ -9432,13 +9657,22 @@
           <a:p>
             <a:pPr algn="ctr"/>
             <a:r>
+              <a:rPr sz="1600" b="1">
+                <a:solidFill>
+                  <a:srgbClr val="38BDF8"/>
+                </a:solidFill>
+                <a:latin typeface="Calibri"/>
+              </a:rPr>
+              <a:t>[PHASE 1]  </a:t>
+            </a:r>
+            <a:r>
               <a:rPr sz="1800" b="1">
                 <a:solidFill>
                   <a:srgbClr val="2563EB"/>
                 </a:solidFill>
                 <a:latin typeface="Calibri"/>
               </a:rPr>
-              <a:t>• Deep Time-Series: </a:t>
+              <a:t>Deep Time-Series: </a:t>
             </a:r>
             <a:r>
               <a:rPr sz="1800" b="0">
@@ -9495,13 +9729,22 @@
           <a:p>
             <a:pPr algn="ctr"/>
             <a:r>
+              <a:rPr sz="1600" b="1">
+                <a:solidFill>
+                  <a:srgbClr val="38BDF8"/>
+                </a:solidFill>
+                <a:latin typeface="Calibri"/>
+              </a:rPr>
+              <a:t>[PHASE 2]  </a:t>
+            </a:r>
+            <a:r>
               <a:rPr sz="1800" b="1">
                 <a:solidFill>
                   <a:srgbClr val="2563EB"/>
                 </a:solidFill>
                 <a:latin typeface="Calibri"/>
               </a:rPr>
-              <a:t>• Flight Profiles: </a:t>
+              <a:t>Flight Profiles: </a:t>
             </a:r>
             <a:r>
               <a:rPr sz="1800" b="0">
@@ -9558,13 +9801,22 @@
           <a:p>
             <a:pPr algn="ctr"/>
             <a:r>
+              <a:rPr sz="1600" b="1">
+                <a:solidFill>
+                  <a:srgbClr val="38BDF8"/>
+                </a:solidFill>
+                <a:latin typeface="Calibri"/>
+              </a:rPr>
+              <a:t>[PHASE 3]  </a:t>
+            </a:r>
+            <a:r>
               <a:rPr sz="1800" b="1">
                 <a:solidFill>
                   <a:srgbClr val="2563EB"/>
                 </a:solidFill>
                 <a:latin typeface="Calibri"/>
               </a:rPr>
-              <a:t>• Edge Deployment: </a:t>
+              <a:t>Edge Deployment: </a:t>
             </a:r>
             <a:r>
               <a:rPr sz="1800" b="0">
@@ -9621,13 +9873,22 @@
           <a:p>
             <a:pPr algn="ctr"/>
             <a:r>
+              <a:rPr sz="1600" b="1">
+                <a:solidFill>
+                  <a:srgbClr val="38BDF8"/>
+                </a:solidFill>
+                <a:latin typeface="Calibri"/>
+              </a:rPr>
+              <a:t>[PHASE 4]  </a:t>
+            </a:r>
+            <a:r>
               <a:rPr sz="1800" b="1">
                 <a:solidFill>
                   <a:srgbClr val="2563EB"/>
                 </a:solidFill>
                 <a:latin typeface="Calibri"/>
               </a:rPr>
-              <a:t>• Cloud Streaming API: </a:t>
+              <a:t>Cloud Streaming API: </a:t>
             </a:r>
             <a:r>
               <a:rPr sz="1800" b="0">
@@ -9684,13 +9945,22 @@
           <a:p>
             <a:pPr algn="ctr"/>
             <a:r>
+              <a:rPr sz="1600" b="1">
+                <a:solidFill>
+                  <a:srgbClr val="38BDF8"/>
+                </a:solidFill>
+                <a:latin typeface="Calibri"/>
+              </a:rPr>
+              <a:t>[PHASE 5]  </a:t>
+            </a:r>
+            <a:r>
               <a:rPr sz="1800" b="1">
                 <a:solidFill>
                   <a:srgbClr val="2563EB"/>
                 </a:solidFill>
                 <a:latin typeface="Calibri"/>
               </a:rPr>
-              <a:t>• Data Augmentation: </a:t>
+              <a:t>Data Augmentation: </a:t>
             </a:r>
             <a:r>
               <a:rPr sz="1800" b="0">
@@ -9837,13 +10107,22 @@
           <a:p>
             <a:pPr algn="ctr"/>
             <a:r>
+              <a:rPr sz="1600" b="1">
+                <a:solidFill>
+                  <a:srgbClr val="38BDF8"/>
+                </a:solidFill>
+                <a:latin typeface="Calibri"/>
+              </a:rPr>
+              <a:t>[DATASET]  </a:t>
+            </a:r>
+            <a:r>
               <a:rPr sz="1800" b="1">
                 <a:solidFill>
                   <a:srgbClr val="2563EB"/>
                 </a:solidFill>
                 <a:latin typeface="Calibri"/>
               </a:rPr>
-              <a:t>• NASA C-MAPSS Dataset: </a:t>
+              <a:t>NASA C-MAPSS Dataset: </a:t>
             </a:r>
             <a:r>
               <a:rPr sz="1800" b="0">
@@ -9900,13 +10179,22 @@
           <a:p>
             <a:pPr algn="ctr"/>
             <a:r>
+              <a:rPr sz="1600" b="1">
+                <a:solidFill>
+                  <a:srgbClr val="38BDF8"/>
+                </a:solidFill>
+                <a:latin typeface="Calibri"/>
+              </a:rPr>
+              <a:t>[PAPER]  </a:t>
+            </a:r>
+            <a:r>
               <a:rPr sz="1800" b="1">
                 <a:solidFill>
                   <a:srgbClr val="2563EB"/>
                 </a:solidFill>
                 <a:latin typeface="Calibri"/>
               </a:rPr>
-              <a:t>• Damage Modeling Paper: </a:t>
+              <a:t>Damage Modeling Paper: </a:t>
             </a:r>
             <a:r>
               <a:rPr sz="1800" b="0">
@@ -9963,13 +10251,22 @@
           <a:p>
             <a:pPr algn="ctr"/>
             <a:r>
+              <a:rPr sz="1600" b="1">
+                <a:solidFill>
+                  <a:srgbClr val="38BDF8"/>
+                </a:solidFill>
+                <a:latin typeface="Calibri"/>
+              </a:rPr>
+              <a:t>[LIBRARY]  </a:t>
+            </a:r>
+            <a:r>
               <a:rPr sz="1800" b="1">
                 <a:solidFill>
                   <a:srgbClr val="2563EB"/>
                 </a:solidFill>
                 <a:latin typeface="Calibri"/>
               </a:rPr>
-              <a:t>• Scikit-Learn Docs: </a:t>
+              <a:t>Scikit-Learn Docs: </a:t>
             </a:r>
             <a:r>
               <a:rPr sz="1800" b="0">
@@ -10026,13 +10323,22 @@
           <a:p>
             <a:pPr algn="ctr"/>
             <a:r>
+              <a:rPr sz="1600" b="1">
+                <a:solidFill>
+                  <a:srgbClr val="38BDF8"/>
+                </a:solidFill>
+                <a:latin typeface="Calibri"/>
+              </a:rPr>
+              <a:t>[FRAMEWORK]  </a:t>
+            </a:r>
+            <a:r>
               <a:rPr sz="1800" b="1">
                 <a:solidFill>
                   <a:srgbClr val="2563EB"/>
                 </a:solidFill>
                 <a:latin typeface="Calibri"/>
               </a:rPr>
-              <a:t>• Keras &amp; TensorFlow: </a:t>
+              <a:t>Keras &amp; TensorFlow: </a:t>
             </a:r>
             <a:r>
               <a:rPr sz="1800" b="0">
@@ -10089,13 +10395,22 @@
           <a:p>
             <a:pPr algn="ctr"/>
             <a:r>
+              <a:rPr sz="1600" b="1">
+                <a:solidFill>
+                  <a:srgbClr val="38BDF8"/>
+                </a:solidFill>
+                <a:latin typeface="Calibri"/>
+              </a:rPr>
+              <a:t>[CODE]  </a:t>
+            </a:r>
+            <a:r>
               <a:rPr sz="1800" b="1">
                 <a:solidFill>
                   <a:srgbClr val="2563EB"/>
                 </a:solidFill>
                 <a:latin typeface="Calibri"/>
               </a:rPr>
-              <a:t>• GitHub Repository: </a:t>
+              <a:t>GitHub Repository: </a:t>
             </a:r>
             <a:r>
               <a:rPr sz="1800" b="0">
@@ -10331,13 +10646,22 @@
           <a:p>
             <a:pPr algn="ctr"/>
             <a:r>
+              <a:rPr sz="1600" b="1">
+                <a:solidFill>
+                  <a:srgbClr val="38BDF8"/>
+                </a:solidFill>
+                <a:latin typeface="Calibri"/>
+              </a:rPr>
+              <a:t>[AGENDA 1]  </a:t>
+            </a:r>
+            <a:r>
               <a:rPr sz="1800" b="1">
                 <a:solidFill>
                   <a:srgbClr val="2563EB"/>
                 </a:solidFill>
                 <a:latin typeface="Calibri"/>
               </a:rPr>
-              <a:t>• Problem Statement: </a:t>
+              <a:t>Problem Statement: </a:t>
             </a:r>
             <a:r>
               <a:rPr sz="1800" b="0">
@@ -10394,13 +10718,22 @@
           <a:p>
             <a:pPr algn="ctr"/>
             <a:r>
+              <a:rPr sz="1600" b="1">
+                <a:solidFill>
+                  <a:srgbClr val="38BDF8"/>
+                </a:solidFill>
+                <a:latin typeface="Calibri"/>
+              </a:rPr>
+              <a:t>[AGENDA 2]  </a:t>
+            </a:r>
+            <a:r>
               <a:rPr sz="1800" b="1">
                 <a:solidFill>
                   <a:srgbClr val="2563EB"/>
                 </a:solidFill>
                 <a:latin typeface="Calibri"/>
               </a:rPr>
-              <a:t>• Project Objectives: </a:t>
+              <a:t>Project Objectives: </a:t>
             </a:r>
             <a:r>
               <a:rPr sz="1800" b="0">
@@ -10457,13 +10790,22 @@
           <a:p>
             <a:pPr algn="ctr"/>
             <a:r>
+              <a:rPr sz="1600" b="1">
+                <a:solidFill>
+                  <a:srgbClr val="38BDF8"/>
+                </a:solidFill>
+                <a:latin typeface="Calibri"/>
+              </a:rPr>
+              <a:t>[AGENDA 3]  </a:t>
+            </a:r>
+            <a:r>
               <a:rPr sz="1800" b="1">
                 <a:solidFill>
                   <a:srgbClr val="2563EB"/>
                 </a:solidFill>
                 <a:latin typeface="Calibri"/>
               </a:rPr>
-              <a:t>• Technology Stack: </a:t>
+              <a:t>Technology Stack: </a:t>
             </a:r>
             <a:r>
               <a:rPr sz="1800" b="0">
@@ -10520,13 +10862,22 @@
           <a:p>
             <a:pPr algn="ctr"/>
             <a:r>
+              <a:rPr sz="1600" b="1">
+                <a:solidFill>
+                  <a:srgbClr val="38BDF8"/>
+                </a:solidFill>
+                <a:latin typeface="Calibri"/>
+              </a:rPr>
+              <a:t>[AGENDA 4]  </a:t>
+            </a:r>
+            <a:r>
               <a:rPr sz="1800" b="1">
                 <a:solidFill>
                   <a:srgbClr val="2563EB"/>
                 </a:solidFill>
                 <a:latin typeface="Calibri"/>
               </a:rPr>
-              <a:t>• System Methodology: </a:t>
+              <a:t>System Methodology: </a:t>
             </a:r>
             <a:r>
               <a:rPr sz="1800" b="0">
@@ -10583,13 +10934,22 @@
           <a:p>
             <a:pPr algn="ctr"/>
             <a:r>
+              <a:rPr sz="1600" b="1">
+                <a:solidFill>
+                  <a:srgbClr val="38BDF8"/>
+                </a:solidFill>
+                <a:latin typeface="Calibri"/>
+              </a:rPr>
+              <a:t>[AGENDA 5]  </a:t>
+            </a:r>
+            <a:r>
               <a:rPr sz="1800" b="1">
                 <a:solidFill>
                   <a:srgbClr val="2563EB"/>
                 </a:solidFill>
                 <a:latin typeface="Calibri"/>
               </a:rPr>
-              <a:t>• Benchmark Results: </a:t>
+              <a:t>Benchmark Results: </a:t>
             </a:r>
             <a:r>
               <a:rPr sz="1800" b="0">
@@ -10736,13 +11096,22 @@
           <a:p>
             <a:pPr algn="ctr"/>
             <a:r>
+              <a:rPr sz="1600" b="1">
+                <a:solidFill>
+                  <a:srgbClr val="38BDF8"/>
+                </a:solidFill>
+                <a:latin typeface="Calibri"/>
+              </a:rPr>
+              <a:t>[HAZARD 1]  </a:t>
+            </a:r>
+            <a:r>
               <a:rPr sz="1800" b="1">
                 <a:solidFill>
                   <a:srgbClr val="2563EB"/>
                 </a:solidFill>
                 <a:latin typeface="Calibri"/>
               </a:rPr>
-              <a:t>• Unscheduled Groundings: </a:t>
+              <a:t>Unscheduled Groundings: </a:t>
             </a:r>
             <a:r>
               <a:rPr sz="1800" b="0">
@@ -10799,13 +11168,22 @@
           <a:p>
             <a:pPr algn="ctr"/>
             <a:r>
+              <a:rPr sz="1600" b="1">
+                <a:solidFill>
+                  <a:srgbClr val="38BDF8"/>
+                </a:solidFill>
+                <a:latin typeface="Calibri"/>
+              </a:rPr>
+              <a:t>[HAZARD 2]  </a:t>
+            </a:r>
+            <a:r>
               <a:rPr sz="1800" b="1">
                 <a:solidFill>
                   <a:srgbClr val="2563EB"/>
                 </a:solidFill>
                 <a:latin typeface="Calibri"/>
               </a:rPr>
-              <a:t>• High Cost Impact: </a:t>
+              <a:t>High Operational Cost: </a:t>
             </a:r>
             <a:r>
               <a:rPr sz="1800" b="0">
@@ -10862,13 +11240,22 @@
           <a:p>
             <a:pPr algn="ctr"/>
             <a:r>
+              <a:rPr sz="1600" b="1">
+                <a:solidFill>
+                  <a:srgbClr val="38BDF8"/>
+                </a:solidFill>
+                <a:latin typeface="Calibri"/>
+              </a:rPr>
+              <a:t>[HAZARD 3]  </a:t>
+            </a:r>
+            <a:r>
               <a:rPr sz="1800" b="1">
                 <a:solidFill>
                   <a:srgbClr val="2563EB"/>
                 </a:solidFill>
                 <a:latin typeface="Calibri"/>
               </a:rPr>
-              <a:t>• Static Servicing Flaws: </a:t>
+              <a:t>Static Servicing Flaws: </a:t>
             </a:r>
             <a:r>
               <a:rPr sz="1800" b="0">
@@ -10925,13 +11312,22 @@
           <a:p>
             <a:pPr algn="ctr"/>
             <a:r>
+              <a:rPr sz="1600" b="1">
+                <a:solidFill>
+                  <a:srgbClr val="38BDF8"/>
+                </a:solidFill>
+                <a:latin typeface="Calibri"/>
+              </a:rPr>
+              <a:t>[HAZARD 4]  </a:t>
+            </a:r>
+            <a:r>
               <a:rPr sz="1800" b="1">
                 <a:solidFill>
                   <a:srgbClr val="2563EB"/>
                 </a:solidFill>
                 <a:latin typeface="Calibri"/>
               </a:rPr>
-              <a:t>• High Sensor Fluctuation: </a:t>
+              <a:t>High Sensor Fluctuation: </a:t>
             </a:r>
             <a:r>
               <a:rPr sz="1800" b="0">
@@ -10988,13 +11384,22 @@
           <a:p>
             <a:pPr algn="ctr"/>
             <a:r>
+              <a:rPr sz="1600" b="1">
+                <a:solidFill>
+                  <a:srgbClr val="38BDF8"/>
+                </a:solidFill>
+                <a:latin typeface="Calibri"/>
+              </a:rPr>
+              <a:t>[HAZARD 5]  </a:t>
+            </a:r>
+            <a:r>
               <a:rPr sz="1800" b="1">
                 <a:solidFill>
                   <a:srgbClr val="2563EB"/>
                 </a:solidFill>
                 <a:latin typeface="Calibri"/>
               </a:rPr>
-              <a:t>• Prognostic Solution Need: </a:t>
+              <a:t>Prognostic Solution Need: </a:t>
             </a:r>
             <a:r>
               <a:rPr sz="1800" b="0">
@@ -11003,7 +11408,7 @@
                 </a:solidFill>
                 <a:latin typeface="Calibri"/>
               </a:rPr>
-              <a:t>Requires real-time AI to forecast RUL.</a:t>
+              <a:t>Requires real-time AI to forecast remaining life.</a:t>
             </a:r>
           </a:p>
         </p:txBody>
@@ -11141,13 +11546,22 @@
           <a:p>
             <a:pPr algn="ctr"/>
             <a:r>
+              <a:rPr sz="1600" b="1">
+                <a:solidFill>
+                  <a:srgbClr val="38BDF8"/>
+                </a:solidFill>
+                <a:latin typeface="Calibri"/>
+              </a:rPr>
+              <a:t>[GOAL 1]  </a:t>
+            </a:r>
+            <a:r>
               <a:rPr sz="1800" b="1">
                 <a:solidFill>
                   <a:srgbClr val="2563EB"/>
                 </a:solidFill>
                 <a:latin typeface="Calibri"/>
               </a:rPr>
-              <a:t>• RUL Forecasting: </a:t>
+              <a:t>RUL Forecasting: </a:t>
             </a:r>
             <a:r>
               <a:rPr sz="1800" b="0">
@@ -11204,13 +11618,22 @@
           <a:p>
             <a:pPr algn="ctr"/>
             <a:r>
+              <a:rPr sz="1600" b="1">
+                <a:solidFill>
+                  <a:srgbClr val="38BDF8"/>
+                </a:solidFill>
+                <a:latin typeface="Calibri"/>
+              </a:rPr>
+              <a:t>[GOAL 2]  </a:t>
+            </a:r>
+            <a:r>
               <a:rPr sz="1800" b="1">
                 <a:solidFill>
                   <a:srgbClr val="2563EB"/>
                 </a:solidFill>
                 <a:latin typeface="Calibri"/>
               </a:rPr>
-              <a:t>• 30-Day Warning Alert: </a:t>
+              <a:t>30-Day Warning Alert: </a:t>
             </a:r>
             <a:r>
               <a:rPr sz="1800" b="0">
@@ -11267,13 +11690,22 @@
           <a:p>
             <a:pPr algn="ctr"/>
             <a:r>
+              <a:rPr sz="1600" b="1">
+                <a:solidFill>
+                  <a:srgbClr val="38BDF8"/>
+                </a:solidFill>
+                <a:latin typeface="Calibri"/>
+              </a:rPr>
+              <a:t>[GOAL 3]  </a:t>
+            </a:r>
+            <a:r>
               <a:rPr sz="1800" b="1">
                 <a:solidFill>
                   <a:srgbClr val="2563EB"/>
                 </a:solidFill>
                 <a:latin typeface="Calibri"/>
               </a:rPr>
-              <a:t>• 3-Tier Hazard Net: </a:t>
+              <a:t>3-Tier Hazard Net: </a:t>
             </a:r>
             <a:r>
               <a:rPr sz="1800" b="0">
@@ -11330,13 +11762,22 @@
           <a:p>
             <a:pPr algn="ctr"/>
             <a:r>
+              <a:rPr sz="1600" b="1">
+                <a:solidFill>
+                  <a:srgbClr val="38BDF8"/>
+                </a:solidFill>
+                <a:latin typeface="Calibri"/>
+              </a:rPr>
+              <a:t>[GOAL 4]  </a:t>
+            </a:r>
+            <a:r>
               <a:rPr sz="1800" b="1">
                 <a:solidFill>
                   <a:srgbClr val="2563EB"/>
                 </a:solidFill>
                 <a:latin typeface="Calibri"/>
               </a:rPr>
-              <a:t>• Real-Time Diagnostics: </a:t>
+              <a:t>Real-Time Diagnostics: </a:t>
             </a:r>
             <a:r>
               <a:rPr sz="1800" b="0">
@@ -11393,13 +11834,22 @@
           <a:p>
             <a:pPr algn="ctr"/>
             <a:r>
+              <a:rPr sz="1600" b="1">
+                <a:solidFill>
+                  <a:srgbClr val="38BDF8"/>
+                </a:solidFill>
+                <a:latin typeface="Calibri"/>
+              </a:rPr>
+              <a:t>[GOAL 5]  </a:t>
+            </a:r>
+            <a:r>
               <a:rPr sz="1800" b="1">
                 <a:solidFill>
                   <a:srgbClr val="2563EB"/>
                 </a:solidFill>
                 <a:latin typeface="Calibri"/>
               </a:rPr>
-              <a:t>• Fleet Cost Reduction: </a:t>
+              <a:t>Fleet Cost Reduction: </a:t>
             </a:r>
             <a:r>
               <a:rPr sz="1800" b="0">
@@ -11546,13 +11996,22 @@
           <a:p>
             <a:pPr algn="ctr"/>
             <a:r>
+              <a:rPr sz="1600" b="1">
+                <a:solidFill>
+                  <a:srgbClr val="38BDF8"/>
+                </a:solidFill>
+                <a:latin typeface="Calibri"/>
+              </a:rPr>
+              <a:t>[LEGACY]  </a:t>
+            </a:r>
+            <a:r>
               <a:rPr sz="1800" b="1">
                 <a:solidFill>
                   <a:srgbClr val="2563EB"/>
                 </a:solidFill>
                 <a:latin typeface="Calibri"/>
               </a:rPr>
-              <a:t>• Traditional Servicing: </a:t>
+              <a:t>Traditional Servicing: </a:t>
             </a:r>
             <a:r>
               <a:rPr sz="1800" b="0">
@@ -11609,13 +12068,22 @@
           <a:p>
             <a:pPr algn="ctr"/>
             <a:r>
+              <a:rPr sz="1600" b="1">
+                <a:solidFill>
+                  <a:srgbClr val="38BDF8"/>
+                </a:solidFill>
+                <a:latin typeface="Calibri"/>
+              </a:rPr>
+              <a:t>[LEGACY]  </a:t>
+            </a:r>
+            <a:r>
               <a:rPr sz="1800" b="1">
                 <a:solidFill>
                   <a:srgbClr val="2563EB"/>
                 </a:solidFill>
                 <a:latin typeface="Calibri"/>
               </a:rPr>
-              <a:t>• Reactive Maintenance: </a:t>
+              <a:t>Reactive Maintenance: </a:t>
             </a:r>
             <a:r>
               <a:rPr sz="1800" b="0">
@@ -11672,13 +12140,22 @@
           <a:p>
             <a:pPr algn="ctr"/>
             <a:r>
+              <a:rPr sz="1600" b="1">
+                <a:solidFill>
+                  <a:srgbClr val="38BDF8"/>
+                </a:solidFill>
+                <a:latin typeface="Calibri"/>
+              </a:rPr>
+              <a:t>[PROPOSED]  </a:t>
+            </a:r>
+            <a:r>
               <a:rPr sz="1800" b="1">
                 <a:solidFill>
                   <a:srgbClr val="2563EB"/>
                 </a:solidFill>
                 <a:latin typeface="Calibri"/>
               </a:rPr>
-              <a:t>• Proposed AI Engine: </a:t>
+              <a:t>Proposed AI Engine: </a:t>
             </a:r>
             <a:r>
               <a:rPr sz="1800" b="0">
@@ -11735,13 +12212,22 @@
           <a:p>
             <a:pPr algn="ctr"/>
             <a:r>
+              <a:rPr sz="1600" b="1">
+                <a:solidFill>
+                  <a:srgbClr val="38BDF8"/>
+                </a:solidFill>
+                <a:latin typeface="Calibri"/>
+              </a:rPr>
+              <a:t>[PROPOSED]  </a:t>
+            </a:r>
+            <a:r>
               <a:rPr sz="1800" b="1">
                 <a:solidFill>
                   <a:srgbClr val="2563EB"/>
                 </a:solidFill>
                 <a:latin typeface="Calibri"/>
               </a:rPr>
-              <a:t>• Proactive Scheduling: </a:t>
+              <a:t>Proactive Scheduling: </a:t>
             </a:r>
             <a:r>
               <a:rPr sz="1800" b="0">
@@ -11798,13 +12284,22 @@
           <a:p>
             <a:pPr algn="ctr"/>
             <a:r>
+              <a:rPr sz="1600" b="1">
+                <a:solidFill>
+                  <a:srgbClr val="38BDF8"/>
+                </a:solidFill>
+                <a:latin typeface="Calibri"/>
+              </a:rPr>
+              <a:t>[BENEFIT]  </a:t>
+            </a:r>
+            <a:r>
               <a:rPr sz="1800" b="1">
                 <a:solidFill>
                   <a:srgbClr val="2563EB"/>
                 </a:solidFill>
                 <a:latin typeface="Calibri"/>
               </a:rPr>
-              <a:t>• Cost Optimization: </a:t>
+              <a:t>Cost Optimization: </a:t>
             </a:r>
             <a:r>
               <a:rPr sz="1800" b="0">
@@ -11936,13 +12431,22 @@
               </a:spcAft>
             </a:pPr>
             <a:r>
+              <a:rPr sz="1400" b="1">
+                <a:solidFill>
+                  <a:srgbClr val="38BDF8"/>
+                </a:solidFill>
+                <a:latin typeface="Calibri"/>
+              </a:rPr>
+              <a:t>[STEP 1] </a:t>
+            </a:r>
+            <a:r>
               <a:rPr sz="1600" b="1">
                 <a:solidFill>
                   <a:srgbClr val="2563EB"/>
                 </a:solidFill>
                 <a:latin typeface="Calibri"/>
               </a:rPr>
-              <a:t>• Stage 1 Ingestion: </a:t>
+              <a:t>Stage 1 Ingestion: </a:t>
             </a:r>
             <a:r>
               <a:rPr sz="1600" b="0">
@@ -11961,13 +12465,22 @@
               </a:spcAft>
             </a:pPr>
             <a:r>
+              <a:rPr sz="1400" b="1">
+                <a:solidFill>
+                  <a:srgbClr val="38BDF8"/>
+                </a:solidFill>
+                <a:latin typeface="Calibri"/>
+              </a:rPr>
+              <a:t>[STEP 2] </a:t>
+            </a:r>
+            <a:r>
               <a:rPr sz="1600" b="1">
                 <a:solidFill>
                   <a:srgbClr val="2563EB"/>
                 </a:solidFill>
                 <a:latin typeface="Calibri"/>
               </a:rPr>
-              <a:t>• Stage 2 Preprocessing: </a:t>
+              <a:t>Stage 2 Preprocessing: </a:t>
             </a:r>
             <a:r>
               <a:rPr sz="1600" b="0">
@@ -11986,13 +12499,22 @@
               </a:spcAft>
             </a:pPr>
             <a:r>
+              <a:rPr sz="1400" b="1">
+                <a:solidFill>
+                  <a:srgbClr val="38BDF8"/>
+                </a:solidFill>
+                <a:latin typeface="Calibri"/>
+              </a:rPr>
+              <a:t>[STEP 3] </a:t>
+            </a:r>
+            <a:r>
               <a:rPr sz="1600" b="1">
                 <a:solidFill>
                   <a:srgbClr val="2563EB"/>
                 </a:solidFill>
                 <a:latin typeface="Calibri"/>
               </a:rPr>
-              <a:t>• Stage 3 Filter: </a:t>
+              <a:t>Stage 3 Filter: </a:t>
             </a:r>
             <a:r>
               <a:rPr sz="1600" b="0">
@@ -12011,13 +12533,22 @@
               </a:spcAft>
             </a:pPr>
             <a:r>
+              <a:rPr sz="1400" b="1">
+                <a:solidFill>
+                  <a:srgbClr val="38BDF8"/>
+                </a:solidFill>
+                <a:latin typeface="Calibri"/>
+              </a:rPr>
+              <a:t>[STEP 4] </a:t>
+            </a:r>
+            <a:r>
               <a:rPr sz="1600" b="1">
                 <a:solidFill>
                   <a:srgbClr val="2563EB"/>
                 </a:solidFill>
                 <a:latin typeface="Calibri"/>
               </a:rPr>
-              <a:t>• Stage 4 AI Engine: </a:t>
+              <a:t>Stage 4 AI Engine: </a:t>
             </a:r>
             <a:r>
               <a:rPr sz="1600" b="0">
@@ -12036,13 +12567,22 @@
               </a:spcAft>
             </a:pPr>
             <a:r>
+              <a:rPr sz="1400" b="1">
+                <a:solidFill>
+                  <a:srgbClr val="38BDF8"/>
+                </a:solidFill>
+                <a:latin typeface="Calibri"/>
+              </a:rPr>
+              <a:t>[STEP 5] </a:t>
+            </a:r>
+            <a:r>
               <a:rPr sz="1600" b="1">
                 <a:solidFill>
                   <a:srgbClr val="2563EB"/>
                 </a:solidFill>
                 <a:latin typeface="Calibri"/>
               </a:rPr>
-              <a:t>• Stage 5 Actionable Report: </a:t>
+              <a:t>Stage 5 Actionable Report: </a:t>
             </a:r>
             <a:r>
               <a:rPr sz="1600" b="0">
@@ -13017,13 +13557,22 @@
           <a:p>
             <a:pPr algn="ctr"/>
             <a:r>
+              <a:rPr sz="1600" b="1">
+                <a:solidFill>
+                  <a:srgbClr val="38BDF8"/>
+                </a:solidFill>
+                <a:latin typeface="Calibri"/>
+              </a:rPr>
+              <a:t>[SOURCE]  </a:t>
+            </a:r>
+            <a:r>
               <a:rPr sz="1800" b="1">
                 <a:solidFill>
                   <a:srgbClr val="2563EB"/>
                 </a:solidFill>
                 <a:latin typeface="Calibri"/>
               </a:rPr>
-              <a:t>• Data Provider: </a:t>
+              <a:t>Data Provider: </a:t>
             </a:r>
             <a:r>
               <a:rPr sz="1800" b="0">
@@ -13080,13 +13629,22 @@
           <a:p>
             <a:pPr algn="ctr"/>
             <a:r>
+              <a:rPr sz="1600" b="1">
+                <a:solidFill>
+                  <a:srgbClr val="38BDF8"/>
+                </a:solidFill>
+                <a:latin typeface="Calibri"/>
+              </a:rPr>
+              <a:t>[TRAIN]  </a:t>
+            </a:r>
+            <a:r>
               <a:rPr sz="1800" b="1">
                 <a:solidFill>
                   <a:srgbClr val="2563EB"/>
                 </a:solidFill>
                 <a:latin typeface="Calibri"/>
               </a:rPr>
-              <a:t>• Training Fleet: </a:t>
+              <a:t>Training Fleet: </a:t>
             </a:r>
             <a:r>
               <a:rPr sz="1800" b="0">
@@ -13143,13 +13701,22 @@
           <a:p>
             <a:pPr algn="ctr"/>
             <a:r>
+              <a:rPr sz="1600" b="1">
+                <a:solidFill>
+                  <a:srgbClr val="38BDF8"/>
+                </a:solidFill>
+                <a:latin typeface="Calibri"/>
+              </a:rPr>
+              <a:t>[TEST]  </a:t>
+            </a:r>
+            <a:r>
               <a:rPr sz="1800" b="1">
                 <a:solidFill>
                   <a:srgbClr val="2563EB"/>
                 </a:solidFill>
                 <a:latin typeface="Calibri"/>
               </a:rPr>
-              <a:t>• Testing Fleet: </a:t>
+              <a:t>Testing Fleet: </a:t>
             </a:r>
             <a:r>
               <a:rPr sz="1800" b="0">
@@ -13206,13 +13773,22 @@
           <a:p>
             <a:pPr algn="ctr"/>
             <a:r>
+              <a:rPr sz="1600" b="1">
+                <a:solidFill>
+                  <a:srgbClr val="38BDF8"/>
+                </a:solidFill>
+                <a:latin typeface="Calibri"/>
+              </a:rPr>
+              <a:t>[TARGET]  </a:t>
+            </a:r>
+            <a:r>
               <a:rPr sz="1800" b="1">
                 <a:solidFill>
                   <a:srgbClr val="2563EB"/>
                 </a:solidFill>
                 <a:latin typeface="Calibri"/>
               </a:rPr>
-              <a:t>• Failure Windows: </a:t>
+              <a:t>Failure Windows: </a:t>
             </a:r>
             <a:r>
               <a:rPr sz="1800" b="0">
@@ -13269,13 +13845,22 @@
           <a:p>
             <a:pPr algn="ctr"/>
             <a:r>
+              <a:rPr sz="1600" b="1">
+                <a:solidFill>
+                  <a:srgbClr val="38BDF8"/>
+                </a:solidFill>
+                <a:latin typeface="Calibri"/>
+              </a:rPr>
+              <a:t>[QUALITY]  </a:t>
+            </a:r>
+            <a:r>
               <a:rPr sz="1800" b="1">
                 <a:solidFill>
                   <a:srgbClr val="2563EB"/>
                 </a:solidFill>
                 <a:latin typeface="Calibri"/>
               </a:rPr>
-              <a:t>• Dataset Quality: </a:t>
+              <a:t>Dataset Quality: </a:t>
             </a:r>
             <a:r>
               <a:rPr sz="1800" b="0">
@@ -13422,13 +14007,22 @@
           <a:p>
             <a:pPr algn="ctr"/>
             <a:r>
+              <a:rPr sz="1600" b="1">
+                <a:solidFill>
+                  <a:srgbClr val="38BDF8"/>
+                </a:solidFill>
+                <a:latin typeface="Calibri"/>
+              </a:rPr>
+              <a:t>[MODEL 1]  </a:t>
+            </a:r>
+            <a:r>
               <a:rPr sz="1800" b="1">
                 <a:solidFill>
                   <a:srgbClr val="2563EB"/>
                 </a:solidFill>
                 <a:latin typeface="Calibri"/>
               </a:rPr>
-              <a:t>• RUL Regression: </a:t>
+              <a:t>RUL Regression: </a:t>
             </a:r>
             <a:r>
               <a:rPr sz="1800" b="0">
@@ -13485,13 +14079,22 @@
           <a:p>
             <a:pPr algn="ctr"/>
             <a:r>
+              <a:rPr sz="1600" b="1">
+                <a:solidFill>
+                  <a:srgbClr val="38BDF8"/>
+                </a:solidFill>
+                <a:latin typeface="Calibri"/>
+              </a:rPr>
+              <a:t>[MODEL 2]  </a:t>
+            </a:r>
+            <a:r>
               <a:rPr sz="1800" b="1">
                 <a:solidFill>
                   <a:srgbClr val="2563EB"/>
                 </a:solidFill>
                 <a:latin typeface="Calibri"/>
               </a:rPr>
-              <a:t>• Binary Classifier: </a:t>
+              <a:t>Binary Classifier: </a:t>
             </a:r>
             <a:r>
               <a:rPr sz="1800" b="0">
@@ -13548,13 +14151,22 @@
           <a:p>
             <a:pPr algn="ctr"/>
             <a:r>
+              <a:rPr sz="1600" b="1">
+                <a:solidFill>
+                  <a:srgbClr val="38BDF8"/>
+                </a:solidFill>
+                <a:latin typeface="Calibri"/>
+              </a:rPr>
+              <a:t>[MODEL 3]  </a:t>
+            </a:r>
+            <a:r>
               <a:rPr sz="1800" b="1">
                 <a:solidFill>
                   <a:srgbClr val="2563EB"/>
                 </a:solidFill>
                 <a:latin typeface="Calibri"/>
               </a:rPr>
-              <a:t>• Neural MLP Net: </a:t>
+              <a:t>Neural MLP Net: </a:t>
             </a:r>
             <a:r>
               <a:rPr sz="1800" b="0">
@@ -13611,13 +14223,22 @@
           <a:p>
             <a:pPr algn="ctr"/>
             <a:r>
+              <a:rPr sz="1600" b="1">
+                <a:solidFill>
+                  <a:srgbClr val="38BDF8"/>
+                </a:solidFill>
+                <a:latin typeface="Calibri"/>
+              </a:rPr>
+              <a:t>[CLASSES]  </a:t>
+            </a:r>
+            <a:r>
               <a:rPr sz="1800" b="1">
                 <a:solidFill>
                   <a:srgbClr val="2563EB"/>
                 </a:solidFill>
                 <a:latin typeface="Calibri"/>
               </a:rPr>
-              <a:t>• Risk Classes: </a:t>
+              <a:t>Risk Classes: </a:t>
             </a:r>
             <a:r>
               <a:rPr sz="1800" b="0">
@@ -13674,13 +14295,22 @@
           <a:p>
             <a:pPr algn="ctr"/>
             <a:r>
+              <a:rPr sz="1600" b="1">
+                <a:solidFill>
+                  <a:srgbClr val="38BDF8"/>
+                </a:solidFill>
+                <a:latin typeface="Calibri"/>
+              </a:rPr>
+              <a:t>[OUTPUT]  </a:t>
+            </a:r>
+            <a:r>
               <a:rPr sz="1800" b="1">
                 <a:solidFill>
                   <a:srgbClr val="2563EB"/>
                 </a:solidFill>
                 <a:latin typeface="Calibri"/>
               </a:rPr>
-              <a:t>• Softmax Output: </a:t>
+              <a:t>Softmax Output: </a:t>
             </a:r>
             <a:r>
               <a:rPr sz="1800" b="0">

</xml_diff>

<commit_message>
Enrich presentation deck with Industrial IoT (IIoT) engineering focus
</commit_message>
<xml_diff>
--- a/Internship Presentation PPTs Template Final.pptx
+++ b/Internship Presentation PPTs Template Final.pptx
@@ -5551,7 +5551,7 @@
           <a:lstStyle/>
           <a:p>
             <a:pPr algn="ctr">
-              <a:defRPr sz="2000" b="1">
+              <a:defRPr sz="1900" b="1">
                 <a:solidFill>
                   <a:srgbClr val="0F172A"/>
                 </a:solidFill>
@@ -5559,7 +5559,7 @@
               </a:defRPr>
             </a:pPr>
             <a:r>
-              <a:t>On Predictive Maintenance for Jet Engines Using Machine Learning</a:t>
+              <a:t>On Predictive Maintenance for Jet Engines Using Industrial IoT &amp; Machine Learning</a:t>
             </a:r>
           </a:p>
           <a:p>
@@ -5712,7 +5712,7 @@
                 </a:solidFill>
                 <a:latin typeface="Calibri"/>
               </a:rPr>
-              <a:t>• Command-Line Diagnostic Tool: </a:t>
+              <a:t>• IIoT Command-Line Diagnostic Tool: </a:t>
             </a:r>
             <a:r>
               <a:rPr sz="1800" b="0">
@@ -5864,7 +5864,7 @@
                 </a:solidFill>
                 <a:latin typeface="Calibri"/>
               </a:rPr>
-              <a:t>• Actionable Maintenance Recommendation: </a:t>
+              <a:t>• Actionable IIoT Recommendation: </a:t>
             </a:r>
             <a:r>
               <a:rPr sz="1800" b="0">
@@ -8646,7 +8646,7 @@
                 </a:solidFill>
                 <a:latin typeface="Calibri"/>
               </a:rPr>
-              <a:t>Built a complete predictive health management pipeline for jet engines.</a:t>
+              <a:t>Built a complete Industrial IoT predictive health management pipeline.</a:t>
             </a:r>
           </a:p>
           <a:p>
@@ -8739,7 +8739,7 @@
                 </a:solidFill>
                 <a:latin typeface="Calibri"/>
               </a:rPr>
-              <a:t>• Sign-to-Speech &amp; CLI Integration: </a:t>
+              <a:t>• IIoT CLI Integration: </a:t>
             </a:r>
             <a:r>
               <a:rPr sz="1800" b="0">
@@ -9010,7 +9010,7 @@
                 </a:solidFill>
                 <a:latin typeface="Calibri"/>
               </a:rPr>
-              <a:t>• Sentence-Level Flight Profiles: </a:t>
+              <a:t>• Edge IIoT Deployment: </a:t>
             </a:r>
             <a:r>
               <a:rPr sz="1800" b="0">
@@ -9019,57 +9019,57 @@
                 </a:solidFill>
                 <a:latin typeface="Calibri"/>
               </a:rPr>
+              <a:t>Export model to TensorFlow Lite (TFLite) for deployment on avionics microcontrollers.</a:t>
+            </a:r>
+          </a:p>
+          <a:p>
+            <a:pPr>
+              <a:spcAft>
+                <a:spcPts val="1000"/>
+              </a:spcAft>
+            </a:pPr>
+            <a:r>
+              <a:rPr sz="1800" b="1">
+                <a:solidFill>
+                  <a:srgbClr val="0F172A"/>
+                </a:solidFill>
+                <a:latin typeface="Calibri"/>
+              </a:rPr>
+              <a:t>• Cloud IIoT Streaming API: </a:t>
+            </a:r>
+            <a:r>
+              <a:rPr sz="1800" b="0">
+                <a:solidFill>
+                  <a:srgbClr val="334155"/>
+                </a:solidFill>
+                <a:latin typeface="Calibri"/>
+              </a:rPr>
+              <a:t>Deploy REST/MQTT endpoints for real-time IIoT stream data ingestion.</a:t>
+            </a:r>
+          </a:p>
+          <a:p>
+            <a:pPr>
+              <a:spcAft>
+                <a:spcPts val="1000"/>
+              </a:spcAft>
+            </a:pPr>
+            <a:r>
+              <a:rPr sz="1800" b="1">
+                <a:solidFill>
+                  <a:srgbClr val="0F172A"/>
+                </a:solidFill>
+                <a:latin typeface="Calibri"/>
+              </a:rPr>
+              <a:t>• Multi-Mode Flight Profiles: </a:t>
+            </a:r>
+            <a:r>
+              <a:rPr sz="1800" b="0">
+                <a:solidFill>
+                  <a:srgbClr val="334155"/>
+                </a:solidFill>
+                <a:latin typeface="Calibri"/>
+              </a:rPr>
               <a:t>Extend from single-mode steady flights to multi-profile flight regimes.</a:t>
-            </a:r>
-          </a:p>
-          <a:p>
-            <a:pPr>
-              <a:spcAft>
-                <a:spcPts val="1000"/>
-              </a:spcAft>
-            </a:pPr>
-            <a:r>
-              <a:rPr sz="1800" b="1">
-                <a:solidFill>
-                  <a:srgbClr val="0F172A"/>
-                </a:solidFill>
-                <a:latin typeface="Calibri"/>
-              </a:rPr>
-              <a:t>• Mobile &amp; Edge Deployment: </a:t>
-            </a:r>
-            <a:r>
-              <a:rPr sz="1800" b="0">
-                <a:solidFill>
-                  <a:srgbClr val="334155"/>
-                </a:solidFill>
-                <a:latin typeface="Calibri"/>
-              </a:rPr>
-              <a:t>Export model to TensorFlow Lite (TFLite) for deployment on avionics hardware.</a:t>
-            </a:r>
-          </a:p>
-          <a:p>
-            <a:pPr>
-              <a:spcAft>
-                <a:spcPts val="1000"/>
-              </a:spcAft>
-            </a:pPr>
-            <a:r>
-              <a:rPr sz="1800" b="1">
-                <a:solidFill>
-                  <a:srgbClr val="0F172A"/>
-                </a:solidFill>
-                <a:latin typeface="Calibri"/>
-              </a:rPr>
-              <a:t>• Cloud Streaming API: </a:t>
-            </a:r>
-            <a:r>
-              <a:rPr sz="1800" b="0">
-                <a:solidFill>
-                  <a:srgbClr val="334155"/>
-                </a:solidFill>
-                <a:latin typeface="Calibri"/>
-              </a:rPr>
-              <a:t>Deploy REST API endpoints for real-time IoT stream data ingestion.</a:t>
             </a:r>
           </a:p>
           <a:p>
@@ -9637,7 +9637,7 @@
                 </a:solidFill>
                 <a:latin typeface="Calibri"/>
               </a:rPr>
-              <a:t>• 1. Introduction &amp; Objectives: </a:t>
+              <a:t>• 1. Introduction &amp; IIoT Scope: </a:t>
             </a:r>
             <a:r>
               <a:rPr sz="1600" b="0">
@@ -9646,7 +9646,7 @@
                 </a:solidFill>
                 <a:latin typeface="Calibri"/>
               </a:rPr>
-              <a:t>Industrial domain, aviation PHM technology &amp; project goals</a:t>
+              <a:t>Industrial IoT domain, aviation PHM sensors &amp; project goals</a:t>
             </a:r>
           </a:p>
           <a:p>
@@ -9671,7 +9671,7 @@
                 </a:solidFill>
                 <a:latin typeface="Calibri"/>
               </a:rPr>
-              <a:t>Challenges in engine failure prediction &amp; cost limitations</a:t>
+              <a:t>Challenges in IIoT engine sensor streams &amp; cost limitations</a:t>
             </a:r>
           </a:p>
           <a:p>
@@ -9696,7 +9696,7 @@
                 </a:solidFill>
                 <a:latin typeface="Calibri"/>
               </a:rPr>
-              <a:t>Hardware setup &amp; software stack (Scikit-Learn, Pandas, NumPy)</a:t>
+              <a:t>IIoT sensor hardware &amp; Python software stack (Scikit-Learn, SciPy)</a:t>
             </a:r>
           </a:p>
           <a:p>
@@ -9712,7 +9712,7 @@
                 </a:solidFill>
                 <a:latin typeface="Calibri"/>
               </a:rPr>
-              <a:t>• 4. System Methodology &amp; Flowchart: </a:t>
+              <a:t>• 4. IIoT Pipeline Methodology: </a:t>
             </a:r>
             <a:r>
               <a:rPr sz="1600" b="0">
@@ -9721,7 +9721,7 @@
                 </a:solidFill>
                 <a:latin typeface="Calibri"/>
               </a:rPr>
-              <a:t>End-to-end telemetry ingestion &amp; pipeline flow</a:t>
+              <a:t>End-to-end 21-sensor IIoT telemetry ingestion &amp; data flow</a:t>
             </a:r>
           </a:p>
           <a:p>
@@ -9746,7 +9746,7 @@
                 </a:solidFill>
                 <a:latin typeface="Calibri"/>
               </a:rPr>
-              <a:t>5-cycle rolling statistics &amp; correlation filtering</a:t>
+              <a:t>5-cycle rolling IIoT statistics &amp; correlation filtering</a:t>
             </a:r>
           </a:p>
         </p:txBody>
@@ -9794,7 +9794,7 @@
                 </a:solidFill>
                 <a:latin typeface="Calibri"/>
               </a:rPr>
-              <a:t>NASA C-MAPSS 21-sensor dataset (20,631 cycles)</a:t>
+              <a:t>NASA C-MAPSS 21 IIoT sensor dataset (20,631 cycles)</a:t>
             </a:r>
           </a:p>
           <a:p>
@@ -9835,7 +9835,7 @@
                 </a:solidFill>
                 <a:latin typeface="Calibri"/>
               </a:rPr>
-              <a:t>• 8. Interactive Terminal Diagnostic: </a:t>
+              <a:t>• 8. IIoT Terminal Diagnostic: </a:t>
             </a:r>
             <a:r>
               <a:rPr sz="1600" b="0">
@@ -9844,7 +9844,7 @@
                 </a:solidFill>
                 <a:latin typeface="Calibri"/>
               </a:rPr>
-              <a:t>Native Python CLI app (predict.py) &amp; threshold gating</a:t>
+              <a:t>Native Python CLI app (predict.py) &amp; real-time gating</a:t>
             </a:r>
           </a:p>
           <a:p>
@@ -9894,7 +9894,7 @@
                 </a:solidFill>
                 <a:latin typeface="Calibri"/>
               </a:rPr>
-              <a:t>Summary of achievements, future scope &amp; academic references</a:t>
+              <a:t>Summary of achievements, edge IIoT scope &amp; references</a:t>
             </a:r>
           </a:p>
         </p:txBody>
@@ -10038,7 +10038,7 @@
                 </a:solidFill>
                 <a:latin typeface="Calibri"/>
               </a:rPr>
-              <a:t>Industrial AI, Reliability Engineering &amp; Aviation Prognostics Health Management (PHM).</a:t>
+              <a:t>Industrial IoT (IIoT), Reliability Engineering &amp; Aviation Prognostics Health Management.</a:t>
             </a:r>
           </a:p>
           <a:p>
@@ -10115,7 +10115,7 @@
                 </a:solidFill>
                 <a:latin typeface="Calibri"/>
               </a:rPr>
-              <a:t>Commercial Aircraft Turbofan Jet Engine Fleet Maintenance Operations &amp; Maintenance.</a:t>
+              <a:t>Commercial Aircraft Turbofan Engine Sensor Telemetry &amp; Fleet Operations.</a:t>
             </a:r>
           </a:p>
           <a:p>
@@ -10140,7 +10140,7 @@
                 </a:solidFill>
                 <a:latin typeface="Calibri"/>
               </a:rPr>
-              <a:t>Transitioning from static time-servicing to AI predictive maintenance.</a:t>
+              <a:t>Transitioning from static time-servicing to IIoT predictive maintenance.</a:t>
             </a:r>
           </a:p>
           <a:p>
@@ -10165,7 +10165,7 @@
                 </a:solidFill>
                 <a:latin typeface="Calibri"/>
               </a:rPr>
-              <a:t>Utilize 21 sensor streams to forecast Remaining Useful Life (RUL) before breakdown.</a:t>
+              <a:t>Utilize 21 IIoT sensor channels to forecast Remaining Useful Life (RUL) before failure.</a:t>
             </a:r>
           </a:p>
           <a:p>
@@ -10334,7 +10334,7 @@
                 </a:solidFill>
                 <a:latin typeface="Calibri"/>
               </a:rPr>
-              <a:t>Sudden engine failures cause expensive flight delays and severe safety risks.</a:t>
+              <a:t>Sudden turbofan breakdowns cause expensive flight delays and severe safety risks.</a:t>
             </a:r>
           </a:p>
           <a:p>
@@ -10411,7 +10411,7 @@
                 </a:solidFill>
                 <a:latin typeface="Calibri"/>
               </a:rPr>
-              <a:t>Replaces functional turbofan parts prematurely or misses failure events.</a:t>
+              <a:t>Replaces functional IIoT turbine parts prematurely or misses breakdown.</a:t>
             </a:r>
           </a:p>
           <a:p>
@@ -10427,7 +10427,7 @@
                 </a:solidFill>
                 <a:latin typeface="Calibri"/>
               </a:rPr>
-              <a:t>• High Sensor Fluctuation: </a:t>
+              <a:t>• High IIoT Sensor Fluctuation: </a:t>
             </a:r>
             <a:r>
               <a:rPr sz="1800" b="0">
@@ -10436,7 +10436,7 @@
                 </a:solidFill>
                 <a:latin typeface="Calibri"/>
               </a:rPr>
-              <a:t>21 continuous telemetry streams exhibit noisy non-linear degradation trends.</a:t>
+              <a:t>21 continuous sensor streams exhibit noisy non-linear thermal degradation.</a:t>
             </a:r>
           </a:p>
           <a:p>
@@ -10477,7 +10477,7 @@
                 </a:solidFill>
                 <a:latin typeface="Calibri"/>
               </a:rPr>
-              <a:t>• Real-Time Constraint: </a:t>
+              <a:t>• Real-Time IIoT Constraint: </a:t>
             </a:r>
             <a:r>
               <a:rPr sz="1800" b="0">
@@ -10486,7 +10486,7 @@
                 </a:solidFill>
                 <a:latin typeface="Calibri"/>
               </a:rPr>
-              <a:t>Achieve fast sub-30ms inference latency for immediate operational dispatch.</a:t>
+              <a:t>Achieve fast sub-30ms inference latency for immediate flight line dispatch.</a:t>
             </a:r>
           </a:p>
         </p:txBody>
@@ -10621,7 +10621,7 @@
                 </a:solidFill>
                 <a:latin typeface="Calibri"/>
               </a:rPr>
-              <a:t>• Hardware Requirements: </a:t>
+              <a:t>• IIoT Hardware Requirements: </a:t>
             </a:r>
             <a:r>
               <a:rPr sz="1800" b="0">
@@ -10630,7 +10630,7 @@
                 </a:solidFill>
                 <a:latin typeface="Calibri"/>
               </a:rPr>
-              <a:t>Intel Core i5/i7 Processor, 16GB RAM, SSD Storage Environment.</a:t>
+              <a:t>Intel Core i5/i7 Processor, 16GB RAM, SSD Storage &amp; IIoT Data Buffers.</a:t>
             </a:r>
           </a:p>
           <a:p>
@@ -10707,7 +10707,7 @@
                 </a:solidFill>
                 <a:latin typeface="Calibri"/>
               </a:rPr>
-              <a:t>Python 3.11 (Core predictive logic, data wrangling &amp; model serialization).</a:t>
+              <a:t>Python 3.11 (Core IIoT predictive logic, data wrangling &amp; serialization).</a:t>
             </a:r>
           </a:p>
           <a:p>
@@ -10757,7 +10757,7 @@
                 </a:solidFill>
                 <a:latin typeface="Calibri"/>
               </a:rPr>
-              <a:t>Pandas, NumPy, SciPy for 5-cycle rolling window aggregations.</a:t>
+              <a:t>Pandas, NumPy, SciPy for 5-cycle rolling window IIoT aggregations.</a:t>
             </a:r>
           </a:p>
           <a:p>
@@ -10911,7 +10911,7 @@
                 </a:solidFill>
                 <a:latin typeface="Calibri"/>
               </a:rPr>
-              <a:t>• Stage 1 Ingestion: </a:t>
+              <a:t>• Stage 1 IIoT Ingestion: </a:t>
             </a:r>
             <a:r>
               <a:rPr sz="1500" b="0">
@@ -10936,7 +10936,7 @@
                 </a:solidFill>
                 <a:latin typeface="Calibri"/>
               </a:rPr>
-              <a:t>• Stage 2 Preprocessing: </a:t>
+              <a:t>• Stage 2 Signal Processing: </a:t>
             </a:r>
             <a:r>
               <a:rPr sz="1500" b="0">
@@ -11020,7 +11020,7 @@
                 </a:solidFill>
                 <a:latin typeface="Calibri"/>
               </a:rPr>
-              <a:t>Computes health score, cost optimization &amp; fleet maintenance schedule.</a:t>
+              <a:t>Computes health score, cost optimization &amp; IIoT maintenance dispatch.</a:t>
             </a:r>
           </a:p>
         </p:txBody>
@@ -11188,7 +11188,7 @@
                 </a:solidFill>
                 <a:latin typeface="Calibri"/>
               </a:rPr>
-              <a:t>Computes 5-cycle rolling mean (av) and rolling std (sd) per sensor.</a:t>
+              <a:t>Computes 5-cycle rolling mean (av) and rolling std (sd) per IIoT sensor.</a:t>
             </a:r>
           </a:p>
           <a:p>
@@ -11265,7 +11265,7 @@
                 </a:solidFill>
                 <a:latin typeface="Calibri"/>
               </a:rPr>
-              <a:t>Smooths high-frequency sensor fluctuation to expose true degradation physics.</a:t>
+              <a:t>Smooths high-frequency IIoT sensor noise to expose true degradation physics.</a:t>
             </a:r>
           </a:p>
           <a:p>
@@ -11340,7 +11340,7 @@
                 </a:solidFill>
                 <a:latin typeface="Calibri"/>
               </a:rPr>
-              <a:t>Expands raw telemetry data into a structured 45-element feature vector.</a:t>
+              <a:t>Expands raw IIoT telemetry data into a structured 45-element feature vector.</a:t>
             </a:r>
           </a:p>
         </p:txBody>
@@ -11475,7 +11475,7 @@
                 </a:solidFill>
                 <a:latin typeface="Calibri"/>
               </a:rPr>
-              <a:t>• Dataset Size &amp; Support: </a:t>
+              <a:t>• IIoT Data Provider: </a:t>
             </a:r>
             <a:r>
               <a:rPr sz="1800" b="0">
@@ -11484,7 +11484,7 @@
                 </a:solidFill>
                 <a:latin typeface="Calibri"/>
               </a:rPr>
-              <a:t>NASA Ames Prognostics Center of Excellence C-MAPSS Turbofan Simulation Dataset.</a:t>
+              <a:t>NASA Ames Prognostics Center of Excellence C-MAPSS Turbofan Sensor Dataset.</a:t>
             </a:r>
           </a:p>
           <a:p>
@@ -11636,7 +11636,7 @@
                 </a:solidFill>
                 <a:latin typeface="Calibri"/>
               </a:rPr>
-              <a:t>Zero missing values, numeric sensor streams, preprocessed clean target series.</a:t>
+              <a:t>Zero missing values, numeric IIoT sensor streams, preprocessed clean target series.</a:t>
             </a:r>
           </a:p>
         </p:txBody>

</xml_diff>